<commit_message>
Implement reporting bible and objective gates
</commit_message>
<xml_diff>
--- a/outputs/commercial-quality/comprehensive-executive-presentation.pptx
+++ b/outputs/commercial-quality/comprehensive-executive-presentation.pptx
@@ -2,22 +2,22 @@
 <file path=ppt/presentation.xml><?xml version="1.0" encoding="utf-8"?>
 <p:presentation xmlns:p="http://schemas.openxmlformats.org/presentationml/2006/main">
   <p:sldMasterIdLst>
-    <p:sldMasterId xmlns:r="http://schemas.openxmlformats.org/officeDocument/2006/relationships" id="2147483648" r:id="Rfff83f5ef40b4703"/>
+    <p:sldMasterId xmlns:r="http://schemas.openxmlformats.org/officeDocument/2006/relationships" id="2147483648" r:id="R77e7ed94a8264d84"/>
   </p:sldMasterIdLst>
   <p:notesMasterIdLst>
-    <p:notesMasterId xmlns:r="http://schemas.openxmlformats.org/officeDocument/2006/relationships" r:id="Rd4fc60f006e444cf"/>
+    <p:notesMasterId xmlns:r="http://schemas.openxmlformats.org/officeDocument/2006/relationships" r:id="Rd4882d21dc2147a9"/>
   </p:notesMasterIdLst>
   <p:sldIdLst>
-    <p:sldId xmlns:r="http://schemas.openxmlformats.org/officeDocument/2006/relationships" id="256" r:id="R6db4dd886dfe4e14"/>
-    <p:sldId xmlns:r="http://schemas.openxmlformats.org/officeDocument/2006/relationships" id="257" r:id="Rf8f08bfcb5ac4ab4"/>
-    <p:sldId xmlns:r="http://schemas.openxmlformats.org/officeDocument/2006/relationships" id="258" r:id="R1c3601a1928e43ed"/>
-    <p:sldId xmlns:r="http://schemas.openxmlformats.org/officeDocument/2006/relationships" id="259" r:id="R3e10845eb7434e12"/>
-    <p:sldId xmlns:r="http://schemas.openxmlformats.org/officeDocument/2006/relationships" id="260" r:id="Rc8a28fe315e24fcc"/>
-    <p:sldId xmlns:r="http://schemas.openxmlformats.org/officeDocument/2006/relationships" id="261" r:id="R285b5c0f682d450f"/>
-    <p:sldId xmlns:r="http://schemas.openxmlformats.org/officeDocument/2006/relationships" id="262" r:id="R42a8a17a328846de"/>
-    <p:sldId xmlns:r="http://schemas.openxmlformats.org/officeDocument/2006/relationships" id="263" r:id="Ra5112cd5a59749b5"/>
-    <p:sldId xmlns:r="http://schemas.openxmlformats.org/officeDocument/2006/relationships" id="264" r:id="Rae8e2639f4804d34"/>
-    <p:sldId xmlns:r="http://schemas.openxmlformats.org/officeDocument/2006/relationships" id="265" r:id="R9391b7aa699a4dc4"/>
+    <p:sldId xmlns:r="http://schemas.openxmlformats.org/officeDocument/2006/relationships" id="256" r:id="R79f9c2a78e6d4c31"/>
+    <p:sldId xmlns:r="http://schemas.openxmlformats.org/officeDocument/2006/relationships" id="257" r:id="R970c988c179d4d62"/>
+    <p:sldId xmlns:r="http://schemas.openxmlformats.org/officeDocument/2006/relationships" id="258" r:id="R2031c965482d4ed2"/>
+    <p:sldId xmlns:r="http://schemas.openxmlformats.org/officeDocument/2006/relationships" id="259" r:id="R238dddf1ee334316"/>
+    <p:sldId xmlns:r="http://schemas.openxmlformats.org/officeDocument/2006/relationships" id="260" r:id="R2c83a6e609e84541"/>
+    <p:sldId xmlns:r="http://schemas.openxmlformats.org/officeDocument/2006/relationships" id="261" r:id="R0b9a4342d38d46b5"/>
+    <p:sldId xmlns:r="http://schemas.openxmlformats.org/officeDocument/2006/relationships" id="262" r:id="R2bd9ce409a4549fe"/>
+    <p:sldId xmlns:r="http://schemas.openxmlformats.org/officeDocument/2006/relationships" id="263" r:id="R70699dfe1a814123"/>
+    <p:sldId xmlns:r="http://schemas.openxmlformats.org/officeDocument/2006/relationships" id="264" r:id="R24e046c90b374cfe"/>
+    <p:sldId xmlns:r="http://schemas.openxmlformats.org/officeDocument/2006/relationships" id="265" r:id="Re32fc3f964cc46a4"/>
   </p:sldIdLst>
   <p:sldSz cx="12192000" cy="6858000"/>
   <p:notesSz cx="6858000" cy="9144000"/>
@@ -471,7 +471,7 @@
           </a:p>
           <a:p xmlns:a="http://schemas.openxmlformats.org/drawingml/2006/main">
             <a:r>
-              <a:t>- Preserve scope, position, evidence boundary, owner, date and proof in the annotated register.</a:t>
+              <a:t>- Preserve scope, position, information boundary, owner, date and proof in the annotated register.</a:t>
             </a:r>
           </a:p>
           <a:p xmlns:a="http://schemas.openxmlformats.org/drawingml/2006/main">
@@ -492,11 +492,6 @@
           <a:p xmlns:a="http://schemas.openxmlformats.org/drawingml/2006/main">
             <a:r>
               <a:t>- Traceability: annotated register preserves the source chain.</a:t>
-            </a:r>
-          </a:p>
-          <a:p xmlns:a="http://schemas.openxmlformats.org/drawingml/2006/main">
-            <a:r>
-              <a:t>- Exhibits: E1, E2, E3, E4, E5, E6, E7, E8, E9, E10.</a:t>
             </a:r>
           </a:p>
           <a:p xmlns:a="http://schemas.openxmlformats.org/drawingml/2006/main">
@@ -591,7 +586,7 @@
           </a:p>
           <a:p xmlns:a="http://schemas.openxmlformats.org/drawingml/2006/main">
             <a:r>
-              <a:t>- Preserve scope, position, evidence boundary, owner, date and proof in the annotated register.</a:t>
+              <a:t>- Preserve scope, position, information boundary, owner, date and proof in the annotated register.</a:t>
             </a:r>
           </a:p>
           <a:p xmlns:a="http://schemas.openxmlformats.org/drawingml/2006/main">
@@ -612,11 +607,6 @@
           <a:p xmlns:a="http://schemas.openxmlformats.org/drawingml/2006/main">
             <a:r>
               <a:t>- Traceability: annotated register preserves the source chain.</a:t>
-            </a:r>
-          </a:p>
-          <a:p xmlns:a="http://schemas.openxmlformats.org/drawingml/2006/main">
-            <a:r>
-              <a:t>- Exhibits: E1, E2, E3, E4, E5, E6, E7, E8, E9, E10.</a:t>
             </a:r>
           </a:p>
           <a:p xmlns:a="http://schemas.openxmlformats.org/drawingml/2006/main">
@@ -711,7 +701,7 @@
           </a:p>
           <a:p xmlns:a="http://schemas.openxmlformats.org/drawingml/2006/main">
             <a:r>
-              <a:t>- Preserve scope, position, evidence boundary, owner, date and proof in the annotated register.</a:t>
+              <a:t>- Preserve scope, position, information boundary, owner, date and proof in the annotated register.</a:t>
             </a:r>
           </a:p>
           <a:p xmlns:a="http://schemas.openxmlformats.org/drawingml/2006/main">
@@ -732,11 +722,6 @@
           <a:p xmlns:a="http://schemas.openxmlformats.org/drawingml/2006/main">
             <a:r>
               <a:t>- Traceability: annotated register preserves the source chain.</a:t>
-            </a:r>
-          </a:p>
-          <a:p xmlns:a="http://schemas.openxmlformats.org/drawingml/2006/main">
-            <a:r>
-              <a:t>- Exhibits: E1, E2, E3, E4, E5, E6, E7, E8, E9, E10.</a:t>
             </a:r>
           </a:p>
           <a:p xmlns:a="http://schemas.openxmlformats.org/drawingml/2006/main">
@@ -831,7 +816,7 @@
           </a:p>
           <a:p xmlns:a="http://schemas.openxmlformats.org/drawingml/2006/main">
             <a:r>
-              <a:t>- Preserve scope, position, evidence boundary, owner, date and proof in the annotated register.</a:t>
+              <a:t>- Preserve scope, position, information boundary, owner, date and proof in the annotated register.</a:t>
             </a:r>
           </a:p>
           <a:p xmlns:a="http://schemas.openxmlformats.org/drawingml/2006/main">
@@ -852,11 +837,6 @@
           <a:p xmlns:a="http://schemas.openxmlformats.org/drawingml/2006/main">
             <a:r>
               <a:t>- Traceability: annotated register preserves the source chain.</a:t>
-            </a:r>
-          </a:p>
-          <a:p xmlns:a="http://schemas.openxmlformats.org/drawingml/2006/main">
-            <a:r>
-              <a:t>- Exhibits: E1, E2, E3, E4, E5, E6, E7, E8, E9, E10.</a:t>
             </a:r>
           </a:p>
           <a:p xmlns:a="http://schemas.openxmlformats.org/drawingml/2006/main">
@@ -951,7 +931,7 @@
           </a:p>
           <a:p xmlns:a="http://schemas.openxmlformats.org/drawingml/2006/main">
             <a:r>
-              <a:t>- Preserve scope, position, evidence boundary, owner, date and proof in the annotated register.</a:t>
+              <a:t>- Preserve scope, position, information boundary, owner, date and proof in the annotated register.</a:t>
             </a:r>
           </a:p>
           <a:p xmlns:a="http://schemas.openxmlformats.org/drawingml/2006/main">
@@ -972,11 +952,6 @@
           <a:p xmlns:a="http://schemas.openxmlformats.org/drawingml/2006/main">
             <a:r>
               <a:t>- Traceability: annotated register preserves the source chain.</a:t>
-            </a:r>
-          </a:p>
-          <a:p xmlns:a="http://schemas.openxmlformats.org/drawingml/2006/main">
-            <a:r>
-              <a:t>- Exhibits: E1, E2, E3, E4, E5, E6, E7, E8, E9, E10.</a:t>
             </a:r>
           </a:p>
           <a:p xmlns:a="http://schemas.openxmlformats.org/drawingml/2006/main">
@@ -1071,7 +1046,7 @@
           </a:p>
           <a:p xmlns:a="http://schemas.openxmlformats.org/drawingml/2006/main">
             <a:r>
-              <a:t>- Preserve scope, position, evidence boundary, owner, date and proof in the annotated register.</a:t>
+              <a:t>- Preserve scope, position, information boundary, owner, date and proof in the annotated register.</a:t>
             </a:r>
           </a:p>
           <a:p xmlns:a="http://schemas.openxmlformats.org/drawingml/2006/main">
@@ -1092,11 +1067,6 @@
           <a:p xmlns:a="http://schemas.openxmlformats.org/drawingml/2006/main">
             <a:r>
               <a:t>- Traceability: annotated register preserves the source chain.</a:t>
-            </a:r>
-          </a:p>
-          <a:p xmlns:a="http://schemas.openxmlformats.org/drawingml/2006/main">
-            <a:r>
-              <a:t>- Exhibits: E1, E2, E3, E4, E5, E6, E7, E8, E9, E10.</a:t>
             </a:r>
           </a:p>
           <a:p xmlns:a="http://schemas.openxmlformats.org/drawingml/2006/main">
@@ -1191,7 +1161,7 @@
           </a:p>
           <a:p xmlns:a="http://schemas.openxmlformats.org/drawingml/2006/main">
             <a:r>
-              <a:t>- Preserve scope, position, evidence boundary, owner, date and proof in the annotated register.</a:t>
+              <a:t>- Preserve scope, position, information boundary, owner, date and proof in the annotated register.</a:t>
             </a:r>
           </a:p>
           <a:p xmlns:a="http://schemas.openxmlformats.org/drawingml/2006/main">
@@ -1212,11 +1182,6 @@
           <a:p xmlns:a="http://schemas.openxmlformats.org/drawingml/2006/main">
             <a:r>
               <a:t>- Traceability: annotated register preserves the source chain.</a:t>
-            </a:r>
-          </a:p>
-          <a:p xmlns:a="http://schemas.openxmlformats.org/drawingml/2006/main">
-            <a:r>
-              <a:t>- Exhibits: E1, E2, E3, E4, E5, E6, E7, E8, E9, E10.</a:t>
             </a:r>
           </a:p>
           <a:p xmlns:a="http://schemas.openxmlformats.org/drawingml/2006/main">
@@ -1311,7 +1276,7 @@
           </a:p>
           <a:p xmlns:a="http://schemas.openxmlformats.org/drawingml/2006/main">
             <a:r>
-              <a:t>- Preserve scope, position, evidence boundary, owner, date and proof in the annotated register.</a:t>
+              <a:t>- Preserve scope, position, information boundary, owner, date and proof in the annotated register.</a:t>
             </a:r>
           </a:p>
           <a:p xmlns:a="http://schemas.openxmlformats.org/drawingml/2006/main">
@@ -1332,11 +1297,6 @@
           <a:p xmlns:a="http://schemas.openxmlformats.org/drawingml/2006/main">
             <a:r>
               <a:t>- Traceability: annotated register preserves the source chain.</a:t>
-            </a:r>
-          </a:p>
-          <a:p xmlns:a="http://schemas.openxmlformats.org/drawingml/2006/main">
-            <a:r>
-              <a:t>- Exhibits: E1, E2, E3, E4, E5, E6, E7, E8, E9, E10.</a:t>
             </a:r>
           </a:p>
           <a:p xmlns:a="http://schemas.openxmlformats.org/drawingml/2006/main">
@@ -1431,7 +1391,7 @@
           </a:p>
           <a:p xmlns:a="http://schemas.openxmlformats.org/drawingml/2006/main">
             <a:r>
-              <a:t>- Preserve scope, position, evidence boundary, owner, date and proof in the annotated register.</a:t>
+              <a:t>- Preserve scope, position, information boundary, owner, date and proof in the annotated register.</a:t>
             </a:r>
           </a:p>
           <a:p xmlns:a="http://schemas.openxmlformats.org/drawingml/2006/main">
@@ -1452,11 +1412,6 @@
           <a:p xmlns:a="http://schemas.openxmlformats.org/drawingml/2006/main">
             <a:r>
               <a:t>- Traceability: annotated register preserves the source chain.</a:t>
-            </a:r>
-          </a:p>
-          <a:p xmlns:a="http://schemas.openxmlformats.org/drawingml/2006/main">
-            <a:r>
-              <a:t>- Exhibits: E1, E2, E3, E4, E5, E6, E7, E8, E9, E10.</a:t>
             </a:r>
           </a:p>
           <a:p xmlns:a="http://schemas.openxmlformats.org/drawingml/2006/main">
@@ -1551,7 +1506,7 @@
           </a:p>
           <a:p xmlns:a="http://schemas.openxmlformats.org/drawingml/2006/main">
             <a:r>
-              <a:t>- Preserve scope, position, evidence boundary, owner, date and proof in the annotated register.</a:t>
+              <a:t>- Preserve scope, position, information boundary, owner, date and proof in the annotated register.</a:t>
             </a:r>
           </a:p>
           <a:p xmlns:a="http://schemas.openxmlformats.org/drawingml/2006/main">
@@ -1572,11 +1527,6 @@
           <a:p xmlns:a="http://schemas.openxmlformats.org/drawingml/2006/main">
             <a:r>
               <a:t>- Traceability: annotated register preserves the source chain.</a:t>
-            </a:r>
-          </a:p>
-          <a:p xmlns:a="http://schemas.openxmlformats.org/drawingml/2006/main">
-            <a:r>
-              <a:t>- Exhibits: E1, E2, E3, E4, E5, E6, E7, E8, E9, E10.</a:t>
             </a:r>
           </a:p>
           <a:p xmlns:a="http://schemas.openxmlformats.org/drawingml/2006/main">
@@ -1649,7 +1599,7 @@
   </p:cSld>
   <p:clrMap bg1="lt1" tx1="dk1" bg2="lt2" tx2="dk2" accent1="accent1" accent2="accent2" accent3="accent3" accent4="accent4" accent5="accent5" accent6="accent6" hlink="hlink" folHlink="folHlink"/>
   <p:sldLayoutIdLst>
-    <p:sldLayoutId xmlns:r="http://schemas.openxmlformats.org/officeDocument/2006/relationships" id="2147483649" r:id="Ra57c76b3ef4d4ad8"/>
+    <p:sldLayoutId xmlns:r="http://schemas.openxmlformats.org/officeDocument/2006/relationships" id="2147483649" r:id="R19e622f7bf7f4309"/>
   </p:sldLayoutIdLst>
   <p:txStyles>
     <p:titleStyle>
@@ -2200,7 +2150,7 @@
           <p:cNvPr id="7" name="">
             <a:extLst xmlns:a="http://schemas.openxmlformats.org/drawingml/2006/main">
               <a:ext uri="{FF2B5EF4-FFF2-40B4-BE49-F238E27FC236}">
-                <a16:creationId xmlns:a16="http://schemas.microsoft.com/office/drawing/2014/main" id="{44FEF23B-E830-4DDE-AF36-0FD5F5FFE9D1}"/>
+                <a16:creationId xmlns:a16="http://schemas.microsoft.com/office/drawing/2014/main" id="{A9230606-D8AD-4B5E-A525-034C6C6ACF19}"/>
               </a:ext>
             </a:extLst>
           </p:cNvPr>
@@ -2233,7 +2183,7 @@
           <p:cNvPr id="2" name="">
             <a:extLst xmlns:a="http://schemas.openxmlformats.org/drawingml/2006/main">
               <a:ext uri="{FF2B5EF4-FFF2-40B4-BE49-F238E27FC236}">
-                <a16:creationId xmlns:a16="http://schemas.microsoft.com/office/drawing/2014/main" id="{ADFD56B8-B8A9-41E7-BE53-71C63B3FAEB1}"/>
+                <a16:creationId xmlns:a16="http://schemas.microsoft.com/office/drawing/2014/main" id="{6E2DD84F-B18A-48E8-9AAB-433C4DCE9E89}"/>
               </a:ext>
             </a:extLst>
           </p:cNvPr>
@@ -2283,7 +2233,7 @@
           <p:cNvPr id="3" name="">
             <a:extLst xmlns:a="http://schemas.openxmlformats.org/drawingml/2006/main">
               <a:ext uri="{FF2B5EF4-FFF2-40B4-BE49-F238E27FC236}">
-                <a16:creationId xmlns:a16="http://schemas.microsoft.com/office/drawing/2014/main" id="{5E7BEB53-E27C-4635-B608-8810D7596BAC}"/>
+                <a16:creationId xmlns:a16="http://schemas.microsoft.com/office/drawing/2014/main" id="{9260D5A4-12C3-4983-A8E8-2760348EDAE9}"/>
               </a:ext>
             </a:extLst>
           </p:cNvPr>
@@ -2323,7 +2273,7 @@
                   <a:srgbClr val="FFFFFF"/>
                 </a:solidFill>
               </a:rPr>
-              <a:t>The evidence review turns a diagnostic into a management decision record.</a:t>
+              <a:t>The target-state blueprint turns a diagnostic into a management decision record.</a:t>
             </a:r>
           </a:p>
         </p:txBody>
@@ -2333,7 +2283,7 @@
           <p:cNvPr id="4" name="">
             <a:extLst xmlns:a="http://schemas.openxmlformats.org/drawingml/2006/main">
               <a:ext uri="{FF2B5EF4-FFF2-40B4-BE49-F238E27FC236}">
-                <a16:creationId xmlns:a16="http://schemas.microsoft.com/office/drawing/2014/main" id="{46C9F060-D6BD-46A1-8C20-E4E17A9889A4}"/>
+                <a16:creationId xmlns:a16="http://schemas.microsoft.com/office/drawing/2014/main" id="{259E2981-3086-4861-9279-71A6C5F9E4E2}"/>
               </a:ext>
             </a:extLst>
           </p:cNvPr>
@@ -2390,7 +2340,7 @@
                   <a:srgbClr val="D9E1E7"/>
                 </a:solidFill>
               </a:rPr>
-              <a:t>Comprehensive review · evidence-led engagement</a:t>
+              <a:t>Comprehensive review · strategic design engagement</a:t>
             </a:r>
           </a:p>
         </p:txBody>
@@ -2400,7 +2350,7 @@
           <p:cNvPr id="5" name="">
             <a:extLst xmlns:a="http://schemas.openxmlformats.org/drawingml/2006/main">
               <a:ext uri="{FF2B5EF4-FFF2-40B4-BE49-F238E27FC236}">
-                <a16:creationId xmlns:a16="http://schemas.microsoft.com/office/drawing/2014/main" id="{691BAE6D-CEDF-44E6-B5C3-6D8D85B60850}"/>
+                <a16:creationId xmlns:a16="http://schemas.microsoft.com/office/drawing/2014/main" id="{D41B472E-6489-4EF4-83A2-0D8AD6D0D4E1}"/>
               </a:ext>
             </a:extLst>
           </p:cNvPr>
@@ -2440,7 +2390,7 @@
                   <a:srgbClr val="D9E1E7"/>
                 </a:solidFill>
               </a:rPr>
-              <a:t>Named reviewer: Independent review lead</a:t>
+              <a:t>Named reviewer: Named review lead</a:t>
             </a:r>
           </a:p>
         </p:txBody>
@@ -2450,7 +2400,7 @@
           <p:cNvPr id="6" name="">
             <a:extLst xmlns:a="http://schemas.openxmlformats.org/drawingml/2006/main">
               <a:ext uri="{FF2B5EF4-FFF2-40B4-BE49-F238E27FC236}">
-                <a16:creationId xmlns:a16="http://schemas.microsoft.com/office/drawing/2014/main" id="{F0ADAA09-243B-499B-B195-383D40B141B9}"/>
+                <a16:creationId xmlns:a16="http://schemas.microsoft.com/office/drawing/2014/main" id="{FF64BB82-AE3B-497F-B095-405BD1437B96}"/>
               </a:ext>
             </a:extLst>
           </p:cNvPr>
@@ -2498,7 +2448,7 @@
     </p:spTree>
     <p:extLst>
       <p:ext uri="{BB962C8B-B14F-4D97-AF65-F5344CB8AC3E}">
-        <p14:creationId xmlns:p14="http://schemas.microsoft.com/office/powerpoint/2010/main" val="2033550414"/>
+        <p14:creationId xmlns:p14="http://schemas.microsoft.com/office/powerpoint/2010/main" val="1120665951"/>
       </p:ext>
     </p:extLst>
   </p:cSld>
@@ -2529,7 +2479,7 @@
           <p:cNvPr id="18" name="">
             <a:extLst xmlns:a="http://schemas.openxmlformats.org/drawingml/2006/main">
               <a:ext uri="{FF2B5EF4-FFF2-40B4-BE49-F238E27FC236}">
-                <a16:creationId xmlns:a16="http://schemas.microsoft.com/office/drawing/2014/main" id="{B12BB3AE-9C7B-48A8-8F84-9CB486C0E8D7}"/>
+                <a16:creationId xmlns:a16="http://schemas.microsoft.com/office/drawing/2014/main" id="{6F8A6E73-C0E9-4DBD-A94E-C068972E8753}"/>
               </a:ext>
             </a:extLst>
           </p:cNvPr>
@@ -2579,7 +2529,7 @@
           <p:cNvPr id="2" name="">
             <a:extLst xmlns:a="http://schemas.openxmlformats.org/drawingml/2006/main">
               <a:ext uri="{FF2B5EF4-FFF2-40B4-BE49-F238E27FC236}">
-                <a16:creationId xmlns:a16="http://schemas.microsoft.com/office/drawing/2014/main" id="{CDD2C90E-3D61-4EC4-89B5-EFE62BCF8D8D}"/>
+                <a16:creationId xmlns:a16="http://schemas.microsoft.com/office/drawing/2014/main" id="{0BD6D83D-49B2-4C6B-ABA7-E4E9A99EF66D}"/>
               </a:ext>
             </a:extLst>
           </p:cNvPr>
@@ -2629,7 +2579,7 @@
           <p:cNvPr id="3" name="">
             <a:extLst xmlns:a="http://schemas.openxmlformats.org/drawingml/2006/main">
               <a:ext uri="{FF2B5EF4-FFF2-40B4-BE49-F238E27FC236}">
-                <a16:creationId xmlns:a16="http://schemas.microsoft.com/office/drawing/2014/main" id="{4A072A94-7071-409E-9DEB-2C32D07FDD2C}"/>
+                <a16:creationId xmlns:a16="http://schemas.microsoft.com/office/drawing/2014/main" id="{F5E10289-71EC-4998-8C56-0A4EC9AA1D01}"/>
               </a:ext>
             </a:extLst>
           </p:cNvPr>
@@ -2679,7 +2629,7 @@
           <p:cNvPr id="4" name="">
             <a:extLst xmlns:a="http://schemas.openxmlformats.org/drawingml/2006/main">
               <a:ext uri="{FF2B5EF4-FFF2-40B4-BE49-F238E27FC236}">
-                <a16:creationId xmlns:a16="http://schemas.microsoft.com/office/drawing/2014/main" id="{D5CD8B3A-C3EA-46D2-A5AE-A108AB749F46}"/>
+                <a16:creationId xmlns:a16="http://schemas.microsoft.com/office/drawing/2014/main" id="{F13361CE-CBD6-4231-902B-ACF5224BBD06}"/>
               </a:ext>
             </a:extLst>
           </p:cNvPr>
@@ -2710,7 +2660,7 @@
           <p:cNvPr id="5" name="">
             <a:extLst xmlns:a="http://schemas.openxmlformats.org/drawingml/2006/main">
               <a:ext uri="{FF2B5EF4-FFF2-40B4-BE49-F238E27FC236}">
-                <a16:creationId xmlns:a16="http://schemas.microsoft.com/office/drawing/2014/main" id="{FC300E52-180E-41A8-B469-3B49858D2AC5}"/>
+                <a16:creationId xmlns:a16="http://schemas.microsoft.com/office/drawing/2014/main" id="{7064E9D2-D79C-4FF0-8A4D-34C1B9B72869}"/>
               </a:ext>
             </a:extLst>
           </p:cNvPr>
@@ -2760,7 +2710,7 @@
           <p:cNvPr id="6" name="">
             <a:extLst xmlns:a="http://schemas.openxmlformats.org/drawingml/2006/main">
               <a:ext uri="{FF2B5EF4-FFF2-40B4-BE49-F238E27FC236}">
-                <a16:creationId xmlns:a16="http://schemas.microsoft.com/office/drawing/2014/main" id="{65625887-201D-4271-BBD6-93455BED0DBD}"/>
+                <a16:creationId xmlns:a16="http://schemas.microsoft.com/office/drawing/2014/main" id="{8DAEDC54-5B20-4B2E-B3E3-CD3D6EA6B68D}"/>
               </a:ext>
             </a:extLst>
           </p:cNvPr>
@@ -2810,7 +2760,7 @@
           <p:cNvPr id="7" name="">
             <a:extLst xmlns:a="http://schemas.openxmlformats.org/drawingml/2006/main">
               <a:ext uri="{FF2B5EF4-FFF2-40B4-BE49-F238E27FC236}">
-                <a16:creationId xmlns:a16="http://schemas.microsoft.com/office/drawing/2014/main" id="{1F7E6F51-08AE-45FA-A3E5-F657A3E5EF91}"/>
+                <a16:creationId xmlns:a16="http://schemas.microsoft.com/office/drawing/2014/main" id="{DC5BEF8F-0E7C-444F-B97C-AB0D8CB085D3}"/>
               </a:ext>
             </a:extLst>
           </p:cNvPr>
@@ -2845,7 +2795,7 @@
           <p:cNvPr id="8" name="">
             <a:extLst xmlns:a="http://schemas.openxmlformats.org/drawingml/2006/main">
               <a:ext uri="{FF2B5EF4-FFF2-40B4-BE49-F238E27FC236}">
-                <a16:creationId xmlns:a16="http://schemas.microsoft.com/office/drawing/2014/main" id="{1CBCF041-B15A-4550-88F3-0D355BD96A61}"/>
+                <a16:creationId xmlns:a16="http://schemas.microsoft.com/office/drawing/2014/main" id="{79638C9D-23AF-473D-A574-2616D3513E83}"/>
               </a:ext>
             </a:extLst>
           </p:cNvPr>
@@ -2895,7 +2845,7 @@
           <p:cNvPr id="9" name="">
             <a:extLst xmlns:a="http://schemas.openxmlformats.org/drawingml/2006/main">
               <a:ext uri="{FF2B5EF4-FFF2-40B4-BE49-F238E27FC236}">
-                <a16:creationId xmlns:a16="http://schemas.microsoft.com/office/drawing/2014/main" id="{929D8EDF-D9BB-4236-91B1-19CE0857696D}"/>
+                <a16:creationId xmlns:a16="http://schemas.microsoft.com/office/drawing/2014/main" id="{0C016F06-F883-4920-AEB4-04926E249E72}"/>
               </a:ext>
             </a:extLst>
           </p:cNvPr>
@@ -2928,7 +2878,7 @@
           <p:cNvPr id="10" name="">
             <a:extLst xmlns:a="http://schemas.openxmlformats.org/drawingml/2006/main">
               <a:ext uri="{FF2B5EF4-FFF2-40B4-BE49-F238E27FC236}">
-                <a16:creationId xmlns:a16="http://schemas.microsoft.com/office/drawing/2014/main" id="{42D5786A-A60F-4AFC-9A5A-3A42E63C3679}"/>
+                <a16:creationId xmlns:a16="http://schemas.microsoft.com/office/drawing/2014/main" id="{C87DE73A-2DD7-4119-AEF1-294A3BFC5360}"/>
               </a:ext>
             </a:extLst>
           </p:cNvPr>
@@ -2978,7 +2928,7 @@
           <p:cNvPr id="11" name="">
             <a:extLst xmlns:a="http://schemas.openxmlformats.org/drawingml/2006/main">
               <a:ext uri="{FF2B5EF4-FFF2-40B4-BE49-F238E27FC236}">
-                <a16:creationId xmlns:a16="http://schemas.microsoft.com/office/drawing/2014/main" id="{7EAD77EE-3406-4B06-9290-43A9C3E4DBAB}"/>
+                <a16:creationId xmlns:a16="http://schemas.microsoft.com/office/drawing/2014/main" id="{7310EF19-37CD-471C-A96C-9FCAF268F50A}"/>
               </a:ext>
             </a:extLst>
           </p:cNvPr>
@@ -3011,7 +2961,7 @@
           <p:cNvPr id="12" name="">
             <a:extLst xmlns:a="http://schemas.openxmlformats.org/drawingml/2006/main">
               <a:ext uri="{FF2B5EF4-FFF2-40B4-BE49-F238E27FC236}">
-                <a16:creationId xmlns:a16="http://schemas.microsoft.com/office/drawing/2014/main" id="{E162C5C1-DE45-408B-B330-B6679171D460}"/>
+                <a16:creationId xmlns:a16="http://schemas.microsoft.com/office/drawing/2014/main" id="{D52B5BAF-154B-4AC6-B5C3-7BE345A2E1E8}"/>
               </a:ext>
             </a:extLst>
           </p:cNvPr>
@@ -3061,7 +3011,7 @@
           <p:cNvPr id="13" name="">
             <a:extLst xmlns:a="http://schemas.openxmlformats.org/drawingml/2006/main">
               <a:ext uri="{FF2B5EF4-FFF2-40B4-BE49-F238E27FC236}">
-                <a16:creationId xmlns:a16="http://schemas.microsoft.com/office/drawing/2014/main" id="{5DC74EC9-A1C1-4E4D-A415-989BE5F83D8F}"/>
+                <a16:creationId xmlns:a16="http://schemas.microsoft.com/office/drawing/2014/main" id="{25230969-9EC5-40D0-9513-47E4309E8B8F}"/>
               </a:ext>
             </a:extLst>
           </p:cNvPr>
@@ -3094,7 +3044,7 @@
           <p:cNvPr id="14" name="">
             <a:extLst xmlns:a="http://schemas.openxmlformats.org/drawingml/2006/main">
               <a:ext uri="{FF2B5EF4-FFF2-40B4-BE49-F238E27FC236}">
-                <a16:creationId xmlns:a16="http://schemas.microsoft.com/office/drawing/2014/main" id="{250524DC-1CBF-4648-9A9D-9D9D88F68941}"/>
+                <a16:creationId xmlns:a16="http://schemas.microsoft.com/office/drawing/2014/main" id="{270ECBAB-ECAA-4F2A-914B-96E700939DF0}"/>
               </a:ext>
             </a:extLst>
           </p:cNvPr>
@@ -3144,7 +3094,7 @@
           <p:cNvPr id="15" name="">
             <a:extLst xmlns:a="http://schemas.openxmlformats.org/drawingml/2006/main">
               <a:ext uri="{FF2B5EF4-FFF2-40B4-BE49-F238E27FC236}">
-                <a16:creationId xmlns:a16="http://schemas.microsoft.com/office/drawing/2014/main" id="{94D25629-8204-42CE-8FB7-69179B974A51}"/>
+                <a16:creationId xmlns:a16="http://schemas.microsoft.com/office/drawing/2014/main" id="{515202FB-2B5D-41CC-ADE8-B8C43BEFB7C8}"/>
               </a:ext>
             </a:extLst>
           </p:cNvPr>
@@ -3177,7 +3127,7 @@
           <p:cNvPr id="16" name="">
             <a:extLst xmlns:a="http://schemas.openxmlformats.org/drawingml/2006/main">
               <a:ext uri="{FF2B5EF4-FFF2-40B4-BE49-F238E27FC236}">
-                <a16:creationId xmlns:a16="http://schemas.microsoft.com/office/drawing/2014/main" id="{D1CBA8C4-1302-422E-A85A-62EE126022A3}"/>
+                <a16:creationId xmlns:a16="http://schemas.microsoft.com/office/drawing/2014/main" id="{A18F11AB-6606-4700-ADAA-9E3B9FE68501}"/>
               </a:ext>
             </a:extLst>
           </p:cNvPr>
@@ -3227,7 +3177,7 @@
           <p:cNvPr id="17" name="">
             <a:extLst xmlns:a="http://schemas.openxmlformats.org/drawingml/2006/main">
               <a:ext uri="{FF2B5EF4-FFF2-40B4-BE49-F238E27FC236}">
-                <a16:creationId xmlns:a16="http://schemas.microsoft.com/office/drawing/2014/main" id="{3EC34322-6163-4A1C-9E13-5B77AFC64141}"/>
+                <a16:creationId xmlns:a16="http://schemas.microsoft.com/office/drawing/2014/main" id="{5E24D12A-99FA-43A8-A5F5-439265521840}"/>
               </a:ext>
             </a:extLst>
           </p:cNvPr>
@@ -3275,7 +3225,7 @@
     </p:spTree>
     <p:extLst>
       <p:ext uri="{BB962C8B-B14F-4D97-AF65-F5344CB8AC3E}">
-        <p14:creationId xmlns:p14="http://schemas.microsoft.com/office/powerpoint/2010/main" val="721759059"/>
+        <p14:creationId xmlns:p14="http://schemas.microsoft.com/office/powerpoint/2010/main" val="2112781286"/>
       </p:ext>
     </p:extLst>
   </p:cSld>
@@ -3306,7 +3256,7 @@
           <p:cNvPr id="30" name="">
             <a:extLst xmlns:a="http://schemas.openxmlformats.org/drawingml/2006/main">
               <a:ext uri="{FF2B5EF4-FFF2-40B4-BE49-F238E27FC236}">
-                <a16:creationId xmlns:a16="http://schemas.microsoft.com/office/drawing/2014/main" id="{4980E0E2-06F2-4AFC-9503-02A18270A2D0}"/>
+                <a16:creationId xmlns:a16="http://schemas.microsoft.com/office/drawing/2014/main" id="{A203B178-5B12-4BAC-8834-93B2EC6C4CDB}"/>
               </a:ext>
             </a:extLst>
           </p:cNvPr>
@@ -3356,7 +3306,7 @@
           <p:cNvPr id="2" name="">
             <a:extLst xmlns:a="http://schemas.openxmlformats.org/drawingml/2006/main">
               <a:ext uri="{FF2B5EF4-FFF2-40B4-BE49-F238E27FC236}">
-                <a16:creationId xmlns:a16="http://schemas.microsoft.com/office/drawing/2014/main" id="{5DD9C016-C89B-4F55-8F5F-4DDEA3AA1FE5}"/>
+                <a16:creationId xmlns:a16="http://schemas.microsoft.com/office/drawing/2014/main" id="{03E848D8-2683-4D38-8CC1-EAEB1ADC47DC}"/>
               </a:ext>
             </a:extLst>
           </p:cNvPr>
@@ -3396,7 +3346,7 @@
                   <a:srgbClr val="142F4C"/>
                 </a:solidFill>
               </a:rPr>
-              <a:t>The recorded position is developing; assurance is narrower than the score.</a:t>
+              <a:t>The recorded position is developing; reliance is narrower than the score.</a:t>
             </a:r>
           </a:p>
         </p:txBody>
@@ -3406,7 +3356,7 @@
           <p:cNvPr id="3" name="">
             <a:extLst xmlns:a="http://schemas.openxmlformats.org/drawingml/2006/main">
               <a:ext uri="{FF2B5EF4-FFF2-40B4-BE49-F238E27FC236}">
-                <a16:creationId xmlns:a16="http://schemas.microsoft.com/office/drawing/2014/main" id="{061F57B3-2AFD-4C2D-9150-0C1629E9E518}"/>
+                <a16:creationId xmlns:a16="http://schemas.microsoft.com/office/drawing/2014/main" id="{A22B4B13-EA77-4717-927B-9965D0B661E4}"/>
               </a:ext>
             </a:extLst>
           </p:cNvPr>
@@ -3446,7 +3396,7 @@
                   <a:srgbClr val="5A6B7C"/>
                 </a:solidFill>
               </a:rPr>
-              <a:t>Separate the deterministic result from what the evidence review can support.</a:t>
+              <a:t>Separate the deterministic result from the information boundary.</a:t>
             </a:r>
           </a:p>
         </p:txBody>
@@ -3456,7 +3406,7 @@
           <p:cNvPr id="4" name="">
             <a:extLst xmlns:a="http://schemas.openxmlformats.org/drawingml/2006/main">
               <a:ext uri="{FF2B5EF4-FFF2-40B4-BE49-F238E27FC236}">
-                <a16:creationId xmlns:a16="http://schemas.microsoft.com/office/drawing/2014/main" id="{FD3067EC-93B0-42A0-9ADA-73E85FA4C1C9}"/>
+                <a16:creationId xmlns:a16="http://schemas.microsoft.com/office/drawing/2014/main" id="{D7C4F327-6F74-401F-9DB2-7BBFC8E24B77}"/>
               </a:ext>
             </a:extLst>
           </p:cNvPr>
@@ -3487,7 +3437,7 @@
           <p:cNvPr id="5" name="">
             <a:extLst xmlns:a="http://schemas.openxmlformats.org/drawingml/2006/main">
               <a:ext uri="{FF2B5EF4-FFF2-40B4-BE49-F238E27FC236}">
-                <a16:creationId xmlns:a16="http://schemas.microsoft.com/office/drawing/2014/main" id="{00C3D77E-B926-406E-BF04-27BEC376C70D}"/>
+                <a16:creationId xmlns:a16="http://schemas.microsoft.com/office/drawing/2014/main" id="{9FF5A5A8-BB33-4244-BBD4-B0D68A608170}"/>
               </a:ext>
             </a:extLst>
           </p:cNvPr>
@@ -3537,7 +3487,7 @@
           <p:cNvPr id="6" name="">
             <a:extLst xmlns:a="http://schemas.openxmlformats.org/drawingml/2006/main">
               <a:ext uri="{FF2B5EF4-FFF2-40B4-BE49-F238E27FC236}">
-                <a16:creationId xmlns:a16="http://schemas.microsoft.com/office/drawing/2014/main" id="{80E70D9A-C496-4ED6-A79A-F0B5F1EAC2E8}"/>
+                <a16:creationId xmlns:a16="http://schemas.microsoft.com/office/drawing/2014/main" id="{5778DC7F-04E7-4613-AED2-E4FAC6043C0F}"/>
               </a:ext>
             </a:extLst>
           </p:cNvPr>
@@ -3587,7 +3537,7 @@
           <p:cNvPr id="7" name="">
             <a:extLst xmlns:a="http://schemas.openxmlformats.org/drawingml/2006/main">
               <a:ext uri="{FF2B5EF4-FFF2-40B4-BE49-F238E27FC236}">
-                <a16:creationId xmlns:a16="http://schemas.microsoft.com/office/drawing/2014/main" id="{A1B7BBB8-3F5B-42AB-A17D-43AB8933D5A1}"/>
+                <a16:creationId xmlns:a16="http://schemas.microsoft.com/office/drawing/2014/main" id="{90FAD54A-57B0-44EC-A98C-D9FA717E5D00}"/>
               </a:ext>
             </a:extLst>
           </p:cNvPr>
@@ -3622,7 +3572,7 @@
           <p:cNvPr id="8" name="">
             <a:extLst xmlns:a="http://schemas.openxmlformats.org/drawingml/2006/main">
               <a:ext uri="{FF2B5EF4-FFF2-40B4-BE49-F238E27FC236}">
-                <a16:creationId xmlns:a16="http://schemas.microsoft.com/office/drawing/2014/main" id="{5F94F9F2-CD90-47DE-BDC8-683E039E1969}"/>
+                <a16:creationId xmlns:a16="http://schemas.microsoft.com/office/drawing/2014/main" id="{85720461-CC28-422A-B669-F3688858329A}"/>
               </a:ext>
             </a:extLst>
           </p:cNvPr>
@@ -3655,7 +3605,7 @@
           <p:cNvPr id="9" name="">
             <a:extLst xmlns:a="http://schemas.openxmlformats.org/drawingml/2006/main">
               <a:ext uri="{FF2B5EF4-FFF2-40B4-BE49-F238E27FC236}">
-                <a16:creationId xmlns:a16="http://schemas.microsoft.com/office/drawing/2014/main" id="{F54748FB-2532-4BE2-9900-9D1575D8F3DE}"/>
+                <a16:creationId xmlns:a16="http://schemas.microsoft.com/office/drawing/2014/main" id="{EB1E8A97-3678-434E-802F-E9280312F5FD}"/>
               </a:ext>
             </a:extLst>
           </p:cNvPr>
@@ -3705,7 +3655,7 @@
           <p:cNvPr id="10" name="">
             <a:extLst xmlns:a="http://schemas.openxmlformats.org/drawingml/2006/main">
               <a:ext uri="{FF2B5EF4-FFF2-40B4-BE49-F238E27FC236}">
-                <a16:creationId xmlns:a16="http://schemas.microsoft.com/office/drawing/2014/main" id="{DDE6F074-FD90-4E70-8F71-24216576F990}"/>
+                <a16:creationId xmlns:a16="http://schemas.microsoft.com/office/drawing/2014/main" id="{B234FE86-F1AD-4900-A414-BD8A294F8AD2}"/>
               </a:ext>
             </a:extLst>
           </p:cNvPr>
@@ -3755,7 +3705,7 @@
           <p:cNvPr id="11" name="">
             <a:extLst xmlns:a="http://schemas.openxmlformats.org/drawingml/2006/main">
               <a:ext uri="{FF2B5EF4-FFF2-40B4-BE49-F238E27FC236}">
-                <a16:creationId xmlns:a16="http://schemas.microsoft.com/office/drawing/2014/main" id="{C1F4EADA-B388-4367-BA22-034178AFBC80}"/>
+                <a16:creationId xmlns:a16="http://schemas.microsoft.com/office/drawing/2014/main" id="{991BC2EA-7748-48E6-8B70-38635A407992}"/>
               </a:ext>
             </a:extLst>
           </p:cNvPr>
@@ -3805,7 +3755,7 @@
           <p:cNvPr id="12" name="">
             <a:extLst xmlns:a="http://schemas.openxmlformats.org/drawingml/2006/main">
               <a:ext uri="{FF2B5EF4-FFF2-40B4-BE49-F238E27FC236}">
-                <a16:creationId xmlns:a16="http://schemas.microsoft.com/office/drawing/2014/main" id="{2260E501-F3D6-4A24-9314-0B08C1C16684}"/>
+                <a16:creationId xmlns:a16="http://schemas.microsoft.com/office/drawing/2014/main" id="{44510E62-8ED3-4AE6-8364-9FA21809DC8A}"/>
               </a:ext>
             </a:extLst>
           </p:cNvPr>
@@ -3840,7 +3790,7 @@
           <p:cNvPr id="13" name="">
             <a:extLst xmlns:a="http://schemas.openxmlformats.org/drawingml/2006/main">
               <a:ext uri="{FF2B5EF4-FFF2-40B4-BE49-F238E27FC236}">
-                <a16:creationId xmlns:a16="http://schemas.microsoft.com/office/drawing/2014/main" id="{99C5B36C-9B0D-4486-AF10-32C7E78DF590}"/>
+                <a16:creationId xmlns:a16="http://schemas.microsoft.com/office/drawing/2014/main" id="{311958E4-69CB-4928-A880-31BD2CAE0F02}"/>
               </a:ext>
             </a:extLst>
           </p:cNvPr>
@@ -3873,7 +3823,7 @@
           <p:cNvPr id="14" name="">
             <a:extLst xmlns:a="http://schemas.openxmlformats.org/drawingml/2006/main">
               <a:ext uri="{FF2B5EF4-FFF2-40B4-BE49-F238E27FC236}">
-                <a16:creationId xmlns:a16="http://schemas.microsoft.com/office/drawing/2014/main" id="{42CF9EA8-B5B4-4689-BF62-7079E2A469C9}"/>
+                <a16:creationId xmlns:a16="http://schemas.microsoft.com/office/drawing/2014/main" id="{4896A7EC-4C0B-4F4F-8DA2-5EEBF7C8FFE8}"/>
               </a:ext>
             </a:extLst>
           </p:cNvPr>
@@ -3923,7 +3873,7 @@
           <p:cNvPr id="15" name="">
             <a:extLst xmlns:a="http://schemas.openxmlformats.org/drawingml/2006/main">
               <a:ext uri="{FF2B5EF4-FFF2-40B4-BE49-F238E27FC236}">
-                <a16:creationId xmlns:a16="http://schemas.microsoft.com/office/drawing/2014/main" id="{56904534-E6C8-4A3A-8269-7443A981A4CE}"/>
+                <a16:creationId xmlns:a16="http://schemas.microsoft.com/office/drawing/2014/main" id="{4363664A-288F-44FC-8C47-AA67F27AC84C}"/>
               </a:ext>
             </a:extLst>
           </p:cNvPr>
@@ -3973,7 +3923,7 @@
           <p:cNvPr id="16" name="">
             <a:extLst xmlns:a="http://schemas.openxmlformats.org/drawingml/2006/main">
               <a:ext uri="{FF2B5EF4-FFF2-40B4-BE49-F238E27FC236}">
-                <a16:creationId xmlns:a16="http://schemas.microsoft.com/office/drawing/2014/main" id="{441669D8-7594-4FB3-B1B8-217145256670}"/>
+                <a16:creationId xmlns:a16="http://schemas.microsoft.com/office/drawing/2014/main" id="{95E3C51A-2F99-40D4-90C7-2FCDA19DB1D1}"/>
               </a:ext>
             </a:extLst>
           </p:cNvPr>
@@ -4023,7 +3973,7 @@
           <p:cNvPr id="17" name="">
             <a:extLst xmlns:a="http://schemas.openxmlformats.org/drawingml/2006/main">
               <a:ext uri="{FF2B5EF4-FFF2-40B4-BE49-F238E27FC236}">
-                <a16:creationId xmlns:a16="http://schemas.microsoft.com/office/drawing/2014/main" id="{04040974-CA0A-4692-8347-4EF70DE49C87}"/>
+                <a16:creationId xmlns:a16="http://schemas.microsoft.com/office/drawing/2014/main" id="{FD92676B-A59E-4A31-A4D8-63B977298A9F}"/>
               </a:ext>
             </a:extLst>
           </p:cNvPr>
@@ -4058,7 +4008,7 @@
           <p:cNvPr id="18" name="">
             <a:extLst xmlns:a="http://schemas.openxmlformats.org/drawingml/2006/main">
               <a:ext uri="{FF2B5EF4-FFF2-40B4-BE49-F238E27FC236}">
-                <a16:creationId xmlns:a16="http://schemas.microsoft.com/office/drawing/2014/main" id="{FAD53C07-790C-468D-AFCF-33038E40741C}"/>
+                <a16:creationId xmlns:a16="http://schemas.microsoft.com/office/drawing/2014/main" id="{ABC9A05F-99EE-4C03-A443-F56A17811D85}"/>
               </a:ext>
             </a:extLst>
           </p:cNvPr>
@@ -4091,7 +4041,7 @@
           <p:cNvPr id="19" name="">
             <a:extLst xmlns:a="http://schemas.openxmlformats.org/drawingml/2006/main">
               <a:ext uri="{FF2B5EF4-FFF2-40B4-BE49-F238E27FC236}">
-                <a16:creationId xmlns:a16="http://schemas.microsoft.com/office/drawing/2014/main" id="{58412124-CA8D-45E2-951D-1337761410FF}"/>
+                <a16:creationId xmlns:a16="http://schemas.microsoft.com/office/drawing/2014/main" id="{573BF0A0-CD5F-4EFD-8A33-98E94AC55599}"/>
               </a:ext>
             </a:extLst>
           </p:cNvPr>
@@ -4131,7 +4081,7 @@
                   <a:srgbClr val="5A6B7C"/>
                 </a:solidFill>
               </a:rPr>
-              <a:t>Supported evidence</a:t>
+              <a:t>Review notes in scope</a:t>
             </a:r>
           </a:p>
         </p:txBody>
@@ -4141,7 +4091,7 @@
           <p:cNvPr id="20" name="">
             <a:extLst xmlns:a="http://schemas.openxmlformats.org/drawingml/2006/main">
               <a:ext uri="{FF2B5EF4-FFF2-40B4-BE49-F238E27FC236}">
-                <a16:creationId xmlns:a16="http://schemas.microsoft.com/office/drawing/2014/main" id="{4B8AFEB8-B4A1-42D6-B2A6-179D58533993}"/>
+                <a16:creationId xmlns:a16="http://schemas.microsoft.com/office/drawing/2014/main" id="{3D1DF570-B563-428C-A08A-20203510BE01}"/>
               </a:ext>
             </a:extLst>
           </p:cNvPr>
@@ -4181,7 +4131,7 @@
                   <a:srgbClr val="142F4C"/>
                 </a:solidFill>
               </a:rPr>
-              <a:t>3</a:t>
+              <a:t>1</a:t>
             </a:r>
           </a:p>
         </p:txBody>
@@ -4191,7 +4141,7 @@
           <p:cNvPr id="21" name="">
             <a:extLst xmlns:a="http://schemas.openxmlformats.org/drawingml/2006/main">
               <a:ext uri="{FF2B5EF4-FFF2-40B4-BE49-F238E27FC236}">
-                <a16:creationId xmlns:a16="http://schemas.microsoft.com/office/drawing/2014/main" id="{BB7AB3BF-3BC9-43B7-A4E4-FF32B4544A68}"/>
+                <a16:creationId xmlns:a16="http://schemas.microsoft.com/office/drawing/2014/main" id="{DB3ECE6D-9818-46E8-BE93-261B81CA8BE2}"/>
               </a:ext>
             </a:extLst>
           </p:cNvPr>
@@ -4231,7 +4181,7 @@
                   <a:srgbClr val="5A6B7C"/>
                 </a:solidFill>
               </a:rPr>
-              <a:t>of 12 items</a:t>
+              <a:t>of 64 items</a:t>
             </a:r>
           </a:p>
         </p:txBody>
@@ -4241,7 +4191,7 @@
           <p:cNvPr id="22" name="">
             <a:extLst xmlns:a="http://schemas.openxmlformats.org/drawingml/2006/main">
               <a:ext uri="{FF2B5EF4-FFF2-40B4-BE49-F238E27FC236}">
-                <a16:creationId xmlns:a16="http://schemas.microsoft.com/office/drawing/2014/main" id="{0C999258-981D-4748-B337-05D7B4AD3C53}"/>
+                <a16:creationId xmlns:a16="http://schemas.microsoft.com/office/drawing/2014/main" id="{ACEF1172-46B3-42E3-BEB0-137D12BBEDC7}"/>
               </a:ext>
             </a:extLst>
           </p:cNvPr>
@@ -4276,7 +4226,7 @@
           <p:cNvPr id="23" name="">
             <a:extLst xmlns:a="http://schemas.openxmlformats.org/drawingml/2006/main">
               <a:ext uri="{FF2B5EF4-FFF2-40B4-BE49-F238E27FC236}">
-                <a16:creationId xmlns:a16="http://schemas.microsoft.com/office/drawing/2014/main" id="{937D2998-FA29-4BD4-B510-72FED31A6A7B}"/>
+                <a16:creationId xmlns:a16="http://schemas.microsoft.com/office/drawing/2014/main" id="{7C858EF8-7B80-4651-AD36-4046716F5E65}"/>
               </a:ext>
             </a:extLst>
           </p:cNvPr>
@@ -4309,7 +4259,7 @@
           <p:cNvPr id="24" name="">
             <a:extLst xmlns:a="http://schemas.openxmlformats.org/drawingml/2006/main">
               <a:ext uri="{FF2B5EF4-FFF2-40B4-BE49-F238E27FC236}">
-                <a16:creationId xmlns:a16="http://schemas.microsoft.com/office/drawing/2014/main" id="{AC765BE2-B5CC-4C56-ACA0-94E3DB99DEA9}"/>
+                <a16:creationId xmlns:a16="http://schemas.microsoft.com/office/drawing/2014/main" id="{E5BD11DE-F069-4600-BF66-ED407B49FB9B}"/>
               </a:ext>
             </a:extLst>
           </p:cNvPr>
@@ -4349,7 +4299,7 @@
                   <a:srgbClr val="5A6B7C"/>
                 </a:solidFill>
               </a:rPr>
-              <a:t>Unresolved evidence</a:t>
+              <a:t>Open information items</a:t>
             </a:r>
           </a:p>
         </p:txBody>
@@ -4359,7 +4309,7 @@
           <p:cNvPr id="25" name="">
             <a:extLst xmlns:a="http://schemas.openxmlformats.org/drawingml/2006/main">
               <a:ext uri="{FF2B5EF4-FFF2-40B4-BE49-F238E27FC236}">
-                <a16:creationId xmlns:a16="http://schemas.microsoft.com/office/drawing/2014/main" id="{88445BB2-AD75-4D82-B8FA-E17190CB2DB4}"/>
+                <a16:creationId xmlns:a16="http://schemas.microsoft.com/office/drawing/2014/main" id="{F6231BAD-1A2D-49DB-9992-4389170C53FE}"/>
               </a:ext>
             </a:extLst>
           </p:cNvPr>
@@ -4399,7 +4349,7 @@
                   <a:srgbClr val="142F4C"/>
                 </a:solidFill>
               </a:rPr>
-              <a:t>8</a:t>
+              <a:t>63</a:t>
             </a:r>
           </a:p>
         </p:txBody>
@@ -4409,7 +4359,7 @@
           <p:cNvPr id="26" name="">
             <a:extLst xmlns:a="http://schemas.openxmlformats.org/drawingml/2006/main">
               <a:ext uri="{FF2B5EF4-FFF2-40B4-BE49-F238E27FC236}">
-                <a16:creationId xmlns:a16="http://schemas.microsoft.com/office/drawing/2014/main" id="{7443601B-53ED-41C4-A846-C4C4B932A112}"/>
+                <a16:creationId xmlns:a16="http://schemas.microsoft.com/office/drawing/2014/main" id="{87CF3402-ED9C-446D-8826-C8614CF4FED2}"/>
               </a:ext>
             </a:extLst>
           </p:cNvPr>
@@ -4459,7 +4409,7 @@
           <p:cNvPr id="27" name="">
             <a:extLst xmlns:a="http://schemas.openxmlformats.org/drawingml/2006/main">
               <a:ext uri="{FF2B5EF4-FFF2-40B4-BE49-F238E27FC236}">
-                <a16:creationId xmlns:a16="http://schemas.microsoft.com/office/drawing/2014/main" id="{AF6F4EDA-A602-4C1F-B602-24FD1ECB7A1E}"/>
+                <a16:creationId xmlns:a16="http://schemas.microsoft.com/office/drawing/2014/main" id="{EB10228F-2157-4ED9-AA7D-7C7D1E2F7114}"/>
               </a:ext>
             </a:extLst>
           </p:cNvPr>
@@ -4494,7 +4444,7 @@
           <p:cNvPr id="28" name="">
             <a:extLst xmlns:a="http://schemas.openxmlformats.org/drawingml/2006/main">
               <a:ext uri="{FF2B5EF4-FFF2-40B4-BE49-F238E27FC236}">
-                <a16:creationId xmlns:a16="http://schemas.microsoft.com/office/drawing/2014/main" id="{63D41E78-1784-412A-BEA7-5E41A894B60C}"/>
+                <a16:creationId xmlns:a16="http://schemas.microsoft.com/office/drawing/2014/main" id="{D78EDF21-9208-45C8-AE2C-D31EAAAE2830}"/>
               </a:ext>
             </a:extLst>
           </p:cNvPr>
@@ -4544,7 +4494,7 @@
           <p:cNvPr id="29" name="">
             <a:extLst xmlns:a="http://schemas.openxmlformats.org/drawingml/2006/main">
               <a:ext uri="{FF2B5EF4-FFF2-40B4-BE49-F238E27FC236}">
-                <a16:creationId xmlns:a16="http://schemas.microsoft.com/office/drawing/2014/main" id="{E4AB5026-37BF-42CC-B626-D2234A777FAF}"/>
+                <a16:creationId xmlns:a16="http://schemas.microsoft.com/office/drawing/2014/main" id="{55421360-78DA-4CA6-B804-979A4C9C206D}"/>
               </a:ext>
             </a:extLst>
           </p:cNvPr>
@@ -4592,7 +4542,7 @@
     </p:spTree>
     <p:extLst>
       <p:ext uri="{BB962C8B-B14F-4D97-AF65-F5344CB8AC3E}">
-        <p14:creationId xmlns:p14="http://schemas.microsoft.com/office/powerpoint/2010/main" val="926849059"/>
+        <p14:creationId xmlns:p14="http://schemas.microsoft.com/office/powerpoint/2010/main" val="396547063"/>
       </p:ext>
     </p:extLst>
   </p:cSld>
@@ -4623,7 +4573,7 @@
           <p:cNvPr id="26" name="">
             <a:extLst xmlns:a="http://schemas.openxmlformats.org/drawingml/2006/main">
               <a:ext uri="{FF2B5EF4-FFF2-40B4-BE49-F238E27FC236}">
-                <a16:creationId xmlns:a16="http://schemas.microsoft.com/office/drawing/2014/main" id="{171A76F9-D7E0-4CC3-A82F-9247EE296B01}"/>
+                <a16:creationId xmlns:a16="http://schemas.microsoft.com/office/drawing/2014/main" id="{A6B00832-C541-4FC8-962A-0D352A410B57}"/>
               </a:ext>
             </a:extLst>
           </p:cNvPr>
@@ -4673,7 +4623,7 @@
           <p:cNvPr id="2" name="">
             <a:extLst xmlns:a="http://schemas.openxmlformats.org/drawingml/2006/main">
               <a:ext uri="{FF2B5EF4-FFF2-40B4-BE49-F238E27FC236}">
-                <a16:creationId xmlns:a16="http://schemas.microsoft.com/office/drawing/2014/main" id="{8615BF5F-4B74-4063-A390-06C503F82A9E}"/>
+                <a16:creationId xmlns:a16="http://schemas.microsoft.com/office/drawing/2014/main" id="{A9E02EF7-B8B5-488A-BA45-61A6AD8FDE67}"/>
               </a:ext>
             </a:extLst>
           </p:cNvPr>
@@ -4713,7 +4663,7 @@
                   <a:srgbClr val="142F4C"/>
                 </a:solidFill>
               </a:rPr>
-              <a:t>Evidence review supports selected positions, but the scope is not fully closed.</a:t>
+              <a:t>The information boundary is visible before decisions are made.</a:t>
             </a:r>
           </a:p>
         </p:txBody>
@@ -4723,7 +4673,7 @@
           <p:cNvPr id="3" name="">
             <a:extLst xmlns:a="http://schemas.openxmlformats.org/drawingml/2006/main">
               <a:ext uri="{FF2B5EF4-FFF2-40B4-BE49-F238E27FC236}">
-                <a16:creationId xmlns:a16="http://schemas.microsoft.com/office/drawing/2014/main" id="{7E5AC73B-39DE-46DE-9215-2F1F7E70A354}"/>
+                <a16:creationId xmlns:a16="http://schemas.microsoft.com/office/drawing/2014/main" id="{14FE0C2C-39AE-4ECB-AD5B-02FA74BDB1CA}"/>
               </a:ext>
             </a:extLst>
           </p:cNvPr>
@@ -4763,7 +4713,7 @@
                   <a:srgbClr val="5A6B7C"/>
                 </a:solidFill>
               </a:rPr>
-              <a:t>The evidence ledger makes the reliance boundary visible in one view.</a:t>
+              <a:t>The register makes scope, review notes and open items visible in one view.</a:t>
             </a:r>
           </a:p>
         </p:txBody>
@@ -4773,7 +4723,7 @@
           <p:cNvPr id="4" name="">
             <a:extLst xmlns:a="http://schemas.openxmlformats.org/drawingml/2006/main">
               <a:ext uri="{FF2B5EF4-FFF2-40B4-BE49-F238E27FC236}">
-                <a16:creationId xmlns:a16="http://schemas.microsoft.com/office/drawing/2014/main" id="{B0F4BC18-0B25-4307-AC71-02167ACCC13B}"/>
+                <a16:creationId xmlns:a16="http://schemas.microsoft.com/office/drawing/2014/main" id="{7D533FDD-BB3B-4DD5-B54B-221178A5C747}"/>
               </a:ext>
             </a:extLst>
           </p:cNvPr>
@@ -4804,7 +4754,7 @@
           <p:cNvPr id="5" name="">
             <a:extLst xmlns:a="http://schemas.openxmlformats.org/drawingml/2006/main">
               <a:ext uri="{FF2B5EF4-FFF2-40B4-BE49-F238E27FC236}">
-                <a16:creationId xmlns:a16="http://schemas.microsoft.com/office/drawing/2014/main" id="{D4EF18AF-E614-445B-BE58-BD6513887B13}"/>
+                <a16:creationId xmlns:a16="http://schemas.microsoft.com/office/drawing/2014/main" id="{20B2BED4-8EB5-4D0F-A953-0A5E59709FE9}"/>
               </a:ext>
             </a:extLst>
           </p:cNvPr>
@@ -4854,7 +4804,7 @@
           <p:cNvPr id="6" name="">
             <a:extLst xmlns:a="http://schemas.openxmlformats.org/drawingml/2006/main">
               <a:ext uri="{FF2B5EF4-FFF2-40B4-BE49-F238E27FC236}">
-                <a16:creationId xmlns:a16="http://schemas.microsoft.com/office/drawing/2014/main" id="{C4780547-DFCE-4167-8A9C-93CBEC2FEC4B}"/>
+                <a16:creationId xmlns:a16="http://schemas.microsoft.com/office/drawing/2014/main" id="{CBB591A5-107B-4BCB-8AF2-5FD6DB1D98DC}"/>
               </a:ext>
             </a:extLst>
           </p:cNvPr>
@@ -4904,7 +4854,7 @@
           <p:cNvPr id="7" name="">
             <a:extLst xmlns:a="http://schemas.openxmlformats.org/drawingml/2006/main">
               <a:ext uri="{FF2B5EF4-FFF2-40B4-BE49-F238E27FC236}">
-                <a16:creationId xmlns:a16="http://schemas.microsoft.com/office/drawing/2014/main" id="{2BBD3862-F26A-462D-88F9-9F09304FC8C2}"/>
+                <a16:creationId xmlns:a16="http://schemas.microsoft.com/office/drawing/2014/main" id="{1E2DE2AE-1C7C-47E7-8356-293B26F00C49}"/>
               </a:ext>
             </a:extLst>
           </p:cNvPr>
@@ -4944,7 +4894,7 @@
                   <a:srgbClr val="142F4C"/>
                 </a:solidFill>
               </a:rPr>
-              <a:t>Supported for stated scope</a:t>
+              <a:t>Review note — stated scope</a:t>
             </a:r>
           </a:p>
         </p:txBody>
@@ -4954,7 +4904,7 @@
           <p:cNvPr id="8" name="">
             <a:extLst xmlns:a="http://schemas.openxmlformats.org/drawingml/2006/main">
               <a:ext uri="{FF2B5EF4-FFF2-40B4-BE49-F238E27FC236}">
-                <a16:creationId xmlns:a16="http://schemas.microsoft.com/office/drawing/2014/main" id="{D831A698-D5D6-423F-BB95-2E520CD88D89}"/>
+                <a16:creationId xmlns:a16="http://schemas.microsoft.com/office/drawing/2014/main" id="{3A9F2A02-461E-4C39-9B4B-2A37023FF9CE}"/>
               </a:ext>
             </a:extLst>
           </p:cNvPr>
@@ -4987,7 +4937,7 @@
           <p:cNvPr id="9" name="">
             <a:extLst xmlns:a="http://schemas.openxmlformats.org/drawingml/2006/main">
               <a:ext uri="{FF2B5EF4-FFF2-40B4-BE49-F238E27FC236}">
-                <a16:creationId xmlns:a16="http://schemas.microsoft.com/office/drawing/2014/main" id="{8636953C-92EF-4C35-904C-018A43A61564}"/>
+                <a16:creationId xmlns:a16="http://schemas.microsoft.com/office/drawing/2014/main" id="{DD379AA0-0DE5-45ED-8E27-A7A44504440A}"/>
               </a:ext>
             </a:extLst>
           </p:cNvPr>
@@ -4999,7 +4949,7 @@
         <p:spPr>
           <a:xfrm xmlns:a="http://schemas.openxmlformats.org/drawingml/2006/main">
             <a:off x="4000500" y="2143125"/>
-            <a:ext cx="1238250" cy="228600"/>
+            <a:ext cx="171450" cy="228600"/>
           </a:xfrm>
           <a:prstGeom xmlns:a="http://schemas.openxmlformats.org/drawingml/2006/main" prst="rect">
             <a:avLst/>
@@ -5020,7 +4970,7 @@
           <p:cNvPr id="10" name="">
             <a:extLst xmlns:a="http://schemas.openxmlformats.org/drawingml/2006/main">
               <a:ext uri="{FF2B5EF4-FFF2-40B4-BE49-F238E27FC236}">
-                <a16:creationId xmlns:a16="http://schemas.microsoft.com/office/drawing/2014/main" id="{6D6B4A45-5B46-4912-A29D-7179E7726BA9}"/>
+                <a16:creationId xmlns:a16="http://schemas.microsoft.com/office/drawing/2014/main" id="{D2CF2424-3D0A-4DF9-A7AA-5316621A2E6D}"/>
               </a:ext>
             </a:extLst>
           </p:cNvPr>
@@ -5060,7 +5010,7 @@
                   <a:srgbClr val="142F4C"/>
                 </a:solidFill>
               </a:rPr>
-              <a:t>3</a:t>
+              <a:t>1</a:t>
             </a:r>
           </a:p>
         </p:txBody>
@@ -5070,7 +5020,7 @@
           <p:cNvPr id="11" name="">
             <a:extLst xmlns:a="http://schemas.openxmlformats.org/drawingml/2006/main">
               <a:ext uri="{FF2B5EF4-FFF2-40B4-BE49-F238E27FC236}">
-                <a16:creationId xmlns:a16="http://schemas.microsoft.com/office/drawing/2014/main" id="{1135BD54-067C-44B8-97C2-ABECB93DCA6A}"/>
+                <a16:creationId xmlns:a16="http://schemas.microsoft.com/office/drawing/2014/main" id="{F444AA37-4F19-462E-96BE-662B571FAC4F}"/>
               </a:ext>
             </a:extLst>
           </p:cNvPr>
@@ -5110,7 +5060,7 @@
                   <a:srgbClr val="142F4C"/>
                 </a:solidFill>
               </a:rPr>
-              <a:t>Evidence reviewed</a:t>
+              <a:t>Management review record</a:t>
             </a:r>
           </a:p>
         </p:txBody>
@@ -5120,7 +5070,7 @@
           <p:cNvPr id="12" name="">
             <a:extLst xmlns:a="http://schemas.openxmlformats.org/drawingml/2006/main">
               <a:ext uri="{FF2B5EF4-FFF2-40B4-BE49-F238E27FC236}">
-                <a16:creationId xmlns:a16="http://schemas.microsoft.com/office/drawing/2014/main" id="{5C3B404F-EBCA-4C69-8F13-4E1271CF1B34}"/>
+                <a16:creationId xmlns:a16="http://schemas.microsoft.com/office/drawing/2014/main" id="{35BB73E9-6547-46FB-8FF0-198FB3327990}"/>
               </a:ext>
             </a:extLst>
           </p:cNvPr>
@@ -5153,7 +5103,7 @@
           <p:cNvPr id="13" name="">
             <a:extLst xmlns:a="http://schemas.openxmlformats.org/drawingml/2006/main">
               <a:ext uri="{FF2B5EF4-FFF2-40B4-BE49-F238E27FC236}">
-                <a16:creationId xmlns:a16="http://schemas.microsoft.com/office/drawing/2014/main" id="{16D51973-4A8F-4E90-8497-CAAD2E27A6BD}"/>
+                <a16:creationId xmlns:a16="http://schemas.microsoft.com/office/drawing/2014/main" id="{CCCCDCA8-321C-4BA0-941C-2135A452915B}"/>
               </a:ext>
             </a:extLst>
           </p:cNvPr>
@@ -5165,7 +5115,7 @@
         <p:spPr>
           <a:xfrm xmlns:a="http://schemas.openxmlformats.org/drawingml/2006/main">
             <a:off x="4000500" y="2733675"/>
-            <a:ext cx="412750" cy="228600"/>
+            <a:ext cx="171450" cy="228600"/>
           </a:xfrm>
           <a:prstGeom xmlns:a="http://schemas.openxmlformats.org/drawingml/2006/main" prst="rect">
             <a:avLst/>
@@ -5186,7 +5136,7 @@
           <p:cNvPr id="14" name="">
             <a:extLst xmlns:a="http://schemas.openxmlformats.org/drawingml/2006/main">
               <a:ext uri="{FF2B5EF4-FFF2-40B4-BE49-F238E27FC236}">
-                <a16:creationId xmlns:a16="http://schemas.microsoft.com/office/drawing/2014/main" id="{156F3F77-A292-4090-9759-A1604CD83008}"/>
+                <a16:creationId xmlns:a16="http://schemas.microsoft.com/office/drawing/2014/main" id="{29A8FCA0-44E3-4E51-B7E4-F890ACF3EB5C}"/>
               </a:ext>
             </a:extLst>
           </p:cNvPr>
@@ -5226,7 +5176,7 @@
                   <a:srgbClr val="142F4C"/>
                 </a:solidFill>
               </a:rPr>
-              <a:t>1</a:t>
+              <a:t>0</a:t>
             </a:r>
           </a:p>
         </p:txBody>
@@ -5236,7 +5186,7 @@
           <p:cNvPr id="15" name="">
             <a:extLst xmlns:a="http://schemas.openxmlformats.org/drawingml/2006/main">
               <a:ext uri="{FF2B5EF4-FFF2-40B4-BE49-F238E27FC236}">
-                <a16:creationId xmlns:a16="http://schemas.microsoft.com/office/drawing/2014/main" id="{6AFEBCB1-E2E7-481A-8468-A08CBC31C9AA}"/>
+                <a16:creationId xmlns:a16="http://schemas.microsoft.com/office/drawing/2014/main" id="{D03A429A-C0F7-4A93-994E-928D86D5F55A}"/>
               </a:ext>
             </a:extLst>
           </p:cNvPr>
@@ -5276,7 +5226,7 @@
                   <a:srgbClr val="142F4C"/>
                 </a:solidFill>
               </a:rPr>
-              <a:t>Insufficient for conclusion</a:t>
+              <a:t>Further basis required</a:t>
             </a:r>
           </a:p>
         </p:txBody>
@@ -5286,7 +5236,7 @@
           <p:cNvPr id="16" name="">
             <a:extLst xmlns:a="http://schemas.openxmlformats.org/drawingml/2006/main">
               <a:ext uri="{FF2B5EF4-FFF2-40B4-BE49-F238E27FC236}">
-                <a16:creationId xmlns:a16="http://schemas.microsoft.com/office/drawing/2014/main" id="{9761A1A7-9D58-4055-B4AB-65BE3DF3661F}"/>
+                <a16:creationId xmlns:a16="http://schemas.microsoft.com/office/drawing/2014/main" id="{5AA82CB4-3023-4F55-9E87-E3E95ED1726E}"/>
               </a:ext>
             </a:extLst>
           </p:cNvPr>
@@ -5319,7 +5269,7 @@
           <p:cNvPr id="17" name="">
             <a:extLst xmlns:a="http://schemas.openxmlformats.org/drawingml/2006/main">
               <a:ext uri="{FF2B5EF4-FFF2-40B4-BE49-F238E27FC236}">
-                <a16:creationId xmlns:a16="http://schemas.microsoft.com/office/drawing/2014/main" id="{74C0EA3B-CF54-46DD-BD98-61B556EC1FF9}"/>
+                <a16:creationId xmlns:a16="http://schemas.microsoft.com/office/drawing/2014/main" id="{76C68314-29F8-48BC-9317-B82100C8EB7D}"/>
               </a:ext>
             </a:extLst>
           </p:cNvPr>
@@ -5331,7 +5281,7 @@
         <p:spPr>
           <a:xfrm xmlns:a="http://schemas.openxmlformats.org/drawingml/2006/main">
             <a:off x="4000500" y="3324225"/>
-            <a:ext cx="825500" cy="228600"/>
+            <a:ext cx="171450" cy="228600"/>
           </a:xfrm>
           <a:prstGeom xmlns:a="http://schemas.openxmlformats.org/drawingml/2006/main" prst="rect">
             <a:avLst/>
@@ -5352,7 +5302,7 @@
           <p:cNvPr id="18" name="">
             <a:extLst xmlns:a="http://schemas.openxmlformats.org/drawingml/2006/main">
               <a:ext uri="{FF2B5EF4-FFF2-40B4-BE49-F238E27FC236}">
-                <a16:creationId xmlns:a16="http://schemas.microsoft.com/office/drawing/2014/main" id="{12442A53-50C2-4E6D-8761-0A2B739E2961}"/>
+                <a16:creationId xmlns:a16="http://schemas.microsoft.com/office/drawing/2014/main" id="{7D453511-850B-447A-B86A-A7940D4493BA}"/>
               </a:ext>
             </a:extLst>
           </p:cNvPr>
@@ -5392,7 +5342,7 @@
                   <a:srgbClr val="142F4C"/>
                 </a:solidFill>
               </a:rPr>
-              <a:t>2</a:t>
+              <a:t>1</a:t>
             </a:r>
           </a:p>
         </p:txBody>
@@ -5402,7 +5352,7 @@
           <p:cNvPr id="19" name="">
             <a:extLst xmlns:a="http://schemas.openxmlformats.org/drawingml/2006/main">
               <a:ext uri="{FF2B5EF4-FFF2-40B4-BE49-F238E27FC236}">
-                <a16:creationId xmlns:a16="http://schemas.microsoft.com/office/drawing/2014/main" id="{559D670D-74BB-4450-934D-D6C7EF200865}"/>
+                <a16:creationId xmlns:a16="http://schemas.microsoft.com/office/drawing/2014/main" id="{5B9F2899-CD1D-4E07-B3B9-86A92DF5FFF5}"/>
               </a:ext>
             </a:extLst>
           </p:cNvPr>
@@ -5442,7 +5392,7 @@
                   <a:srgbClr val="142F4C"/>
                 </a:solidFill>
               </a:rPr>
-              <a:t>Self-reported / open</a:t>
+              <a:t>Recorded / open</a:t>
             </a:r>
           </a:p>
         </p:txBody>
@@ -5452,7 +5402,7 @@
           <p:cNvPr id="20" name="">
             <a:extLst xmlns:a="http://schemas.openxmlformats.org/drawingml/2006/main">
               <a:ext uri="{FF2B5EF4-FFF2-40B4-BE49-F238E27FC236}">
-                <a16:creationId xmlns:a16="http://schemas.microsoft.com/office/drawing/2014/main" id="{12B6847E-6E98-47E0-8B89-62157E9C3EBF}"/>
+                <a16:creationId xmlns:a16="http://schemas.microsoft.com/office/drawing/2014/main" id="{8C08062F-9464-4C08-8527-749B0376765B}"/>
               </a:ext>
             </a:extLst>
           </p:cNvPr>
@@ -5485,7 +5435,7 @@
           <p:cNvPr id="21" name="">
             <a:extLst xmlns:a="http://schemas.openxmlformats.org/drawingml/2006/main">
               <a:ext uri="{FF2B5EF4-FFF2-40B4-BE49-F238E27FC236}">
-                <a16:creationId xmlns:a16="http://schemas.microsoft.com/office/drawing/2014/main" id="{1669D5D4-0648-4EA7-94E5-9106AEC58861}"/>
+                <a16:creationId xmlns:a16="http://schemas.microsoft.com/office/drawing/2014/main" id="{CE143B89-54AE-4023-B6B9-9DCDAED58FBE}"/>
               </a:ext>
             </a:extLst>
           </p:cNvPr>
@@ -5497,7 +5447,7 @@
         <p:spPr>
           <a:xfrm xmlns:a="http://schemas.openxmlformats.org/drawingml/2006/main">
             <a:off x="4000500" y="3914775"/>
-            <a:ext cx="1651000" cy="228600"/>
+            <a:ext cx="4720828" cy="228600"/>
           </a:xfrm>
           <a:prstGeom xmlns:a="http://schemas.openxmlformats.org/drawingml/2006/main" prst="rect">
             <a:avLst/>
@@ -5518,7 +5468,7 @@
           <p:cNvPr id="22" name="">
             <a:extLst xmlns:a="http://schemas.openxmlformats.org/drawingml/2006/main">
               <a:ext uri="{FF2B5EF4-FFF2-40B4-BE49-F238E27FC236}">
-                <a16:creationId xmlns:a16="http://schemas.microsoft.com/office/drawing/2014/main" id="{8C9D9A08-723C-4790-8BA5-4FF409C3082C}"/>
+                <a16:creationId xmlns:a16="http://schemas.microsoft.com/office/drawing/2014/main" id="{821752F9-F9CD-4D74-9014-C3F7D5F1FF75}"/>
               </a:ext>
             </a:extLst>
           </p:cNvPr>
@@ -5558,7 +5508,7 @@
                   <a:srgbClr val="142F4C"/>
                 </a:solidFill>
               </a:rPr>
-              <a:t>4</a:t>
+              <a:t>61</a:t>
             </a:r>
           </a:p>
         </p:txBody>
@@ -5568,7 +5518,7 @@
           <p:cNvPr id="23" name="">
             <a:extLst xmlns:a="http://schemas.openxmlformats.org/drawingml/2006/main">
               <a:ext uri="{FF2B5EF4-FFF2-40B4-BE49-F238E27FC236}">
-                <a16:creationId xmlns:a16="http://schemas.microsoft.com/office/drawing/2014/main" id="{B1786E08-F1E2-4935-A0F7-A4A0374A6FD7}"/>
+                <a16:creationId xmlns:a16="http://schemas.microsoft.com/office/drawing/2014/main" id="{6027C477-FD4E-48FD-81D1-3BFDBD425506}"/>
               </a:ext>
             </a:extLst>
           </p:cNvPr>
@@ -5603,7 +5553,7 @@
           <p:cNvPr id="24" name="">
             <a:extLst xmlns:a="http://schemas.openxmlformats.org/drawingml/2006/main">
               <a:ext uri="{FF2B5EF4-FFF2-40B4-BE49-F238E27FC236}">
-                <a16:creationId xmlns:a16="http://schemas.microsoft.com/office/drawing/2014/main" id="{57EC7FFA-89E7-4AE0-ACA9-09D2FFB183B0}"/>
+                <a16:creationId xmlns:a16="http://schemas.microsoft.com/office/drawing/2014/main" id="{B877741B-2441-4B38-90E7-C28D4DA1AC6D}"/>
               </a:ext>
             </a:extLst>
           </p:cNvPr>
@@ -5653,7 +5603,7 @@
           <p:cNvPr id="25" name="">
             <a:extLst xmlns:a="http://schemas.openxmlformats.org/drawingml/2006/main">
               <a:ext uri="{FF2B5EF4-FFF2-40B4-BE49-F238E27FC236}">
-                <a16:creationId xmlns:a16="http://schemas.microsoft.com/office/drawing/2014/main" id="{7BA7E6C4-EE00-40E3-B6D2-53ACD3033345}"/>
+                <a16:creationId xmlns:a16="http://schemas.microsoft.com/office/drawing/2014/main" id="{9A3BDAE5-2DEC-4305-83C9-D67DC908774C}"/>
               </a:ext>
             </a:extLst>
           </p:cNvPr>
@@ -5693,7 +5643,7 @@
                   <a:srgbClr val="1A2634"/>
                 </a:solidFill>
               </a:rPr>
-              <a:t>Only the named evidence scope. “Insufficient” means the evidence did not establish a conclusion; it does not mean misconduct occurred.</a:t>
+              <a:t>Only the named information scope. An open item limits reliance; it does not mean misconduct occurred.</a:t>
             </a:r>
           </a:p>
         </p:txBody>
@@ -5701,7 +5651,7 @@
     </p:spTree>
     <p:extLst>
       <p:ext uri="{BB962C8B-B14F-4D97-AF65-F5344CB8AC3E}">
-        <p14:creationId xmlns:p14="http://schemas.microsoft.com/office/powerpoint/2010/main" val="124705682"/>
+        <p14:creationId xmlns:p14="http://schemas.microsoft.com/office/powerpoint/2010/main" val="461055899"/>
       </p:ext>
     </p:extLst>
   </p:cSld>
@@ -5732,7 +5682,7 @@
           <p:cNvPr id="23" name="">
             <a:extLst xmlns:a="http://schemas.openxmlformats.org/drawingml/2006/main">
               <a:ext uri="{FF2B5EF4-FFF2-40B4-BE49-F238E27FC236}">
-                <a16:creationId xmlns:a16="http://schemas.microsoft.com/office/drawing/2014/main" id="{AC4B91A0-254B-470B-85CB-54CAD0BB59AE}"/>
+                <a16:creationId xmlns:a16="http://schemas.microsoft.com/office/drawing/2014/main" id="{04F9E7D7-2914-4A80-81C9-CC077DAA2636}"/>
               </a:ext>
             </a:extLst>
           </p:cNvPr>
@@ -5782,7 +5732,7 @@
           <p:cNvPr id="2" name="">
             <a:extLst xmlns:a="http://schemas.openxmlformats.org/drawingml/2006/main">
               <a:ext uri="{FF2B5EF4-FFF2-40B4-BE49-F238E27FC236}">
-                <a16:creationId xmlns:a16="http://schemas.microsoft.com/office/drawing/2014/main" id="{491B29F8-8F63-4C87-8385-1A2A6E90C8CC}"/>
+                <a16:creationId xmlns:a16="http://schemas.microsoft.com/office/drawing/2014/main" id="{394D7A68-FCBE-4403-9F86-17DE27FCF980}"/>
               </a:ext>
             </a:extLst>
           </p:cNvPr>
@@ -5822,7 +5772,7 @@
                   <a:srgbClr val="142F4C"/>
                 </a:solidFill>
               </a:rPr>
-              <a:t>Human review adds judgement where the self-assessment is too broad.</a:t>
+              <a:t>Management review adds context where the assessment is too broad.</a:t>
             </a:r>
           </a:p>
         </p:txBody>
@@ -5832,7 +5782,7 @@
           <p:cNvPr id="3" name="">
             <a:extLst xmlns:a="http://schemas.openxmlformats.org/drawingml/2006/main">
               <a:ext uri="{FF2B5EF4-FFF2-40B4-BE49-F238E27FC236}">
-                <a16:creationId xmlns:a16="http://schemas.microsoft.com/office/drawing/2014/main" id="{432EA8C3-A01D-425B-8CF8-9A4A955F689B}"/>
+                <a16:creationId xmlns:a16="http://schemas.microsoft.com/office/drawing/2014/main" id="{1270EDDB-6062-4C07-B9B8-F22D6CFFF897}"/>
               </a:ext>
             </a:extLst>
           </p:cNvPr>
@@ -5872,7 +5822,7 @@
                   <a:srgbClr val="5A6B7C"/>
                 </a:solidFill>
               </a:rPr>
-              <a:t>The review narrows claims to the population and artefacts actually examined.</a:t>
+              <a:t>Review notes narrow the conversation to the population and records actually supplied.</a:t>
             </a:r>
           </a:p>
         </p:txBody>
@@ -5882,7 +5832,7 @@
           <p:cNvPr id="4" name="">
             <a:extLst xmlns:a="http://schemas.openxmlformats.org/drawingml/2006/main">
               <a:ext uri="{FF2B5EF4-FFF2-40B4-BE49-F238E27FC236}">
-                <a16:creationId xmlns:a16="http://schemas.microsoft.com/office/drawing/2014/main" id="{699D066C-6167-4CE8-BB67-B403D2A685FA}"/>
+                <a16:creationId xmlns:a16="http://schemas.microsoft.com/office/drawing/2014/main" id="{ADB34519-6185-4C4A-B53C-431DB3A80A2D}"/>
               </a:ext>
             </a:extLst>
           </p:cNvPr>
@@ -5913,7 +5863,7 @@
           <p:cNvPr id="5" name="">
             <a:extLst xmlns:a="http://schemas.openxmlformats.org/drawingml/2006/main">
               <a:ext uri="{FF2B5EF4-FFF2-40B4-BE49-F238E27FC236}">
-                <a16:creationId xmlns:a16="http://schemas.microsoft.com/office/drawing/2014/main" id="{152AF78F-F1BE-434F-8A26-0EF3FA903857}"/>
+                <a16:creationId xmlns:a16="http://schemas.microsoft.com/office/drawing/2014/main" id="{84ABD712-D8E1-4F48-A193-CC7FD571531D}"/>
               </a:ext>
             </a:extLst>
           </p:cNvPr>
@@ -5963,7 +5913,7 @@
           <p:cNvPr id="6" name="">
             <a:extLst xmlns:a="http://schemas.openxmlformats.org/drawingml/2006/main">
               <a:ext uri="{FF2B5EF4-FFF2-40B4-BE49-F238E27FC236}">
-                <a16:creationId xmlns:a16="http://schemas.microsoft.com/office/drawing/2014/main" id="{0166AAE6-C063-4924-BD79-F420C9CB0B5A}"/>
+                <a16:creationId xmlns:a16="http://schemas.microsoft.com/office/drawing/2014/main" id="{6739AD5D-EA2B-42A5-A0B6-F32A6D652DB9}"/>
               </a:ext>
             </a:extLst>
           </p:cNvPr>
@@ -6013,7 +5963,7 @@
           <p:cNvPr id="7" name="">
             <a:extLst xmlns:a="http://schemas.openxmlformats.org/drawingml/2006/main">
               <a:ext uri="{FF2B5EF4-FFF2-40B4-BE49-F238E27FC236}">
-                <a16:creationId xmlns:a16="http://schemas.microsoft.com/office/drawing/2014/main" id="{97ECAC77-23C8-48BD-BAA8-174E9F4B07C5}"/>
+                <a16:creationId xmlns:a16="http://schemas.microsoft.com/office/drawing/2014/main" id="{5D3516BC-0275-4C81-B1FF-B8B6D28BD8DC}"/>
               </a:ext>
             </a:extLst>
           </p:cNvPr>
@@ -6046,7 +5996,7 @@
           <p:cNvPr id="8" name="">
             <a:extLst xmlns:a="http://schemas.openxmlformats.org/drawingml/2006/main">
               <a:ext uri="{FF2B5EF4-FFF2-40B4-BE49-F238E27FC236}">
-                <a16:creationId xmlns:a16="http://schemas.microsoft.com/office/drawing/2014/main" id="{EEFDDF4B-A98E-490E-8C8D-2E497BC4527E}"/>
+                <a16:creationId xmlns:a16="http://schemas.microsoft.com/office/drawing/2014/main" id="{5A324ED2-1466-433C-B925-C19EF20CEA71}"/>
               </a:ext>
             </a:extLst>
           </p:cNvPr>
@@ -6086,7 +6036,7 @@
                   <a:srgbClr val="142F4C"/>
                 </a:solidFill>
               </a:rPr>
-              <a:t>Awareness completion is not reconciled to higher-risk roles</a:t>
+              <a:t>control design</a:t>
             </a:r>
           </a:p>
         </p:txBody>
@@ -6096,7 +6046,7 @@
           <p:cNvPr id="9" name="">
             <a:extLst xmlns:a="http://schemas.openxmlformats.org/drawingml/2006/main">
               <a:ext uri="{FF2B5EF4-FFF2-40B4-BE49-F238E27FC236}">
-                <a16:creationId xmlns:a16="http://schemas.microsoft.com/office/drawing/2014/main" id="{C7896C2E-AF97-41BB-BC85-60182B1E1480}"/>
+                <a16:creationId xmlns:a16="http://schemas.microsoft.com/office/drawing/2014/main" id="{EA014FE8-5BEA-4EDC-9E51-FEE7D5B4E68F}"/>
               </a:ext>
             </a:extLst>
           </p:cNvPr>
@@ -6136,7 +6086,7 @@
                   <a:srgbClr val="5A6B7C"/>
                 </a:solidFill>
               </a:rPr>
-              <a:t>Recorded: Self-reported position: Exists only informally or inconsistently</a:t>
+              <a:t>Recorded: Self-reported position retained unless separately evidenced.</a:t>
             </a:r>
           </a:p>
         </p:txBody>
@@ -6146,7 +6096,7 @@
           <p:cNvPr id="10" name="">
             <a:extLst xmlns:a="http://schemas.openxmlformats.org/drawingml/2006/main">
               <a:ext uri="{FF2B5EF4-FFF2-40B4-BE49-F238E27FC236}">
-                <a16:creationId xmlns:a16="http://schemas.microsoft.com/office/drawing/2014/main" id="{ADBA07A3-B89D-4728-ACC3-5659D4458644}"/>
+                <a16:creationId xmlns:a16="http://schemas.microsoft.com/office/drawing/2014/main" id="{8F91DC7D-3BE3-49AC-BB21-75467CE4C5E9}"/>
               </a:ext>
             </a:extLst>
           </p:cNvPr>
@@ -6174,19 +6124,19 @@
           <a:lstStyle xmlns:a="http://schemas.openxmlformats.org/drawingml/2006/main"/>
           <a:p xmlns:a="http://schemas.openxmlformats.org/drawingml/2006/main">
             <a:pPr>
-              <a:defRPr sz="1200">
+              <a:defRPr sz="1125">
                 <a:solidFill>
                   <a:srgbClr val="1A2634"/>
                 </a:solidFill>
               </a:defRPr>
             </a:pPr>
             <a:r>
-              <a:rPr sz="1200">
+              <a:rPr sz="1125">
                 <a:solidFill>
                   <a:srgbClr val="1A2634"/>
                 </a:solidFill>
               </a:rPr>
-              <a:t>Reviewer view: Retain the deterministic issue while keeping assurance bounded.</a:t>
+              <a:t>Review note: Design weakness: the control has no specification. Without red-flag definitions per process, monitoring frequency, population scope and an exception-handling route, two competent…</a:t>
             </a:r>
           </a:p>
         </p:txBody>
@@ -6196,7 +6146,7 @@
           <p:cNvPr id="11" name="">
             <a:extLst xmlns:a="http://schemas.openxmlformats.org/drawingml/2006/main">
               <a:ext uri="{FF2B5EF4-FFF2-40B4-BE49-F238E27FC236}">
-                <a16:creationId xmlns:a16="http://schemas.microsoft.com/office/drawing/2014/main" id="{D34672D0-77EE-4F61-8EC9-75C6DE378343}"/>
+                <a16:creationId xmlns:a16="http://schemas.microsoft.com/office/drawing/2014/main" id="{65D81EE8-DC2B-4A7B-AC7A-999F8F00AF60}"/>
               </a:ext>
             </a:extLst>
           </p:cNvPr>
@@ -6229,7 +6179,7 @@
           <p:cNvPr id="12" name="">
             <a:extLst xmlns:a="http://schemas.openxmlformats.org/drawingml/2006/main">
               <a:ext uri="{FF2B5EF4-FFF2-40B4-BE49-F238E27FC236}">
-                <a16:creationId xmlns:a16="http://schemas.microsoft.com/office/drawing/2014/main" id="{82689EA5-76C3-40BF-BCF0-98F9D20C4C10}"/>
+                <a16:creationId xmlns:a16="http://schemas.microsoft.com/office/drawing/2014/main" id="{09801302-E456-4E35-96B8-653401049A14}"/>
               </a:ext>
             </a:extLst>
           </p:cNvPr>
@@ -6269,7 +6219,7 @@
                   <a:srgbClr val="142F4C"/>
                 </a:solidFill>
               </a:rPr>
-              <a:t>Committee oversight does not yet evidence a complete fraud-risk cycle</a:t>
+              <a:t>decision</a:t>
             </a:r>
           </a:p>
         </p:txBody>
@@ -6279,7 +6229,7 @@
           <p:cNvPr id="13" name="">
             <a:extLst xmlns:a="http://schemas.openxmlformats.org/drawingml/2006/main">
               <a:ext uri="{FF2B5EF4-FFF2-40B4-BE49-F238E27FC236}">
-                <a16:creationId xmlns:a16="http://schemas.microsoft.com/office/drawing/2014/main" id="{DB30BE57-5857-4FAA-93D9-5B705BFC8C9B}"/>
+                <a16:creationId xmlns:a16="http://schemas.microsoft.com/office/drawing/2014/main" id="{5B9DAFF2-4503-40CD-9FC6-BE0033E6D4CB}"/>
               </a:ext>
             </a:extLst>
           </p:cNvPr>
@@ -6319,7 +6269,7 @@
                   <a:srgbClr val="5A6B7C"/>
                 </a:solidFill>
               </a:rPr>
-              <a:t>Recorded: Self-reported position: No control exists</a:t>
+              <a:t>Recorded: Self-reported position retained unless separately evidenced.</a:t>
             </a:r>
           </a:p>
         </p:txBody>
@@ -6329,7 +6279,7 @@
           <p:cNvPr id="14" name="">
             <a:extLst xmlns:a="http://schemas.openxmlformats.org/drawingml/2006/main">
               <a:ext uri="{FF2B5EF4-FFF2-40B4-BE49-F238E27FC236}">
-                <a16:creationId xmlns:a16="http://schemas.microsoft.com/office/drawing/2014/main" id="{6D894032-4B76-460C-9B52-067DE4FFE199}"/>
+                <a16:creationId xmlns:a16="http://schemas.microsoft.com/office/drawing/2014/main" id="{1B6B4187-1B3A-4239-A73B-5E8FF85196AB}"/>
               </a:ext>
             </a:extLst>
           </p:cNvPr>
@@ -6357,19 +6307,19 @@
           <a:lstStyle xmlns:a="http://schemas.openxmlformats.org/drawingml/2006/main"/>
           <a:p xmlns:a="http://schemas.openxmlformats.org/drawingml/2006/main">
             <a:pPr>
-              <a:defRPr sz="1200">
+              <a:defRPr sz="1125">
                 <a:solidFill>
                   <a:srgbClr val="1A2634"/>
                 </a:solidFill>
               </a:defRPr>
             </a:pPr>
             <a:r>
-              <a:rPr sz="1200">
+              <a:rPr sz="1125">
                 <a:solidFill>
                   <a:srgbClr val="1A2634"/>
                 </a:solidFill>
               </a:rPr>
-              <a:t>Reviewer view: Retain the conclusion for the reviewed scope only.</a:t>
+              <a:t>Review note: Viable options considered. Option A - leave accountability with the Finance Director as the policy currently states. Trade-off: preserves the approved policy…</a:t>
             </a:r>
           </a:p>
         </p:txBody>
@@ -6379,7 +6329,7 @@
           <p:cNvPr id="15" name="">
             <a:extLst xmlns:a="http://schemas.openxmlformats.org/drawingml/2006/main">
               <a:ext uri="{FF2B5EF4-FFF2-40B4-BE49-F238E27FC236}">
-                <a16:creationId xmlns:a16="http://schemas.microsoft.com/office/drawing/2014/main" id="{B8C3D078-5504-4B30-96F4-BC6261676757}"/>
+                <a16:creationId xmlns:a16="http://schemas.microsoft.com/office/drawing/2014/main" id="{F1526F73-B0C6-423B-BD34-8E2D75D0575C}"/>
               </a:ext>
             </a:extLst>
           </p:cNvPr>
@@ -6412,7 +6362,7 @@
           <p:cNvPr id="16" name="">
             <a:extLst xmlns:a="http://schemas.openxmlformats.org/drawingml/2006/main">
               <a:ext uri="{FF2B5EF4-FFF2-40B4-BE49-F238E27FC236}">
-                <a16:creationId xmlns:a16="http://schemas.microsoft.com/office/drawing/2014/main" id="{1B9AE348-A1DC-466B-99D5-D49BA5F15C1E}"/>
+                <a16:creationId xmlns:a16="http://schemas.microsoft.com/office/drawing/2014/main" id="{427DB87D-E27B-4479-A6D7-12061F706E91}"/>
               </a:ext>
             </a:extLst>
           </p:cNvPr>
@@ -6452,7 +6402,7 @@
                   <a:srgbClr val="142F4C"/>
                 </a:solidFill>
               </a:rPr>
-              <a:t>Detection tuning and alert ageing need a fixed management rhythm</a:t>
+              <a:t>finding</a:t>
             </a:r>
           </a:p>
         </p:txBody>
@@ -6462,7 +6412,7 @@
           <p:cNvPr id="17" name="">
             <a:extLst xmlns:a="http://schemas.openxmlformats.org/drawingml/2006/main">
               <a:ext uri="{FF2B5EF4-FFF2-40B4-BE49-F238E27FC236}">
-                <a16:creationId xmlns:a16="http://schemas.microsoft.com/office/drawing/2014/main" id="{F2263CCD-2560-470E-A844-EEDBABC52104}"/>
+                <a16:creationId xmlns:a16="http://schemas.microsoft.com/office/drawing/2014/main" id="{0DB204FE-D831-49C0-A145-3343DC4299BF}"/>
               </a:ext>
             </a:extLst>
           </p:cNvPr>
@@ -6502,7 +6452,7 @@
                   <a:srgbClr val="5A6B7C"/>
                 </a:solidFill>
               </a:rPr>
-              <a:t>Recorded: Self-reported position: No control exists</a:t>
+              <a:t>Recorded: Self-reported position retained unless separately evidenced.</a:t>
             </a:r>
           </a:p>
         </p:txBody>
@@ -6512,7 +6462,7 @@
           <p:cNvPr id="18" name="">
             <a:extLst xmlns:a="http://schemas.openxmlformats.org/drawingml/2006/main">
               <a:ext uri="{FF2B5EF4-FFF2-40B4-BE49-F238E27FC236}">
-                <a16:creationId xmlns:a16="http://schemas.microsoft.com/office/drawing/2014/main" id="{793DD82E-3916-457F-8DD7-FB334D1067C5}"/>
+                <a16:creationId xmlns:a16="http://schemas.microsoft.com/office/drawing/2014/main" id="{C4937E1B-F6C1-4362-AD0C-2B66FC321A56}"/>
               </a:ext>
             </a:extLst>
           </p:cNvPr>
@@ -6540,19 +6490,19 @@
           <a:lstStyle xmlns:a="http://schemas.openxmlformats.org/drawingml/2006/main"/>
           <a:p xmlns:a="http://schemas.openxmlformats.org/drawingml/2006/main">
             <a:pPr>
-              <a:defRPr sz="1200">
+              <a:defRPr sz="1125">
                 <a:solidFill>
                   <a:srgbClr val="1A2634"/>
                 </a:solidFill>
               </a:defRPr>
             </a:pPr>
             <a:r>
-              <a:rPr sz="1200">
+              <a:rPr sz="1125">
                 <a:solidFill>
                   <a:srgbClr val="1A2634"/>
                 </a:solidFill>
               </a:rPr>
-              <a:t>Reviewer view: Retain the deterministic issue while keeping assurance bounded.</a:t>
+              <a:t>Review note: Partially supported, and materially weaker than the self-assessed position. Kestrel asserts transaction and operational monitoring for unusual patterns. The evidence establishes that…</a:t>
             </a:r>
           </a:p>
         </p:txBody>
@@ -6562,7 +6512,7 @@
           <p:cNvPr id="19" name="">
             <a:extLst xmlns:a="http://schemas.openxmlformats.org/drawingml/2006/main">
               <a:ext uri="{FF2B5EF4-FFF2-40B4-BE49-F238E27FC236}">
-                <a16:creationId xmlns:a16="http://schemas.microsoft.com/office/drawing/2014/main" id="{FB69F127-C3E5-4CD0-A97A-A27BDAFB14F0}"/>
+                <a16:creationId xmlns:a16="http://schemas.microsoft.com/office/drawing/2014/main" id="{B964C89E-B7CD-4126-B555-47ADAE794851}"/>
               </a:ext>
             </a:extLst>
           </p:cNvPr>
@@ -6595,7 +6545,7 @@
           <p:cNvPr id="20" name="">
             <a:extLst xmlns:a="http://schemas.openxmlformats.org/drawingml/2006/main">
               <a:ext uri="{FF2B5EF4-FFF2-40B4-BE49-F238E27FC236}">
-                <a16:creationId xmlns:a16="http://schemas.microsoft.com/office/drawing/2014/main" id="{6B0B79B2-54F5-4885-BDAD-965C461A75FF}"/>
+                <a16:creationId xmlns:a16="http://schemas.microsoft.com/office/drawing/2014/main" id="{2E5715CD-C428-4C16-BCE3-EC0EB8F99184}"/>
               </a:ext>
             </a:extLst>
           </p:cNvPr>
@@ -6635,7 +6585,7 @@
                   <a:srgbClr val="142F4C"/>
                 </a:solidFill>
               </a:rPr>
-              <a:t>Evidence review: Approved fraud risk management policy and committee terms</a:t>
+              <a:t>Fraud Detection Capability: The organisation monitors transactions or operational activity for unusual patterns, anomalies or red flags.</a:t>
             </a:r>
           </a:p>
         </p:txBody>
@@ -6645,7 +6595,7 @@
           <p:cNvPr id="21" name="">
             <a:extLst xmlns:a="http://schemas.openxmlformats.org/drawingml/2006/main">
               <a:ext uri="{FF2B5EF4-FFF2-40B4-BE49-F238E27FC236}">
-                <a16:creationId xmlns:a16="http://schemas.microsoft.com/office/drawing/2014/main" id="{F81AC1AB-2784-43DB-B15B-0B0A025841B7}"/>
+                <a16:creationId xmlns:a16="http://schemas.microsoft.com/office/drawing/2014/main" id="{E656196C-905B-4F4B-A8A7-C95C86D0BBF9}"/>
               </a:ext>
             </a:extLst>
           </p:cNvPr>
@@ -6685,7 +6635,7 @@
                   <a:srgbClr val="5A6B7C"/>
                 </a:solidFill>
               </a:rPr>
-              <a:t>Recorded: Self-reported position retained unless separately evidenced.</a:t>
+              <a:t>Recorded: Self-reported position: Partially designed — Some elements exist, but implementation is incomplete, inconsistent or not evidenced.</a:t>
             </a:r>
           </a:p>
         </p:txBody>
@@ -6695,7 +6645,7 @@
           <p:cNvPr id="22" name="">
             <a:extLst xmlns:a="http://schemas.openxmlformats.org/drawingml/2006/main">
               <a:ext uri="{FF2B5EF4-FFF2-40B4-BE49-F238E27FC236}">
-                <a16:creationId xmlns:a16="http://schemas.microsoft.com/office/drawing/2014/main" id="{04FABD61-AE5A-432C-B9C7-3712C2D42C69}"/>
+                <a16:creationId xmlns:a16="http://schemas.microsoft.com/office/drawing/2014/main" id="{4FE61DAD-16A2-46EE-86C4-D386D91CD2C1}"/>
               </a:ext>
             </a:extLst>
           </p:cNvPr>
@@ -6723,19 +6673,19 @@
           <a:lstStyle xmlns:a="http://schemas.openxmlformats.org/drawingml/2006/main"/>
           <a:p xmlns:a="http://schemas.openxmlformats.org/drawingml/2006/main">
             <a:pPr>
-              <a:defRPr sz="1200">
+              <a:defRPr sz="1125">
                 <a:solidFill>
                   <a:srgbClr val="1A2634"/>
                 </a:solidFill>
               </a:defRPr>
             </a:pPr>
             <a:r>
-              <a:rPr sz="1200">
+              <a:rPr sz="1125">
                 <a:solidFill>
                   <a:srgbClr val="1A2634"/>
                 </a:solidFill>
               </a:rPr>
-              <a:t>Reviewer view: The reviewed artefact supports the stated scope.</a:t>
+              <a:t>Review note: The supplied information does not establish an unqualified conclusion for the recorded scope.</a:t>
             </a:r>
           </a:p>
         </p:txBody>
@@ -6743,7 +6693,7 @@
     </p:spTree>
     <p:extLst>
       <p:ext uri="{BB962C8B-B14F-4D97-AF65-F5344CB8AC3E}">
-        <p14:creationId xmlns:p14="http://schemas.microsoft.com/office/powerpoint/2010/main" val="1702326953"/>
+        <p14:creationId xmlns:p14="http://schemas.microsoft.com/office/powerpoint/2010/main" val="445794860"/>
       </p:ext>
     </p:extLst>
   </p:cSld>
@@ -6774,7 +6724,7 @@
           <p:cNvPr id="32" name="">
             <a:extLst xmlns:a="http://schemas.openxmlformats.org/drawingml/2006/main">
               <a:ext uri="{FF2B5EF4-FFF2-40B4-BE49-F238E27FC236}">
-                <a16:creationId xmlns:a16="http://schemas.microsoft.com/office/drawing/2014/main" id="{20820C72-0B6A-4852-ACE5-0793EAB2CBD3}"/>
+                <a16:creationId xmlns:a16="http://schemas.microsoft.com/office/drawing/2014/main" id="{8E25FE16-8A15-410E-9BE0-143AFB22F473}"/>
               </a:ext>
             </a:extLst>
           </p:cNvPr>
@@ -6824,7 +6774,7 @@
           <p:cNvPr id="2" name="">
             <a:extLst xmlns:a="http://schemas.openxmlformats.org/drawingml/2006/main">
               <a:ext uri="{FF2B5EF4-FFF2-40B4-BE49-F238E27FC236}">
-                <a16:creationId xmlns:a16="http://schemas.microsoft.com/office/drawing/2014/main" id="{5F0ED855-B3FA-4CB9-ABDB-C1D642EB3F5D}"/>
+                <a16:creationId xmlns:a16="http://schemas.microsoft.com/office/drawing/2014/main" id="{9A2B0077-C379-4C83-AC18-CB196310ED0C}"/>
               </a:ext>
             </a:extLst>
           </p:cNvPr>
@@ -6874,7 +6824,7 @@
           <p:cNvPr id="3" name="">
             <a:extLst xmlns:a="http://schemas.openxmlformats.org/drawingml/2006/main">
               <a:ext uri="{FF2B5EF4-FFF2-40B4-BE49-F238E27FC236}">
-                <a16:creationId xmlns:a16="http://schemas.microsoft.com/office/drawing/2014/main" id="{671275F3-F78A-482B-9E62-F7E56D031FFE}"/>
+                <a16:creationId xmlns:a16="http://schemas.microsoft.com/office/drawing/2014/main" id="{DB7628B8-05AA-4C28-8B07-08DFA437AA9B}"/>
               </a:ext>
             </a:extLst>
           </p:cNvPr>
@@ -6924,7 +6874,7 @@
           <p:cNvPr id="4" name="">
             <a:extLst xmlns:a="http://schemas.openxmlformats.org/drawingml/2006/main">
               <a:ext uri="{FF2B5EF4-FFF2-40B4-BE49-F238E27FC236}">
-                <a16:creationId xmlns:a16="http://schemas.microsoft.com/office/drawing/2014/main" id="{CC573C39-5C66-4391-B7C3-8830400C344B}"/>
+                <a16:creationId xmlns:a16="http://schemas.microsoft.com/office/drawing/2014/main" id="{11BCBA76-E98E-403E-AB9B-7ABAB3B07D51}"/>
               </a:ext>
             </a:extLst>
           </p:cNvPr>
@@ -6955,7 +6905,7 @@
           <p:cNvPr id="5" name="">
             <a:extLst xmlns:a="http://schemas.openxmlformats.org/drawingml/2006/main">
               <a:ext uri="{FF2B5EF4-FFF2-40B4-BE49-F238E27FC236}">
-                <a16:creationId xmlns:a16="http://schemas.microsoft.com/office/drawing/2014/main" id="{2BC89845-A97A-4366-8397-C4752F83A526}"/>
+                <a16:creationId xmlns:a16="http://schemas.microsoft.com/office/drawing/2014/main" id="{2472AF65-0B12-4A4A-A0FC-B01C06C2D468}"/>
               </a:ext>
             </a:extLst>
           </p:cNvPr>
@@ -7005,7 +6955,7 @@
           <p:cNvPr id="6" name="">
             <a:extLst xmlns:a="http://schemas.openxmlformats.org/drawingml/2006/main">
               <a:ext uri="{FF2B5EF4-FFF2-40B4-BE49-F238E27FC236}">
-                <a16:creationId xmlns:a16="http://schemas.microsoft.com/office/drawing/2014/main" id="{594B0574-1473-4717-B1F9-FA1285320D53}"/>
+                <a16:creationId xmlns:a16="http://schemas.microsoft.com/office/drawing/2014/main" id="{4F7725BC-47B9-42EF-88D5-D7406A6DB844}"/>
               </a:ext>
             </a:extLst>
           </p:cNvPr>
@@ -7055,7 +7005,7 @@
           <p:cNvPr id="7" name="">
             <a:extLst xmlns:a="http://schemas.openxmlformats.org/drawingml/2006/main">
               <a:ext uri="{FF2B5EF4-FFF2-40B4-BE49-F238E27FC236}">
-                <a16:creationId xmlns:a16="http://schemas.microsoft.com/office/drawing/2014/main" id="{0865804D-FAE5-4D73-802C-148B4B75CE45}"/>
+                <a16:creationId xmlns:a16="http://schemas.microsoft.com/office/drawing/2014/main" id="{5D758043-37CB-45C5-89DB-B91E4AD14F4B}"/>
               </a:ext>
             </a:extLst>
           </p:cNvPr>
@@ -7095,7 +7045,7 @@
                   <a:srgbClr val="142F4C"/>
                 </a:solidFill>
               </a:rPr>
-              <a:t>A supplier bank change may redirect a legitimate payment</a:t>
+              <a:t>Unauthorised system access enables transaction or record manipulation</a:t>
             </a:r>
           </a:p>
         </p:txBody>
@@ -7105,7 +7055,7 @@
           <p:cNvPr id="8" name="">
             <a:extLst xmlns:a="http://schemas.openxmlformats.org/drawingml/2006/main">
               <a:ext uri="{FF2B5EF4-FFF2-40B4-BE49-F238E27FC236}">
-                <a16:creationId xmlns:a16="http://schemas.microsoft.com/office/drawing/2014/main" id="{C5C56F36-EFCD-4965-A400-2ABEF2936018}"/>
+                <a16:creationId xmlns:a16="http://schemas.microsoft.com/office/drawing/2014/main" id="{52589CE1-BEEB-4973-9C26-229D31A0A8E7}"/>
               </a:ext>
             </a:extLst>
           </p:cNvPr>
@@ -7138,7 +7088,7 @@
           <p:cNvPr id="9" name="">
             <a:extLst xmlns:a="http://schemas.openxmlformats.org/drawingml/2006/main">
               <a:ext uri="{FF2B5EF4-FFF2-40B4-BE49-F238E27FC236}">
-                <a16:creationId xmlns:a16="http://schemas.microsoft.com/office/drawing/2014/main" id="{D8F9769F-99DD-4A63-B92E-4E025B378CC0}"/>
+                <a16:creationId xmlns:a16="http://schemas.microsoft.com/office/drawing/2014/main" id="{2E906821-18AA-4888-BCD8-C75C20CFAE4A}"/>
               </a:ext>
             </a:extLst>
           </p:cNvPr>
@@ -7171,7 +7121,7 @@
           <p:cNvPr id="10" name="">
             <a:extLst xmlns:a="http://schemas.openxmlformats.org/drawingml/2006/main">
               <a:ext uri="{FF2B5EF4-FFF2-40B4-BE49-F238E27FC236}">
-                <a16:creationId xmlns:a16="http://schemas.microsoft.com/office/drawing/2014/main" id="{B4147DA6-0B29-41C2-A280-83BF023BA833}"/>
+                <a16:creationId xmlns:a16="http://schemas.microsoft.com/office/drawing/2014/main" id="{5E953E44-C413-4CD0-9862-7DC505F52B98}"/>
               </a:ext>
             </a:extLst>
           </p:cNvPr>
@@ -7221,7 +7171,7 @@
           <p:cNvPr id="11" name="">
             <a:extLst xmlns:a="http://schemas.openxmlformats.org/drawingml/2006/main">
               <a:ext uri="{FF2B5EF4-FFF2-40B4-BE49-F238E27FC236}">
-                <a16:creationId xmlns:a16="http://schemas.microsoft.com/office/drawing/2014/main" id="{5D254F37-4721-47F6-A3F1-B90BC3717A0F}"/>
+                <a16:creationId xmlns:a16="http://schemas.microsoft.com/office/drawing/2014/main" id="{63462F32-647B-424A-9DB9-167C268560E5}"/>
               </a:ext>
             </a:extLst>
           </p:cNvPr>
@@ -7249,19 +7199,19 @@
           <a:lstStyle xmlns:a="http://schemas.openxmlformats.org/drawingml/2006/main"/>
           <a:p xmlns:a="http://schemas.openxmlformats.org/drawingml/2006/main">
             <a:pPr>
-              <a:defRPr sz="1050">
+              <a:defRPr sz="975">
                 <a:solidFill>
                   <a:srgbClr val="5A6B7C"/>
                 </a:solidFill>
               </a:defRPr>
             </a:pPr>
             <a:r>
-              <a:rPr sz="1050">
+              <a:rPr sz="975">
                 <a:solidFill>
                   <a:srgbClr val="5A6B7C"/>
                 </a:solidFill>
               </a:rPr>
-              <a:t>Implement a complete role-based access review.</a:t>
+              <a:t>Unauthorised system access enables transaction or record manipulation. IT…</a:t>
             </a:r>
           </a:p>
         </p:txBody>
@@ -7271,7 +7221,7 @@
           <p:cNvPr id="12" name="">
             <a:extLst xmlns:a="http://schemas.openxmlformats.org/drawingml/2006/main">
               <a:ext uri="{FF2B5EF4-FFF2-40B4-BE49-F238E27FC236}">
-                <a16:creationId xmlns:a16="http://schemas.microsoft.com/office/drawing/2014/main" id="{67BA5233-9FFC-49A1-BAFD-C768F502C32C}"/>
+                <a16:creationId xmlns:a16="http://schemas.microsoft.com/office/drawing/2014/main" id="{B686102E-4F64-4E75-87B4-E81C5785DA41}"/>
               </a:ext>
             </a:extLst>
           </p:cNvPr>
@@ -7311,7 +7261,7 @@
                   <a:srgbClr val="142F4C"/>
                 </a:solidFill>
               </a:rPr>
-              <a:t>Privileged access may enable unauthorised record changes</a:t>
+              <a:t>Fraud Detection Capability control effectiveness risk</a:t>
             </a:r>
           </a:p>
         </p:txBody>
@@ -7321,7 +7271,7 @@
           <p:cNvPr id="13" name="">
             <a:extLst xmlns:a="http://schemas.openxmlformats.org/drawingml/2006/main">
               <a:ext uri="{FF2B5EF4-FFF2-40B4-BE49-F238E27FC236}">
-                <a16:creationId xmlns:a16="http://schemas.microsoft.com/office/drawing/2014/main" id="{9369D5BA-7107-43B9-AFC5-694E4CA5A121}"/>
+                <a16:creationId xmlns:a16="http://schemas.microsoft.com/office/drawing/2014/main" id="{6CC319DD-DC1E-4028-9526-C003FC76C2F6}"/>
               </a:ext>
             </a:extLst>
           </p:cNvPr>
@@ -7354,7 +7304,7 @@
           <p:cNvPr id="14" name="">
             <a:extLst xmlns:a="http://schemas.openxmlformats.org/drawingml/2006/main">
               <a:ext uri="{FF2B5EF4-FFF2-40B4-BE49-F238E27FC236}">
-                <a16:creationId xmlns:a16="http://schemas.microsoft.com/office/drawing/2014/main" id="{ADD55166-0FF2-488E-A59A-F72484BE8391}"/>
+                <a16:creationId xmlns:a16="http://schemas.microsoft.com/office/drawing/2014/main" id="{ED3AF546-6F2C-452C-BF7D-228B272BB3D8}"/>
               </a:ext>
             </a:extLst>
           </p:cNvPr>
@@ -7387,7 +7337,7 @@
           <p:cNvPr id="15" name="">
             <a:extLst xmlns:a="http://schemas.openxmlformats.org/drawingml/2006/main">
               <a:ext uri="{FF2B5EF4-FFF2-40B4-BE49-F238E27FC236}">
-                <a16:creationId xmlns:a16="http://schemas.microsoft.com/office/drawing/2014/main" id="{8F3AABE6-8E94-4A7E-B017-3D558F12C868}"/>
+                <a16:creationId xmlns:a16="http://schemas.microsoft.com/office/drawing/2014/main" id="{7FF18383-8B70-4127-8EAE-96EE572C53E7}"/>
               </a:ext>
             </a:extLst>
           </p:cNvPr>
@@ -7437,7 +7387,7 @@
           <p:cNvPr id="16" name="">
             <a:extLst xmlns:a="http://schemas.openxmlformats.org/drawingml/2006/main">
               <a:ext uri="{FF2B5EF4-FFF2-40B4-BE49-F238E27FC236}">
-                <a16:creationId xmlns:a16="http://schemas.microsoft.com/office/drawing/2014/main" id="{F653CEF8-55EC-4AC0-9E87-BC76CF18A343}"/>
+                <a16:creationId xmlns:a16="http://schemas.microsoft.com/office/drawing/2014/main" id="{41C64CA4-7F68-4D10-8B79-F58984A67280}"/>
               </a:ext>
             </a:extLst>
           </p:cNvPr>
@@ -7465,19 +7415,19 @@
           <a:lstStyle xmlns:a="http://schemas.openxmlformats.org/drawingml/2006/main"/>
           <a:p xmlns:a="http://schemas.openxmlformats.org/drawingml/2006/main">
             <a:pPr>
-              <a:defRPr sz="1050">
+              <a:defRPr sz="975">
                 <a:solidFill>
                   <a:srgbClr val="5A6B7C"/>
                 </a:solidFill>
               </a:defRPr>
             </a:pPr>
             <a:r>
-              <a:rPr sz="1050">
+              <a:rPr sz="975">
                 <a:solidFill>
                   <a:srgbClr val="5A6B7C"/>
                 </a:solidFill>
               </a:rPr>
-              <a:t>Implement a complete role-based access review.</a:t>
+              <a:t>Fraud Detection Capability control effectiveness risk. The monitoring owner…</a:t>
             </a:r>
           </a:p>
         </p:txBody>
@@ -7487,7 +7437,7 @@
           <p:cNvPr id="17" name="">
             <a:extLst xmlns:a="http://schemas.openxmlformats.org/drawingml/2006/main">
               <a:ext uri="{FF2B5EF4-FFF2-40B4-BE49-F238E27FC236}">
-                <a16:creationId xmlns:a16="http://schemas.microsoft.com/office/drawing/2014/main" id="{ABC8374A-002D-4094-BD13-940ACC8515F9}"/>
+                <a16:creationId xmlns:a16="http://schemas.microsoft.com/office/drawing/2014/main" id="{3DE95C71-143E-45C0-9E47-4A6298D88CAA}"/>
               </a:ext>
             </a:extLst>
           </p:cNvPr>
@@ -7527,7 +7477,7 @@
                   <a:srgbClr val="142F4C"/>
                 </a:solidFill>
               </a:rPr>
-              <a:t>Fraud-risk decisions may remain unchallenged</a:t>
+              <a:t>Continuous Improvement and Fraud Risk Monitoring control effectiveness risk</a:t>
             </a:r>
           </a:p>
         </p:txBody>
@@ -7537,7 +7487,7 @@
           <p:cNvPr id="18" name="">
             <a:extLst xmlns:a="http://schemas.openxmlformats.org/drawingml/2006/main">
               <a:ext uri="{FF2B5EF4-FFF2-40B4-BE49-F238E27FC236}">
-                <a16:creationId xmlns:a16="http://schemas.microsoft.com/office/drawing/2014/main" id="{982013CD-BBB8-4267-A858-82F783710F50}"/>
+                <a16:creationId xmlns:a16="http://schemas.microsoft.com/office/drawing/2014/main" id="{38B708C0-B21C-460D-9BE5-9D8A8A4BCCA3}"/>
               </a:ext>
             </a:extLst>
           </p:cNvPr>
@@ -7570,7 +7520,7 @@
           <p:cNvPr id="19" name="">
             <a:extLst xmlns:a="http://schemas.openxmlformats.org/drawingml/2006/main">
               <a:ext uri="{FF2B5EF4-FFF2-40B4-BE49-F238E27FC236}">
-                <a16:creationId xmlns:a16="http://schemas.microsoft.com/office/drawing/2014/main" id="{8AFB07FC-EAD7-49CE-8440-8C2D06F50BEE}"/>
+                <a16:creationId xmlns:a16="http://schemas.microsoft.com/office/drawing/2014/main" id="{919E2D93-BC66-4235-843F-CBE0F6A6C4A5}"/>
               </a:ext>
             </a:extLst>
           </p:cNvPr>
@@ -7582,17 +7532,17 @@
         <p:spPr>
           <a:xfrm xmlns:a="http://schemas.openxmlformats.org/drawingml/2006/main">
             <a:off x="4810125" y="3390900"/>
-            <a:ext cx="2476500" cy="190500"/>
+            <a:ext cx="3429000" cy="190500"/>
           </a:xfrm>
           <a:prstGeom xmlns:a="http://schemas.openxmlformats.org/drawingml/2006/main" prst="rect">
             <a:avLst/>
           </a:prstGeom>
           <a:solidFill xmlns:a="http://schemas.openxmlformats.org/drawingml/2006/main">
-            <a:srgbClr val="C9A227"/>
+            <a:srgbClr val="A32020"/>
           </a:solidFill>
           <a:ln xmlns:a="http://schemas.openxmlformats.org/drawingml/2006/main" w="0">
             <a:solidFill>
-              <a:srgbClr val="C9A227"/>
+              <a:srgbClr val="A32020"/>
             </a:solidFill>
             <a:prstDash val="solid"/>
           </a:ln>
@@ -7603,7 +7553,7 @@
           <p:cNvPr id="20" name="">
             <a:extLst xmlns:a="http://schemas.openxmlformats.org/drawingml/2006/main">
               <a:ext uri="{FF2B5EF4-FFF2-40B4-BE49-F238E27FC236}">
-                <a16:creationId xmlns:a16="http://schemas.microsoft.com/office/drawing/2014/main" id="{9FFCF11C-688C-4DEC-B3B6-507B5A4DECC2}"/>
+                <a16:creationId xmlns:a16="http://schemas.microsoft.com/office/drawing/2014/main" id="{8B8D04AD-6148-4562-8D8A-429CF37CF2E2}"/>
               </a:ext>
             </a:extLst>
           </p:cNvPr>
@@ -7633,17 +7583,17 @@
             <a:pPr>
               <a:defRPr sz="1200" b="1">
                 <a:solidFill>
-                  <a:srgbClr val="C9A227"/>
+                  <a:srgbClr val="A32020"/>
                 </a:solidFill>
               </a:defRPr>
             </a:pPr>
             <a:r>
               <a:rPr sz="1200" b="1">
                 <a:solidFill>
-                  <a:srgbClr val="C9A227"/>
-                </a:solidFill>
-              </a:rPr>
-              <a:t>High</a:t>
+                  <a:srgbClr val="A32020"/>
+                </a:solidFill>
+              </a:rPr>
+              <a:t>Critical</a:t>
             </a:r>
           </a:p>
         </p:txBody>
@@ -7653,7 +7603,7 @@
           <p:cNvPr id="21" name="">
             <a:extLst xmlns:a="http://schemas.openxmlformats.org/drawingml/2006/main">
               <a:ext uri="{FF2B5EF4-FFF2-40B4-BE49-F238E27FC236}">
-                <a16:creationId xmlns:a16="http://schemas.microsoft.com/office/drawing/2014/main" id="{B3C89847-674C-4081-B766-E9BDF060A1F9}"/>
+                <a16:creationId xmlns:a16="http://schemas.microsoft.com/office/drawing/2014/main" id="{8FDABE29-A5CD-40B7-AC81-F3B3D44B80A0}"/>
               </a:ext>
             </a:extLst>
           </p:cNvPr>
@@ -7681,19 +7631,19 @@
           <a:lstStyle xmlns:a="http://schemas.openxmlformats.org/drawingml/2006/main"/>
           <a:p xmlns:a="http://schemas.openxmlformats.org/drawingml/2006/main">
             <a:pPr>
-              <a:defRPr sz="1050">
+              <a:defRPr sz="975">
                 <a:solidFill>
                   <a:srgbClr val="5A6B7C"/>
                 </a:solidFill>
               </a:defRPr>
             </a:pPr>
             <a:r>
-              <a:rPr sz="1050">
+              <a:rPr sz="975">
                 <a:solidFill>
                   <a:srgbClr val="5A6B7C"/>
                 </a:solidFill>
               </a:rPr>
-              <a:t>Implement a complete role-based access review.</a:t>
+              <a:t>Continuous Improvement and Fraud Risk Monitoring control effectiveness risk.…</a:t>
             </a:r>
           </a:p>
         </p:txBody>
@@ -7703,7 +7653,7 @@
           <p:cNvPr id="22" name="">
             <a:extLst xmlns:a="http://schemas.openxmlformats.org/drawingml/2006/main">
               <a:ext uri="{FF2B5EF4-FFF2-40B4-BE49-F238E27FC236}">
-                <a16:creationId xmlns:a16="http://schemas.microsoft.com/office/drawing/2014/main" id="{1C0E8A65-235E-4F29-8F2B-9CD830E5EC80}"/>
+                <a16:creationId xmlns:a16="http://schemas.microsoft.com/office/drawing/2014/main" id="{AD377CF0-F9E6-4BC1-BA2C-2BBFFEDD0CBA}"/>
               </a:ext>
             </a:extLst>
           </p:cNvPr>
@@ -7743,7 +7693,7 @@
                   <a:srgbClr val="142F4C"/>
                 </a:solidFill>
               </a:rPr>
-              <a:t>Stale detection rules may delay an alert</a:t>
+              <a:t>Fraud Risk Identification control effectiveness risk</a:t>
             </a:r>
           </a:p>
         </p:txBody>
@@ -7753,7 +7703,7 @@
           <p:cNvPr id="23" name="">
             <a:extLst xmlns:a="http://schemas.openxmlformats.org/drawingml/2006/main">
               <a:ext uri="{FF2B5EF4-FFF2-40B4-BE49-F238E27FC236}">
-                <a16:creationId xmlns:a16="http://schemas.microsoft.com/office/drawing/2014/main" id="{903A0119-3A2C-46CD-BE72-D5F923B9ECC7}"/>
+                <a16:creationId xmlns:a16="http://schemas.microsoft.com/office/drawing/2014/main" id="{1997D485-B9B0-4F77-B00C-BD2B2E5E87EA}"/>
               </a:ext>
             </a:extLst>
           </p:cNvPr>
@@ -7786,7 +7736,7 @@
           <p:cNvPr id="24" name="">
             <a:extLst xmlns:a="http://schemas.openxmlformats.org/drawingml/2006/main">
               <a:ext uri="{FF2B5EF4-FFF2-40B4-BE49-F238E27FC236}">
-                <a16:creationId xmlns:a16="http://schemas.microsoft.com/office/drawing/2014/main" id="{9978670E-828F-4CE3-8D6F-72A168C71245}"/>
+                <a16:creationId xmlns:a16="http://schemas.microsoft.com/office/drawing/2014/main" id="{EEEFD3A3-1731-43AB-A9D9-54BAA521A2A8}"/>
               </a:ext>
             </a:extLst>
           </p:cNvPr>
@@ -7798,17 +7748,17 @@
         <p:spPr>
           <a:xfrm xmlns:a="http://schemas.openxmlformats.org/drawingml/2006/main">
             <a:off x="4810125" y="4057650"/>
-            <a:ext cx="2476500" cy="190500"/>
+            <a:ext cx="3429000" cy="190500"/>
           </a:xfrm>
           <a:prstGeom xmlns:a="http://schemas.openxmlformats.org/drawingml/2006/main" prst="rect">
             <a:avLst/>
           </a:prstGeom>
           <a:solidFill xmlns:a="http://schemas.openxmlformats.org/drawingml/2006/main">
-            <a:srgbClr val="C9A227"/>
+            <a:srgbClr val="A32020"/>
           </a:solidFill>
           <a:ln xmlns:a="http://schemas.openxmlformats.org/drawingml/2006/main" w="0">
             <a:solidFill>
-              <a:srgbClr val="C9A227"/>
+              <a:srgbClr val="A32020"/>
             </a:solidFill>
             <a:prstDash val="solid"/>
           </a:ln>
@@ -7819,7 +7769,7 @@
           <p:cNvPr id="25" name="">
             <a:extLst xmlns:a="http://schemas.openxmlformats.org/drawingml/2006/main">
               <a:ext uri="{FF2B5EF4-FFF2-40B4-BE49-F238E27FC236}">
-                <a16:creationId xmlns:a16="http://schemas.microsoft.com/office/drawing/2014/main" id="{F4CCD584-CE3D-4800-83F3-F667931BABEB}"/>
+                <a16:creationId xmlns:a16="http://schemas.microsoft.com/office/drawing/2014/main" id="{175F83A5-A3B0-477F-9F98-1DFDFDB98D97}"/>
               </a:ext>
             </a:extLst>
           </p:cNvPr>
@@ -7849,17 +7799,17 @@
             <a:pPr>
               <a:defRPr sz="1200" b="1">
                 <a:solidFill>
-                  <a:srgbClr val="C9A227"/>
+                  <a:srgbClr val="A32020"/>
                 </a:solidFill>
               </a:defRPr>
             </a:pPr>
             <a:r>
               <a:rPr sz="1200" b="1">
                 <a:solidFill>
-                  <a:srgbClr val="C9A227"/>
-                </a:solidFill>
-              </a:rPr>
-              <a:t>High</a:t>
+                  <a:srgbClr val="A32020"/>
+                </a:solidFill>
+              </a:rPr>
+              <a:t>Critical</a:t>
             </a:r>
           </a:p>
         </p:txBody>
@@ -7869,7 +7819,7 @@
           <p:cNvPr id="26" name="">
             <a:extLst xmlns:a="http://schemas.openxmlformats.org/drawingml/2006/main">
               <a:ext uri="{FF2B5EF4-FFF2-40B4-BE49-F238E27FC236}">
-                <a16:creationId xmlns:a16="http://schemas.microsoft.com/office/drawing/2014/main" id="{22EA9A06-692F-4744-AB8C-EE4FE55A670B}"/>
+                <a16:creationId xmlns:a16="http://schemas.microsoft.com/office/drawing/2014/main" id="{ABB519FE-2F2C-4A05-813C-E843453AE72E}"/>
               </a:ext>
             </a:extLst>
           </p:cNvPr>
@@ -7897,19 +7847,19 @@
           <a:lstStyle xmlns:a="http://schemas.openxmlformats.org/drawingml/2006/main"/>
           <a:p xmlns:a="http://schemas.openxmlformats.org/drawingml/2006/main">
             <a:pPr>
-              <a:defRPr sz="1050">
+              <a:defRPr sz="975">
                 <a:solidFill>
                   <a:srgbClr val="5A6B7C"/>
                 </a:solidFill>
               </a:defRPr>
             </a:pPr>
             <a:r>
-              <a:rPr sz="1050">
+              <a:rPr sz="975">
                 <a:solidFill>
                   <a:srgbClr val="5A6B7C"/>
                 </a:solidFill>
               </a:rPr>
-              <a:t>Implement a complete role-based access review.</a:t>
+              <a:t>Fraud Risk Identification control effectiveness risk. The Head of…</a:t>
             </a:r>
           </a:p>
         </p:txBody>
@@ -7919,7 +7869,7 @@
           <p:cNvPr id="27" name="">
             <a:extLst xmlns:a="http://schemas.openxmlformats.org/drawingml/2006/main">
               <a:ext uri="{FF2B5EF4-FFF2-40B4-BE49-F238E27FC236}">
-                <a16:creationId xmlns:a16="http://schemas.microsoft.com/office/drawing/2014/main" id="{3D298E6F-EDAC-41E5-80F7-7391CDE78F7B}"/>
+                <a16:creationId xmlns:a16="http://schemas.microsoft.com/office/drawing/2014/main" id="{CEA62278-32A1-4036-AB76-CD63A839A9B7}"/>
               </a:ext>
             </a:extLst>
           </p:cNvPr>
@@ -7959,7 +7909,7 @@
                   <a:srgbClr val="142F4C"/>
                 </a:solidFill>
               </a:rPr>
-              <a:t>Incident lessons may not reduce repeat exposure</a:t>
+              <a:t>Digital and Identity Fraud Risk control effectiveness risk</a:t>
             </a:r>
           </a:p>
         </p:txBody>
@@ -7969,7 +7919,7 @@
           <p:cNvPr id="28" name="">
             <a:extLst xmlns:a="http://schemas.openxmlformats.org/drawingml/2006/main">
               <a:ext uri="{FF2B5EF4-FFF2-40B4-BE49-F238E27FC236}">
-                <a16:creationId xmlns:a16="http://schemas.microsoft.com/office/drawing/2014/main" id="{B487085D-F130-436E-B45E-F77965C0E394}"/>
+                <a16:creationId xmlns:a16="http://schemas.microsoft.com/office/drawing/2014/main" id="{2F39BFA4-4335-4234-A485-1E27C8B88310}"/>
               </a:ext>
             </a:extLst>
           </p:cNvPr>
@@ -8002,7 +7952,7 @@
           <p:cNvPr id="29" name="">
             <a:extLst xmlns:a="http://schemas.openxmlformats.org/drawingml/2006/main">
               <a:ext uri="{FF2B5EF4-FFF2-40B4-BE49-F238E27FC236}">
-                <a16:creationId xmlns:a16="http://schemas.microsoft.com/office/drawing/2014/main" id="{A51F8DA2-64F1-4E6A-8915-E2156D986177}"/>
+                <a16:creationId xmlns:a16="http://schemas.microsoft.com/office/drawing/2014/main" id="{EF4DBE9C-C26E-4892-9AC3-F186420FD376}"/>
               </a:ext>
             </a:extLst>
           </p:cNvPr>
@@ -8014,17 +7964,17 @@
         <p:spPr>
           <a:xfrm xmlns:a="http://schemas.openxmlformats.org/drawingml/2006/main">
             <a:off x="4810125" y="4724400"/>
-            <a:ext cx="2476500" cy="190500"/>
+            <a:ext cx="3429000" cy="190500"/>
           </a:xfrm>
           <a:prstGeom xmlns:a="http://schemas.openxmlformats.org/drawingml/2006/main" prst="rect">
             <a:avLst/>
           </a:prstGeom>
           <a:solidFill xmlns:a="http://schemas.openxmlformats.org/drawingml/2006/main">
-            <a:srgbClr val="C9A227"/>
+            <a:srgbClr val="A32020"/>
           </a:solidFill>
           <a:ln xmlns:a="http://schemas.openxmlformats.org/drawingml/2006/main" w="0">
             <a:solidFill>
-              <a:srgbClr val="C9A227"/>
+              <a:srgbClr val="A32020"/>
             </a:solidFill>
             <a:prstDash val="solid"/>
           </a:ln>
@@ -8035,7 +7985,7 @@
           <p:cNvPr id="30" name="">
             <a:extLst xmlns:a="http://schemas.openxmlformats.org/drawingml/2006/main">
               <a:ext uri="{FF2B5EF4-FFF2-40B4-BE49-F238E27FC236}">
-                <a16:creationId xmlns:a16="http://schemas.microsoft.com/office/drawing/2014/main" id="{AB5CDB23-4208-46D2-B726-442ABB1ED71B}"/>
+                <a16:creationId xmlns:a16="http://schemas.microsoft.com/office/drawing/2014/main" id="{562A53E1-8AFD-408A-B61B-793CAD07636E}"/>
               </a:ext>
             </a:extLst>
           </p:cNvPr>
@@ -8065,17 +8015,17 @@
             <a:pPr>
               <a:defRPr sz="1200" b="1">
                 <a:solidFill>
-                  <a:srgbClr val="C9A227"/>
+                  <a:srgbClr val="A32020"/>
                 </a:solidFill>
               </a:defRPr>
             </a:pPr>
             <a:r>
               <a:rPr sz="1200" b="1">
                 <a:solidFill>
-                  <a:srgbClr val="C9A227"/>
-                </a:solidFill>
-              </a:rPr>
-              <a:t>High</a:t>
+                  <a:srgbClr val="A32020"/>
+                </a:solidFill>
+              </a:rPr>
+              <a:t>Critical</a:t>
             </a:r>
           </a:p>
         </p:txBody>
@@ -8085,7 +8035,7 @@
           <p:cNvPr id="31" name="">
             <a:extLst xmlns:a="http://schemas.openxmlformats.org/drawingml/2006/main">
               <a:ext uri="{FF2B5EF4-FFF2-40B4-BE49-F238E27FC236}">
-                <a16:creationId xmlns:a16="http://schemas.microsoft.com/office/drawing/2014/main" id="{437B20BD-346B-4787-AF66-7779D472A004}"/>
+                <a16:creationId xmlns:a16="http://schemas.microsoft.com/office/drawing/2014/main" id="{718F40CA-71DB-427C-9E9A-F000113BC260}"/>
               </a:ext>
             </a:extLst>
           </p:cNvPr>
@@ -8113,19 +8063,19 @@
           <a:lstStyle xmlns:a="http://schemas.openxmlformats.org/drawingml/2006/main"/>
           <a:p xmlns:a="http://schemas.openxmlformats.org/drawingml/2006/main">
             <a:pPr>
-              <a:defRPr sz="1050">
+              <a:defRPr sz="975">
                 <a:solidFill>
                   <a:srgbClr val="5A6B7C"/>
                 </a:solidFill>
               </a:defRPr>
             </a:pPr>
             <a:r>
-              <a:rPr sz="1050">
+              <a:rPr sz="975">
                 <a:solidFill>
                   <a:srgbClr val="5A6B7C"/>
                 </a:solidFill>
               </a:rPr>
-              <a:t>Implement a complete role-based access review.</a:t>
+              <a:t>Digital and Identity Fraud Risk control effectiveness risk. The…</a:t>
             </a:r>
           </a:p>
         </p:txBody>
@@ -8133,7 +8083,7 @@
     </p:spTree>
     <p:extLst>
       <p:ext uri="{BB962C8B-B14F-4D97-AF65-F5344CB8AC3E}">
-        <p14:creationId xmlns:p14="http://schemas.microsoft.com/office/powerpoint/2010/main" val="506516728"/>
+        <p14:creationId xmlns:p14="http://schemas.microsoft.com/office/powerpoint/2010/main" val="41349895"/>
       </p:ext>
     </p:extLst>
   </p:cSld>
@@ -8164,7 +8114,7 @@
           <p:cNvPr id="22" name="">
             <a:extLst xmlns:a="http://schemas.openxmlformats.org/drawingml/2006/main">
               <a:ext uri="{FF2B5EF4-FFF2-40B4-BE49-F238E27FC236}">
-                <a16:creationId xmlns:a16="http://schemas.microsoft.com/office/drawing/2014/main" id="{87929952-6B7E-40B5-8C37-27636D816EE7}"/>
+                <a16:creationId xmlns:a16="http://schemas.microsoft.com/office/drawing/2014/main" id="{134EFD82-C3EC-4632-823C-729955326ACD}"/>
               </a:ext>
             </a:extLst>
           </p:cNvPr>
@@ -8214,7 +8164,7 @@
           <p:cNvPr id="2" name="">
             <a:extLst xmlns:a="http://schemas.openxmlformats.org/drawingml/2006/main">
               <a:ext uri="{FF2B5EF4-FFF2-40B4-BE49-F238E27FC236}">
-                <a16:creationId xmlns:a16="http://schemas.microsoft.com/office/drawing/2014/main" id="{073C5893-9771-4B28-89D5-97C21BAA7F16}"/>
+                <a16:creationId xmlns:a16="http://schemas.microsoft.com/office/drawing/2014/main" id="{83C6CFC2-119D-4BC0-BCA4-FD28063C78B3}"/>
               </a:ext>
             </a:extLst>
           </p:cNvPr>
@@ -8264,7 +8214,7 @@
           <p:cNvPr id="3" name="">
             <a:extLst xmlns:a="http://schemas.openxmlformats.org/drawingml/2006/main">
               <a:ext uri="{FF2B5EF4-FFF2-40B4-BE49-F238E27FC236}">
-                <a16:creationId xmlns:a16="http://schemas.microsoft.com/office/drawing/2014/main" id="{670E1151-C766-40BE-ABD0-406DCCF6552C}"/>
+                <a16:creationId xmlns:a16="http://schemas.microsoft.com/office/drawing/2014/main" id="{ED47D162-ABC5-4A93-B1D1-6E57CEB1F7E0}"/>
               </a:ext>
             </a:extLst>
           </p:cNvPr>
@@ -8304,7 +8254,7 @@
                   <a:srgbClr val="5A6B7C"/>
                 </a:solidFill>
               </a:rPr>
-              <a:t>Scenario logic helps management validate prevention, detection and containment together.</a:t>
+              <a:t>Scenario logic helps management test prevention, detection and containment together.</a:t>
             </a:r>
           </a:p>
         </p:txBody>
@@ -8314,7 +8264,7 @@
           <p:cNvPr id="4" name="">
             <a:extLst xmlns:a="http://schemas.openxmlformats.org/drawingml/2006/main">
               <a:ext uri="{FF2B5EF4-FFF2-40B4-BE49-F238E27FC236}">
-                <a16:creationId xmlns:a16="http://schemas.microsoft.com/office/drawing/2014/main" id="{449B5329-445E-4AA4-AC2E-5AAADC72A1E9}"/>
+                <a16:creationId xmlns:a16="http://schemas.microsoft.com/office/drawing/2014/main" id="{D3486118-E6D0-402B-AE51-3C8817EBEDB3}"/>
               </a:ext>
             </a:extLst>
           </p:cNvPr>
@@ -8345,7 +8295,7 @@
           <p:cNvPr id="5" name="">
             <a:extLst xmlns:a="http://schemas.openxmlformats.org/drawingml/2006/main">
               <a:ext uri="{FF2B5EF4-FFF2-40B4-BE49-F238E27FC236}">
-                <a16:creationId xmlns:a16="http://schemas.microsoft.com/office/drawing/2014/main" id="{3371D55F-8768-42C4-AE3D-C28400E76B94}"/>
+                <a16:creationId xmlns:a16="http://schemas.microsoft.com/office/drawing/2014/main" id="{46B43ADE-4BB6-42FF-8608-0D7A34803FCF}"/>
               </a:ext>
             </a:extLst>
           </p:cNvPr>
@@ -8395,7 +8345,7 @@
           <p:cNvPr id="6" name="">
             <a:extLst xmlns:a="http://schemas.openxmlformats.org/drawingml/2006/main">
               <a:ext uri="{FF2B5EF4-FFF2-40B4-BE49-F238E27FC236}">
-                <a16:creationId xmlns:a16="http://schemas.microsoft.com/office/drawing/2014/main" id="{C2B3BBC7-B10A-4E14-B832-18104E9DDE18}"/>
+                <a16:creationId xmlns:a16="http://schemas.microsoft.com/office/drawing/2014/main" id="{81126BB7-7F89-494D-9731-D590AAF97E1A}"/>
               </a:ext>
             </a:extLst>
           </p:cNvPr>
@@ -8445,7 +8395,7 @@
           <p:cNvPr id="7" name="">
             <a:extLst xmlns:a="http://schemas.openxmlformats.org/drawingml/2006/main">
               <a:ext uri="{FF2B5EF4-FFF2-40B4-BE49-F238E27FC236}">
-                <a16:creationId xmlns:a16="http://schemas.microsoft.com/office/drawing/2014/main" id="{CC74F1EA-DCD9-4A98-9731-5DC6E565EC0C}"/>
+                <a16:creationId xmlns:a16="http://schemas.microsoft.com/office/drawing/2014/main" id="{1DB5347D-F849-425A-A1F6-7DD7BDC203B8}"/>
               </a:ext>
             </a:extLst>
           </p:cNvPr>
@@ -8480,7 +8430,7 @@
           <p:cNvPr id="8" name="">
             <a:extLst xmlns:a="http://schemas.openxmlformats.org/drawingml/2006/main">
               <a:ext uri="{FF2B5EF4-FFF2-40B4-BE49-F238E27FC236}">
-                <a16:creationId xmlns:a16="http://schemas.microsoft.com/office/drawing/2014/main" id="{3FD9BDB2-C603-4A2F-9540-63A576DFA6B8}"/>
+                <a16:creationId xmlns:a16="http://schemas.microsoft.com/office/drawing/2014/main" id="{AFE3C1AF-12B0-47BF-B7D0-F0FF9F1D7B73}"/>
               </a:ext>
             </a:extLst>
           </p:cNvPr>
@@ -8530,7 +8480,7 @@
           <p:cNvPr id="9" name="">
             <a:extLst xmlns:a="http://schemas.openxmlformats.org/drawingml/2006/main">
               <a:ext uri="{FF2B5EF4-FFF2-40B4-BE49-F238E27FC236}">
-                <a16:creationId xmlns:a16="http://schemas.microsoft.com/office/drawing/2014/main" id="{9704ADEB-54E9-480A-B224-D6F94BD09513}"/>
+                <a16:creationId xmlns:a16="http://schemas.microsoft.com/office/drawing/2014/main" id="{59D50987-6954-47DC-A257-6F0582395F2C}"/>
               </a:ext>
             </a:extLst>
           </p:cNvPr>
@@ -8570,7 +8520,7 @@
                   <a:srgbClr val="142F4C"/>
                 </a:solidFill>
               </a:rPr>
-              <a:t>Supplier bank-detail redirection</a:t>
+              <a:t>Without deliberate monitoring, fraud is found only by accident, complaint or external notification, typically long after the loss has compounded</a:t>
             </a:r>
           </a:p>
         </p:txBody>
@@ -8580,7 +8530,7 @@
           <p:cNvPr id="10" name="">
             <a:extLst xmlns:a="http://schemas.openxmlformats.org/drawingml/2006/main">
               <a:ext uri="{FF2B5EF4-FFF2-40B4-BE49-F238E27FC236}">
-                <a16:creationId xmlns:a16="http://schemas.microsoft.com/office/drawing/2014/main" id="{C8BB96A3-BE40-4DA0-ABA1-98105C9288F7}"/>
+                <a16:creationId xmlns:a16="http://schemas.microsoft.com/office/drawing/2014/main" id="{F8CF9201-40FB-49A0-8442-EC7CB039CC78}"/>
               </a:ext>
             </a:extLst>
           </p:cNvPr>
@@ -8620,7 +8570,7 @@
                   <a:srgbClr val="5A6B7C"/>
                 </a:solidFill>
               </a:rPr>
-              <a:t>A stale or excessive account remains active.</a:t>
+              <a:t>The recorded control condition is engaged through Fraud Detection Capability: The organisation monitors transactions or operational activity for unusual patterns, anomalies or red flags.</a:t>
             </a:r>
           </a:p>
         </p:txBody>
@@ -8630,7 +8580,7 @@
           <p:cNvPr id="11" name="">
             <a:extLst xmlns:a="http://schemas.openxmlformats.org/drawingml/2006/main">
               <a:ext uri="{FF2B5EF4-FFF2-40B4-BE49-F238E27FC236}">
-                <a16:creationId xmlns:a16="http://schemas.microsoft.com/office/drawing/2014/main" id="{073AFEA4-C678-4623-8C45-7433CBE13240}"/>
+                <a16:creationId xmlns:a16="http://schemas.microsoft.com/office/drawing/2014/main" id="{684BE82E-37E3-4BE9-8421-124838908D03}"/>
               </a:ext>
             </a:extLst>
           </p:cNvPr>
@@ -8670,7 +8620,7 @@
                   <a:srgbClr val="1A2634"/>
                 </a:solidFill>
               </a:rPr>
-              <a:t>An unauthorised change is made and the audit trail is obscured or discovered late.</a:t>
+              <a:t>Misuse can occur when an actor exploits the recorded control condition and without deliberate monitoring, fraud is found only by accident, complaint or external notification, typically long after the loss has compounded.</a:t>
             </a:r>
           </a:p>
         </p:txBody>
@@ -8680,7 +8630,7 @@
           <p:cNvPr id="12" name="">
             <a:extLst xmlns:a="http://schemas.openxmlformats.org/drawingml/2006/main">
               <a:ext uri="{FF2B5EF4-FFF2-40B4-BE49-F238E27FC236}">
-                <a16:creationId xmlns:a16="http://schemas.microsoft.com/office/drawing/2014/main" id="{CF10921F-970B-49B0-8428-BF950DDA1310}"/>
+                <a16:creationId xmlns:a16="http://schemas.microsoft.com/office/drawing/2014/main" id="{825DF27B-27F6-40CA-93DB-1B79EAF4654A}"/>
               </a:ext>
             </a:extLst>
           </p:cNvPr>
@@ -8715,7 +8665,7 @@
           <p:cNvPr id="13" name="">
             <a:extLst xmlns:a="http://schemas.openxmlformats.org/drawingml/2006/main">
               <a:ext uri="{FF2B5EF4-FFF2-40B4-BE49-F238E27FC236}">
-                <a16:creationId xmlns:a16="http://schemas.microsoft.com/office/drawing/2014/main" id="{AD79B96B-721C-4C08-BF1C-0529565C28DB}"/>
+                <a16:creationId xmlns:a16="http://schemas.microsoft.com/office/drawing/2014/main" id="{694D5EC1-8293-427B-8B64-2A06AC2A79F0}"/>
               </a:ext>
             </a:extLst>
           </p:cNvPr>
@@ -8765,7 +8715,7 @@
           <p:cNvPr id="14" name="">
             <a:extLst xmlns:a="http://schemas.openxmlformats.org/drawingml/2006/main">
               <a:ext uri="{FF2B5EF4-FFF2-40B4-BE49-F238E27FC236}">
-                <a16:creationId xmlns:a16="http://schemas.microsoft.com/office/drawing/2014/main" id="{14107113-1728-4C26-8C4F-CD54F984B30C}"/>
+                <a16:creationId xmlns:a16="http://schemas.microsoft.com/office/drawing/2014/main" id="{01F24B10-644B-477E-ADF4-93CE3B7CBF43}"/>
               </a:ext>
             </a:extLst>
           </p:cNvPr>
@@ -8805,7 +8755,7 @@
                   <a:srgbClr val="142F4C"/>
                 </a:solidFill>
               </a:rPr>
-              <a:t>Incident escalation delay</a:t>
+              <a:t>Controls decay quietly through staff turnover, system change and workload pressure, so a control believed to be operating may have lapsed months earlier</a:t>
             </a:r>
           </a:p>
         </p:txBody>
@@ -8815,7 +8765,7 @@
           <p:cNvPr id="15" name="">
             <a:extLst xmlns:a="http://schemas.openxmlformats.org/drawingml/2006/main">
               <a:ext uri="{FF2B5EF4-FFF2-40B4-BE49-F238E27FC236}">
-                <a16:creationId xmlns:a16="http://schemas.microsoft.com/office/drawing/2014/main" id="{8DE0A075-F0C4-4260-A365-D7BB2BC7D0C7}"/>
+                <a16:creationId xmlns:a16="http://schemas.microsoft.com/office/drawing/2014/main" id="{522B5DA1-E14F-47E5-9801-6737AA55C27C}"/>
               </a:ext>
             </a:extLst>
           </p:cNvPr>
@@ -8855,7 +8805,7 @@
                   <a:srgbClr val="5A6B7C"/>
                 </a:solidFill>
               </a:rPr>
-              <a:t>A stale or excessive account remains active.</a:t>
+              <a:t>The recorded control condition is engaged through Continuous Improvement and Fraud Risk Monitoring: The organisation periodically reviews its fraud risks and control environment.</a:t>
             </a:r>
           </a:p>
         </p:txBody>
@@ -8865,7 +8815,7 @@
           <p:cNvPr id="16" name="">
             <a:extLst xmlns:a="http://schemas.openxmlformats.org/drawingml/2006/main">
               <a:ext uri="{FF2B5EF4-FFF2-40B4-BE49-F238E27FC236}">
-                <a16:creationId xmlns:a16="http://schemas.microsoft.com/office/drawing/2014/main" id="{5405FEBB-DFCC-4551-B01A-04F576D8CB9F}"/>
+                <a16:creationId xmlns:a16="http://schemas.microsoft.com/office/drawing/2014/main" id="{9D0FC37D-8F52-4A08-BD8B-CC06531DA19A}"/>
               </a:ext>
             </a:extLst>
           </p:cNvPr>
@@ -8905,7 +8855,7 @@
                   <a:srgbClr val="1A2634"/>
                 </a:solidFill>
               </a:rPr>
-              <a:t>An unauthorised change is made and the audit trail is obscured or discovered late.</a:t>
+              <a:t>Misuse can occur when an actor exploits the recorded control condition and controls decay quietly through staff turnover, system change and workload pressure, so a control believed to be operating may have lapsed months earlier.</a:t>
             </a:r>
           </a:p>
         </p:txBody>
@@ -8915,7 +8865,7 @@
           <p:cNvPr id="17" name="">
             <a:extLst xmlns:a="http://schemas.openxmlformats.org/drawingml/2006/main">
               <a:ext uri="{FF2B5EF4-FFF2-40B4-BE49-F238E27FC236}">
-                <a16:creationId xmlns:a16="http://schemas.microsoft.com/office/drawing/2014/main" id="{BFAD8056-976D-4F6A-A190-D1C124D02DEA}"/>
+                <a16:creationId xmlns:a16="http://schemas.microsoft.com/office/drawing/2014/main" id="{01102B22-AC50-441B-AD66-65B4A9018CBD}"/>
               </a:ext>
             </a:extLst>
           </p:cNvPr>
@@ -8950,7 +8900,7 @@
           <p:cNvPr id="18" name="">
             <a:extLst xmlns:a="http://schemas.openxmlformats.org/drawingml/2006/main">
               <a:ext uri="{FF2B5EF4-FFF2-40B4-BE49-F238E27FC236}">
-                <a16:creationId xmlns:a16="http://schemas.microsoft.com/office/drawing/2014/main" id="{F456A378-9577-4A8B-8259-8F14AA41DBD7}"/>
+                <a16:creationId xmlns:a16="http://schemas.microsoft.com/office/drawing/2014/main" id="{AD3DA666-F6F3-40EF-80BE-1BE95EE00D21}"/>
               </a:ext>
             </a:extLst>
           </p:cNvPr>
@@ -9000,7 +8950,7 @@
           <p:cNvPr id="19" name="">
             <a:extLst xmlns:a="http://schemas.openxmlformats.org/drawingml/2006/main">
               <a:ext uri="{FF2B5EF4-FFF2-40B4-BE49-F238E27FC236}">
-                <a16:creationId xmlns:a16="http://schemas.microsoft.com/office/drawing/2014/main" id="{761847F8-534A-43C5-9151-D49CE04DE912}"/>
+                <a16:creationId xmlns:a16="http://schemas.microsoft.com/office/drawing/2014/main" id="{8ACAFB3B-91E7-4E3A-A5B2-CBA7A3571470}"/>
               </a:ext>
             </a:extLst>
           </p:cNvPr>
@@ -9040,7 +8990,7 @@
                   <a:srgbClr val="142F4C"/>
                 </a:solidFill>
               </a:rPr>
-              <a:t>Privileged access misuse</a:t>
+              <a:t>Without a current structured assessment, control investment follows intuition and recent events, leaving whole exposure areas unexamined and unfunded</a:t>
             </a:r>
           </a:p>
         </p:txBody>
@@ -9050,7 +9000,7 @@
           <p:cNvPr id="20" name="">
             <a:extLst xmlns:a="http://schemas.openxmlformats.org/drawingml/2006/main">
               <a:ext uri="{FF2B5EF4-FFF2-40B4-BE49-F238E27FC236}">
-                <a16:creationId xmlns:a16="http://schemas.microsoft.com/office/drawing/2014/main" id="{D600E4A9-2CD4-4697-808B-2E820A3CED61}"/>
+                <a16:creationId xmlns:a16="http://schemas.microsoft.com/office/drawing/2014/main" id="{AC269FBF-E41D-4275-886B-EE0485562194}"/>
               </a:ext>
             </a:extLst>
           </p:cNvPr>
@@ -9090,7 +9040,7 @@
                   <a:srgbClr val="5A6B7C"/>
                 </a:solidFill>
               </a:rPr>
-              <a:t>A pattern changes after the last rule review.</a:t>
+              <a:t>The recorded control condition is engaged through Fraud Risk Identification: The organisation has completed a structured fraud risk assessment within the past two years.</a:t>
             </a:r>
           </a:p>
         </p:txBody>
@@ -9100,7 +9050,7 @@
           <p:cNvPr id="21" name="">
             <a:extLst xmlns:a="http://schemas.openxmlformats.org/drawingml/2006/main">
               <a:ext uri="{FF2B5EF4-FFF2-40B4-BE49-F238E27FC236}">
-                <a16:creationId xmlns:a16="http://schemas.microsoft.com/office/drawing/2014/main" id="{0EF67B69-7A3E-4DDD-9974-C3C7439A6ED2}"/>
+                <a16:creationId xmlns:a16="http://schemas.microsoft.com/office/drawing/2014/main" id="{7E28C1FE-BC9E-4227-8B00-065B6D2662B0}"/>
               </a:ext>
             </a:extLst>
           </p:cNvPr>
@@ -9140,7 +9090,7 @@
                   <a:srgbClr val="1A2634"/>
                 </a:solidFill>
               </a:rPr>
-              <a:t>Activity continues below or outside stale thresholds until a manual review identifies it.</a:t>
+              <a:t>Misuse can occur when an actor exploits the recorded control condition and without a current structured assessment, control investment follows intuition and recent events, leaving whole exposure areas unexamined and unfunded.</a:t>
             </a:r>
           </a:p>
         </p:txBody>
@@ -9148,7 +9098,7 @@
     </p:spTree>
     <p:extLst>
       <p:ext uri="{BB962C8B-B14F-4D97-AF65-F5344CB8AC3E}">
-        <p14:creationId xmlns:p14="http://schemas.microsoft.com/office/powerpoint/2010/main" val="2006776088"/>
+        <p14:creationId xmlns:p14="http://schemas.microsoft.com/office/powerpoint/2010/main" val="502274825"/>
       </p:ext>
     </p:extLst>
   </p:cSld>
@@ -9176,10 +9126,10 @@
       </p:grpSpPr>
       <p:sp>
         <p:nvSpPr>
-          <p:cNvPr id="19" name="">
-            <a:extLst xmlns:a="http://schemas.openxmlformats.org/drawingml/2006/main">
-              <a:ext uri="{FF2B5EF4-FFF2-40B4-BE49-F238E27FC236}">
-                <a16:creationId xmlns:a16="http://schemas.microsoft.com/office/drawing/2014/main" id="{073AC0AA-7B18-4DFD-B5FB-0AFB5CF7CD80}"/>
+          <p:cNvPr id="24" name="">
+            <a:extLst xmlns:a="http://schemas.openxmlformats.org/drawingml/2006/main">
+              <a:ext uri="{FF2B5EF4-FFF2-40B4-BE49-F238E27FC236}">
+                <a16:creationId xmlns:a16="http://schemas.microsoft.com/office/drawing/2014/main" id="{091D8200-EF46-403D-AE01-0D540014BC19}"/>
               </a:ext>
             </a:extLst>
           </p:cNvPr>
@@ -9229,7 +9179,7 @@
           <p:cNvPr id="2" name="">
             <a:extLst xmlns:a="http://schemas.openxmlformats.org/drawingml/2006/main">
               <a:ext uri="{FF2B5EF4-FFF2-40B4-BE49-F238E27FC236}">
-                <a16:creationId xmlns:a16="http://schemas.microsoft.com/office/drawing/2014/main" id="{141720C5-11B5-414B-92D9-D826EFA407CC}"/>
+                <a16:creationId xmlns:a16="http://schemas.microsoft.com/office/drawing/2014/main" id="{BD57159E-4A9D-42E9-9AA2-0F3775C54A2C}"/>
               </a:ext>
             </a:extLst>
           </p:cNvPr>
@@ -9279,7 +9229,7 @@
           <p:cNvPr id="3" name="">
             <a:extLst xmlns:a="http://schemas.openxmlformats.org/drawingml/2006/main">
               <a:ext uri="{FF2B5EF4-FFF2-40B4-BE49-F238E27FC236}">
-                <a16:creationId xmlns:a16="http://schemas.microsoft.com/office/drawing/2014/main" id="{C6A1BF51-E8AE-4C94-A917-8C03467B131E}"/>
+                <a16:creationId xmlns:a16="http://schemas.microsoft.com/office/drawing/2014/main" id="{45AF0946-02D9-4051-8B50-45EB036081EA}"/>
               </a:ext>
             </a:extLst>
           </p:cNvPr>
@@ -9329,7 +9279,7 @@
           <p:cNvPr id="4" name="">
             <a:extLst xmlns:a="http://schemas.openxmlformats.org/drawingml/2006/main">
               <a:ext uri="{FF2B5EF4-FFF2-40B4-BE49-F238E27FC236}">
-                <a16:creationId xmlns:a16="http://schemas.microsoft.com/office/drawing/2014/main" id="{64F905C2-5FD7-4A76-AE54-60E8CFE34098}"/>
+                <a16:creationId xmlns:a16="http://schemas.microsoft.com/office/drawing/2014/main" id="{B22150E0-EB03-4B41-8DA9-F84AFE596822}"/>
               </a:ext>
             </a:extLst>
           </p:cNvPr>
@@ -9360,7 +9310,7 @@
           <p:cNvPr id="5" name="">
             <a:extLst xmlns:a="http://schemas.openxmlformats.org/drawingml/2006/main">
               <a:ext uri="{FF2B5EF4-FFF2-40B4-BE49-F238E27FC236}">
-                <a16:creationId xmlns:a16="http://schemas.microsoft.com/office/drawing/2014/main" id="{F0A3D648-D1EF-44F7-AA42-F9D3BE68B785}"/>
+                <a16:creationId xmlns:a16="http://schemas.microsoft.com/office/drawing/2014/main" id="{9F7DE107-66EE-40D9-8D48-1B5915ED7D55}"/>
               </a:ext>
             </a:extLst>
           </p:cNvPr>
@@ -9410,7 +9360,7 @@
           <p:cNvPr id="6" name="">
             <a:extLst xmlns:a="http://schemas.openxmlformats.org/drawingml/2006/main">
               <a:ext uri="{FF2B5EF4-FFF2-40B4-BE49-F238E27FC236}">
-                <a16:creationId xmlns:a16="http://schemas.microsoft.com/office/drawing/2014/main" id="{AA962AE2-C64F-44CF-A9DD-D9BADAD0D95C}"/>
+                <a16:creationId xmlns:a16="http://schemas.microsoft.com/office/drawing/2014/main" id="{7CACC288-9936-494C-9CC5-C98137D89DB6}"/>
               </a:ext>
             </a:extLst>
           </p:cNvPr>
@@ -9460,7 +9410,7 @@
           <p:cNvPr id="7" name="">
             <a:extLst xmlns:a="http://schemas.openxmlformats.org/drawingml/2006/main">
               <a:ext uri="{FF2B5EF4-FFF2-40B4-BE49-F238E27FC236}">
-                <a16:creationId xmlns:a16="http://schemas.microsoft.com/office/drawing/2014/main" id="{5B7E2B4E-375D-4ECE-BBAC-C5B4436108CD}"/>
+                <a16:creationId xmlns:a16="http://schemas.microsoft.com/office/drawing/2014/main" id="{39911EF7-EC02-40A2-B84D-DD51307943CE}"/>
               </a:ext>
             </a:extLst>
           </p:cNvPr>
@@ -9500,7 +9450,7 @@
                   <a:srgbClr val="142F4C"/>
                 </a:solidFill>
               </a:rPr>
-              <a:t>Approve the Financial Controller mandate for detection ownership and evidence-led oversight.</a:t>
+              <a:t>Approve accountable executive mandates and escalation authority for priority remediation.</a:t>
             </a:r>
           </a:p>
         </p:txBody>
@@ -9510,7 +9460,7 @@
           <p:cNvPr id="8" name="">
             <a:extLst xmlns:a="http://schemas.openxmlformats.org/drawingml/2006/main">
               <a:ext uri="{FF2B5EF4-FFF2-40B4-BE49-F238E27FC236}">
-                <a16:creationId xmlns:a16="http://schemas.microsoft.com/office/drawing/2014/main" id="{3F49706E-85D7-42E3-8B47-82DD975B31EC}"/>
+                <a16:creationId xmlns:a16="http://schemas.microsoft.com/office/drawing/2014/main" id="{48843D9C-E25C-4797-AAE2-5BC3F9E184EF}"/>
               </a:ext>
             </a:extLst>
           </p:cNvPr>
@@ -9545,7 +9495,7 @@
           <p:cNvPr id="9" name="">
             <a:extLst xmlns:a="http://schemas.openxmlformats.org/drawingml/2006/main">
               <a:ext uri="{FF2B5EF4-FFF2-40B4-BE49-F238E27FC236}">
-                <a16:creationId xmlns:a16="http://schemas.microsoft.com/office/drawing/2014/main" id="{B239F24B-B9E3-43FE-A98A-F413E48B75AB}"/>
+                <a16:creationId xmlns:a16="http://schemas.microsoft.com/office/drawing/2014/main" id="{AFB45680-D46D-414F-B0E8-5023B8B9EB90}"/>
               </a:ext>
             </a:extLst>
           </p:cNvPr>
@@ -9595,7 +9545,7 @@
           <p:cNvPr id="10" name="">
             <a:extLst xmlns:a="http://schemas.openxmlformats.org/drawingml/2006/main">
               <a:ext uri="{FF2B5EF4-FFF2-40B4-BE49-F238E27FC236}">
-                <a16:creationId xmlns:a16="http://schemas.microsoft.com/office/drawing/2014/main" id="{CEC5EBED-73E8-4B6E-B737-471D54DD5176}"/>
+                <a16:creationId xmlns:a16="http://schemas.microsoft.com/office/drawing/2014/main" id="{CE616CF6-FD07-487C-BDE5-5D227FF151BA}"/>
               </a:ext>
             </a:extLst>
           </p:cNvPr>
@@ -9607,35 +9557,35 @@
         <p:spPr>
           <a:xfrm xmlns:a="http://schemas.openxmlformats.org/drawingml/2006/main">
             <a:off x="1028700" y="3543300"/>
-            <a:ext cx="2381250" cy="666750"/>
-          </a:xfrm>
-          <a:prstGeom xmlns:a="http://schemas.openxmlformats.org/drawingml/2006/main" prst="rect">
-            <a:avLst/>
-          </a:prstGeom>
-          <a:noFill xmlns:a="http://schemas.openxmlformats.org/drawingml/2006/main"/>
-          <a:ln xmlns:a="http://schemas.openxmlformats.org/drawingml/2006/main" w="0">
-            <a:noFill/>
-            <a:prstDash val="solid"/>
-          </a:ln>
-        </p:spPr>
-        <p:txBody>
-          <a:bodyPr xmlns:a="http://schemas.openxmlformats.org/drawingml/2006/main"/>
-          <a:lstStyle xmlns:a="http://schemas.openxmlformats.org/drawingml/2006/main"/>
-          <a:p xmlns:a="http://schemas.openxmlformats.org/drawingml/2006/main">
-            <a:pPr>
-              <a:defRPr sz="1500" b="1">
+            <a:ext cx="2381250" cy="419100"/>
+          </a:xfrm>
+          <a:prstGeom xmlns:a="http://schemas.openxmlformats.org/drawingml/2006/main" prst="rect">
+            <a:avLst/>
+          </a:prstGeom>
+          <a:noFill xmlns:a="http://schemas.openxmlformats.org/drawingml/2006/main"/>
+          <a:ln xmlns:a="http://schemas.openxmlformats.org/drawingml/2006/main" w="0">
+            <a:noFill/>
+            <a:prstDash val="solid"/>
+          </a:ln>
+        </p:spPr>
+        <p:txBody>
+          <a:bodyPr xmlns:a="http://schemas.openxmlformats.org/drawingml/2006/main"/>
+          <a:lstStyle xmlns:a="http://schemas.openxmlformats.org/drawingml/2006/main"/>
+          <a:p xmlns:a="http://schemas.openxmlformats.org/drawingml/2006/main">
+            <a:pPr>
+              <a:defRPr sz="1275" b="1">
                 <a:solidFill>
                   <a:srgbClr val="142F4C"/>
                 </a:solidFill>
               </a:defRPr>
             </a:pPr>
             <a:r>
-              <a:rPr sz="1500" b="1">
+              <a:rPr sz="1275" b="1">
                 <a:solidFill>
                   <a:srgbClr val="142F4C"/>
                 </a:solidFill>
               </a:rPr>
-              <a:t>Option A: assign ownership internally</a:t>
+              <a:t>Option A - retain accountability with the Finance Director (rejected: design and adjudication would sit with one executive)</a:t>
             </a:r>
           </a:p>
         </p:txBody>
@@ -9645,7 +9595,108 @@
           <p:cNvPr id="11" name="">
             <a:extLst xmlns:a="http://schemas.openxmlformats.org/drawingml/2006/main">
               <a:ext uri="{FF2B5EF4-FFF2-40B4-BE49-F238E27FC236}">
-                <a16:creationId xmlns:a16="http://schemas.microsoft.com/office/drawing/2014/main" id="{CA62F5C2-FAF1-4E13-AE99-06CE4D470929}"/>
+                <a16:creationId xmlns:a16="http://schemas.microsoft.com/office/drawing/2014/main" id="{C106A9CA-DBBD-46A2-B8FF-E2D432E94587}"/>
+              </a:ext>
+            </a:extLst>
+          </p:cNvPr>
+          <p:cNvSpPr>
+            <a:spLocks xmlns:a="http://schemas.openxmlformats.org/drawingml/2006/main" noGrp="1"/>
+          </p:cNvSpPr>
+          <p:nvPr/>
+        </p:nvSpPr>
+        <p:spPr>
+          <a:xfrm xmlns:a="http://schemas.openxmlformats.org/drawingml/2006/main">
+            <a:off x="1028700" y="4019550"/>
+            <a:ext cx="2381250" cy="628650"/>
+          </a:xfrm>
+          <a:prstGeom xmlns:a="http://schemas.openxmlformats.org/drawingml/2006/main" prst="rect">
+            <a:avLst/>
+          </a:prstGeom>
+          <a:noFill xmlns:a="http://schemas.openxmlformats.org/drawingml/2006/main"/>
+          <a:ln xmlns:a="http://schemas.openxmlformats.org/drawingml/2006/main" w="0">
+            <a:noFill/>
+            <a:prstDash val="solid"/>
+          </a:ln>
+        </p:spPr>
+        <p:txBody>
+          <a:bodyPr xmlns:a="http://schemas.openxmlformats.org/drawingml/2006/main"/>
+          <a:lstStyle xmlns:a="http://schemas.openxmlformats.org/drawingml/2006/main"/>
+          <a:p xmlns:a="http://schemas.openxmlformats.org/drawingml/2006/main">
+            <a:pPr>
+              <a:defRPr sz="900">
+                <a:solidFill>
+                  <a:srgbClr val="5A6B7C"/>
+                </a:solidFill>
+              </a:defRPr>
+            </a:pPr>
+            <a:r>
+              <a:rPr sz="900">
+                <a:solidFill>
+                  <a:srgbClr val="5A6B7C"/>
+                </a:solidFill>
+              </a:rPr>
+              <a:t>Cost: Cost and effort require management confirmation before approval.</a:t>
+            </a:r>
+          </a:p>
+          <a:p xmlns:a="http://schemas.openxmlformats.org/drawingml/2006/main">
+            <a:pPr>
+              <a:defRPr sz="900">
+                <a:solidFill>
+                  <a:srgbClr val="5A6B7C"/>
+                </a:solidFill>
+              </a:defRPr>
+            </a:pPr>
+            <a:r>
+              <a:rPr sz="900">
+                <a:solidFill>
+                  <a:srgbClr val="5A6B7C"/>
+                </a:solidFill>
+              </a:rPr>
+              <a:t>Benefit: Builds durable ownership inside the organisation.</a:t>
+            </a:r>
+          </a:p>
+          <a:p xmlns:a="http://schemas.openxmlformats.org/drawingml/2006/main">
+            <a:pPr>
+              <a:defRPr sz="900">
+                <a:solidFill>
+                  <a:srgbClr val="5A6B7C"/>
+                </a:solidFill>
+              </a:defRPr>
+            </a:pPr>
+            <a:r>
+              <a:rPr sz="900">
+                <a:solidFill>
+                  <a:srgbClr val="5A6B7C"/>
+                </a:solidFill>
+              </a:rPr>
+              <a:t>Trade-off: Uses internal capacity and may move more slowly where capability is immature.</a:t>
+            </a:r>
+          </a:p>
+          <a:p xmlns:a="http://schemas.openxmlformats.org/drawingml/2006/main">
+            <a:pPr>
+              <a:defRPr sz="900">
+                <a:solidFill>
+                  <a:srgbClr val="5A6B7C"/>
+                </a:solidFill>
+              </a:defRPr>
+            </a:pPr>
+            <a:r>
+              <a:rPr sz="900">
+                <a:solidFill>
+                  <a:srgbClr val="5A6B7C"/>
+                </a:solidFill>
+              </a:rPr>
+              <a:t>Rejection reason: rejected: design and adjudication would sit with one executive</a:t>
+            </a:r>
+          </a:p>
+        </p:txBody>
+      </p:sp>
+      <p:sp>
+        <p:nvSpPr>
+          <p:cNvPr id="12" name="">
+            <a:extLst xmlns:a="http://schemas.openxmlformats.org/drawingml/2006/main">
+              <a:ext uri="{FF2B5EF4-FFF2-40B4-BE49-F238E27FC236}">
+                <a16:creationId xmlns:a16="http://schemas.microsoft.com/office/drawing/2014/main" id="{DADE4D0A-4CDB-469D-B19D-107E87EF9191}"/>
               </a:ext>
             </a:extLst>
           </p:cNvPr>
@@ -9677,10 +9728,10 @@
       </p:sp>
       <p:sp>
         <p:nvSpPr>
-          <p:cNvPr id="12" name="">
-            <a:extLst xmlns:a="http://schemas.openxmlformats.org/drawingml/2006/main">
-              <a:ext uri="{FF2B5EF4-FFF2-40B4-BE49-F238E27FC236}">
-                <a16:creationId xmlns:a16="http://schemas.microsoft.com/office/drawing/2014/main" id="{6A6A36A1-18D6-4AF3-923B-5B731C26E006}"/>
+          <p:cNvPr id="13" name="">
+            <a:extLst xmlns:a="http://schemas.openxmlformats.org/drawingml/2006/main">
+              <a:ext uri="{FF2B5EF4-FFF2-40B4-BE49-F238E27FC236}">
+                <a16:creationId xmlns:a16="http://schemas.microsoft.com/office/drawing/2014/main" id="{925B99AC-2162-44C1-A736-CD1029EBF6A2}"/>
               </a:ext>
             </a:extLst>
           </p:cNvPr>
@@ -9727,10 +9778,10 @@
       </p:sp>
       <p:sp>
         <p:nvSpPr>
-          <p:cNvPr id="13" name="">
-            <a:extLst xmlns:a="http://schemas.openxmlformats.org/drawingml/2006/main">
-              <a:ext uri="{FF2B5EF4-FFF2-40B4-BE49-F238E27FC236}">
-                <a16:creationId xmlns:a16="http://schemas.microsoft.com/office/drawing/2014/main" id="{BB2BDE31-02A8-4764-ADD1-4EA3A965A93A}"/>
+          <p:cNvPr id="14" name="">
+            <a:extLst xmlns:a="http://schemas.openxmlformats.org/drawingml/2006/main">
+              <a:ext uri="{FF2B5EF4-FFF2-40B4-BE49-F238E27FC236}">
+                <a16:creationId xmlns:a16="http://schemas.microsoft.com/office/drawing/2014/main" id="{28403F59-AD88-4520-A005-30342A27EC97}"/>
               </a:ext>
             </a:extLst>
           </p:cNvPr>
@@ -9742,45 +9793,146 @@
         <p:spPr>
           <a:xfrm xmlns:a="http://schemas.openxmlformats.org/drawingml/2006/main">
             <a:off x="4219575" y="3543300"/>
-            <a:ext cx="2381250" cy="666750"/>
-          </a:xfrm>
-          <a:prstGeom xmlns:a="http://schemas.openxmlformats.org/drawingml/2006/main" prst="rect">
-            <a:avLst/>
-          </a:prstGeom>
-          <a:noFill xmlns:a="http://schemas.openxmlformats.org/drawingml/2006/main"/>
-          <a:ln xmlns:a="http://schemas.openxmlformats.org/drawingml/2006/main" w="0">
-            <a:noFill/>
-            <a:prstDash val="solid"/>
-          </a:ln>
-        </p:spPr>
-        <p:txBody>
-          <a:bodyPr xmlns:a="http://schemas.openxmlformats.org/drawingml/2006/main"/>
-          <a:lstStyle xmlns:a="http://schemas.openxmlformats.org/drawingml/2006/main"/>
-          <a:p xmlns:a="http://schemas.openxmlformats.org/drawingml/2006/main">
-            <a:pPr>
-              <a:defRPr sz="1500" b="1">
+            <a:ext cx="2381250" cy="419100"/>
+          </a:xfrm>
+          <a:prstGeom xmlns:a="http://schemas.openxmlformats.org/drawingml/2006/main" prst="rect">
+            <a:avLst/>
+          </a:prstGeom>
+          <a:noFill xmlns:a="http://schemas.openxmlformats.org/drawingml/2006/main"/>
+          <a:ln xmlns:a="http://schemas.openxmlformats.org/drawingml/2006/main" w="0">
+            <a:noFill/>
+            <a:prstDash val="solid"/>
+          </a:ln>
+        </p:spPr>
+        <p:txBody>
+          <a:bodyPr xmlns:a="http://schemas.openxmlformats.org/drawingml/2006/main"/>
+          <a:lstStyle xmlns:a="http://schemas.openxmlformats.org/drawingml/2006/main"/>
+          <a:p xmlns:a="http://schemas.openxmlformats.org/drawingml/2006/main">
+            <a:pPr>
+              <a:defRPr sz="1275" b="1">
                 <a:solidFill>
                   <a:srgbClr val="142F4C"/>
                 </a:solidFill>
               </a:defRPr>
             </a:pPr>
             <a:r>
-              <a:rPr sz="1500" b="1">
+              <a:rPr sz="1275" b="1">
                 <a:solidFill>
                   <a:srgbClr val="142F4C"/>
                 </a:solidFill>
               </a:rPr>
-              <a:t>Option B: appoint a specialist partner for the first cycle</a:t>
-            </a:r>
-          </a:p>
-        </p:txBody>
-      </p:sp>
-      <p:sp>
-        <p:nvSpPr>
-          <p:cNvPr id="14" name="">
-            <a:extLst xmlns:a="http://schemas.openxmlformats.org/drawingml/2006/main">
-              <a:ext uri="{FF2B5EF4-FFF2-40B4-BE49-F238E27FC236}">
-                <a16:creationId xmlns:a16="http://schemas.microsoft.com/office/drawing/2014/main" id="{D66787FB-B887-4639-A420-3428A212DFBE}"/>
+              <a:t>Option B - delegate detection design to the Financial Controller with quarterly Audit and Risk Committee reporting (recommended and accepted)</a:t>
+            </a:r>
+          </a:p>
+        </p:txBody>
+      </p:sp>
+      <p:sp>
+        <p:nvSpPr>
+          <p:cNvPr id="15" name="">
+            <a:extLst xmlns:a="http://schemas.openxmlformats.org/drawingml/2006/main">
+              <a:ext uri="{FF2B5EF4-FFF2-40B4-BE49-F238E27FC236}">
+                <a16:creationId xmlns:a16="http://schemas.microsoft.com/office/drawing/2014/main" id="{74FD47CF-59F5-4E50-9249-487E91924478}"/>
+              </a:ext>
+            </a:extLst>
+          </p:cNvPr>
+          <p:cNvSpPr>
+            <a:spLocks xmlns:a="http://schemas.openxmlformats.org/drawingml/2006/main" noGrp="1"/>
+          </p:cNvSpPr>
+          <p:nvPr/>
+        </p:nvSpPr>
+        <p:spPr>
+          <a:xfrm xmlns:a="http://schemas.openxmlformats.org/drawingml/2006/main">
+            <a:off x="4219575" y="4019550"/>
+            <a:ext cx="2381250" cy="628650"/>
+          </a:xfrm>
+          <a:prstGeom xmlns:a="http://schemas.openxmlformats.org/drawingml/2006/main" prst="rect">
+            <a:avLst/>
+          </a:prstGeom>
+          <a:noFill xmlns:a="http://schemas.openxmlformats.org/drawingml/2006/main"/>
+          <a:ln xmlns:a="http://schemas.openxmlformats.org/drawingml/2006/main" w="0">
+            <a:noFill/>
+            <a:prstDash val="solid"/>
+          </a:ln>
+        </p:spPr>
+        <p:txBody>
+          <a:bodyPr xmlns:a="http://schemas.openxmlformats.org/drawingml/2006/main"/>
+          <a:lstStyle xmlns:a="http://schemas.openxmlformats.org/drawingml/2006/main"/>
+          <a:p xmlns:a="http://schemas.openxmlformats.org/drawingml/2006/main">
+            <a:pPr>
+              <a:defRPr sz="900">
+                <a:solidFill>
+                  <a:srgbClr val="5A6B7C"/>
+                </a:solidFill>
+              </a:defRPr>
+            </a:pPr>
+            <a:r>
+              <a:rPr sz="900">
+                <a:solidFill>
+                  <a:srgbClr val="5A6B7C"/>
+                </a:solidFill>
+              </a:rPr>
+              <a:t>Cost: Cost and effort require management confirmation before approval.</a:t>
+            </a:r>
+          </a:p>
+          <a:p xmlns:a="http://schemas.openxmlformats.org/drawingml/2006/main">
+            <a:pPr>
+              <a:defRPr sz="900">
+                <a:solidFill>
+                  <a:srgbClr val="5A6B7C"/>
+                </a:solidFill>
+              </a:defRPr>
+            </a:pPr>
+            <a:r>
+              <a:rPr sz="900">
+                <a:solidFill>
+                  <a:srgbClr val="5A6B7C"/>
+                </a:solidFill>
+              </a:rPr>
+              <a:t>Benefit: Adds focused specialist capacity against the named priority.</a:t>
+            </a:r>
+          </a:p>
+          <a:p xmlns:a="http://schemas.openxmlformats.org/drawingml/2006/main">
+            <a:pPr>
+              <a:defRPr sz="900">
+                <a:solidFill>
+                  <a:srgbClr val="5A6B7C"/>
+                </a:solidFill>
+              </a:defRPr>
+            </a:pPr>
+            <a:r>
+              <a:rPr sz="900">
+                <a:solidFill>
+                  <a:srgbClr val="5A6B7C"/>
+                </a:solidFill>
+              </a:rPr>
+              <a:t>Trade-off: Introduces external cost, handover effort and a dependency on clear scope.</a:t>
+            </a:r>
+          </a:p>
+          <a:p xmlns:a="http://schemas.openxmlformats.org/drawingml/2006/main">
+            <a:pPr>
+              <a:defRPr sz="900">
+                <a:solidFill>
+                  <a:srgbClr val="5A6B7C"/>
+                </a:solidFill>
+              </a:defRPr>
+            </a:pPr>
+            <a:r>
+              <a:rPr sz="900">
+                <a:solidFill>
+                  <a:srgbClr val="5A6B7C"/>
+                </a:solidFill>
+              </a:rPr>
+              <a:t>Recommended option</a:t>
+            </a:r>
+          </a:p>
+        </p:txBody>
+      </p:sp>
+      <p:sp>
+        <p:nvSpPr>
+          <p:cNvPr id="16" name="">
+            <a:extLst xmlns:a="http://schemas.openxmlformats.org/drawingml/2006/main">
+              <a:ext uri="{FF2B5EF4-FFF2-40B4-BE49-F238E27FC236}">
+                <a16:creationId xmlns:a16="http://schemas.microsoft.com/office/drawing/2014/main" id="{25A17970-F6A0-45DA-8937-4CE5CA028C63}"/>
               </a:ext>
             </a:extLst>
           </p:cNvPr>
@@ -9812,10 +9964,10 @@
       </p:sp>
       <p:sp>
         <p:nvSpPr>
-          <p:cNvPr id="15" name="">
-            <a:extLst xmlns:a="http://schemas.openxmlformats.org/drawingml/2006/main">
-              <a:ext uri="{FF2B5EF4-FFF2-40B4-BE49-F238E27FC236}">
-                <a16:creationId xmlns:a16="http://schemas.microsoft.com/office/drawing/2014/main" id="{F3BA31C2-C5B4-4172-8A1B-1D1CAF0A174D}"/>
+          <p:cNvPr id="17" name="">
+            <a:extLst xmlns:a="http://schemas.openxmlformats.org/drawingml/2006/main">
+              <a:ext uri="{FF2B5EF4-FFF2-40B4-BE49-F238E27FC236}">
+                <a16:creationId xmlns:a16="http://schemas.microsoft.com/office/drawing/2014/main" id="{3B53975F-C856-46CA-823E-BD42FDDBE47D}"/>
               </a:ext>
             </a:extLst>
           </p:cNvPr>
@@ -9862,10 +10014,10 @@
       </p:sp>
       <p:sp>
         <p:nvSpPr>
-          <p:cNvPr id="16" name="">
-            <a:extLst xmlns:a="http://schemas.openxmlformats.org/drawingml/2006/main">
-              <a:ext uri="{FF2B5EF4-FFF2-40B4-BE49-F238E27FC236}">
-                <a16:creationId xmlns:a16="http://schemas.microsoft.com/office/drawing/2014/main" id="{7F29A49F-D3B0-43F2-8C9D-B7AD29070B58}"/>
+          <p:cNvPr id="18" name="">
+            <a:extLst xmlns:a="http://schemas.openxmlformats.org/drawingml/2006/main">
+              <a:ext uri="{FF2B5EF4-FFF2-40B4-BE49-F238E27FC236}">
+                <a16:creationId xmlns:a16="http://schemas.microsoft.com/office/drawing/2014/main" id="{3E9995D6-DA30-440E-A87F-40361B391C6A}"/>
               </a:ext>
             </a:extLst>
           </p:cNvPr>
@@ -9877,45 +10029,146 @@
         <p:spPr>
           <a:xfrm xmlns:a="http://schemas.openxmlformats.org/drawingml/2006/main">
             <a:off x="7410450" y="3543300"/>
-            <a:ext cx="2381250" cy="666750"/>
-          </a:xfrm>
-          <a:prstGeom xmlns:a="http://schemas.openxmlformats.org/drawingml/2006/main" prst="rect">
-            <a:avLst/>
-          </a:prstGeom>
-          <a:noFill xmlns:a="http://schemas.openxmlformats.org/drawingml/2006/main"/>
-          <a:ln xmlns:a="http://schemas.openxmlformats.org/drawingml/2006/main" w="0">
-            <a:noFill/>
-            <a:prstDash val="solid"/>
-          </a:ln>
-        </p:spPr>
-        <p:txBody>
-          <a:bodyPr xmlns:a="http://schemas.openxmlformats.org/drawingml/2006/main"/>
-          <a:lstStyle xmlns:a="http://schemas.openxmlformats.org/drawingml/2006/main"/>
-          <a:p xmlns:a="http://schemas.openxmlformats.org/drawingml/2006/main">
-            <a:pPr>
-              <a:defRPr sz="1500" b="1">
+            <a:ext cx="2381250" cy="419100"/>
+          </a:xfrm>
+          <a:prstGeom xmlns:a="http://schemas.openxmlformats.org/drawingml/2006/main" prst="rect">
+            <a:avLst/>
+          </a:prstGeom>
+          <a:noFill xmlns:a="http://schemas.openxmlformats.org/drawingml/2006/main"/>
+          <a:ln xmlns:a="http://schemas.openxmlformats.org/drawingml/2006/main" w="0">
+            <a:noFill/>
+            <a:prstDash val="solid"/>
+          </a:ln>
+        </p:spPr>
+        <p:txBody>
+          <a:bodyPr xmlns:a="http://schemas.openxmlformats.org/drawingml/2006/main"/>
+          <a:lstStyle xmlns:a="http://schemas.openxmlformats.org/drawingml/2006/main"/>
+          <a:p xmlns:a="http://schemas.openxmlformats.org/drawingml/2006/main">
+            <a:pPr>
+              <a:defRPr sz="1275" b="1">
                 <a:solidFill>
                   <a:srgbClr val="142F4C"/>
                 </a:solidFill>
               </a:defRPr>
             </a:pPr>
             <a:r>
-              <a:rPr sz="1500" b="1">
+              <a:rPr sz="1275" b="1">
                 <a:solidFill>
                   <a:srgbClr val="142F4C"/>
                 </a:solidFill>
               </a:rPr>
-              <a:t>Option C: combine internal ownership with targeted specialist validation.</a:t>
-            </a:r>
-          </a:p>
-        </p:txBody>
-      </p:sp>
-      <p:sp>
-        <p:nvSpPr>
-          <p:cNvPr id="17" name="">
-            <a:extLst xmlns:a="http://schemas.openxmlformats.org/drawingml/2006/main">
-              <a:ext uri="{FF2B5EF4-FFF2-40B4-BE49-F238E27FC236}">
-                <a16:creationId xmlns:a16="http://schemas.microsoft.com/office/drawing/2014/main" id="{A08F20C9-9DA4-4032-85A7-2C68ED0929E4}"/>
+              <a:t>Option C - outsource monitoring to an external provider (rejected at current maturity: Kestrel cannot yet specify the indicator set it needs)</a:t>
+            </a:r>
+          </a:p>
+        </p:txBody>
+      </p:sp>
+      <p:sp>
+        <p:nvSpPr>
+          <p:cNvPr id="19" name="">
+            <a:extLst xmlns:a="http://schemas.openxmlformats.org/drawingml/2006/main">
+              <a:ext uri="{FF2B5EF4-FFF2-40B4-BE49-F238E27FC236}">
+                <a16:creationId xmlns:a16="http://schemas.microsoft.com/office/drawing/2014/main" id="{F8DEEC7D-8758-4F68-8F14-C32B880BD1F2}"/>
+              </a:ext>
+            </a:extLst>
+          </p:cNvPr>
+          <p:cNvSpPr>
+            <a:spLocks xmlns:a="http://schemas.openxmlformats.org/drawingml/2006/main" noGrp="1"/>
+          </p:cNvSpPr>
+          <p:nvPr/>
+        </p:nvSpPr>
+        <p:spPr>
+          <a:xfrm xmlns:a="http://schemas.openxmlformats.org/drawingml/2006/main">
+            <a:off x="7410450" y="4019550"/>
+            <a:ext cx="2381250" cy="628650"/>
+          </a:xfrm>
+          <a:prstGeom xmlns:a="http://schemas.openxmlformats.org/drawingml/2006/main" prst="rect">
+            <a:avLst/>
+          </a:prstGeom>
+          <a:noFill xmlns:a="http://schemas.openxmlformats.org/drawingml/2006/main"/>
+          <a:ln xmlns:a="http://schemas.openxmlformats.org/drawingml/2006/main" w="0">
+            <a:noFill/>
+            <a:prstDash val="solid"/>
+          </a:ln>
+        </p:spPr>
+        <p:txBody>
+          <a:bodyPr xmlns:a="http://schemas.openxmlformats.org/drawingml/2006/main"/>
+          <a:lstStyle xmlns:a="http://schemas.openxmlformats.org/drawingml/2006/main"/>
+          <a:p xmlns:a="http://schemas.openxmlformats.org/drawingml/2006/main">
+            <a:pPr>
+              <a:defRPr sz="900">
+                <a:solidFill>
+                  <a:srgbClr val="5A6B7C"/>
+                </a:solidFill>
+              </a:defRPr>
+            </a:pPr>
+            <a:r>
+              <a:rPr sz="900">
+                <a:solidFill>
+                  <a:srgbClr val="5A6B7C"/>
+                </a:solidFill>
+              </a:rPr>
+              <a:t>Cost: Cost and effort require management confirmation before approval.</a:t>
+            </a:r>
+          </a:p>
+          <a:p xmlns:a="http://schemas.openxmlformats.org/drawingml/2006/main">
+            <a:pPr>
+              <a:defRPr sz="900">
+                <a:solidFill>
+                  <a:srgbClr val="5A6B7C"/>
+                </a:solidFill>
+              </a:defRPr>
+            </a:pPr>
+            <a:r>
+              <a:rPr sz="900">
+                <a:solidFill>
+                  <a:srgbClr val="5A6B7C"/>
+                </a:solidFill>
+              </a:rPr>
+              <a:t>Benefit: Combines internal accountability with targeted specialist support.</a:t>
+            </a:r>
+          </a:p>
+          <a:p xmlns:a="http://schemas.openxmlformats.org/drawingml/2006/main">
+            <a:pPr>
+              <a:defRPr sz="900">
+                <a:solidFill>
+                  <a:srgbClr val="5A6B7C"/>
+                </a:solidFill>
+              </a:defRPr>
+            </a:pPr>
+            <a:r>
+              <a:rPr sz="900">
+                <a:solidFill>
+                  <a:srgbClr val="5A6B7C"/>
+                </a:solidFill>
+              </a:rPr>
+              <a:t>Trade-off: Needs explicit boundaries so ownership and escalation are not diluted.</a:t>
+            </a:r>
+          </a:p>
+          <a:p xmlns:a="http://schemas.openxmlformats.org/drawingml/2006/main">
+            <a:pPr>
+              <a:defRPr sz="900">
+                <a:solidFill>
+                  <a:srgbClr val="5A6B7C"/>
+                </a:solidFill>
+              </a:defRPr>
+            </a:pPr>
+            <a:r>
+              <a:rPr sz="900">
+                <a:solidFill>
+                  <a:srgbClr val="5A6B7C"/>
+                </a:solidFill>
+              </a:rPr>
+              <a:t>Rejection reason: rejected at current maturity: Kestrel cannot yet specify the indicator set it needs</a:t>
+            </a:r>
+          </a:p>
+        </p:txBody>
+      </p:sp>
+      <p:sp>
+        <p:nvSpPr>
+          <p:cNvPr id="20" name="">
+            <a:extLst xmlns:a="http://schemas.openxmlformats.org/drawingml/2006/main">
+              <a:ext uri="{FF2B5EF4-FFF2-40B4-BE49-F238E27FC236}">
+                <a16:creationId xmlns:a16="http://schemas.microsoft.com/office/drawing/2014/main" id="{27F175AC-FCDA-4F86-9E10-F4D4A568315E}"/>
               </a:ext>
             </a:extLst>
           </p:cNvPr>
@@ -9947,50 +10200,150 @@
       </p:sp>
       <p:sp>
         <p:nvSpPr>
-          <p:cNvPr id="18" name="">
-            <a:extLst xmlns:a="http://schemas.openxmlformats.org/drawingml/2006/main">
-              <a:ext uri="{FF2B5EF4-FFF2-40B4-BE49-F238E27FC236}">
-                <a16:creationId xmlns:a16="http://schemas.microsoft.com/office/drawing/2014/main" id="{2CA41098-D00B-45D6-B786-91DC28E45408}"/>
-              </a:ext>
-            </a:extLst>
-          </p:cNvPr>
-          <p:cNvSpPr>
-            <a:spLocks xmlns:a="http://schemas.openxmlformats.org/drawingml/2006/main" noGrp="1"/>
-          </p:cNvSpPr>
-          <p:nvPr/>
-        </p:nvSpPr>
-        <p:spPr>
-          <a:xfrm xmlns:a="http://schemas.openxmlformats.org/drawingml/2006/main">
-            <a:off x="1066800" y="5181600"/>
-            <a:ext cx="8667750" cy="342900"/>
-          </a:xfrm>
-          <a:prstGeom xmlns:a="http://schemas.openxmlformats.org/drawingml/2006/main" prst="rect">
-            <a:avLst/>
-          </a:prstGeom>
-          <a:noFill xmlns:a="http://schemas.openxmlformats.org/drawingml/2006/main"/>
-          <a:ln xmlns:a="http://schemas.openxmlformats.org/drawingml/2006/main" w="0">
-            <a:noFill/>
-            <a:prstDash val="solid"/>
-          </a:ln>
-        </p:spPr>
-        <p:txBody>
-          <a:bodyPr xmlns:a="http://schemas.openxmlformats.org/drawingml/2006/main"/>
-          <a:lstStyle xmlns:a="http://schemas.openxmlformats.org/drawingml/2006/main"/>
-          <a:p xmlns:a="http://schemas.openxmlformats.org/drawingml/2006/main">
-            <a:pPr>
-              <a:defRPr sz="1350">
+          <p:cNvPr id="21" name="">
+            <a:extLst xmlns:a="http://schemas.openxmlformats.org/drawingml/2006/main">
+              <a:ext uri="{FF2B5EF4-FFF2-40B4-BE49-F238E27FC236}">
+                <a16:creationId xmlns:a16="http://schemas.microsoft.com/office/drawing/2014/main" id="{1CA1A955-4BDD-4D12-A70E-7AF2409EC467}"/>
+              </a:ext>
+            </a:extLst>
+          </p:cNvPr>
+          <p:cNvSpPr>
+            <a:spLocks xmlns:a="http://schemas.openxmlformats.org/drawingml/2006/main" noGrp="1"/>
+          </p:cNvSpPr>
+          <p:nvPr/>
+        </p:nvSpPr>
+        <p:spPr>
+          <a:xfrm xmlns:a="http://schemas.openxmlformats.org/drawingml/2006/main">
+            <a:off x="1066800" y="5067300"/>
+            <a:ext cx="8667750" cy="190500"/>
+          </a:xfrm>
+          <a:prstGeom xmlns:a="http://schemas.openxmlformats.org/drawingml/2006/main" prst="rect">
+            <a:avLst/>
+          </a:prstGeom>
+          <a:noFill xmlns:a="http://schemas.openxmlformats.org/drawingml/2006/main"/>
+          <a:ln xmlns:a="http://schemas.openxmlformats.org/drawingml/2006/main" w="0">
+            <a:noFill/>
+            <a:prstDash val="solid"/>
+          </a:ln>
+        </p:spPr>
+        <p:txBody>
+          <a:bodyPr xmlns:a="http://schemas.openxmlformats.org/drawingml/2006/main"/>
+          <a:lstStyle xmlns:a="http://schemas.openxmlformats.org/drawingml/2006/main"/>
+          <a:p xmlns:a="http://schemas.openxmlformats.org/drawingml/2006/main">
+            <a:pPr>
+              <a:defRPr sz="975">
                 <a:solidFill>
                   <a:srgbClr val="142F4C"/>
                 </a:solidFill>
               </a:defRPr>
             </a:pPr>
             <a:r>
-              <a:rPr sz="1350">
+              <a:rPr sz="975">
                 <a:solidFill>
                   <a:srgbClr val="142F4C"/>
                 </a:solidFill>
               </a:rPr>
-              <a:t>Trade-off to record: Option B provides the fastest independent capability uplift but creates recurring cost and a handover dependency.</a:t>
+              <a:t>MK recommendation: Viable options considered. Option A - leave accountability with the Finance Director as the policy currently states. Trade-off:…</a:t>
+            </a:r>
+          </a:p>
+        </p:txBody>
+      </p:sp>
+      <p:sp>
+        <p:nvSpPr>
+          <p:cNvPr id="22" name="">
+            <a:extLst xmlns:a="http://schemas.openxmlformats.org/drawingml/2006/main">
+              <a:ext uri="{FF2B5EF4-FFF2-40B4-BE49-F238E27FC236}">
+                <a16:creationId xmlns:a16="http://schemas.microsoft.com/office/drawing/2014/main" id="{AC9C194D-71A1-44E4-B2B0-98399AB9E023}"/>
+              </a:ext>
+            </a:extLst>
+          </p:cNvPr>
+          <p:cNvSpPr>
+            <a:spLocks xmlns:a="http://schemas.openxmlformats.org/drawingml/2006/main" noGrp="1"/>
+          </p:cNvSpPr>
+          <p:nvPr/>
+        </p:nvSpPr>
+        <p:spPr>
+          <a:xfrm xmlns:a="http://schemas.openxmlformats.org/drawingml/2006/main">
+            <a:off x="1066800" y="5257800"/>
+            <a:ext cx="8667750" cy="190500"/>
+          </a:xfrm>
+          <a:prstGeom xmlns:a="http://schemas.openxmlformats.org/drawingml/2006/main" prst="rect">
+            <a:avLst/>
+          </a:prstGeom>
+          <a:noFill xmlns:a="http://schemas.openxmlformats.org/drawingml/2006/main"/>
+          <a:ln xmlns:a="http://schemas.openxmlformats.org/drawingml/2006/main" w="0">
+            <a:noFill/>
+            <a:prstDash val="solid"/>
+          </a:ln>
+        </p:spPr>
+        <p:txBody>
+          <a:bodyPr xmlns:a="http://schemas.openxmlformats.org/drawingml/2006/main"/>
+          <a:lstStyle xmlns:a="http://schemas.openxmlformats.org/drawingml/2006/main"/>
+          <a:p xmlns:a="http://schemas.openxmlformats.org/drawingml/2006/main">
+            <a:pPr>
+              <a:defRPr sz="975">
+                <a:solidFill>
+                  <a:srgbClr val="142F4C"/>
+                </a:solidFill>
+              </a:defRPr>
+            </a:pPr>
+            <a:r>
+              <a:rPr sz="975">
+                <a:solidFill>
+                  <a:srgbClr val="142F4C"/>
+                </a:solidFill>
+              </a:rPr>
+              <a:t>Recommendation rationale: The recommendation follows the linked deterministic finding and risk priorities; management must confirm the final route, cost and…</a:t>
+            </a:r>
+          </a:p>
+        </p:txBody>
+      </p:sp>
+      <p:sp>
+        <p:nvSpPr>
+          <p:cNvPr id="23" name="">
+            <a:extLst xmlns:a="http://schemas.openxmlformats.org/drawingml/2006/main">
+              <a:ext uri="{FF2B5EF4-FFF2-40B4-BE49-F238E27FC236}">
+                <a16:creationId xmlns:a16="http://schemas.microsoft.com/office/drawing/2014/main" id="{1243896E-2CA4-430D-8DC2-F76FD6ED0228}"/>
+              </a:ext>
+            </a:extLst>
+          </p:cNvPr>
+          <p:cNvSpPr>
+            <a:spLocks xmlns:a="http://schemas.openxmlformats.org/drawingml/2006/main" noGrp="1"/>
+          </p:cNvSpPr>
+          <p:nvPr/>
+        </p:nvSpPr>
+        <p:spPr>
+          <a:xfrm xmlns:a="http://schemas.openxmlformats.org/drawingml/2006/main">
+            <a:off x="1066800" y="5448300"/>
+            <a:ext cx="8667750" cy="171450"/>
+          </a:xfrm>
+          <a:prstGeom xmlns:a="http://schemas.openxmlformats.org/drawingml/2006/main" prst="rect">
+            <a:avLst/>
+          </a:prstGeom>
+          <a:noFill xmlns:a="http://schemas.openxmlformats.org/drawingml/2006/main"/>
+          <a:ln xmlns:a="http://schemas.openxmlformats.org/drawingml/2006/main" w="0">
+            <a:noFill/>
+            <a:prstDash val="solid"/>
+          </a:ln>
+        </p:spPr>
+        <p:txBody>
+          <a:bodyPr xmlns:a="http://schemas.openxmlformats.org/drawingml/2006/main"/>
+          <a:lstStyle xmlns:a="http://schemas.openxmlformats.org/drawingml/2006/main"/>
+          <a:p xmlns:a="http://schemas.openxmlformats.org/drawingml/2006/main">
+            <a:pPr>
+              <a:defRPr sz="975">
+                <a:solidFill>
+                  <a:srgbClr val="142F4C"/>
+                </a:solidFill>
+              </a:defRPr>
+            </a:pPr>
+            <a:r>
+              <a:rPr sz="975">
+                <a:solidFill>
+                  <a:srgbClr val="142F4C"/>
+                </a:solidFill>
+              </a:rPr>
+              <a:t>Owner: CEO / Managing Director · Deadline: 30 days</a:t>
             </a:r>
           </a:p>
         </p:txBody>
@@ -9998,7 +10351,7 @@
     </p:spTree>
     <p:extLst>
       <p:ext uri="{BB962C8B-B14F-4D97-AF65-F5344CB8AC3E}">
-        <p14:creationId xmlns:p14="http://schemas.microsoft.com/office/powerpoint/2010/main" val="832103088"/>
+        <p14:creationId xmlns:p14="http://schemas.microsoft.com/office/powerpoint/2010/main" val="1676871416"/>
       </p:ext>
     </p:extLst>
   </p:cSld>
@@ -10029,7 +10382,7 @@
           <p:cNvPr id="30" name="">
             <a:extLst xmlns:a="http://schemas.openxmlformats.org/drawingml/2006/main">
               <a:ext uri="{FF2B5EF4-FFF2-40B4-BE49-F238E27FC236}">
-                <a16:creationId xmlns:a16="http://schemas.microsoft.com/office/drawing/2014/main" id="{14CF539A-36C5-41FA-9CE2-537673BF13E7}"/>
+                <a16:creationId xmlns:a16="http://schemas.microsoft.com/office/drawing/2014/main" id="{C53CDAB7-45B1-4570-A241-9514A25548AA}"/>
               </a:ext>
             </a:extLst>
           </p:cNvPr>
@@ -10079,7 +10432,7 @@
           <p:cNvPr id="2" name="">
             <a:extLst xmlns:a="http://schemas.openxmlformats.org/drawingml/2006/main">
               <a:ext uri="{FF2B5EF4-FFF2-40B4-BE49-F238E27FC236}">
-                <a16:creationId xmlns:a16="http://schemas.microsoft.com/office/drawing/2014/main" id="{782F067D-9D94-4CF0-9A3A-7C9CC9C93E3F}"/>
+                <a16:creationId xmlns:a16="http://schemas.microsoft.com/office/drawing/2014/main" id="{7F46292A-5BE8-4CAA-9158-E4B16A258B3A}"/>
               </a:ext>
             </a:extLst>
           </p:cNvPr>
@@ -10119,7 +10472,7 @@
                   <a:srgbClr val="142F4C"/>
                 </a:solidFill>
               </a:rPr>
-              <a:t>The first 90 days should establish population, ownership and validate evidence.</a:t>
+              <a:t>The first 90 days should establish population, ownership and proof.</a:t>
             </a:r>
           </a:p>
         </p:txBody>
@@ -10129,7 +10482,7 @@
           <p:cNvPr id="3" name="">
             <a:extLst xmlns:a="http://schemas.openxmlformats.org/drawingml/2006/main">
               <a:ext uri="{FF2B5EF4-FFF2-40B4-BE49-F238E27FC236}">
-                <a16:creationId xmlns:a16="http://schemas.microsoft.com/office/drawing/2014/main" id="{F84D8543-C3F4-417D-99D8-C09B1D9646B0}"/>
+                <a16:creationId xmlns:a16="http://schemas.microsoft.com/office/drawing/2014/main" id="{42D80E31-B409-43E9-B2DE-B7C50E930D06}"/>
               </a:ext>
             </a:extLst>
           </p:cNvPr>
@@ -10179,7 +10532,7 @@
           <p:cNvPr id="4" name="">
             <a:extLst xmlns:a="http://schemas.openxmlformats.org/drawingml/2006/main">
               <a:ext uri="{FF2B5EF4-FFF2-40B4-BE49-F238E27FC236}">
-                <a16:creationId xmlns:a16="http://schemas.microsoft.com/office/drawing/2014/main" id="{B1A9B004-52C5-431F-9F16-9FA2A40A6B98}"/>
+                <a16:creationId xmlns:a16="http://schemas.microsoft.com/office/drawing/2014/main" id="{FB38F29A-8AA8-4BD5-9F9D-928CD2F601A2}"/>
               </a:ext>
             </a:extLst>
           </p:cNvPr>
@@ -10210,7 +10563,7 @@
           <p:cNvPr id="5" name="">
             <a:extLst xmlns:a="http://schemas.openxmlformats.org/drawingml/2006/main">
               <a:ext uri="{FF2B5EF4-FFF2-40B4-BE49-F238E27FC236}">
-                <a16:creationId xmlns:a16="http://schemas.microsoft.com/office/drawing/2014/main" id="{D63940FF-7164-47AA-ADC9-4C88B8CBBB11}"/>
+                <a16:creationId xmlns:a16="http://schemas.microsoft.com/office/drawing/2014/main" id="{03DA3849-EFA1-4B32-B9DA-D94CF090530E}"/>
               </a:ext>
             </a:extLst>
           </p:cNvPr>
@@ -10260,7 +10613,7 @@
           <p:cNvPr id="6" name="">
             <a:extLst xmlns:a="http://schemas.openxmlformats.org/drawingml/2006/main">
               <a:ext uri="{FF2B5EF4-FFF2-40B4-BE49-F238E27FC236}">
-                <a16:creationId xmlns:a16="http://schemas.microsoft.com/office/drawing/2014/main" id="{06392477-FD69-4C9D-8A29-6FB2813753B2}"/>
+                <a16:creationId xmlns:a16="http://schemas.microsoft.com/office/drawing/2014/main" id="{9BC56F33-4BD0-4A0B-8AB5-63EDA7ADA74A}"/>
               </a:ext>
             </a:extLst>
           </p:cNvPr>
@@ -10310,7 +10663,7 @@
           <p:cNvPr id="7" name="">
             <a:extLst xmlns:a="http://schemas.openxmlformats.org/drawingml/2006/main">
               <a:ext uri="{FF2B5EF4-FFF2-40B4-BE49-F238E27FC236}">
-                <a16:creationId xmlns:a16="http://schemas.microsoft.com/office/drawing/2014/main" id="{C8C1BD9C-5A7D-4AEC-A184-0CA3DDCAD343}"/>
+                <a16:creationId xmlns:a16="http://schemas.microsoft.com/office/drawing/2014/main" id="{65108431-5230-409E-9D86-482D39CF82DB}"/>
               </a:ext>
             </a:extLst>
           </p:cNvPr>
@@ -10345,7 +10698,7 @@
           <p:cNvPr id="8" name="">
             <a:extLst xmlns:a="http://schemas.openxmlformats.org/drawingml/2006/main">
               <a:ext uri="{FF2B5EF4-FFF2-40B4-BE49-F238E27FC236}">
-                <a16:creationId xmlns:a16="http://schemas.microsoft.com/office/drawing/2014/main" id="{9CD2B1A3-1C51-4CBE-B5F7-803838980893}"/>
+                <a16:creationId xmlns:a16="http://schemas.microsoft.com/office/drawing/2014/main" id="{61CB5E99-D0DE-4AF4-BFBB-6C9D653E35CD}"/>
               </a:ext>
             </a:extLst>
           </p:cNvPr>
@@ -10378,7 +10731,7 @@
           <p:cNvPr id="9" name="">
             <a:extLst xmlns:a="http://schemas.openxmlformats.org/drawingml/2006/main">
               <a:ext uri="{FF2B5EF4-FFF2-40B4-BE49-F238E27FC236}">
-                <a16:creationId xmlns:a16="http://schemas.microsoft.com/office/drawing/2014/main" id="{599608BD-D0E1-47BF-88FD-DA1324A39984}"/>
+                <a16:creationId xmlns:a16="http://schemas.microsoft.com/office/drawing/2014/main" id="{011286B1-C06B-4135-A0D8-42539FB6FD80}"/>
               </a:ext>
             </a:extLst>
           </p:cNvPr>
@@ -10428,7 +10781,7 @@
           <p:cNvPr id="10" name="">
             <a:extLst xmlns:a="http://schemas.openxmlformats.org/drawingml/2006/main">
               <a:ext uri="{FF2B5EF4-FFF2-40B4-BE49-F238E27FC236}">
-                <a16:creationId xmlns:a16="http://schemas.microsoft.com/office/drawing/2014/main" id="{078D7C75-5242-4AE2-9930-0FC05DA87DED}"/>
+                <a16:creationId xmlns:a16="http://schemas.microsoft.com/office/drawing/2014/main" id="{361745C8-6408-4AD0-A85C-9E307830781B}"/>
               </a:ext>
             </a:extLst>
           </p:cNvPr>
@@ -10461,7 +10814,7 @@
           <p:cNvPr id="11" name="">
             <a:extLst xmlns:a="http://schemas.openxmlformats.org/drawingml/2006/main">
               <a:ext uri="{FF2B5EF4-FFF2-40B4-BE49-F238E27FC236}">
-                <a16:creationId xmlns:a16="http://schemas.microsoft.com/office/drawing/2014/main" id="{E226E25E-542F-4546-89D4-9861CEA2196B}"/>
+                <a16:creationId xmlns:a16="http://schemas.microsoft.com/office/drawing/2014/main" id="{FE831D9C-FD7B-4087-A321-A777BFF73422}"/>
               </a:ext>
             </a:extLst>
           </p:cNvPr>
@@ -10501,7 +10854,7 @@
                   <a:srgbClr val="1A2634"/>
                 </a:solidFill>
               </a:rPr>
-              <a:t>Approve the detection ownership mandate and first evidence cycle.</a:t>
+              <a:t>The CEO and audit-committee chair must approve a RACI that assigns control operation to management and risk owners,…</a:t>
             </a:r>
           </a:p>
         </p:txBody>
@@ -10511,7 +10864,7 @@
           <p:cNvPr id="12" name="">
             <a:extLst xmlns:a="http://schemas.openxmlformats.org/drawingml/2006/main">
               <a:ext uri="{FF2B5EF4-FFF2-40B4-BE49-F238E27FC236}">
-                <a16:creationId xmlns:a16="http://schemas.microsoft.com/office/drawing/2014/main" id="{8E481755-BD0A-40AB-B2B8-9C22C0B1C487}"/>
+                <a16:creationId xmlns:a16="http://schemas.microsoft.com/office/drawing/2014/main" id="{901654F2-D941-4B96-85D6-D2F446957657}"/>
               </a:ext>
             </a:extLst>
           </p:cNvPr>
@@ -10544,7 +10897,7 @@
           <p:cNvPr id="13" name="">
             <a:extLst xmlns:a="http://schemas.openxmlformats.org/drawingml/2006/main">
               <a:ext uri="{FF2B5EF4-FFF2-40B4-BE49-F238E27FC236}">
-                <a16:creationId xmlns:a16="http://schemas.microsoft.com/office/drawing/2014/main" id="{894A0CFD-B8A0-4D0A-AEB2-A8CEEC1C0236}"/>
+                <a16:creationId xmlns:a16="http://schemas.microsoft.com/office/drawing/2014/main" id="{6840C705-D5E5-4605-B70D-3C05328BC39F}"/>
               </a:ext>
             </a:extLst>
           </p:cNvPr>
@@ -10584,7 +10937,7 @@
                   <a:srgbClr val="1A2634"/>
                 </a:solidFill>
               </a:rPr>
-              <a:t>Run the first fixed-cycle detection tuning review.</a:t>
+              <a:t>The Head of Risk must publish escalation criteria defining what must be escalated, to whom and within what…</a:t>
             </a:r>
           </a:p>
         </p:txBody>
@@ -10594,7 +10947,7 @@
           <p:cNvPr id="14" name="">
             <a:extLst xmlns:a="http://schemas.openxmlformats.org/drawingml/2006/main">
               <a:ext uri="{FF2B5EF4-FFF2-40B4-BE49-F238E27FC236}">
-                <a16:creationId xmlns:a16="http://schemas.microsoft.com/office/drawing/2014/main" id="{83EE14D5-BD78-45F1-9D41-DB94117FD412}"/>
+                <a16:creationId xmlns:a16="http://schemas.microsoft.com/office/drawing/2014/main" id="{4057BBE0-AA88-40D2-9643-C88B9BB7FC64}"/>
               </a:ext>
             </a:extLst>
           </p:cNvPr>
@@ -10627,7 +10980,7 @@
           <p:cNvPr id="15" name="">
             <a:extLst xmlns:a="http://schemas.openxmlformats.org/drawingml/2006/main">
               <a:ext uri="{FF2B5EF4-FFF2-40B4-BE49-F238E27FC236}">
-                <a16:creationId xmlns:a16="http://schemas.microsoft.com/office/drawing/2014/main" id="{272D8E08-EE24-42CC-AB9A-4A9DDE5D6040}"/>
+                <a16:creationId xmlns:a16="http://schemas.microsoft.com/office/drawing/2014/main" id="{CB1871BF-B7EF-4B42-BC61-46B8C8687ECA}"/>
               </a:ext>
             </a:extLst>
           </p:cNvPr>
@@ -10667,7 +11020,7 @@
                   <a:srgbClr val="1A2634"/>
                 </a:solidFill>
               </a:rPr>
-              <a:t>Review segregation-of-duties overrides and expiry.</a:t>
+              <a:t>The ethics owner must publish reporting routes in plain language across the channels the workforce actually uses —…</a:t>
             </a:r>
           </a:p>
         </p:txBody>
@@ -10677,7 +11030,7 @@
           <p:cNvPr id="16" name="">
             <a:extLst xmlns:a="http://schemas.openxmlformats.org/drawingml/2006/main">
               <a:ext uri="{FF2B5EF4-FFF2-40B4-BE49-F238E27FC236}">
-                <a16:creationId xmlns:a16="http://schemas.microsoft.com/office/drawing/2014/main" id="{D7A6480E-B026-4ADC-898A-93A83067CCF2}"/>
+                <a16:creationId xmlns:a16="http://schemas.microsoft.com/office/drawing/2014/main" id="{D2EB16F4-4974-415B-BACC-CC1658020D5C}"/>
               </a:ext>
             </a:extLst>
           </p:cNvPr>
@@ -10712,7 +11065,7 @@
           <p:cNvPr id="17" name="">
             <a:extLst xmlns:a="http://schemas.openxmlformats.org/drawingml/2006/main">
               <a:ext uri="{FF2B5EF4-FFF2-40B4-BE49-F238E27FC236}">
-                <a16:creationId xmlns:a16="http://schemas.microsoft.com/office/drawing/2014/main" id="{54EBBFA5-1E70-43D0-80C2-BE77E6079C26}"/>
+                <a16:creationId xmlns:a16="http://schemas.microsoft.com/office/drawing/2014/main" id="{CCDD7697-8007-4C5B-98A5-B113C134187F}"/>
               </a:ext>
             </a:extLst>
           </p:cNvPr>
@@ -10745,7 +11098,7 @@
           <p:cNvPr id="18" name="">
             <a:extLst xmlns:a="http://schemas.openxmlformats.org/drawingml/2006/main">
               <a:ext uri="{FF2B5EF4-FFF2-40B4-BE49-F238E27FC236}">
-                <a16:creationId xmlns:a16="http://schemas.microsoft.com/office/drawing/2014/main" id="{EB1C7394-CEFD-4641-B6C2-38222A694889}"/>
+                <a16:creationId xmlns:a16="http://schemas.microsoft.com/office/drawing/2014/main" id="{6901DE07-0645-4216-B106-47112329145E}"/>
               </a:ext>
             </a:extLst>
           </p:cNvPr>
@@ -10795,7 +11148,7 @@
           <p:cNvPr id="19" name="">
             <a:extLst xmlns:a="http://schemas.openxmlformats.org/drawingml/2006/main">
               <a:ext uri="{FF2B5EF4-FFF2-40B4-BE49-F238E27FC236}">
-                <a16:creationId xmlns:a16="http://schemas.microsoft.com/office/drawing/2014/main" id="{281BB8D4-C630-47A5-AA36-BE356B1F3F24}"/>
+                <a16:creationId xmlns:a16="http://schemas.microsoft.com/office/drawing/2014/main" id="{755E0D4B-81E8-4953-BF9D-16A1F7FFF6DD}"/>
               </a:ext>
             </a:extLst>
           </p:cNvPr>
@@ -10828,7 +11181,7 @@
           <p:cNvPr id="20" name="">
             <a:extLst xmlns:a="http://schemas.openxmlformats.org/drawingml/2006/main">
               <a:ext uri="{FF2B5EF4-FFF2-40B4-BE49-F238E27FC236}">
-                <a16:creationId xmlns:a16="http://schemas.microsoft.com/office/drawing/2014/main" id="{69C742E2-2501-4758-9286-C10CA1AAB647}"/>
+                <a16:creationId xmlns:a16="http://schemas.microsoft.com/office/drawing/2014/main" id="{26CC047A-FC00-467B-B5FF-0A9796319060}"/>
               </a:ext>
             </a:extLst>
           </p:cNvPr>
@@ -10868,7 +11221,7 @@
                   <a:srgbClr val="1A2634"/>
                 </a:solidFill>
               </a:rPr>
-              <a:t>Reconcile supplier bank-detail changes and add independent verification.</a:t>
+              <a:t>IT Security maintains a complete privileged-account register, links each human and service account to an owner and approved…</a:t>
             </a:r>
           </a:p>
         </p:txBody>
@@ -10878,7 +11231,7 @@
           <p:cNvPr id="21" name="">
             <a:extLst xmlns:a="http://schemas.openxmlformats.org/drawingml/2006/main">
               <a:ext uri="{FF2B5EF4-FFF2-40B4-BE49-F238E27FC236}">
-                <a16:creationId xmlns:a16="http://schemas.microsoft.com/office/drawing/2014/main" id="{EF199FE2-B282-4DA2-97B0-3CF4AAEFD313}"/>
+                <a16:creationId xmlns:a16="http://schemas.microsoft.com/office/drawing/2014/main" id="{0F4F79AF-CEC6-4552-9424-6406EDCB4753}"/>
               </a:ext>
             </a:extLst>
           </p:cNvPr>
@@ -10911,7 +11264,7 @@
           <p:cNvPr id="22" name="">
             <a:extLst xmlns:a="http://schemas.openxmlformats.org/drawingml/2006/main">
               <a:ext uri="{FF2B5EF4-FFF2-40B4-BE49-F238E27FC236}">
-                <a16:creationId xmlns:a16="http://schemas.microsoft.com/office/drawing/2014/main" id="{B8C4B7EC-ABDF-4ACA-8D76-3563241F4172}"/>
+                <a16:creationId xmlns:a16="http://schemas.microsoft.com/office/drawing/2014/main" id="{0FE756E5-708E-46A3-9649-680A6B0AF197}"/>
               </a:ext>
             </a:extLst>
           </p:cNvPr>
@@ -10951,7 +11304,7 @@
                   <a:srgbClr val="1A2634"/>
                 </a:solidFill>
               </a:rPr>
-              <a:t>Reconcile role-based awareness coverage.</a:t>
+              <a:t>The process owner must define the risk points requiring verification — customer or beneficiary enrolment, employee onboarding, supplier…</a:t>
             </a:r>
           </a:p>
         </p:txBody>
@@ -10961,7 +11314,7 @@
           <p:cNvPr id="23" name="">
             <a:extLst xmlns:a="http://schemas.openxmlformats.org/drawingml/2006/main">
               <a:ext uri="{FF2B5EF4-FFF2-40B4-BE49-F238E27FC236}">
-                <a16:creationId xmlns:a16="http://schemas.microsoft.com/office/drawing/2014/main" id="{CCC3A27F-12C0-4C0D-AAD1-7E285DF95263}"/>
+                <a16:creationId xmlns:a16="http://schemas.microsoft.com/office/drawing/2014/main" id="{E2C19006-D19A-4C6E-AD91-B5E97D856C05}"/>
               </a:ext>
             </a:extLst>
           </p:cNvPr>
@@ -10994,7 +11347,7 @@
           <p:cNvPr id="24" name="">
             <a:extLst xmlns:a="http://schemas.openxmlformats.org/drawingml/2006/main">
               <a:ext uri="{FF2B5EF4-FFF2-40B4-BE49-F238E27FC236}">
-                <a16:creationId xmlns:a16="http://schemas.microsoft.com/office/drawing/2014/main" id="{4506C593-08CD-4809-9E7C-6DE070B57575}"/>
+                <a16:creationId xmlns:a16="http://schemas.microsoft.com/office/drawing/2014/main" id="{AAB2FD2B-A2A8-4A18-9D82-13E8B3382621}"/>
               </a:ext>
             </a:extLst>
           </p:cNvPr>
@@ -11034,7 +11387,7 @@
                   <a:srgbClr val="1A2634"/>
                 </a:solidFill>
               </a:rPr>
-              <a:t>Link incident closure to root cause and control improvement.</a:t>
+              <a:t>The investigation lead opens an evidence register for every material case; trained custodians identify sources, create forensic copies…</a:t>
             </a:r>
           </a:p>
         </p:txBody>
@@ -11044,7 +11397,7 @@
           <p:cNvPr id="25" name="">
             <a:extLst xmlns:a="http://schemas.openxmlformats.org/drawingml/2006/main">
               <a:ext uri="{FF2B5EF4-FFF2-40B4-BE49-F238E27FC236}">
-                <a16:creationId xmlns:a16="http://schemas.microsoft.com/office/drawing/2014/main" id="{09EB7BC4-30FB-42C0-B8B4-F42D5385B7EA}"/>
+                <a16:creationId xmlns:a16="http://schemas.microsoft.com/office/drawing/2014/main" id="{2398FCD4-D692-41C2-8DF6-F62C90D9FA85}"/>
               </a:ext>
             </a:extLst>
           </p:cNvPr>
@@ -11079,7 +11432,7 @@
           <p:cNvPr id="26" name="">
             <a:extLst xmlns:a="http://schemas.openxmlformats.org/drawingml/2006/main">
               <a:ext uri="{FF2B5EF4-FFF2-40B4-BE49-F238E27FC236}">
-                <a16:creationId xmlns:a16="http://schemas.microsoft.com/office/drawing/2014/main" id="{953F2B34-D105-4948-89EF-ED69697E8494}"/>
+                <a16:creationId xmlns:a16="http://schemas.microsoft.com/office/drawing/2014/main" id="{CEFFF89B-AD13-4FCB-9A8C-47A3F2CE0EDE}"/>
               </a:ext>
             </a:extLst>
           </p:cNvPr>
@@ -11112,7 +11465,7 @@
           <p:cNvPr id="27" name="">
             <a:extLst xmlns:a="http://schemas.openxmlformats.org/drawingml/2006/main">
               <a:ext uri="{FF2B5EF4-FFF2-40B4-BE49-F238E27FC236}">
-                <a16:creationId xmlns:a16="http://schemas.microsoft.com/office/drawing/2014/main" id="{19296343-7BD7-452E-BC7E-D3CE2EAA6E9D}"/>
+                <a16:creationId xmlns:a16="http://schemas.microsoft.com/office/drawing/2014/main" id="{1F62F1EF-4084-40BD-B0A5-C76D15E1E66A}"/>
               </a:ext>
             </a:extLst>
           </p:cNvPr>
@@ -11162,7 +11515,7 @@
           <p:cNvPr id="28" name="">
             <a:extLst xmlns:a="http://schemas.openxmlformats.org/drawingml/2006/main">
               <a:ext uri="{FF2B5EF4-FFF2-40B4-BE49-F238E27FC236}">
-                <a16:creationId xmlns:a16="http://schemas.microsoft.com/office/drawing/2014/main" id="{95DB30CA-E84F-4901-8CA5-35FAD1CB8549}"/>
+                <a16:creationId xmlns:a16="http://schemas.microsoft.com/office/drawing/2014/main" id="{B089555E-41D6-4CD6-BCC9-8187EFA02101}"/>
               </a:ext>
             </a:extLst>
           </p:cNvPr>
@@ -11195,7 +11548,7 @@
           <p:cNvPr id="29" name="">
             <a:extLst xmlns:a="http://schemas.openxmlformats.org/drawingml/2006/main">
               <a:ext uri="{FF2B5EF4-FFF2-40B4-BE49-F238E27FC236}">
-                <a16:creationId xmlns:a16="http://schemas.microsoft.com/office/drawing/2014/main" id="{AAC2C1BD-1DBB-4EF1-BB78-2A101EB7D7AA}"/>
+                <a16:creationId xmlns:a16="http://schemas.microsoft.com/office/drawing/2014/main" id="{0C728B78-1BA1-4586-A2AF-FBE270AFC1CD}"/>
               </a:ext>
             </a:extLst>
           </p:cNvPr>
@@ -11235,7 +11588,7 @@
                   <a:srgbClr val="1A2634"/>
                 </a:solidFill>
               </a:rPr>
-              <a:t>Approve the detection ownership mandate and first evidence cycle.</a:t>
+              <a:t>No committed actions recorded for this period.</a:t>
             </a:r>
           </a:p>
         </p:txBody>
@@ -11243,7 +11596,7 @@
     </p:spTree>
     <p:extLst>
       <p:ext uri="{BB962C8B-B14F-4D97-AF65-F5344CB8AC3E}">
-        <p14:creationId xmlns:p14="http://schemas.microsoft.com/office/powerpoint/2010/main" val="1891488876"/>
+        <p14:creationId xmlns:p14="http://schemas.microsoft.com/office/powerpoint/2010/main" val="551909309"/>
       </p:ext>
     </p:extLst>
   </p:cSld>
@@ -11274,7 +11627,7 @@
           <p:cNvPr id="35" name="">
             <a:extLst xmlns:a="http://schemas.openxmlformats.org/drawingml/2006/main">
               <a:ext uri="{FF2B5EF4-FFF2-40B4-BE49-F238E27FC236}">
-                <a16:creationId xmlns:a16="http://schemas.microsoft.com/office/drawing/2014/main" id="{25B095A5-F85D-4A8E-BECB-14F929F68C1B}"/>
+                <a16:creationId xmlns:a16="http://schemas.microsoft.com/office/drawing/2014/main" id="{E62D8FDA-0B1A-4CE0-9869-27A046229F53}"/>
               </a:ext>
             </a:extLst>
           </p:cNvPr>
@@ -11324,7 +11677,7 @@
           <p:cNvPr id="2" name="">
             <a:extLst xmlns:a="http://schemas.openxmlformats.org/drawingml/2006/main">
               <a:ext uri="{FF2B5EF4-FFF2-40B4-BE49-F238E27FC236}">
-                <a16:creationId xmlns:a16="http://schemas.microsoft.com/office/drawing/2014/main" id="{31F311EA-C8FB-4816-913C-DD9FE198DDC9}"/>
+                <a16:creationId xmlns:a16="http://schemas.microsoft.com/office/drawing/2014/main" id="{0BC1E598-0C61-4354-A9CA-8F74F66988B1}"/>
               </a:ext>
             </a:extLst>
           </p:cNvPr>
@@ -11374,7 +11727,7 @@
           <p:cNvPr id="3" name="">
             <a:extLst xmlns:a="http://schemas.openxmlformats.org/drawingml/2006/main">
               <a:ext uri="{FF2B5EF4-FFF2-40B4-BE49-F238E27FC236}">
-                <a16:creationId xmlns:a16="http://schemas.microsoft.com/office/drawing/2014/main" id="{9834F271-0966-4C19-9A96-ABE8C054E61A}"/>
+                <a16:creationId xmlns:a16="http://schemas.microsoft.com/office/drawing/2014/main" id="{A55D80B6-885A-41C0-8322-D4B3EC870D5B}"/>
               </a:ext>
             </a:extLst>
           </p:cNvPr>
@@ -11424,7 +11777,7 @@
           <p:cNvPr id="4" name="">
             <a:extLst xmlns:a="http://schemas.openxmlformats.org/drawingml/2006/main">
               <a:ext uri="{FF2B5EF4-FFF2-40B4-BE49-F238E27FC236}">
-                <a16:creationId xmlns:a16="http://schemas.microsoft.com/office/drawing/2014/main" id="{0F1FDF4F-D90B-462C-B06A-6530EA5157B3}"/>
+                <a16:creationId xmlns:a16="http://schemas.microsoft.com/office/drawing/2014/main" id="{17904AEE-999C-48D0-BA20-66F4FA1A78E9}"/>
               </a:ext>
             </a:extLst>
           </p:cNvPr>
@@ -11455,7 +11808,7 @@
           <p:cNvPr id="5" name="">
             <a:extLst xmlns:a="http://schemas.openxmlformats.org/drawingml/2006/main">
               <a:ext uri="{FF2B5EF4-FFF2-40B4-BE49-F238E27FC236}">
-                <a16:creationId xmlns:a16="http://schemas.microsoft.com/office/drawing/2014/main" id="{CC067BB4-90F9-4FA9-A707-0F5479F02ED4}"/>
+                <a16:creationId xmlns:a16="http://schemas.microsoft.com/office/drawing/2014/main" id="{81920C4C-413F-4666-83F5-EDEDADFCD44F}"/>
               </a:ext>
             </a:extLst>
           </p:cNvPr>
@@ -11505,7 +11858,7 @@
           <p:cNvPr id="6" name="">
             <a:extLst xmlns:a="http://schemas.openxmlformats.org/drawingml/2006/main">
               <a:ext uri="{FF2B5EF4-FFF2-40B4-BE49-F238E27FC236}">
-                <a16:creationId xmlns:a16="http://schemas.microsoft.com/office/drawing/2014/main" id="{5C16B903-D3D9-431B-AEDC-9FE22086F6AB}"/>
+                <a16:creationId xmlns:a16="http://schemas.microsoft.com/office/drawing/2014/main" id="{25E39E66-59E4-437D-995A-8EB8040BDDAD}"/>
               </a:ext>
             </a:extLst>
           </p:cNvPr>
@@ -11555,7 +11908,7 @@
           <p:cNvPr id="7" name="">
             <a:extLst xmlns:a="http://schemas.openxmlformats.org/drawingml/2006/main">
               <a:ext uri="{FF2B5EF4-FFF2-40B4-BE49-F238E27FC236}">
-                <a16:creationId xmlns:a16="http://schemas.microsoft.com/office/drawing/2014/main" id="{96A41F0F-8196-461E-B25D-3AA08C3A0C77}"/>
+                <a16:creationId xmlns:a16="http://schemas.microsoft.com/office/drawing/2014/main" id="{B677A021-E574-4C69-AF9B-FB6D2EA8E4A4}"/>
               </a:ext>
             </a:extLst>
           </p:cNvPr>
@@ -11586,7 +11939,7 @@
           <p:cNvPr id="8" name="">
             <a:extLst xmlns:a="http://schemas.openxmlformats.org/drawingml/2006/main">
               <a:ext uri="{FF2B5EF4-FFF2-40B4-BE49-F238E27FC236}">
-                <a16:creationId xmlns:a16="http://schemas.microsoft.com/office/drawing/2014/main" id="{6A84FE6A-62C8-421A-8C7C-8E2C8ACB7091}"/>
+                <a16:creationId xmlns:a16="http://schemas.microsoft.com/office/drawing/2014/main" id="{3B621E58-47F3-47D7-89D5-A9D6986428F1}"/>
               </a:ext>
             </a:extLst>
           </p:cNvPr>
@@ -11614,19 +11967,19 @@
           <a:lstStyle xmlns:a="http://schemas.openxmlformats.org/drawingml/2006/main"/>
           <a:p xmlns:a="http://schemas.openxmlformats.org/drawingml/2006/main">
             <a:pPr>
-              <a:defRPr sz="1275" b="1">
+              <a:defRPr sz="1125" b="1">
                 <a:solidFill>
                   <a:srgbClr val="142F4C"/>
                 </a:solidFill>
               </a:defRPr>
             </a:pPr>
             <a:r>
-              <a:rPr sz="1275" b="1">
+              <a:rPr sz="1125" b="1">
                 <a:solidFill>
                   <a:srgbClr val="142F4C"/>
                 </a:solidFill>
               </a:rPr>
-              <a:t>Approve the detection ownership mandate and first evidence cycle.</a:t>
+              <a:t>The CEO and audit-committee chair must approve a RACI that assigns control operation to management and risk owners,…</a:t>
             </a:r>
           </a:p>
         </p:txBody>
@@ -11636,7 +11989,7 @@
           <p:cNvPr id="9" name="">
             <a:extLst xmlns:a="http://schemas.openxmlformats.org/drawingml/2006/main">
               <a:ext uri="{FF2B5EF4-FFF2-40B4-BE49-F238E27FC236}">
-                <a16:creationId xmlns:a16="http://schemas.microsoft.com/office/drawing/2014/main" id="{E1FB1FFC-2B5C-4BAE-B82F-E0E811F63644}"/>
+                <a16:creationId xmlns:a16="http://schemas.microsoft.com/office/drawing/2014/main" id="{11221F50-EF2E-443D-84C7-2B5BBAC51171}"/>
               </a:ext>
             </a:extLst>
           </p:cNvPr>
@@ -11676,7 +12029,7 @@
                   <a:srgbClr val="1A2634"/>
                 </a:solidFill>
               </a:rPr>
-              <a:t>Financial Controller</a:t>
+              <a:t>CEO / Managing Director</a:t>
             </a:r>
           </a:p>
         </p:txBody>
@@ -11686,7 +12039,7 @@
           <p:cNvPr id="10" name="">
             <a:extLst xmlns:a="http://schemas.openxmlformats.org/drawingml/2006/main">
               <a:ext uri="{FF2B5EF4-FFF2-40B4-BE49-F238E27FC236}">
-                <a16:creationId xmlns:a16="http://schemas.microsoft.com/office/drawing/2014/main" id="{A872651C-4B6E-4A16-BD2F-FD2D5C6FE0B8}"/>
+                <a16:creationId xmlns:a16="http://schemas.microsoft.com/office/drawing/2014/main" id="{FE4866E0-9EA2-4CCE-88DD-3E5F3381AEB9}"/>
               </a:ext>
             </a:extLst>
           </p:cNvPr>
@@ -11736,7 +12089,7 @@
           <p:cNvPr id="11" name="">
             <a:extLst xmlns:a="http://schemas.openxmlformats.org/drawingml/2006/main">
               <a:ext uri="{FF2B5EF4-FFF2-40B4-BE49-F238E27FC236}">
-                <a16:creationId xmlns:a16="http://schemas.microsoft.com/office/drawing/2014/main" id="{FC4EC274-EA14-4947-BF4E-4DACED03F31A}"/>
+                <a16:creationId xmlns:a16="http://schemas.microsoft.com/office/drawing/2014/main" id="{7BD3CD45-D910-4075-BD4C-39D66578FE55}"/>
               </a:ext>
             </a:extLst>
           </p:cNvPr>
@@ -11776,7 +12129,7 @@
                   <a:srgbClr val="5A6B7C"/>
                 </a:solidFill>
               </a:rPr>
-              <a:t>100% of in-scope access reviewed.</a:t>
+              <a:t>No key fraud control is both operated and independently certified by the same accountable function.</a:t>
             </a:r>
           </a:p>
         </p:txBody>
@@ -11786,7 +12139,7 @@
           <p:cNvPr id="12" name="">
             <a:extLst xmlns:a="http://schemas.openxmlformats.org/drawingml/2006/main">
               <a:ext uri="{FF2B5EF4-FFF2-40B4-BE49-F238E27FC236}">
-                <a16:creationId xmlns:a16="http://schemas.microsoft.com/office/drawing/2014/main" id="{99A41198-A522-42E2-8A7F-2FE39F1A1AB0}"/>
+                <a16:creationId xmlns:a16="http://schemas.microsoft.com/office/drawing/2014/main" id="{B587DB79-C7C4-4130-AE77-0E89023B4699}"/>
               </a:ext>
             </a:extLst>
           </p:cNvPr>
@@ -11817,7 +12170,7 @@
           <p:cNvPr id="13" name="">
             <a:extLst xmlns:a="http://schemas.openxmlformats.org/drawingml/2006/main">
               <a:ext uri="{FF2B5EF4-FFF2-40B4-BE49-F238E27FC236}">
-                <a16:creationId xmlns:a16="http://schemas.microsoft.com/office/drawing/2014/main" id="{AFAD2DF1-65A2-4103-9805-D949FADF3D84}"/>
+                <a16:creationId xmlns:a16="http://schemas.microsoft.com/office/drawing/2014/main" id="{2FD35E16-97E4-476E-B76E-777F1EA96ACC}"/>
               </a:ext>
             </a:extLst>
           </p:cNvPr>
@@ -11845,19 +12198,19 @@
           <a:lstStyle xmlns:a="http://schemas.openxmlformats.org/drawingml/2006/main"/>
           <a:p xmlns:a="http://schemas.openxmlformats.org/drawingml/2006/main">
             <a:pPr>
-              <a:defRPr sz="1275" b="1">
+              <a:defRPr sz="1125" b="1">
                 <a:solidFill>
                   <a:srgbClr val="142F4C"/>
                 </a:solidFill>
               </a:defRPr>
             </a:pPr>
             <a:r>
-              <a:rPr sz="1275" b="1">
+              <a:rPr sz="1125" b="1">
                 <a:solidFill>
                   <a:srgbClr val="142F4C"/>
                 </a:solidFill>
               </a:rPr>
-              <a:t>Run the first fixed-cycle detection tuning review.</a:t>
+              <a:t>The Head of Risk must publish escalation criteria defining what must be escalated, to whom and within what…</a:t>
             </a:r>
           </a:p>
         </p:txBody>
@@ -11867,7 +12220,7 @@
           <p:cNvPr id="14" name="">
             <a:extLst xmlns:a="http://schemas.openxmlformats.org/drawingml/2006/main">
               <a:ext uri="{FF2B5EF4-FFF2-40B4-BE49-F238E27FC236}">
-                <a16:creationId xmlns:a16="http://schemas.microsoft.com/office/drawing/2014/main" id="{3F8CC41E-910A-475E-AFB0-2D94C6B599D2}"/>
+                <a16:creationId xmlns:a16="http://schemas.microsoft.com/office/drawing/2014/main" id="{F60CA730-6860-443B-8801-F9A8CFD8F43E}"/>
               </a:ext>
             </a:extLst>
           </p:cNvPr>
@@ -11907,7 +12260,7 @@
                   <a:srgbClr val="1A2634"/>
                 </a:solidFill>
               </a:rPr>
-              <a:t>Chief Information Officer</a:t>
+              <a:t>Head of Risk</a:t>
             </a:r>
           </a:p>
         </p:txBody>
@@ -11917,7 +12270,7 @@
           <p:cNvPr id="15" name="">
             <a:extLst xmlns:a="http://schemas.openxmlformats.org/drawingml/2006/main">
               <a:ext uri="{FF2B5EF4-FFF2-40B4-BE49-F238E27FC236}">
-                <a16:creationId xmlns:a16="http://schemas.microsoft.com/office/drawing/2014/main" id="{4EA66A71-DF36-4ABA-9BDB-7B44E48BC0CB}"/>
+                <a16:creationId xmlns:a16="http://schemas.microsoft.com/office/drawing/2014/main" id="{A21D1653-9FA2-43D0-946C-7193BBB298E2}"/>
               </a:ext>
             </a:extLst>
           </p:cNvPr>
@@ -11967,7 +12320,7 @@
           <p:cNvPr id="16" name="">
             <a:extLst xmlns:a="http://schemas.openxmlformats.org/drawingml/2006/main">
               <a:ext uri="{FF2B5EF4-FFF2-40B4-BE49-F238E27FC236}">
-                <a16:creationId xmlns:a16="http://schemas.microsoft.com/office/drawing/2014/main" id="{80DF0FE5-7BF5-4245-96E0-C1E5639D6372}"/>
+                <a16:creationId xmlns:a16="http://schemas.microsoft.com/office/drawing/2014/main" id="{F682F86B-9DE0-4874-A667-772492F0C316}"/>
               </a:ext>
             </a:extLst>
           </p:cNvPr>
@@ -12007,7 +12360,7 @@
                   <a:srgbClr val="5A6B7C"/>
                 </a:solidFill>
               </a:rPr>
-              <a:t>100% of in-scope access reviewed.</a:t>
+              <a:t>100% of qualifying matters escalated within the stated timeframe, with an available conflict-free route.</a:t>
             </a:r>
           </a:p>
         </p:txBody>
@@ -12017,7 +12370,7 @@
           <p:cNvPr id="17" name="">
             <a:extLst xmlns:a="http://schemas.openxmlformats.org/drawingml/2006/main">
               <a:ext uri="{FF2B5EF4-FFF2-40B4-BE49-F238E27FC236}">
-                <a16:creationId xmlns:a16="http://schemas.microsoft.com/office/drawing/2014/main" id="{43D0EC43-65E2-47E2-AE25-E43A4C78191E}"/>
+                <a16:creationId xmlns:a16="http://schemas.microsoft.com/office/drawing/2014/main" id="{9FA5F53E-8DB8-4B32-9923-F0CA3267914F}"/>
               </a:ext>
             </a:extLst>
           </p:cNvPr>
@@ -12048,7 +12401,7 @@
           <p:cNvPr id="18" name="">
             <a:extLst xmlns:a="http://schemas.openxmlformats.org/drawingml/2006/main">
               <a:ext uri="{FF2B5EF4-FFF2-40B4-BE49-F238E27FC236}">
-                <a16:creationId xmlns:a16="http://schemas.microsoft.com/office/drawing/2014/main" id="{C1EBCD9A-E5D2-4DC2-8984-E7FCF2693902}"/>
+                <a16:creationId xmlns:a16="http://schemas.microsoft.com/office/drawing/2014/main" id="{CAEDF892-4D44-45CE-AF95-0C21C8F9E534}"/>
               </a:ext>
             </a:extLst>
           </p:cNvPr>
@@ -12076,19 +12429,19 @@
           <a:lstStyle xmlns:a="http://schemas.openxmlformats.org/drawingml/2006/main"/>
           <a:p xmlns:a="http://schemas.openxmlformats.org/drawingml/2006/main">
             <a:pPr>
-              <a:defRPr sz="1275" b="1">
+              <a:defRPr sz="1125" b="1">
                 <a:solidFill>
                   <a:srgbClr val="142F4C"/>
                 </a:solidFill>
               </a:defRPr>
             </a:pPr>
             <a:r>
-              <a:rPr sz="1275" b="1">
+              <a:rPr sz="1125" b="1">
                 <a:solidFill>
                   <a:srgbClr val="142F4C"/>
                 </a:solidFill>
               </a:rPr>
-              <a:t>Review segregation-of-duties overrides and expiry.</a:t>
+              <a:t>The ethics owner must publish reporting routes in plain language across the channels the workforce actually uses —…</a:t>
             </a:r>
           </a:p>
         </p:txBody>
@@ -12098,7 +12451,7 @@
           <p:cNvPr id="19" name="">
             <a:extLst xmlns:a="http://schemas.openxmlformats.org/drawingml/2006/main">
               <a:ext uri="{FF2B5EF4-FFF2-40B4-BE49-F238E27FC236}">
-                <a16:creationId xmlns:a16="http://schemas.microsoft.com/office/drawing/2014/main" id="{C008EF75-A117-4515-B106-F6D752C69DDF}"/>
+                <a16:creationId xmlns:a16="http://schemas.microsoft.com/office/drawing/2014/main" id="{CF220A8A-59BB-490C-B8BF-432E49B636F7}"/>
               </a:ext>
             </a:extLst>
           </p:cNvPr>
@@ -12138,7 +12491,7 @@
                   <a:srgbClr val="1A2634"/>
                 </a:solidFill>
               </a:rPr>
-              <a:t>Financial Controller</a:t>
+              <a:t>Chief People Officer / COO</a:t>
             </a:r>
           </a:p>
         </p:txBody>
@@ -12148,7 +12501,7 @@
           <p:cNvPr id="20" name="">
             <a:extLst xmlns:a="http://schemas.openxmlformats.org/drawingml/2006/main">
               <a:ext uri="{FF2B5EF4-FFF2-40B4-BE49-F238E27FC236}">
-                <a16:creationId xmlns:a16="http://schemas.microsoft.com/office/drawing/2014/main" id="{F1A0BD4E-12AA-43F0-BEFC-9C5B4B7491D6}"/>
+                <a16:creationId xmlns:a16="http://schemas.microsoft.com/office/drawing/2014/main" id="{5D36247E-2DA7-4C34-8669-D4F23F2E21F1}"/>
               </a:ext>
             </a:extLst>
           </p:cNvPr>
@@ -12198,7 +12551,7 @@
           <p:cNvPr id="21" name="">
             <a:extLst xmlns:a="http://schemas.openxmlformats.org/drawingml/2006/main">
               <a:ext uri="{FF2B5EF4-FFF2-40B4-BE49-F238E27FC236}">
-                <a16:creationId xmlns:a16="http://schemas.microsoft.com/office/drawing/2014/main" id="{F4BCBF53-E21B-458C-A927-867A04B72EC8}"/>
+                <a16:creationId xmlns:a16="http://schemas.microsoft.com/office/drawing/2014/main" id="{93774A2A-E785-4B80-82BC-0F2956868D43}"/>
               </a:ext>
             </a:extLst>
           </p:cNvPr>
@@ -12238,7 +12591,7 @@
                   <a:srgbClr val="5A6B7C"/>
                 </a:solidFill>
               </a:rPr>
-              <a:t>100% of in-scope access reviewed.</a:t>
+              <a:t>At least 90% of surveyed staff can correctly identify a fraud reporting route, across all sites and worker types.</a:t>
             </a:r>
           </a:p>
         </p:txBody>
@@ -12248,7 +12601,7 @@
           <p:cNvPr id="22" name="">
             <a:extLst xmlns:a="http://schemas.openxmlformats.org/drawingml/2006/main">
               <a:ext uri="{FF2B5EF4-FFF2-40B4-BE49-F238E27FC236}">
-                <a16:creationId xmlns:a16="http://schemas.microsoft.com/office/drawing/2014/main" id="{5DA45BA4-DFC2-4791-B43E-FE9E417647A8}"/>
+                <a16:creationId xmlns:a16="http://schemas.microsoft.com/office/drawing/2014/main" id="{0DE7CDEC-1937-4DC1-983B-B7FE078A40A0}"/>
               </a:ext>
             </a:extLst>
           </p:cNvPr>
@@ -12279,7 +12632,7 @@
           <p:cNvPr id="23" name="">
             <a:extLst xmlns:a="http://schemas.openxmlformats.org/drawingml/2006/main">
               <a:ext uri="{FF2B5EF4-FFF2-40B4-BE49-F238E27FC236}">
-                <a16:creationId xmlns:a16="http://schemas.microsoft.com/office/drawing/2014/main" id="{05888A79-F5D7-4CD0-9282-F0973403BB7B}"/>
+                <a16:creationId xmlns:a16="http://schemas.microsoft.com/office/drawing/2014/main" id="{8CCFA851-4B4F-4ADC-9953-16EA6D428078}"/>
               </a:ext>
             </a:extLst>
           </p:cNvPr>
@@ -12307,19 +12660,19 @@
           <a:lstStyle xmlns:a="http://schemas.openxmlformats.org/drawingml/2006/main"/>
           <a:p xmlns:a="http://schemas.openxmlformats.org/drawingml/2006/main">
             <a:pPr>
-              <a:defRPr sz="1275" b="1">
+              <a:defRPr sz="1125" b="1">
                 <a:solidFill>
                   <a:srgbClr val="142F4C"/>
                 </a:solidFill>
               </a:defRPr>
             </a:pPr>
             <a:r>
-              <a:rPr sz="1275" b="1">
+              <a:rPr sz="1125" b="1">
                 <a:solidFill>
                   <a:srgbClr val="142F4C"/>
                 </a:solidFill>
               </a:rPr>
-              <a:t>Reconcile supplier bank-detail changes and add independent verification.</a:t>
+              <a:t>IT Security maintains a complete privileged-account register, links each human and service account to an owner and approved…</a:t>
             </a:r>
           </a:p>
         </p:txBody>
@@ -12329,7 +12682,7 @@
           <p:cNvPr id="24" name="">
             <a:extLst xmlns:a="http://schemas.openxmlformats.org/drawingml/2006/main">
               <a:ext uri="{FF2B5EF4-FFF2-40B4-BE49-F238E27FC236}">
-                <a16:creationId xmlns:a16="http://schemas.microsoft.com/office/drawing/2014/main" id="{6987D3FC-9E12-40C3-80BA-3E0C1808AFB7}"/>
+                <a16:creationId xmlns:a16="http://schemas.microsoft.com/office/drawing/2014/main" id="{89A23C2C-7296-4AA5-9C7B-897EAF869D61}"/>
               </a:ext>
             </a:extLst>
           </p:cNvPr>
@@ -12369,7 +12722,7 @@
                   <a:srgbClr val="1A2634"/>
                 </a:solidFill>
               </a:rPr>
-              <a:t>Chief Information Officer</a:t>
+              <a:t>Chief Technology Officer</a:t>
             </a:r>
           </a:p>
         </p:txBody>
@@ -12379,7 +12732,7 @@
           <p:cNvPr id="25" name="">
             <a:extLst xmlns:a="http://schemas.openxmlformats.org/drawingml/2006/main">
               <a:ext uri="{FF2B5EF4-FFF2-40B4-BE49-F238E27FC236}">
-                <a16:creationId xmlns:a16="http://schemas.microsoft.com/office/drawing/2014/main" id="{1FCFF5C3-D301-4FC6-B2D3-C96AA563C3E9}"/>
+                <a16:creationId xmlns:a16="http://schemas.microsoft.com/office/drawing/2014/main" id="{0D298707-2178-4A47-9938-9D59B106A50A}"/>
               </a:ext>
             </a:extLst>
           </p:cNvPr>
@@ -12419,7 +12772,7 @@
                   <a:srgbClr val="C9A227"/>
                 </a:solidFill>
               </a:rPr>
-              <a:t>30 days</a:t>
+              <a:t>60 days</a:t>
             </a:r>
           </a:p>
         </p:txBody>
@@ -12429,7 +12782,7 @@
           <p:cNvPr id="26" name="">
             <a:extLst xmlns:a="http://schemas.openxmlformats.org/drawingml/2006/main">
               <a:ext uri="{FF2B5EF4-FFF2-40B4-BE49-F238E27FC236}">
-                <a16:creationId xmlns:a16="http://schemas.microsoft.com/office/drawing/2014/main" id="{E9538F4E-AC0A-4028-AE7B-F2F5DB9E0D05}"/>
+                <a16:creationId xmlns:a16="http://schemas.microsoft.com/office/drawing/2014/main" id="{3CF48F6D-360C-4B88-8B5E-3639E3173AD1}"/>
               </a:ext>
             </a:extLst>
           </p:cNvPr>
@@ -12469,7 +12822,7 @@
                   <a:srgbClr val="5A6B7C"/>
                 </a:solidFill>
               </a:rPr>
-              <a:t>100% of in-scope access reviewed.</a:t>
+              <a:t>100% privileged accounts recertified quarterly; leaver access removed within 24 hours; zero unjustified shared admin accounts.</a:t>
             </a:r>
           </a:p>
         </p:txBody>
@@ -12479,7 +12832,7 @@
           <p:cNvPr id="27" name="">
             <a:extLst xmlns:a="http://schemas.openxmlformats.org/drawingml/2006/main">
               <a:ext uri="{FF2B5EF4-FFF2-40B4-BE49-F238E27FC236}">
-                <a16:creationId xmlns:a16="http://schemas.microsoft.com/office/drawing/2014/main" id="{FA1DF1D8-4E6D-4512-B05C-8AD5FDE9A673}"/>
+                <a16:creationId xmlns:a16="http://schemas.microsoft.com/office/drawing/2014/main" id="{3313EF43-161D-4683-BC71-DB25B4E487C5}"/>
               </a:ext>
             </a:extLst>
           </p:cNvPr>
@@ -12510,7 +12863,7 @@
           <p:cNvPr id="28" name="">
             <a:extLst xmlns:a="http://schemas.openxmlformats.org/drawingml/2006/main">
               <a:ext uri="{FF2B5EF4-FFF2-40B4-BE49-F238E27FC236}">
-                <a16:creationId xmlns:a16="http://schemas.microsoft.com/office/drawing/2014/main" id="{FC27232D-F730-42C9-A593-B111499F872D}"/>
+                <a16:creationId xmlns:a16="http://schemas.microsoft.com/office/drawing/2014/main" id="{39C61D55-1192-49A5-B422-4B61EB8C66C7}"/>
               </a:ext>
             </a:extLst>
           </p:cNvPr>
@@ -12538,19 +12891,19 @@
           <a:lstStyle xmlns:a="http://schemas.openxmlformats.org/drawingml/2006/main"/>
           <a:p xmlns:a="http://schemas.openxmlformats.org/drawingml/2006/main">
             <a:pPr>
-              <a:defRPr sz="1275" b="1">
+              <a:defRPr sz="1125" b="1">
                 <a:solidFill>
                   <a:srgbClr val="142F4C"/>
                 </a:solidFill>
               </a:defRPr>
             </a:pPr>
             <a:r>
-              <a:rPr sz="1275" b="1">
+              <a:rPr sz="1125" b="1">
                 <a:solidFill>
                   <a:srgbClr val="142F4C"/>
                 </a:solidFill>
               </a:rPr>
-              <a:t>Reconcile supplier bank-detail changes and add independent verification.</a:t>
+              <a:t>The process owner must define the risk points requiring verification — customer or beneficiary enrolment, employee onboarding, supplier…</a:t>
             </a:r>
           </a:p>
         </p:txBody>
@@ -12560,7 +12913,7 @@
           <p:cNvPr id="29" name="">
             <a:extLst xmlns:a="http://schemas.openxmlformats.org/drawingml/2006/main">
               <a:ext uri="{FF2B5EF4-FFF2-40B4-BE49-F238E27FC236}">
-                <a16:creationId xmlns:a16="http://schemas.microsoft.com/office/drawing/2014/main" id="{9171E93D-0905-4CE7-B6E5-BCCE000CCB0D}"/>
+                <a16:creationId xmlns:a16="http://schemas.microsoft.com/office/drawing/2014/main" id="{B694E88B-8DCB-4EA0-9E55-B41B22BE84EE}"/>
               </a:ext>
             </a:extLst>
           </p:cNvPr>
@@ -12600,7 +12953,7 @@
                   <a:srgbClr val="1A2634"/>
                 </a:solidFill>
               </a:rPr>
-              <a:t>Chief Information Officer</a:t>
+              <a:t>COO / CFO</a:t>
             </a:r>
           </a:p>
         </p:txBody>
@@ -12610,7 +12963,7 @@
           <p:cNvPr id="30" name="">
             <a:extLst xmlns:a="http://schemas.openxmlformats.org/drawingml/2006/main">
               <a:ext uri="{FF2B5EF4-FFF2-40B4-BE49-F238E27FC236}">
-                <a16:creationId xmlns:a16="http://schemas.microsoft.com/office/drawing/2014/main" id="{BD4B520A-7CC1-44F5-B963-6B7ED3C3D98F}"/>
+                <a16:creationId xmlns:a16="http://schemas.microsoft.com/office/drawing/2014/main" id="{84788481-54B7-4F68-939D-2F74A60C61C6}"/>
               </a:ext>
             </a:extLst>
           </p:cNvPr>
@@ -12660,7 +13013,7 @@
           <p:cNvPr id="31" name="">
             <a:extLst xmlns:a="http://schemas.openxmlformats.org/drawingml/2006/main">
               <a:ext uri="{FF2B5EF4-FFF2-40B4-BE49-F238E27FC236}">
-                <a16:creationId xmlns:a16="http://schemas.microsoft.com/office/drawing/2014/main" id="{59E38FFE-1D9E-436F-8846-2CB6E2AA77CB}"/>
+                <a16:creationId xmlns:a16="http://schemas.microsoft.com/office/drawing/2014/main" id="{0CC5AFB3-494B-454C-8EDF-0A75F6C58897}"/>
               </a:ext>
             </a:extLst>
           </p:cNvPr>
@@ -12700,7 +13053,7 @@
                   <a:srgbClr val="5A6B7C"/>
                 </a:solidFill>
               </a:rPr>
-              <a:t>All active rules reviewed monthly.</a:t>
+              <a:t>100% of in-scope enrolments and activations carry completed verification before activation, with all exceptions approved.</a:t>
             </a:r>
           </a:p>
         </p:txBody>
@@ -12710,7 +13063,7 @@
           <p:cNvPr id="32" name="">
             <a:extLst xmlns:a="http://schemas.openxmlformats.org/drawingml/2006/main">
               <a:ext uri="{FF2B5EF4-FFF2-40B4-BE49-F238E27FC236}">
-                <a16:creationId xmlns:a16="http://schemas.microsoft.com/office/drawing/2014/main" id="{741B94E0-471C-4C93-A68C-922DD4ABEE47}"/>
+                <a16:creationId xmlns:a16="http://schemas.microsoft.com/office/drawing/2014/main" id="{FF53C60B-CC9A-4BFB-A0AD-AC1F5EDCDCAD}"/>
               </a:ext>
             </a:extLst>
           </p:cNvPr>
@@ -12760,7 +13113,7 @@
           <p:cNvPr id="33" name="">
             <a:extLst xmlns:a="http://schemas.openxmlformats.org/drawingml/2006/main">
               <a:ext uri="{FF2B5EF4-FFF2-40B4-BE49-F238E27FC236}">
-                <a16:creationId xmlns:a16="http://schemas.microsoft.com/office/drawing/2014/main" id="{EFD9D673-93AA-4B20-8FE4-B93FA5C8B2F8}"/>
+                <a16:creationId xmlns:a16="http://schemas.microsoft.com/office/drawing/2014/main" id="{9BBD5993-CC83-40FB-B178-671010AE4EEA}"/>
               </a:ext>
             </a:extLst>
           </p:cNvPr>
@@ -12810,7 +13163,7 @@
           <p:cNvPr id="34" name="">
             <a:extLst xmlns:a="http://schemas.openxmlformats.org/drawingml/2006/main">
               <a:ext uri="{FF2B5EF4-FFF2-40B4-BE49-F238E27FC236}">
-                <a16:creationId xmlns:a16="http://schemas.microsoft.com/office/drawing/2014/main" id="{84E2DAF9-59F9-4E9D-8ED9-266B7FEB15AA}"/>
+                <a16:creationId xmlns:a16="http://schemas.microsoft.com/office/drawing/2014/main" id="{7649C361-D09A-429B-B20C-06BD7F9B6EFE}"/>
               </a:ext>
             </a:extLst>
           </p:cNvPr>
@@ -12858,7 +13211,7 @@
     </p:spTree>
     <p:extLst>
       <p:ext uri="{BB962C8B-B14F-4D97-AF65-F5344CB8AC3E}">
-        <p14:creationId xmlns:p14="http://schemas.microsoft.com/office/powerpoint/2010/main" val="1908084576"/>
+        <p14:creationId xmlns:p14="http://schemas.microsoft.com/office/powerpoint/2010/main" val="785619931"/>
       </p:ext>
     </p:extLst>
   </p:cSld>

</xml_diff>

<commit_message>
Correct Comprehensive Reporting Bible architecture
</commit_message>
<xml_diff>
--- a/outputs/commercial-quality/comprehensive-executive-presentation.pptx
+++ b/outputs/commercial-quality/comprehensive-executive-presentation.pptx
@@ -2,22 +2,22 @@
 <file path=ppt/presentation.xml><?xml version="1.0" encoding="utf-8"?>
 <p:presentation xmlns:p="http://schemas.openxmlformats.org/presentationml/2006/main">
   <p:sldMasterIdLst>
-    <p:sldMasterId xmlns:r="http://schemas.openxmlformats.org/officeDocument/2006/relationships" id="2147483648" r:id="R77e7ed94a8264d84"/>
+    <p:sldMasterId xmlns:r="http://schemas.openxmlformats.org/officeDocument/2006/relationships" id="2147483648" r:id="Rbc8fdca0378545cc"/>
   </p:sldMasterIdLst>
   <p:notesMasterIdLst>
-    <p:notesMasterId xmlns:r="http://schemas.openxmlformats.org/officeDocument/2006/relationships" r:id="Rd4882d21dc2147a9"/>
+    <p:notesMasterId xmlns:r="http://schemas.openxmlformats.org/officeDocument/2006/relationships" r:id="Refa7e803820844bc"/>
   </p:notesMasterIdLst>
   <p:sldIdLst>
-    <p:sldId xmlns:r="http://schemas.openxmlformats.org/officeDocument/2006/relationships" id="256" r:id="R79f9c2a78e6d4c31"/>
-    <p:sldId xmlns:r="http://schemas.openxmlformats.org/officeDocument/2006/relationships" id="257" r:id="R970c988c179d4d62"/>
-    <p:sldId xmlns:r="http://schemas.openxmlformats.org/officeDocument/2006/relationships" id="258" r:id="R2031c965482d4ed2"/>
-    <p:sldId xmlns:r="http://schemas.openxmlformats.org/officeDocument/2006/relationships" id="259" r:id="R238dddf1ee334316"/>
-    <p:sldId xmlns:r="http://schemas.openxmlformats.org/officeDocument/2006/relationships" id="260" r:id="R2c83a6e609e84541"/>
-    <p:sldId xmlns:r="http://schemas.openxmlformats.org/officeDocument/2006/relationships" id="261" r:id="R0b9a4342d38d46b5"/>
-    <p:sldId xmlns:r="http://schemas.openxmlformats.org/officeDocument/2006/relationships" id="262" r:id="R2bd9ce409a4549fe"/>
-    <p:sldId xmlns:r="http://schemas.openxmlformats.org/officeDocument/2006/relationships" id="263" r:id="R70699dfe1a814123"/>
-    <p:sldId xmlns:r="http://schemas.openxmlformats.org/officeDocument/2006/relationships" id="264" r:id="R24e046c90b374cfe"/>
-    <p:sldId xmlns:r="http://schemas.openxmlformats.org/officeDocument/2006/relationships" id="265" r:id="Re32fc3f964cc46a4"/>
+    <p:sldId xmlns:r="http://schemas.openxmlformats.org/officeDocument/2006/relationships" id="256" r:id="Rdc80dca792114131"/>
+    <p:sldId xmlns:r="http://schemas.openxmlformats.org/officeDocument/2006/relationships" id="257" r:id="R1c66a3f64b904bca"/>
+    <p:sldId xmlns:r="http://schemas.openxmlformats.org/officeDocument/2006/relationships" id="258" r:id="Rf08038cf7e4f48f6"/>
+    <p:sldId xmlns:r="http://schemas.openxmlformats.org/officeDocument/2006/relationships" id="259" r:id="R272dc053a96143b8"/>
+    <p:sldId xmlns:r="http://schemas.openxmlformats.org/officeDocument/2006/relationships" id="260" r:id="Ra80898965cb7407d"/>
+    <p:sldId xmlns:r="http://schemas.openxmlformats.org/officeDocument/2006/relationships" id="261" r:id="R754d2d02113d498d"/>
+    <p:sldId xmlns:r="http://schemas.openxmlformats.org/officeDocument/2006/relationships" id="262" r:id="R111487fa306c4972"/>
+    <p:sldId xmlns:r="http://schemas.openxmlformats.org/officeDocument/2006/relationships" id="263" r:id="R70ad29d0efef405f"/>
+    <p:sldId xmlns:r="http://schemas.openxmlformats.org/officeDocument/2006/relationships" id="264" r:id="Rf524070479f04417"/>
+    <p:sldId xmlns:r="http://schemas.openxmlformats.org/officeDocument/2006/relationships" id="265" r:id="Ref41d1f2946f4772"/>
   </p:sldIdLst>
   <p:sldSz cx="12192000" cy="6858000"/>
   <p:notesSz cx="6858000" cy="9144000"/>
@@ -456,7 +456,7 @@
           </a:p>
           <a:p xmlns:a="http://schemas.openxmlformats.org/drawingml/2006/main">
             <a:r>
-              <a:t>- Source: persisted Kestrel engagement MKORD-2026-7FBBEE23.</a:t>
+              <a:t>- Source: persisted Kestrel assessment MKORD-2026-7FBBEE23.</a:t>
             </a:r>
           </a:p>
           <a:p xmlns:a="http://schemas.openxmlformats.org/drawingml/2006/main">
@@ -571,7 +571,7 @@
           </a:p>
           <a:p xmlns:a="http://schemas.openxmlformats.org/drawingml/2006/main">
             <a:r>
-              <a:t>- Source: persisted Kestrel engagement MKORD-2026-7FBBEE23.</a:t>
+              <a:t>- Source: persisted Kestrel assessment MKORD-2026-7FBBEE23.</a:t>
             </a:r>
           </a:p>
           <a:p xmlns:a="http://schemas.openxmlformats.org/drawingml/2006/main">
@@ -686,7 +686,7 @@
           </a:p>
           <a:p xmlns:a="http://schemas.openxmlformats.org/drawingml/2006/main">
             <a:r>
-              <a:t>- Source: persisted Kestrel engagement MKORD-2026-7FBBEE23.</a:t>
+              <a:t>- Source: persisted Kestrel assessment MKORD-2026-7FBBEE23.</a:t>
             </a:r>
           </a:p>
           <a:p xmlns:a="http://schemas.openxmlformats.org/drawingml/2006/main">
@@ -801,7 +801,7 @@
           </a:p>
           <a:p xmlns:a="http://schemas.openxmlformats.org/drawingml/2006/main">
             <a:r>
-              <a:t>- Source: persisted Kestrel engagement MKORD-2026-7FBBEE23.</a:t>
+              <a:t>- Source: persisted Kestrel assessment MKORD-2026-7FBBEE23.</a:t>
             </a:r>
           </a:p>
           <a:p xmlns:a="http://schemas.openxmlformats.org/drawingml/2006/main">
@@ -916,7 +916,7 @@
           </a:p>
           <a:p xmlns:a="http://schemas.openxmlformats.org/drawingml/2006/main">
             <a:r>
-              <a:t>- Source: persisted Kestrel engagement MKORD-2026-7FBBEE23.</a:t>
+              <a:t>- Source: persisted Kestrel assessment MKORD-2026-7FBBEE23.</a:t>
             </a:r>
           </a:p>
           <a:p xmlns:a="http://schemas.openxmlformats.org/drawingml/2006/main">
@@ -1031,7 +1031,7 @@
           </a:p>
           <a:p xmlns:a="http://schemas.openxmlformats.org/drawingml/2006/main">
             <a:r>
-              <a:t>- Source: persisted Kestrel engagement MKORD-2026-7FBBEE23.</a:t>
+              <a:t>- Source: persisted Kestrel assessment MKORD-2026-7FBBEE23.</a:t>
             </a:r>
           </a:p>
           <a:p xmlns:a="http://schemas.openxmlformats.org/drawingml/2006/main">
@@ -1146,7 +1146,7 @@
           </a:p>
           <a:p xmlns:a="http://schemas.openxmlformats.org/drawingml/2006/main">
             <a:r>
-              <a:t>- Source: persisted Kestrel engagement MKORD-2026-7FBBEE23.</a:t>
+              <a:t>- Source: persisted Kestrel assessment MKORD-2026-7FBBEE23.</a:t>
             </a:r>
           </a:p>
           <a:p xmlns:a="http://schemas.openxmlformats.org/drawingml/2006/main">
@@ -1261,7 +1261,7 @@
           </a:p>
           <a:p xmlns:a="http://schemas.openxmlformats.org/drawingml/2006/main">
             <a:r>
-              <a:t>- Source: persisted Kestrel engagement MKORD-2026-7FBBEE23.</a:t>
+              <a:t>- Source: persisted Kestrel assessment MKORD-2026-7FBBEE23.</a:t>
             </a:r>
           </a:p>
           <a:p xmlns:a="http://schemas.openxmlformats.org/drawingml/2006/main">
@@ -1376,7 +1376,7 @@
           </a:p>
           <a:p xmlns:a="http://schemas.openxmlformats.org/drawingml/2006/main">
             <a:r>
-              <a:t>- Source: persisted Kestrel engagement MKORD-2026-7FBBEE23.</a:t>
+              <a:t>- Source: persisted Kestrel assessment MKORD-2026-7FBBEE23.</a:t>
             </a:r>
           </a:p>
           <a:p xmlns:a="http://schemas.openxmlformats.org/drawingml/2006/main">
@@ -1491,7 +1491,7 @@
           </a:p>
           <a:p xmlns:a="http://schemas.openxmlformats.org/drawingml/2006/main">
             <a:r>
-              <a:t>- Source: persisted Kestrel engagement MKORD-2026-7FBBEE23.</a:t>
+              <a:t>- Source: persisted Kestrel assessment MKORD-2026-7FBBEE23.</a:t>
             </a:r>
           </a:p>
           <a:p xmlns:a="http://schemas.openxmlformats.org/drawingml/2006/main">
@@ -1599,7 +1599,7 @@
   </p:cSld>
   <p:clrMap bg1="lt1" tx1="dk1" bg2="lt2" tx2="dk2" accent1="accent1" accent2="accent2" accent3="accent3" accent4="accent4" accent5="accent5" accent6="accent6" hlink="hlink" folHlink="folHlink"/>
   <p:sldLayoutIdLst>
-    <p:sldLayoutId xmlns:r="http://schemas.openxmlformats.org/officeDocument/2006/relationships" id="2147483649" r:id="R19e622f7bf7f4309"/>
+    <p:sldLayoutId xmlns:r="http://schemas.openxmlformats.org/officeDocument/2006/relationships" id="2147483649" r:id="R3f15ed3c209d47f0"/>
   </p:sldLayoutIdLst>
   <p:txStyles>
     <p:titleStyle>
@@ -2150,7 +2150,7 @@
           <p:cNvPr id="7" name="">
             <a:extLst xmlns:a="http://schemas.openxmlformats.org/drawingml/2006/main">
               <a:ext uri="{FF2B5EF4-FFF2-40B4-BE49-F238E27FC236}">
-                <a16:creationId xmlns:a16="http://schemas.microsoft.com/office/drawing/2014/main" id="{A9230606-D8AD-4B5E-A525-034C6C6ACF19}"/>
+                <a16:creationId xmlns:a16="http://schemas.microsoft.com/office/drawing/2014/main" id="{E40B2B45-0451-4CE4-8F41-DF3C59C439C7}"/>
               </a:ext>
             </a:extLst>
           </p:cNvPr>
@@ -2183,7 +2183,7 @@
           <p:cNvPr id="2" name="">
             <a:extLst xmlns:a="http://schemas.openxmlformats.org/drawingml/2006/main">
               <a:ext uri="{FF2B5EF4-FFF2-40B4-BE49-F238E27FC236}">
-                <a16:creationId xmlns:a16="http://schemas.microsoft.com/office/drawing/2014/main" id="{6E2DD84F-B18A-48E8-9AAB-433C4DCE9E89}"/>
+                <a16:creationId xmlns:a16="http://schemas.microsoft.com/office/drawing/2014/main" id="{2A35DC8A-93D5-4290-A7EC-D1370E35B088}"/>
               </a:ext>
             </a:extLst>
           </p:cNvPr>
@@ -2233,7 +2233,7 @@
           <p:cNvPr id="3" name="">
             <a:extLst xmlns:a="http://schemas.openxmlformats.org/drawingml/2006/main">
               <a:ext uri="{FF2B5EF4-FFF2-40B4-BE49-F238E27FC236}">
-                <a16:creationId xmlns:a16="http://schemas.microsoft.com/office/drawing/2014/main" id="{9260D5A4-12C3-4983-A8E8-2760348EDAE9}"/>
+                <a16:creationId xmlns:a16="http://schemas.microsoft.com/office/drawing/2014/main" id="{287411AC-9405-49E1-8ACA-7996BAD7E2B5}"/>
               </a:ext>
             </a:extLst>
           </p:cNvPr>
@@ -2283,7 +2283,7 @@
           <p:cNvPr id="4" name="">
             <a:extLst xmlns:a="http://schemas.openxmlformats.org/drawingml/2006/main">
               <a:ext uri="{FF2B5EF4-FFF2-40B4-BE49-F238E27FC236}">
-                <a16:creationId xmlns:a16="http://schemas.microsoft.com/office/drawing/2014/main" id="{259E2981-3086-4861-9279-71A6C5F9E4E2}"/>
+                <a16:creationId xmlns:a16="http://schemas.microsoft.com/office/drawing/2014/main" id="{81E5AFE0-EAAD-4140-8F80-44284D927D2F}"/>
               </a:ext>
             </a:extLst>
           </p:cNvPr>
@@ -2340,7 +2340,7 @@
                   <a:srgbClr val="D9E1E7"/>
                 </a:solidFill>
               </a:rPr>
-              <a:t>Comprehensive review · strategic design engagement</a:t>
+              <a:t>Comprehensive blueprint · strategic design engagement</a:t>
             </a:r>
           </a:p>
         </p:txBody>
@@ -2350,7 +2350,7 @@
           <p:cNvPr id="5" name="">
             <a:extLst xmlns:a="http://schemas.openxmlformats.org/drawingml/2006/main">
               <a:ext uri="{FF2B5EF4-FFF2-40B4-BE49-F238E27FC236}">
-                <a16:creationId xmlns:a16="http://schemas.microsoft.com/office/drawing/2014/main" id="{D41B472E-6489-4EF4-83A2-0D8AD6D0D4E1}"/>
+                <a16:creationId xmlns:a16="http://schemas.microsoft.com/office/drawing/2014/main" id="{003C4E5E-CABD-4937-861F-DC0F920F8B9C}"/>
               </a:ext>
             </a:extLst>
           </p:cNvPr>
@@ -2362,7 +2362,7 @@
         <p:spPr>
           <a:xfrm xmlns:a="http://schemas.openxmlformats.org/drawingml/2006/main">
             <a:off x="857250" y="5619750"/>
-            <a:ext cx="6667500" cy="266700"/>
+            <a:ext cx="7620000" cy="266700"/>
           </a:xfrm>
           <a:prstGeom xmlns:a="http://schemas.openxmlformats.org/drawingml/2006/main" prst="rect">
             <a:avLst/>
@@ -2390,7 +2390,7 @@
                   <a:srgbClr val="D9E1E7"/>
                 </a:solidFill>
               </a:rPr>
-              <a:t>Named reviewer: Named review lead</a:t>
+              <a:t>Based on management's recorded Fraud Readiness assessment responses</a:t>
             </a:r>
           </a:p>
         </p:txBody>
@@ -2400,7 +2400,7 @@
           <p:cNvPr id="6" name="">
             <a:extLst xmlns:a="http://schemas.openxmlformats.org/drawingml/2006/main">
               <a:ext uri="{FF2B5EF4-FFF2-40B4-BE49-F238E27FC236}">
-                <a16:creationId xmlns:a16="http://schemas.microsoft.com/office/drawing/2014/main" id="{FF64BB82-AE3B-497F-B095-405BD1437B96}"/>
+                <a16:creationId xmlns:a16="http://schemas.microsoft.com/office/drawing/2014/main" id="{EDC20AFA-B770-45C7-BD8F-D4E9E1DFA56B}"/>
               </a:ext>
             </a:extLst>
           </p:cNvPr>
@@ -2448,7 +2448,7 @@
     </p:spTree>
     <p:extLst>
       <p:ext uri="{BB962C8B-B14F-4D97-AF65-F5344CB8AC3E}">
-        <p14:creationId xmlns:p14="http://schemas.microsoft.com/office/powerpoint/2010/main" val="1120665951"/>
+        <p14:creationId xmlns:p14="http://schemas.microsoft.com/office/powerpoint/2010/main" val="967095293"/>
       </p:ext>
     </p:extLst>
   </p:cSld>
@@ -2479,7 +2479,7 @@
           <p:cNvPr id="18" name="">
             <a:extLst xmlns:a="http://schemas.openxmlformats.org/drawingml/2006/main">
               <a:ext uri="{FF2B5EF4-FFF2-40B4-BE49-F238E27FC236}">
-                <a16:creationId xmlns:a16="http://schemas.microsoft.com/office/drawing/2014/main" id="{6F8A6E73-C0E9-4DBD-A94E-C068972E8753}"/>
+                <a16:creationId xmlns:a16="http://schemas.microsoft.com/office/drawing/2014/main" id="{01A54BF6-5B81-4F38-B2E8-9EEFC655D280}"/>
               </a:ext>
             </a:extLst>
           </p:cNvPr>
@@ -2529,7 +2529,7 @@
           <p:cNvPr id="2" name="">
             <a:extLst xmlns:a="http://schemas.openxmlformats.org/drawingml/2006/main">
               <a:ext uri="{FF2B5EF4-FFF2-40B4-BE49-F238E27FC236}">
-                <a16:creationId xmlns:a16="http://schemas.microsoft.com/office/drawing/2014/main" id="{0BD6D83D-49B2-4C6B-ABA7-E4E9A99EF66D}"/>
+                <a16:creationId xmlns:a16="http://schemas.microsoft.com/office/drawing/2014/main" id="{C4CC4B3A-199C-499D-8CF5-CE99D222D245}"/>
               </a:ext>
             </a:extLst>
           </p:cNvPr>
@@ -2569,7 +2569,7 @@
                   <a:srgbClr val="142F4C"/>
                 </a:solidFill>
               </a:rPr>
-              <a:t>Next checkpoint: review evidence closure and overdue action ageing.</a:t>
+              <a:t>Next checkpoint: review proof, measures and overdue action ageing.</a:t>
             </a:r>
           </a:p>
         </p:txBody>
@@ -2579,7 +2579,7 @@
           <p:cNvPr id="3" name="">
             <a:extLst xmlns:a="http://schemas.openxmlformats.org/drawingml/2006/main">
               <a:ext uri="{FF2B5EF4-FFF2-40B4-BE49-F238E27FC236}">
-                <a16:creationId xmlns:a16="http://schemas.microsoft.com/office/drawing/2014/main" id="{F5E10289-71EC-4998-8C56-0A4EC9AA1D01}"/>
+                <a16:creationId xmlns:a16="http://schemas.microsoft.com/office/drawing/2014/main" id="{8D0A414A-E4ED-47CA-A4FC-3075828B6AC3}"/>
               </a:ext>
             </a:extLst>
           </p:cNvPr>
@@ -2619,7 +2619,7 @@
                   <a:srgbClr val="5A6B7C"/>
                 </a:solidFill>
               </a:rPr>
-              <a:t>The deliverable is complete when the decision record and proof of operation are both maintained.</a:t>
+              <a:t>The blueprint is useful when the decision record and operating measures are maintained.</a:t>
             </a:r>
           </a:p>
         </p:txBody>
@@ -2629,7 +2629,7 @@
           <p:cNvPr id="4" name="">
             <a:extLst xmlns:a="http://schemas.openxmlformats.org/drawingml/2006/main">
               <a:ext uri="{FF2B5EF4-FFF2-40B4-BE49-F238E27FC236}">
-                <a16:creationId xmlns:a16="http://schemas.microsoft.com/office/drawing/2014/main" id="{F13361CE-CBD6-4231-902B-ACF5224BBD06}"/>
+                <a16:creationId xmlns:a16="http://schemas.microsoft.com/office/drawing/2014/main" id="{08BC271C-0D82-4843-A285-8BC7DCF7540B}"/>
               </a:ext>
             </a:extLst>
           </p:cNvPr>
@@ -2660,7 +2660,7 @@
           <p:cNvPr id="5" name="">
             <a:extLst xmlns:a="http://schemas.openxmlformats.org/drawingml/2006/main">
               <a:ext uri="{FF2B5EF4-FFF2-40B4-BE49-F238E27FC236}">
-                <a16:creationId xmlns:a16="http://schemas.microsoft.com/office/drawing/2014/main" id="{7064E9D2-D79C-4FF0-8A4D-34C1B9B72869}"/>
+                <a16:creationId xmlns:a16="http://schemas.microsoft.com/office/drawing/2014/main" id="{7AEF4226-8185-4F35-A27B-32F80CE66ECC}"/>
               </a:ext>
             </a:extLst>
           </p:cNvPr>
@@ -2710,7 +2710,7 @@
           <p:cNvPr id="6" name="">
             <a:extLst xmlns:a="http://schemas.openxmlformats.org/drawingml/2006/main">
               <a:ext uri="{FF2B5EF4-FFF2-40B4-BE49-F238E27FC236}">
-                <a16:creationId xmlns:a16="http://schemas.microsoft.com/office/drawing/2014/main" id="{8DAEDC54-5B20-4B2E-B3E3-CD3D6EA6B68D}"/>
+                <a16:creationId xmlns:a16="http://schemas.microsoft.com/office/drawing/2014/main" id="{3600A0F0-20B1-4E6A-BE6C-EB5ECDCA7310}"/>
               </a:ext>
             </a:extLst>
           </p:cNvPr>
@@ -2760,7 +2760,7 @@
           <p:cNvPr id="7" name="">
             <a:extLst xmlns:a="http://schemas.openxmlformats.org/drawingml/2006/main">
               <a:ext uri="{FF2B5EF4-FFF2-40B4-BE49-F238E27FC236}">
-                <a16:creationId xmlns:a16="http://schemas.microsoft.com/office/drawing/2014/main" id="{DC5BEF8F-0E7C-444F-B97C-AB0D8CB085D3}"/>
+                <a16:creationId xmlns:a16="http://schemas.microsoft.com/office/drawing/2014/main" id="{0A563F4C-4A50-4EA1-AEAD-2E7FC26C81D2}"/>
               </a:ext>
             </a:extLst>
           </p:cNvPr>
@@ -2795,7 +2795,7 @@
           <p:cNvPr id="8" name="">
             <a:extLst xmlns:a="http://schemas.openxmlformats.org/drawingml/2006/main">
               <a:ext uri="{FF2B5EF4-FFF2-40B4-BE49-F238E27FC236}">
-                <a16:creationId xmlns:a16="http://schemas.microsoft.com/office/drawing/2014/main" id="{79638C9D-23AF-473D-A574-2616D3513E83}"/>
+                <a16:creationId xmlns:a16="http://schemas.microsoft.com/office/drawing/2014/main" id="{1688BE7F-B7B0-4382-A5D8-3830B4E3FA9A}"/>
               </a:ext>
             </a:extLst>
           </p:cNvPr>
@@ -2845,7 +2845,7 @@
           <p:cNvPr id="9" name="">
             <a:extLst xmlns:a="http://schemas.openxmlformats.org/drawingml/2006/main">
               <a:ext uri="{FF2B5EF4-FFF2-40B4-BE49-F238E27FC236}">
-                <a16:creationId xmlns:a16="http://schemas.microsoft.com/office/drawing/2014/main" id="{0C016F06-F883-4920-AEB4-04926E249E72}"/>
+                <a16:creationId xmlns:a16="http://schemas.microsoft.com/office/drawing/2014/main" id="{FA6DE497-E96E-4B3E-A887-C79E3FE9F261}"/>
               </a:ext>
             </a:extLst>
           </p:cNvPr>
@@ -2878,7 +2878,7 @@
           <p:cNvPr id="10" name="">
             <a:extLst xmlns:a="http://schemas.openxmlformats.org/drawingml/2006/main">
               <a:ext uri="{FF2B5EF4-FFF2-40B4-BE49-F238E27FC236}">
-                <a16:creationId xmlns:a16="http://schemas.microsoft.com/office/drawing/2014/main" id="{C87DE73A-2DD7-4119-AEF1-294A3BFC5360}"/>
+                <a16:creationId xmlns:a16="http://schemas.microsoft.com/office/drawing/2014/main" id="{AE956A90-D3C5-4525-A60E-62962CCB011A}"/>
               </a:ext>
             </a:extLst>
           </p:cNvPr>
@@ -2918,7 +2918,7 @@
                   <a:srgbClr val="FFFFFF"/>
                 </a:solidFill>
               </a:rPr>
-              <a:t>Completed evidence items with a clear scope statement</a:t>
+              <a:t>Proof requirements and retained control records</a:t>
             </a:r>
           </a:p>
         </p:txBody>
@@ -2928,7 +2928,7 @@
           <p:cNvPr id="11" name="">
             <a:extLst xmlns:a="http://schemas.openxmlformats.org/drawingml/2006/main">
               <a:ext uri="{FF2B5EF4-FFF2-40B4-BE49-F238E27FC236}">
-                <a16:creationId xmlns:a16="http://schemas.microsoft.com/office/drawing/2014/main" id="{7310EF19-37CD-471C-A96C-9FCAF268F50A}"/>
+                <a16:creationId xmlns:a16="http://schemas.microsoft.com/office/drawing/2014/main" id="{F5F357A6-A338-48D4-8288-4FF59F83487C}"/>
               </a:ext>
             </a:extLst>
           </p:cNvPr>
@@ -2961,7 +2961,7 @@
           <p:cNvPr id="12" name="">
             <a:extLst xmlns:a="http://schemas.openxmlformats.org/drawingml/2006/main">
               <a:ext uri="{FF2B5EF4-FFF2-40B4-BE49-F238E27FC236}">
-                <a16:creationId xmlns:a16="http://schemas.microsoft.com/office/drawing/2014/main" id="{D52B5BAF-154B-4AC6-B5C3-7BE345A2E1E8}"/>
+                <a16:creationId xmlns:a16="http://schemas.microsoft.com/office/drawing/2014/main" id="{91459229-AE67-4CB1-9553-34C685C2EBDC}"/>
               </a:ext>
             </a:extLst>
           </p:cNvPr>
@@ -3011,7 +3011,7 @@
           <p:cNvPr id="13" name="">
             <a:extLst xmlns:a="http://schemas.openxmlformats.org/drawingml/2006/main">
               <a:ext uri="{FF2B5EF4-FFF2-40B4-BE49-F238E27FC236}">
-                <a16:creationId xmlns:a16="http://schemas.microsoft.com/office/drawing/2014/main" id="{25230969-9EC5-40D0-9513-47E4309E8B8F}"/>
+                <a16:creationId xmlns:a16="http://schemas.microsoft.com/office/drawing/2014/main" id="{C741D1F8-F4DB-47A6-82E0-46A66688F357}"/>
               </a:ext>
             </a:extLst>
           </p:cNvPr>
@@ -3044,7 +3044,7 @@
           <p:cNvPr id="14" name="">
             <a:extLst xmlns:a="http://schemas.openxmlformats.org/drawingml/2006/main">
               <a:ext uri="{FF2B5EF4-FFF2-40B4-BE49-F238E27FC236}">
-                <a16:creationId xmlns:a16="http://schemas.microsoft.com/office/drawing/2014/main" id="{270ECBAB-ECAA-4F2A-914B-96E700939DF0}"/>
+                <a16:creationId xmlns:a16="http://schemas.microsoft.com/office/drawing/2014/main" id="{7E8FFE8A-DBE9-4D30-BEF8-3174E5253BA2}"/>
               </a:ext>
             </a:extLst>
           </p:cNvPr>
@@ -3094,7 +3094,7 @@
           <p:cNvPr id="15" name="">
             <a:extLst xmlns:a="http://schemas.openxmlformats.org/drawingml/2006/main">
               <a:ext uri="{FF2B5EF4-FFF2-40B4-BE49-F238E27FC236}">
-                <a16:creationId xmlns:a16="http://schemas.microsoft.com/office/drawing/2014/main" id="{515202FB-2B5D-41CC-ADE8-B8C43BEFB7C8}"/>
+                <a16:creationId xmlns:a16="http://schemas.microsoft.com/office/drawing/2014/main" id="{2F122739-7AFA-4D6F-A167-7BC36A60AF30}"/>
               </a:ext>
             </a:extLst>
           </p:cNvPr>
@@ -3127,7 +3127,7 @@
           <p:cNvPr id="16" name="">
             <a:extLst xmlns:a="http://schemas.openxmlformats.org/drawingml/2006/main">
               <a:ext uri="{FF2B5EF4-FFF2-40B4-BE49-F238E27FC236}">
-                <a16:creationId xmlns:a16="http://schemas.microsoft.com/office/drawing/2014/main" id="{A18F11AB-6606-4700-ADAA-9E3B9FE68501}"/>
+                <a16:creationId xmlns:a16="http://schemas.microsoft.com/office/drawing/2014/main" id="{8F4B54C8-79C9-4488-80B6-4FE13E04A66A}"/>
               </a:ext>
             </a:extLst>
           </p:cNvPr>
@@ -3177,7 +3177,7 @@
           <p:cNvPr id="17" name="">
             <a:extLst xmlns:a="http://schemas.openxmlformats.org/drawingml/2006/main">
               <a:ext uri="{FF2B5EF4-FFF2-40B4-BE49-F238E27FC236}">
-                <a16:creationId xmlns:a16="http://schemas.microsoft.com/office/drawing/2014/main" id="{5E24D12A-99FA-43A8-A5F5-439265521840}"/>
+                <a16:creationId xmlns:a16="http://schemas.microsoft.com/office/drawing/2014/main" id="{4CB9B2B5-21F4-41A9-B97E-642D49AA63A2}"/>
               </a:ext>
             </a:extLst>
           </p:cNvPr>
@@ -3217,7 +3217,7 @@
                   <a:srgbClr val="142F4C"/>
                 </a:solidFill>
               </a:rPr>
-              <a:t>The board should see the decision, the owner, the date and the proof - not a longer register.</a:t>
+              <a:t>The board should see the decision, the owner, the target period, the measure and the response - not a longer register.</a:t>
             </a:r>
           </a:p>
         </p:txBody>
@@ -3225,7 +3225,7 @@
     </p:spTree>
     <p:extLst>
       <p:ext uri="{BB962C8B-B14F-4D97-AF65-F5344CB8AC3E}">
-        <p14:creationId xmlns:p14="http://schemas.microsoft.com/office/powerpoint/2010/main" val="2112781286"/>
+        <p14:creationId xmlns:p14="http://schemas.microsoft.com/office/powerpoint/2010/main" val="1875324454"/>
       </p:ext>
     </p:extLst>
   </p:cSld>
@@ -3256,7 +3256,7 @@
           <p:cNvPr id="30" name="">
             <a:extLst xmlns:a="http://schemas.openxmlformats.org/drawingml/2006/main">
               <a:ext uri="{FF2B5EF4-FFF2-40B4-BE49-F238E27FC236}">
-                <a16:creationId xmlns:a16="http://schemas.microsoft.com/office/drawing/2014/main" id="{A203B178-5B12-4BAC-8834-93B2EC6C4CDB}"/>
+                <a16:creationId xmlns:a16="http://schemas.microsoft.com/office/drawing/2014/main" id="{5B8EAE43-A83F-4B82-A4DC-AEB94A3292FC}"/>
               </a:ext>
             </a:extLst>
           </p:cNvPr>
@@ -3306,7 +3306,7 @@
           <p:cNvPr id="2" name="">
             <a:extLst xmlns:a="http://schemas.openxmlformats.org/drawingml/2006/main">
               <a:ext uri="{FF2B5EF4-FFF2-40B4-BE49-F238E27FC236}">
-                <a16:creationId xmlns:a16="http://schemas.microsoft.com/office/drawing/2014/main" id="{03E848D8-2683-4D38-8CC1-EAEB1ADC47DC}"/>
+                <a16:creationId xmlns:a16="http://schemas.microsoft.com/office/drawing/2014/main" id="{16941D88-1EDC-4946-8DCC-F47AD165287B}"/>
               </a:ext>
             </a:extLst>
           </p:cNvPr>
@@ -3356,7 +3356,7 @@
           <p:cNvPr id="3" name="">
             <a:extLst xmlns:a="http://schemas.openxmlformats.org/drawingml/2006/main">
               <a:ext uri="{FF2B5EF4-FFF2-40B4-BE49-F238E27FC236}">
-                <a16:creationId xmlns:a16="http://schemas.microsoft.com/office/drawing/2014/main" id="{A22B4B13-EA77-4717-927B-9965D0B661E4}"/>
+                <a16:creationId xmlns:a16="http://schemas.microsoft.com/office/drawing/2014/main" id="{FC9F53E2-BE0F-4B19-8ACE-D252728C0060}"/>
               </a:ext>
             </a:extLst>
           </p:cNvPr>
@@ -3406,7 +3406,7 @@
           <p:cNvPr id="4" name="">
             <a:extLst xmlns:a="http://schemas.openxmlformats.org/drawingml/2006/main">
               <a:ext uri="{FF2B5EF4-FFF2-40B4-BE49-F238E27FC236}">
-                <a16:creationId xmlns:a16="http://schemas.microsoft.com/office/drawing/2014/main" id="{D7C4F327-6F74-401F-9DB2-7BBFC8E24B77}"/>
+                <a16:creationId xmlns:a16="http://schemas.microsoft.com/office/drawing/2014/main" id="{3FD2FC09-5A75-448E-BB5D-A30E5185EAB6}"/>
               </a:ext>
             </a:extLst>
           </p:cNvPr>
@@ -3437,7 +3437,7 @@
           <p:cNvPr id="5" name="">
             <a:extLst xmlns:a="http://schemas.openxmlformats.org/drawingml/2006/main">
               <a:ext uri="{FF2B5EF4-FFF2-40B4-BE49-F238E27FC236}">
-                <a16:creationId xmlns:a16="http://schemas.microsoft.com/office/drawing/2014/main" id="{9FF5A5A8-BB33-4244-BBD4-B0D68A608170}"/>
+                <a16:creationId xmlns:a16="http://schemas.microsoft.com/office/drawing/2014/main" id="{DC340B8F-C077-4DE6-9A67-3917884BB241}"/>
               </a:ext>
             </a:extLst>
           </p:cNvPr>
@@ -3487,7 +3487,7 @@
           <p:cNvPr id="6" name="">
             <a:extLst xmlns:a="http://schemas.openxmlformats.org/drawingml/2006/main">
               <a:ext uri="{FF2B5EF4-FFF2-40B4-BE49-F238E27FC236}">
-                <a16:creationId xmlns:a16="http://schemas.microsoft.com/office/drawing/2014/main" id="{5778DC7F-04E7-4613-AED2-E4FAC6043C0F}"/>
+                <a16:creationId xmlns:a16="http://schemas.microsoft.com/office/drawing/2014/main" id="{B67ACCEB-B1A5-4DCA-B6A3-2F8CA36EAE63}"/>
               </a:ext>
             </a:extLst>
           </p:cNvPr>
@@ -3537,7 +3537,7 @@
           <p:cNvPr id="7" name="">
             <a:extLst xmlns:a="http://schemas.openxmlformats.org/drawingml/2006/main">
               <a:ext uri="{FF2B5EF4-FFF2-40B4-BE49-F238E27FC236}">
-                <a16:creationId xmlns:a16="http://schemas.microsoft.com/office/drawing/2014/main" id="{90FAD54A-57B0-44EC-A98C-D9FA717E5D00}"/>
+                <a16:creationId xmlns:a16="http://schemas.microsoft.com/office/drawing/2014/main" id="{09C62136-4DC5-463E-B5FB-B3CE396E656B}"/>
               </a:ext>
             </a:extLst>
           </p:cNvPr>
@@ -3572,7 +3572,7 @@
           <p:cNvPr id="8" name="">
             <a:extLst xmlns:a="http://schemas.openxmlformats.org/drawingml/2006/main">
               <a:ext uri="{FF2B5EF4-FFF2-40B4-BE49-F238E27FC236}">
-                <a16:creationId xmlns:a16="http://schemas.microsoft.com/office/drawing/2014/main" id="{85720461-CC28-422A-B669-F3688858329A}"/>
+                <a16:creationId xmlns:a16="http://schemas.microsoft.com/office/drawing/2014/main" id="{30373F1F-A5C9-4F0E-BABB-317F0A1FD39F}"/>
               </a:ext>
             </a:extLst>
           </p:cNvPr>
@@ -3605,7 +3605,7 @@
           <p:cNvPr id="9" name="">
             <a:extLst xmlns:a="http://schemas.openxmlformats.org/drawingml/2006/main">
               <a:ext uri="{FF2B5EF4-FFF2-40B4-BE49-F238E27FC236}">
-                <a16:creationId xmlns:a16="http://schemas.microsoft.com/office/drawing/2014/main" id="{EB1E8A97-3678-434E-802F-E9280312F5FD}"/>
+                <a16:creationId xmlns:a16="http://schemas.microsoft.com/office/drawing/2014/main" id="{67FDB168-288F-4A3B-961C-48555A0BEDAF}"/>
               </a:ext>
             </a:extLst>
           </p:cNvPr>
@@ -3655,7 +3655,7 @@
           <p:cNvPr id="10" name="">
             <a:extLst xmlns:a="http://schemas.openxmlformats.org/drawingml/2006/main">
               <a:ext uri="{FF2B5EF4-FFF2-40B4-BE49-F238E27FC236}">
-                <a16:creationId xmlns:a16="http://schemas.microsoft.com/office/drawing/2014/main" id="{B234FE86-F1AD-4900-A414-BD8A294F8AD2}"/>
+                <a16:creationId xmlns:a16="http://schemas.microsoft.com/office/drawing/2014/main" id="{DCF9666D-0694-4D80-A2BF-9227014CEC3B}"/>
               </a:ext>
             </a:extLst>
           </p:cNvPr>
@@ -3705,7 +3705,7 @@
           <p:cNvPr id="11" name="">
             <a:extLst xmlns:a="http://schemas.openxmlformats.org/drawingml/2006/main">
               <a:ext uri="{FF2B5EF4-FFF2-40B4-BE49-F238E27FC236}">
-                <a16:creationId xmlns:a16="http://schemas.microsoft.com/office/drawing/2014/main" id="{991BC2EA-7748-48E6-8B70-38635A407992}"/>
+                <a16:creationId xmlns:a16="http://schemas.microsoft.com/office/drawing/2014/main" id="{44483A01-9E73-4AED-A468-1769F83B245F}"/>
               </a:ext>
             </a:extLst>
           </p:cNvPr>
@@ -3755,7 +3755,7 @@
           <p:cNvPr id="12" name="">
             <a:extLst xmlns:a="http://schemas.openxmlformats.org/drawingml/2006/main">
               <a:ext uri="{FF2B5EF4-FFF2-40B4-BE49-F238E27FC236}">
-                <a16:creationId xmlns:a16="http://schemas.microsoft.com/office/drawing/2014/main" id="{44510E62-8ED3-4AE6-8364-9FA21809DC8A}"/>
+                <a16:creationId xmlns:a16="http://schemas.microsoft.com/office/drawing/2014/main" id="{BE08C76A-08FE-433C-BA8A-1238527774E8}"/>
               </a:ext>
             </a:extLst>
           </p:cNvPr>
@@ -3790,7 +3790,7 @@
           <p:cNvPr id="13" name="">
             <a:extLst xmlns:a="http://schemas.openxmlformats.org/drawingml/2006/main">
               <a:ext uri="{FF2B5EF4-FFF2-40B4-BE49-F238E27FC236}">
-                <a16:creationId xmlns:a16="http://schemas.microsoft.com/office/drawing/2014/main" id="{311958E4-69CB-4928-A880-31BD2CAE0F02}"/>
+                <a16:creationId xmlns:a16="http://schemas.microsoft.com/office/drawing/2014/main" id="{E7C536AD-C70B-415D-A3CA-BD72BF630768}"/>
               </a:ext>
             </a:extLst>
           </p:cNvPr>
@@ -3823,7 +3823,7 @@
           <p:cNvPr id="14" name="">
             <a:extLst xmlns:a="http://schemas.openxmlformats.org/drawingml/2006/main">
               <a:ext uri="{FF2B5EF4-FFF2-40B4-BE49-F238E27FC236}">
-                <a16:creationId xmlns:a16="http://schemas.microsoft.com/office/drawing/2014/main" id="{4896A7EC-4C0B-4F4F-8DA2-5EEBF7C8FFE8}"/>
+                <a16:creationId xmlns:a16="http://schemas.microsoft.com/office/drawing/2014/main" id="{BFD34E15-D860-4F02-B758-18725724439C}"/>
               </a:ext>
             </a:extLst>
           </p:cNvPr>
@@ -3873,7 +3873,7 @@
           <p:cNvPr id="15" name="">
             <a:extLst xmlns:a="http://schemas.openxmlformats.org/drawingml/2006/main">
               <a:ext uri="{FF2B5EF4-FFF2-40B4-BE49-F238E27FC236}">
-                <a16:creationId xmlns:a16="http://schemas.microsoft.com/office/drawing/2014/main" id="{4363664A-288F-44FC-8C47-AA67F27AC84C}"/>
+                <a16:creationId xmlns:a16="http://schemas.microsoft.com/office/drawing/2014/main" id="{41E48B7F-75D3-46B7-B236-D6FD5C343ED6}"/>
               </a:ext>
             </a:extLst>
           </p:cNvPr>
@@ -3923,7 +3923,7 @@
           <p:cNvPr id="16" name="">
             <a:extLst xmlns:a="http://schemas.openxmlformats.org/drawingml/2006/main">
               <a:ext uri="{FF2B5EF4-FFF2-40B4-BE49-F238E27FC236}">
-                <a16:creationId xmlns:a16="http://schemas.microsoft.com/office/drawing/2014/main" id="{95E3C51A-2F99-40D4-90C7-2FCDA19DB1D1}"/>
+                <a16:creationId xmlns:a16="http://schemas.microsoft.com/office/drawing/2014/main" id="{5D0BBB86-EAE4-4845-8668-7464916CD346}"/>
               </a:ext>
             </a:extLst>
           </p:cNvPr>
@@ -3973,7 +3973,7 @@
           <p:cNvPr id="17" name="">
             <a:extLst xmlns:a="http://schemas.openxmlformats.org/drawingml/2006/main">
               <a:ext uri="{FF2B5EF4-FFF2-40B4-BE49-F238E27FC236}">
-                <a16:creationId xmlns:a16="http://schemas.microsoft.com/office/drawing/2014/main" id="{FD92676B-A59E-4A31-A4D8-63B977298A9F}"/>
+                <a16:creationId xmlns:a16="http://schemas.microsoft.com/office/drawing/2014/main" id="{A9AFB841-7E20-4600-911A-6D2F976E8CBB}"/>
               </a:ext>
             </a:extLst>
           </p:cNvPr>
@@ -4008,7 +4008,7 @@
           <p:cNvPr id="18" name="">
             <a:extLst xmlns:a="http://schemas.openxmlformats.org/drawingml/2006/main">
               <a:ext uri="{FF2B5EF4-FFF2-40B4-BE49-F238E27FC236}">
-                <a16:creationId xmlns:a16="http://schemas.microsoft.com/office/drawing/2014/main" id="{ABC9A05F-99EE-4C03-A443-F56A17811D85}"/>
+                <a16:creationId xmlns:a16="http://schemas.microsoft.com/office/drawing/2014/main" id="{F6D3D123-0EDF-444D-8257-27FEAF763D8D}"/>
               </a:ext>
             </a:extLst>
           </p:cNvPr>
@@ -4041,7 +4041,7 @@
           <p:cNvPr id="19" name="">
             <a:extLst xmlns:a="http://schemas.openxmlformats.org/drawingml/2006/main">
               <a:ext uri="{FF2B5EF4-FFF2-40B4-BE49-F238E27FC236}">
-                <a16:creationId xmlns:a16="http://schemas.microsoft.com/office/drawing/2014/main" id="{573BF0A0-CD5F-4EFD-8A33-98E94AC55599}"/>
+                <a16:creationId xmlns:a16="http://schemas.microsoft.com/office/drawing/2014/main" id="{E9E7D230-759A-4B17-BA17-B333EAE83D22}"/>
               </a:ext>
             </a:extLst>
           </p:cNvPr>
@@ -4081,7 +4081,7 @@
                   <a:srgbClr val="5A6B7C"/>
                 </a:solidFill>
               </a:rPr>
-              <a:t>Review notes in scope</a:t>
+              <a:t>Material findings</a:t>
             </a:r>
           </a:p>
         </p:txBody>
@@ -4091,7 +4091,7 @@
           <p:cNvPr id="20" name="">
             <a:extLst xmlns:a="http://schemas.openxmlformats.org/drawingml/2006/main">
               <a:ext uri="{FF2B5EF4-FFF2-40B4-BE49-F238E27FC236}">
-                <a16:creationId xmlns:a16="http://schemas.microsoft.com/office/drawing/2014/main" id="{3D1DF570-B563-428C-A08A-20203510BE01}"/>
+                <a16:creationId xmlns:a16="http://schemas.microsoft.com/office/drawing/2014/main" id="{BA0251F5-6F7B-4071-8A6E-6F9A47864E7B}"/>
               </a:ext>
             </a:extLst>
           </p:cNvPr>
@@ -4131,7 +4131,7 @@
                   <a:srgbClr val="142F4C"/>
                 </a:solidFill>
               </a:rPr>
-              <a:t>1</a:t>
+              <a:t>15</a:t>
             </a:r>
           </a:p>
         </p:txBody>
@@ -4141,7 +4141,7 @@
           <p:cNvPr id="21" name="">
             <a:extLst xmlns:a="http://schemas.openxmlformats.org/drawingml/2006/main">
               <a:ext uri="{FF2B5EF4-FFF2-40B4-BE49-F238E27FC236}">
-                <a16:creationId xmlns:a16="http://schemas.microsoft.com/office/drawing/2014/main" id="{DB3ECE6D-9818-46E8-BE93-261B81CA8BE2}"/>
+                <a16:creationId xmlns:a16="http://schemas.microsoft.com/office/drawing/2014/main" id="{F3ABA5FB-B0AB-4DEE-8085-D30A77A1E6F8}"/>
               </a:ext>
             </a:extLst>
           </p:cNvPr>
@@ -4181,7 +4181,7 @@
                   <a:srgbClr val="5A6B7C"/>
                 </a:solidFill>
               </a:rPr>
-              <a:t>of 64 items</a:t>
+              <a:t>priority diagnosis</a:t>
             </a:r>
           </a:p>
         </p:txBody>
@@ -4191,7 +4191,7 @@
           <p:cNvPr id="22" name="">
             <a:extLst xmlns:a="http://schemas.openxmlformats.org/drawingml/2006/main">
               <a:ext uri="{FF2B5EF4-FFF2-40B4-BE49-F238E27FC236}">
-                <a16:creationId xmlns:a16="http://schemas.microsoft.com/office/drawing/2014/main" id="{ACEF1172-46B3-42E3-BEB0-137D12BBEDC7}"/>
+                <a16:creationId xmlns:a16="http://schemas.microsoft.com/office/drawing/2014/main" id="{88CCC5AC-A2A5-4AC9-AC01-C61EFB2712C2}"/>
               </a:ext>
             </a:extLst>
           </p:cNvPr>
@@ -4226,7 +4226,7 @@
           <p:cNvPr id="23" name="">
             <a:extLst xmlns:a="http://schemas.openxmlformats.org/drawingml/2006/main">
               <a:ext uri="{FF2B5EF4-FFF2-40B4-BE49-F238E27FC236}">
-                <a16:creationId xmlns:a16="http://schemas.microsoft.com/office/drawing/2014/main" id="{7C858EF8-7B80-4651-AD36-4046716F5E65}"/>
+                <a16:creationId xmlns:a16="http://schemas.microsoft.com/office/drawing/2014/main" id="{DF89159E-2530-49CD-9866-33D8BFA310D3}"/>
               </a:ext>
             </a:extLst>
           </p:cNvPr>
@@ -4259,7 +4259,7 @@
           <p:cNvPr id="24" name="">
             <a:extLst xmlns:a="http://schemas.openxmlformats.org/drawingml/2006/main">
               <a:ext uri="{FF2B5EF4-FFF2-40B4-BE49-F238E27FC236}">
-                <a16:creationId xmlns:a16="http://schemas.microsoft.com/office/drawing/2014/main" id="{E5BD11DE-F069-4600-BF66-ED407B49FB9B}"/>
+                <a16:creationId xmlns:a16="http://schemas.microsoft.com/office/drawing/2014/main" id="{A7363DF0-B8A5-4BDE-BD01-6F30A2821A02}"/>
               </a:ext>
             </a:extLst>
           </p:cNvPr>
@@ -4299,7 +4299,7 @@
                   <a:srgbClr val="5A6B7C"/>
                 </a:solidFill>
               </a:rPr>
-              <a:t>Open information items</a:t>
+              <a:t>Target controls</a:t>
             </a:r>
           </a:p>
         </p:txBody>
@@ -4309,7 +4309,7 @@
           <p:cNvPr id="25" name="">
             <a:extLst xmlns:a="http://schemas.openxmlformats.org/drawingml/2006/main">
               <a:ext uri="{FF2B5EF4-FFF2-40B4-BE49-F238E27FC236}">
-                <a16:creationId xmlns:a16="http://schemas.microsoft.com/office/drawing/2014/main" id="{F6231BAD-1A2D-49DB-9992-4389170C53FE}"/>
+                <a16:creationId xmlns:a16="http://schemas.microsoft.com/office/drawing/2014/main" id="{B09F610E-37BA-412C-99B8-C2CD57CF08A5}"/>
               </a:ext>
             </a:extLst>
           </p:cNvPr>
@@ -4349,7 +4349,7 @@
                   <a:srgbClr val="142F4C"/>
                 </a:solidFill>
               </a:rPr>
-              <a:t>63</a:t>
+              <a:t>15</a:t>
             </a:r>
           </a:p>
         </p:txBody>
@@ -4359,7 +4359,7 @@
           <p:cNvPr id="26" name="">
             <a:extLst xmlns:a="http://schemas.openxmlformats.org/drawingml/2006/main">
               <a:ext uri="{FF2B5EF4-FFF2-40B4-BE49-F238E27FC236}">
-                <a16:creationId xmlns:a16="http://schemas.microsoft.com/office/drawing/2014/main" id="{87CF3402-ED9C-446D-8826-C8614CF4FED2}"/>
+                <a16:creationId xmlns:a16="http://schemas.microsoft.com/office/drawing/2014/main" id="{E3D7EA46-7112-4E39-BDFA-1173BB45B2F9}"/>
               </a:ext>
             </a:extLst>
           </p:cNvPr>
@@ -4399,7 +4399,7 @@
                   <a:srgbClr val="5A6B7C"/>
                 </a:solidFill>
               </a:rPr>
-              <a:t>items requiring closure</a:t>
+              <a:t>blueprints to build</a:t>
             </a:r>
           </a:p>
         </p:txBody>
@@ -4409,7 +4409,7 @@
           <p:cNvPr id="27" name="">
             <a:extLst xmlns:a="http://schemas.openxmlformats.org/drawingml/2006/main">
               <a:ext uri="{FF2B5EF4-FFF2-40B4-BE49-F238E27FC236}">
-                <a16:creationId xmlns:a16="http://schemas.microsoft.com/office/drawing/2014/main" id="{EB10228F-2157-4ED9-AA7D-7C7D1E2F7114}"/>
+                <a16:creationId xmlns:a16="http://schemas.microsoft.com/office/drawing/2014/main" id="{BCB6400F-F10F-4A25-B102-0EF502950CAE}"/>
               </a:ext>
             </a:extLst>
           </p:cNvPr>
@@ -4444,7 +4444,7 @@
           <p:cNvPr id="28" name="">
             <a:extLst xmlns:a="http://schemas.openxmlformats.org/drawingml/2006/main">
               <a:ext uri="{FF2B5EF4-FFF2-40B4-BE49-F238E27FC236}">
-                <a16:creationId xmlns:a16="http://schemas.microsoft.com/office/drawing/2014/main" id="{D78EDF21-9208-45C8-AE2C-D31EAAAE2830}"/>
+                <a16:creationId xmlns:a16="http://schemas.microsoft.com/office/drawing/2014/main" id="{5A77CA33-9E3A-4AD0-A06A-4E0F29FA440B}"/>
               </a:ext>
             </a:extLst>
           </p:cNvPr>
@@ -4494,7 +4494,7 @@
           <p:cNvPr id="29" name="">
             <a:extLst xmlns:a="http://schemas.openxmlformats.org/drawingml/2006/main">
               <a:ext uri="{FF2B5EF4-FFF2-40B4-BE49-F238E27FC236}">
-                <a16:creationId xmlns:a16="http://schemas.microsoft.com/office/drawing/2014/main" id="{55421360-78DA-4CA6-B804-979A4C9C206D}"/>
+                <a16:creationId xmlns:a16="http://schemas.microsoft.com/office/drawing/2014/main" id="{7AFA772B-FF86-481C-ACF4-C7B80117B881}"/>
               </a:ext>
             </a:extLst>
           </p:cNvPr>
@@ -4534,7 +4534,7 @@
                   <a:srgbClr val="142F4C"/>
                 </a:solidFill>
               </a:rPr>
-              <a:t>The score is the locked recorded result. Human review changes the confidence, scope and decision implications around that result; it does not silently recalculate it.</a:t>
+              <a:t>The score is the locked recorded result. The blueprint translates management's recorded responses into diagnosis, decisions and target-state control design.</a:t>
             </a:r>
           </a:p>
         </p:txBody>
@@ -4542,7 +4542,7 @@
     </p:spTree>
     <p:extLst>
       <p:ext uri="{BB962C8B-B14F-4D97-AF65-F5344CB8AC3E}">
-        <p14:creationId xmlns:p14="http://schemas.microsoft.com/office/powerpoint/2010/main" val="396547063"/>
+        <p14:creationId xmlns:p14="http://schemas.microsoft.com/office/powerpoint/2010/main" val="1990216605"/>
       </p:ext>
     </p:extLst>
   </p:cSld>
@@ -4573,7 +4573,7 @@
           <p:cNvPr id="26" name="">
             <a:extLst xmlns:a="http://schemas.openxmlformats.org/drawingml/2006/main">
               <a:ext uri="{FF2B5EF4-FFF2-40B4-BE49-F238E27FC236}">
-                <a16:creationId xmlns:a16="http://schemas.microsoft.com/office/drawing/2014/main" id="{A6B00832-C541-4FC8-962A-0D352A410B57}"/>
+                <a16:creationId xmlns:a16="http://schemas.microsoft.com/office/drawing/2014/main" id="{1CED9AF6-6B5D-4E5D-8283-FD0C8D04C99B}"/>
               </a:ext>
             </a:extLst>
           </p:cNvPr>
@@ -4623,7 +4623,7 @@
           <p:cNvPr id="2" name="">
             <a:extLst xmlns:a="http://schemas.openxmlformats.org/drawingml/2006/main">
               <a:ext uri="{FF2B5EF4-FFF2-40B4-BE49-F238E27FC236}">
-                <a16:creationId xmlns:a16="http://schemas.microsoft.com/office/drawing/2014/main" id="{A9E02EF7-B8B5-488A-BA45-61A6AD8FDE67}"/>
+                <a16:creationId xmlns:a16="http://schemas.microsoft.com/office/drawing/2014/main" id="{F82F32DF-1143-471F-8E63-88DFD26D927E}"/>
               </a:ext>
             </a:extLst>
           </p:cNvPr>
@@ -4663,7 +4663,7 @@
                   <a:srgbClr val="142F4C"/>
                 </a:solidFill>
               </a:rPr>
-              <a:t>The information boundary is visible before decisions are made.</a:t>
+              <a:t>Diagnosis shows where exposure concentrates.</a:t>
             </a:r>
           </a:p>
         </p:txBody>
@@ -4673,7 +4673,7 @@
           <p:cNvPr id="3" name="">
             <a:extLst xmlns:a="http://schemas.openxmlformats.org/drawingml/2006/main">
               <a:ext uri="{FF2B5EF4-FFF2-40B4-BE49-F238E27FC236}">
-                <a16:creationId xmlns:a16="http://schemas.microsoft.com/office/drawing/2014/main" id="{14FE0C2C-39AE-4ECB-AD5B-02FA74BDB1CA}"/>
+                <a16:creationId xmlns:a16="http://schemas.microsoft.com/office/drawing/2014/main" id="{36BA9C4F-8496-4EFE-9DE4-EDDC44E9BCB5}"/>
               </a:ext>
             </a:extLst>
           </p:cNvPr>
@@ -4713,7 +4713,7 @@
                   <a:srgbClr val="5A6B7C"/>
                 </a:solidFill>
               </a:rPr>
-              <a:t>The register makes scope, review notes and open items visible in one view.</a:t>
+              <a:t>Material findings, risks and control blueprints are the decision-useful analytical universe.</a:t>
             </a:r>
           </a:p>
         </p:txBody>
@@ -4723,7 +4723,7 @@
           <p:cNvPr id="4" name="">
             <a:extLst xmlns:a="http://schemas.openxmlformats.org/drawingml/2006/main">
               <a:ext uri="{FF2B5EF4-FFF2-40B4-BE49-F238E27FC236}">
-                <a16:creationId xmlns:a16="http://schemas.microsoft.com/office/drawing/2014/main" id="{7D533FDD-BB3B-4DD5-B54B-221178A5C747}"/>
+                <a16:creationId xmlns:a16="http://schemas.microsoft.com/office/drawing/2014/main" id="{0811B19A-3055-42D5-B23B-BFE6EE494D63}"/>
               </a:ext>
             </a:extLst>
           </p:cNvPr>
@@ -4754,7 +4754,7 @@
           <p:cNvPr id="5" name="">
             <a:extLst xmlns:a="http://schemas.openxmlformats.org/drawingml/2006/main">
               <a:ext uri="{FF2B5EF4-FFF2-40B4-BE49-F238E27FC236}">
-                <a16:creationId xmlns:a16="http://schemas.microsoft.com/office/drawing/2014/main" id="{20B2BED4-8EB5-4D0F-A953-0A5E59709FE9}"/>
+                <a16:creationId xmlns:a16="http://schemas.microsoft.com/office/drawing/2014/main" id="{5F4A3123-6CDF-4012-8BBD-25E0AA3C2DB4}"/>
               </a:ext>
             </a:extLst>
           </p:cNvPr>
@@ -4804,7 +4804,7 @@
           <p:cNvPr id="6" name="">
             <a:extLst xmlns:a="http://schemas.openxmlformats.org/drawingml/2006/main">
               <a:ext uri="{FF2B5EF4-FFF2-40B4-BE49-F238E27FC236}">
-                <a16:creationId xmlns:a16="http://schemas.microsoft.com/office/drawing/2014/main" id="{CBB591A5-107B-4BCB-8AF2-5FD6DB1D98DC}"/>
+                <a16:creationId xmlns:a16="http://schemas.microsoft.com/office/drawing/2014/main" id="{6FF92F8B-0FAD-49C0-A562-4B73A4147B8F}"/>
               </a:ext>
             </a:extLst>
           </p:cNvPr>
@@ -4854,7 +4854,7 @@
           <p:cNvPr id="7" name="">
             <a:extLst xmlns:a="http://schemas.openxmlformats.org/drawingml/2006/main">
               <a:ext uri="{FF2B5EF4-FFF2-40B4-BE49-F238E27FC236}">
-                <a16:creationId xmlns:a16="http://schemas.microsoft.com/office/drawing/2014/main" id="{1E2DE2AE-1C7C-47E7-8356-293B26F00C49}"/>
+                <a16:creationId xmlns:a16="http://schemas.microsoft.com/office/drawing/2014/main" id="{9F1CACCE-5D41-4BC1-9B31-4A5149D13212}"/>
               </a:ext>
             </a:extLst>
           </p:cNvPr>
@@ -4894,7 +4894,7 @@
                   <a:srgbClr val="142F4C"/>
                 </a:solidFill>
               </a:rPr>
-              <a:t>Review note — stated scope</a:t>
+              <a:t>Material findings</a:t>
             </a:r>
           </a:p>
         </p:txBody>
@@ -4904,7 +4904,7 @@
           <p:cNvPr id="8" name="">
             <a:extLst xmlns:a="http://schemas.openxmlformats.org/drawingml/2006/main">
               <a:ext uri="{FF2B5EF4-FFF2-40B4-BE49-F238E27FC236}">
-                <a16:creationId xmlns:a16="http://schemas.microsoft.com/office/drawing/2014/main" id="{3A9F2A02-461E-4C39-9B4B-2A37023FF9CE}"/>
+                <a16:creationId xmlns:a16="http://schemas.microsoft.com/office/drawing/2014/main" id="{0B74E5EC-A958-475E-96B3-F2EC1938941C}"/>
               </a:ext>
             </a:extLst>
           </p:cNvPr>
@@ -4937,7 +4937,7 @@
           <p:cNvPr id="9" name="">
             <a:extLst xmlns:a="http://schemas.openxmlformats.org/drawingml/2006/main">
               <a:ext uri="{FF2B5EF4-FFF2-40B4-BE49-F238E27FC236}">
-                <a16:creationId xmlns:a16="http://schemas.microsoft.com/office/drawing/2014/main" id="{DD379AA0-0DE5-45ED-8E27-A7A44504440A}"/>
+                <a16:creationId xmlns:a16="http://schemas.microsoft.com/office/drawing/2014/main" id="{8843BD51-1AAD-45F3-8FD6-B9C8A1C3B8A2}"/>
               </a:ext>
             </a:extLst>
           </p:cNvPr>
@@ -4949,7 +4949,7 @@
         <p:spPr>
           <a:xfrm xmlns:a="http://schemas.openxmlformats.org/drawingml/2006/main">
             <a:off x="4000500" y="2143125"/>
-            <a:ext cx="171450" cy="228600"/>
+            <a:ext cx="1485900" cy="228600"/>
           </a:xfrm>
           <a:prstGeom xmlns:a="http://schemas.openxmlformats.org/drawingml/2006/main" prst="rect">
             <a:avLst/>
@@ -4970,7 +4970,7 @@
           <p:cNvPr id="10" name="">
             <a:extLst xmlns:a="http://schemas.openxmlformats.org/drawingml/2006/main">
               <a:ext uri="{FF2B5EF4-FFF2-40B4-BE49-F238E27FC236}">
-                <a16:creationId xmlns:a16="http://schemas.microsoft.com/office/drawing/2014/main" id="{D2CF2424-3D0A-4DF9-A7AA-5316621A2E6D}"/>
+                <a16:creationId xmlns:a16="http://schemas.microsoft.com/office/drawing/2014/main" id="{BC7DE93D-9F56-4CD5-AC85-0D6F1F86C0E9}"/>
               </a:ext>
             </a:extLst>
           </p:cNvPr>
@@ -5010,7 +5010,7 @@
                   <a:srgbClr val="142F4C"/>
                 </a:solidFill>
               </a:rPr>
-              <a:t>1</a:t>
+              <a:t>15</a:t>
             </a:r>
           </a:p>
         </p:txBody>
@@ -5020,7 +5020,7 @@
           <p:cNvPr id="11" name="">
             <a:extLst xmlns:a="http://schemas.openxmlformats.org/drawingml/2006/main">
               <a:ext uri="{FF2B5EF4-FFF2-40B4-BE49-F238E27FC236}">
-                <a16:creationId xmlns:a16="http://schemas.microsoft.com/office/drawing/2014/main" id="{F444AA37-4F19-462E-96BE-662B571FAC4F}"/>
+                <a16:creationId xmlns:a16="http://schemas.microsoft.com/office/drawing/2014/main" id="{18DF0774-1A83-4F59-BAD1-5F033CFAAF37}"/>
               </a:ext>
             </a:extLst>
           </p:cNvPr>
@@ -5060,7 +5060,7 @@
                   <a:srgbClr val="142F4C"/>
                 </a:solidFill>
               </a:rPr>
-              <a:t>Management review record</a:t>
+              <a:t>Priority risks</a:t>
             </a:r>
           </a:p>
         </p:txBody>
@@ -5070,7 +5070,7 @@
           <p:cNvPr id="12" name="">
             <a:extLst xmlns:a="http://schemas.openxmlformats.org/drawingml/2006/main">
               <a:ext uri="{FF2B5EF4-FFF2-40B4-BE49-F238E27FC236}">
-                <a16:creationId xmlns:a16="http://schemas.microsoft.com/office/drawing/2014/main" id="{35BB73E9-6547-46FB-8FF0-198FB3327990}"/>
+                <a16:creationId xmlns:a16="http://schemas.microsoft.com/office/drawing/2014/main" id="{973BA020-3A07-4134-AE3C-790CC938633E}"/>
               </a:ext>
             </a:extLst>
           </p:cNvPr>
@@ -5103,7 +5103,7 @@
           <p:cNvPr id="13" name="">
             <a:extLst xmlns:a="http://schemas.openxmlformats.org/drawingml/2006/main">
               <a:ext uri="{FF2B5EF4-FFF2-40B4-BE49-F238E27FC236}">
-                <a16:creationId xmlns:a16="http://schemas.microsoft.com/office/drawing/2014/main" id="{CCCCDCA8-321C-4BA0-941C-2135A452915B}"/>
+                <a16:creationId xmlns:a16="http://schemas.microsoft.com/office/drawing/2014/main" id="{B9AB5354-7DA3-42EC-A8B3-9E2845E7D37A}"/>
               </a:ext>
             </a:extLst>
           </p:cNvPr>
@@ -5115,7 +5115,7 @@
         <p:spPr>
           <a:xfrm xmlns:a="http://schemas.openxmlformats.org/drawingml/2006/main">
             <a:off x="4000500" y="2733675"/>
-            <a:ext cx="171450" cy="228600"/>
+            <a:ext cx="1485900" cy="228600"/>
           </a:xfrm>
           <a:prstGeom xmlns:a="http://schemas.openxmlformats.org/drawingml/2006/main" prst="rect">
             <a:avLst/>
@@ -5136,7 +5136,7 @@
           <p:cNvPr id="14" name="">
             <a:extLst xmlns:a="http://schemas.openxmlformats.org/drawingml/2006/main">
               <a:ext uri="{FF2B5EF4-FFF2-40B4-BE49-F238E27FC236}">
-                <a16:creationId xmlns:a16="http://schemas.microsoft.com/office/drawing/2014/main" id="{29A8FCA0-44E3-4E51-B7E4-F890ACF3EB5C}"/>
+                <a16:creationId xmlns:a16="http://schemas.microsoft.com/office/drawing/2014/main" id="{FF64F109-FF9A-43C9-B932-4058704DC618}"/>
               </a:ext>
             </a:extLst>
           </p:cNvPr>
@@ -5176,7 +5176,7 @@
                   <a:srgbClr val="142F4C"/>
                 </a:solidFill>
               </a:rPr>
-              <a:t>0</a:t>
+              <a:t>15</a:t>
             </a:r>
           </a:p>
         </p:txBody>
@@ -5186,7 +5186,7 @@
           <p:cNvPr id="15" name="">
             <a:extLst xmlns:a="http://schemas.openxmlformats.org/drawingml/2006/main">
               <a:ext uri="{FF2B5EF4-FFF2-40B4-BE49-F238E27FC236}">
-                <a16:creationId xmlns:a16="http://schemas.microsoft.com/office/drawing/2014/main" id="{D03A429A-C0F7-4A93-994E-928D86D5F55A}"/>
+                <a16:creationId xmlns:a16="http://schemas.microsoft.com/office/drawing/2014/main" id="{8759E8F6-68A9-422E-B141-9831AA2CA03A}"/>
               </a:ext>
             </a:extLst>
           </p:cNvPr>
@@ -5226,7 +5226,7 @@
                   <a:srgbClr val="142F4C"/>
                 </a:solidFill>
               </a:rPr>
-              <a:t>Further basis required</a:t>
+              <a:t>Scenarios</a:t>
             </a:r>
           </a:p>
         </p:txBody>
@@ -5236,7 +5236,7 @@
           <p:cNvPr id="16" name="">
             <a:extLst xmlns:a="http://schemas.openxmlformats.org/drawingml/2006/main">
               <a:ext uri="{FF2B5EF4-FFF2-40B4-BE49-F238E27FC236}">
-                <a16:creationId xmlns:a16="http://schemas.microsoft.com/office/drawing/2014/main" id="{5AA82CB4-3023-4F55-9E87-E3E95ED1726E}"/>
+                <a16:creationId xmlns:a16="http://schemas.microsoft.com/office/drawing/2014/main" id="{70D028FD-04A5-4FB1-AE95-867E74D76FE5}"/>
               </a:ext>
             </a:extLst>
           </p:cNvPr>
@@ -5269,7 +5269,7 @@
           <p:cNvPr id="17" name="">
             <a:extLst xmlns:a="http://schemas.openxmlformats.org/drawingml/2006/main">
               <a:ext uri="{FF2B5EF4-FFF2-40B4-BE49-F238E27FC236}">
-                <a16:creationId xmlns:a16="http://schemas.microsoft.com/office/drawing/2014/main" id="{76C68314-29F8-48BC-9317-B82100C8EB7D}"/>
+                <a16:creationId xmlns:a16="http://schemas.microsoft.com/office/drawing/2014/main" id="{B60D556E-F9E4-4068-A9AF-C601A85DE146}"/>
               </a:ext>
             </a:extLst>
           </p:cNvPr>
@@ -5281,7 +5281,7 @@
         <p:spPr>
           <a:xfrm xmlns:a="http://schemas.openxmlformats.org/drawingml/2006/main">
             <a:off x="4000500" y="3324225"/>
-            <a:ext cx="171450" cy="228600"/>
+            <a:ext cx="495300" cy="228600"/>
           </a:xfrm>
           <a:prstGeom xmlns:a="http://schemas.openxmlformats.org/drawingml/2006/main" prst="rect">
             <a:avLst/>
@@ -5302,7 +5302,7 @@
           <p:cNvPr id="18" name="">
             <a:extLst xmlns:a="http://schemas.openxmlformats.org/drawingml/2006/main">
               <a:ext uri="{FF2B5EF4-FFF2-40B4-BE49-F238E27FC236}">
-                <a16:creationId xmlns:a16="http://schemas.microsoft.com/office/drawing/2014/main" id="{7D453511-850B-447A-B86A-A7940D4493BA}"/>
+                <a16:creationId xmlns:a16="http://schemas.microsoft.com/office/drawing/2014/main" id="{20CF923D-BED2-4B19-B3DF-7655E653D167}"/>
               </a:ext>
             </a:extLst>
           </p:cNvPr>
@@ -5342,7 +5342,7 @@
                   <a:srgbClr val="142F4C"/>
                 </a:solidFill>
               </a:rPr>
-              <a:t>1</a:t>
+              <a:t>5</a:t>
             </a:r>
           </a:p>
         </p:txBody>
@@ -5352,7 +5352,7 @@
           <p:cNvPr id="19" name="">
             <a:extLst xmlns:a="http://schemas.openxmlformats.org/drawingml/2006/main">
               <a:ext uri="{FF2B5EF4-FFF2-40B4-BE49-F238E27FC236}">
-                <a16:creationId xmlns:a16="http://schemas.microsoft.com/office/drawing/2014/main" id="{5B9F2899-CD1D-4E07-B3B9-86A92DF5FFF5}"/>
+                <a16:creationId xmlns:a16="http://schemas.microsoft.com/office/drawing/2014/main" id="{1F894101-5478-434A-9D0A-625084246768}"/>
               </a:ext>
             </a:extLst>
           </p:cNvPr>
@@ -5392,7 +5392,7 @@
                   <a:srgbClr val="142F4C"/>
                 </a:solidFill>
               </a:rPr>
-              <a:t>Recorded / open</a:t>
+              <a:t>Target controls</a:t>
             </a:r>
           </a:p>
         </p:txBody>
@@ -5402,7 +5402,7 @@
           <p:cNvPr id="20" name="">
             <a:extLst xmlns:a="http://schemas.openxmlformats.org/drawingml/2006/main">
               <a:ext uri="{FF2B5EF4-FFF2-40B4-BE49-F238E27FC236}">
-                <a16:creationId xmlns:a16="http://schemas.microsoft.com/office/drawing/2014/main" id="{8C08062F-9464-4C08-8527-749B0376765B}"/>
+                <a16:creationId xmlns:a16="http://schemas.microsoft.com/office/drawing/2014/main" id="{AA63FB76-440D-42C4-A1B4-8762E87B57B3}"/>
               </a:ext>
             </a:extLst>
           </p:cNvPr>
@@ -5435,7 +5435,7 @@
           <p:cNvPr id="21" name="">
             <a:extLst xmlns:a="http://schemas.openxmlformats.org/drawingml/2006/main">
               <a:ext uri="{FF2B5EF4-FFF2-40B4-BE49-F238E27FC236}">
-                <a16:creationId xmlns:a16="http://schemas.microsoft.com/office/drawing/2014/main" id="{CE143B89-54AE-4023-B6B9-9DCDAED58FBE}"/>
+                <a16:creationId xmlns:a16="http://schemas.microsoft.com/office/drawing/2014/main" id="{370D531D-54FA-46A0-B3E4-A7591ACB4B2F}"/>
               </a:ext>
             </a:extLst>
           </p:cNvPr>
@@ -5447,7 +5447,7 @@
         <p:spPr>
           <a:xfrm xmlns:a="http://schemas.openxmlformats.org/drawingml/2006/main">
             <a:off x="4000500" y="3914775"/>
-            <a:ext cx="4720828" cy="228600"/>
+            <a:ext cx="1485900" cy="228600"/>
           </a:xfrm>
           <a:prstGeom xmlns:a="http://schemas.openxmlformats.org/drawingml/2006/main" prst="rect">
             <a:avLst/>
@@ -5468,7 +5468,7 @@
           <p:cNvPr id="22" name="">
             <a:extLst xmlns:a="http://schemas.openxmlformats.org/drawingml/2006/main">
               <a:ext uri="{FF2B5EF4-FFF2-40B4-BE49-F238E27FC236}">
-                <a16:creationId xmlns:a16="http://schemas.microsoft.com/office/drawing/2014/main" id="{821752F9-F9CD-4D74-9014-C3F7D5F1FF75}"/>
+                <a16:creationId xmlns:a16="http://schemas.microsoft.com/office/drawing/2014/main" id="{3708563C-2515-44C3-906C-7DC48DA69B9A}"/>
               </a:ext>
             </a:extLst>
           </p:cNvPr>
@@ -5508,7 +5508,7 @@
                   <a:srgbClr val="142F4C"/>
                 </a:solidFill>
               </a:rPr>
-              <a:t>61</a:t>
+              <a:t>15</a:t>
             </a:r>
           </a:p>
         </p:txBody>
@@ -5518,7 +5518,7 @@
           <p:cNvPr id="23" name="">
             <a:extLst xmlns:a="http://schemas.openxmlformats.org/drawingml/2006/main">
               <a:ext uri="{FF2B5EF4-FFF2-40B4-BE49-F238E27FC236}">
-                <a16:creationId xmlns:a16="http://schemas.microsoft.com/office/drawing/2014/main" id="{6027C477-FD4E-48FD-81D1-3BFDBD425506}"/>
+                <a16:creationId xmlns:a16="http://schemas.microsoft.com/office/drawing/2014/main" id="{78638634-A7A8-45C5-A7E1-418BB42F3E59}"/>
               </a:ext>
             </a:extLst>
           </p:cNvPr>
@@ -5553,7 +5553,7 @@
           <p:cNvPr id="24" name="">
             <a:extLst xmlns:a="http://schemas.openxmlformats.org/drawingml/2006/main">
               <a:ext uri="{FF2B5EF4-FFF2-40B4-BE49-F238E27FC236}">
-                <a16:creationId xmlns:a16="http://schemas.microsoft.com/office/drawing/2014/main" id="{B877741B-2441-4B38-90E7-C28D4DA1AC6D}"/>
+                <a16:creationId xmlns:a16="http://schemas.microsoft.com/office/drawing/2014/main" id="{DB762F22-91B8-42B1-A51F-8772052FA94C}"/>
               </a:ext>
             </a:extLst>
           </p:cNvPr>
@@ -5593,7 +5593,7 @@
                   <a:srgbClr val="C9A227"/>
                 </a:solidFill>
               </a:rPr>
-              <a:t>What the board can rely on</a:t>
+              <a:t>Blueprint reading rule</a:t>
             </a:r>
           </a:p>
         </p:txBody>
@@ -5603,7 +5603,7 @@
           <p:cNvPr id="25" name="">
             <a:extLst xmlns:a="http://schemas.openxmlformats.org/drawingml/2006/main">
               <a:ext uri="{FF2B5EF4-FFF2-40B4-BE49-F238E27FC236}">
-                <a16:creationId xmlns:a16="http://schemas.microsoft.com/office/drawing/2014/main" id="{9A3BDAE5-2DEC-4305-83C9-D67DC908774C}"/>
+                <a16:creationId xmlns:a16="http://schemas.microsoft.com/office/drawing/2014/main" id="{C39DAED2-09DB-41B8-82E3-2997D2450D75}"/>
               </a:ext>
             </a:extLst>
           </p:cNvPr>
@@ -5643,7 +5643,7 @@
                   <a:srgbClr val="1A2634"/>
                 </a:solidFill>
               </a:rPr>
-              <a:t>Only the named information scope. An open item limits reliance; it does not mean misconduct occurred.</a:t>
+              <a:t>The deterministic engine decides; bounded narrative explains. The target state is a management design, not a claim that operating effectiveness is already established.</a:t>
             </a:r>
           </a:p>
         </p:txBody>
@@ -5651,7 +5651,7 @@
     </p:spTree>
     <p:extLst>
       <p:ext uri="{BB962C8B-B14F-4D97-AF65-F5344CB8AC3E}">
-        <p14:creationId xmlns:p14="http://schemas.microsoft.com/office/powerpoint/2010/main" val="461055899"/>
+        <p14:creationId xmlns:p14="http://schemas.microsoft.com/office/powerpoint/2010/main" val="2129750882"/>
       </p:ext>
     </p:extLst>
   </p:cSld>
@@ -5679,10 +5679,10 @@
       </p:grpSpPr>
       <p:sp>
         <p:nvSpPr>
-          <p:cNvPr id="23" name="">
-            <a:extLst xmlns:a="http://schemas.openxmlformats.org/drawingml/2006/main">
-              <a:ext uri="{FF2B5EF4-FFF2-40B4-BE49-F238E27FC236}">
-                <a16:creationId xmlns:a16="http://schemas.microsoft.com/office/drawing/2014/main" id="{04F9E7D7-2914-4A80-81C9-CC077DAA2636}"/>
+          <p:cNvPr id="11" name="">
+            <a:extLst xmlns:a="http://schemas.openxmlformats.org/drawingml/2006/main">
+              <a:ext uri="{FF2B5EF4-FFF2-40B4-BE49-F238E27FC236}">
+                <a16:creationId xmlns:a16="http://schemas.microsoft.com/office/drawing/2014/main" id="{380FAE77-86D6-40B5-B3BC-B9F347F63D8C}"/>
               </a:ext>
             </a:extLst>
           </p:cNvPr>
@@ -5732,7 +5732,7 @@
           <p:cNvPr id="2" name="">
             <a:extLst xmlns:a="http://schemas.openxmlformats.org/drawingml/2006/main">
               <a:ext uri="{FF2B5EF4-FFF2-40B4-BE49-F238E27FC236}">
-                <a16:creationId xmlns:a16="http://schemas.microsoft.com/office/drawing/2014/main" id="{394D7A68-FCBE-4403-9F86-17DE27FCF980}"/>
+                <a16:creationId xmlns:a16="http://schemas.microsoft.com/office/drawing/2014/main" id="{6C69295E-6C94-4F2A-8A8D-79014FC74262}"/>
               </a:ext>
             </a:extLst>
           </p:cNvPr>
@@ -5772,7 +5772,7 @@
                   <a:srgbClr val="142F4C"/>
                 </a:solidFill>
               </a:rPr>
-              <a:t>Management review adds context where the assessment is too broad.</a:t>
+              <a:t>The themes interact across the control environment.</a:t>
             </a:r>
           </a:p>
         </p:txBody>
@@ -5782,7 +5782,7 @@
           <p:cNvPr id="3" name="">
             <a:extLst xmlns:a="http://schemas.openxmlformats.org/drawingml/2006/main">
               <a:ext uri="{FF2B5EF4-FFF2-40B4-BE49-F238E27FC236}">
-                <a16:creationId xmlns:a16="http://schemas.microsoft.com/office/drawing/2014/main" id="{1270EDDB-6062-4C07-B9B8-F22D6CFFF897}"/>
+                <a16:creationId xmlns:a16="http://schemas.microsoft.com/office/drawing/2014/main" id="{5888DB95-67B7-4974-828C-6668F09B511F}"/>
               </a:ext>
             </a:extLst>
           </p:cNvPr>
@@ -5822,7 +5822,7 @@
                   <a:srgbClr val="5A6B7C"/>
                 </a:solidFill>
               </a:rPr>
-              <a:t>Review notes narrow the conversation to the population and records actually supplied.</a:t>
+              <a:t>Use interaction patterns to prioritise target-state design.</a:t>
             </a:r>
           </a:p>
         </p:txBody>
@@ -5832,7 +5832,7 @@
           <p:cNvPr id="4" name="">
             <a:extLst xmlns:a="http://schemas.openxmlformats.org/drawingml/2006/main">
               <a:ext uri="{FF2B5EF4-FFF2-40B4-BE49-F238E27FC236}">
-                <a16:creationId xmlns:a16="http://schemas.microsoft.com/office/drawing/2014/main" id="{ADB34519-6185-4C4A-B53C-431DB3A80A2D}"/>
+                <a16:creationId xmlns:a16="http://schemas.microsoft.com/office/drawing/2014/main" id="{CC804553-AA06-4E36-881E-DA6C479FD15C}"/>
               </a:ext>
             </a:extLst>
           </p:cNvPr>
@@ -5863,7 +5863,7 @@
           <p:cNvPr id="5" name="">
             <a:extLst xmlns:a="http://schemas.openxmlformats.org/drawingml/2006/main">
               <a:ext uri="{FF2B5EF4-FFF2-40B4-BE49-F238E27FC236}">
-                <a16:creationId xmlns:a16="http://schemas.microsoft.com/office/drawing/2014/main" id="{84ABD712-D8E1-4F48-A193-CC7FD571531D}"/>
+                <a16:creationId xmlns:a16="http://schemas.microsoft.com/office/drawing/2014/main" id="{F1EA6CDB-E530-4EA6-8DE2-2196868C896C}"/>
               </a:ext>
             </a:extLst>
           </p:cNvPr>
@@ -5913,7 +5913,7 @@
           <p:cNvPr id="6" name="">
             <a:extLst xmlns:a="http://schemas.openxmlformats.org/drawingml/2006/main">
               <a:ext uri="{FF2B5EF4-FFF2-40B4-BE49-F238E27FC236}">
-                <a16:creationId xmlns:a16="http://schemas.microsoft.com/office/drawing/2014/main" id="{6739AD5D-EA2B-42A5-A0B6-F32A6D652DB9}"/>
+                <a16:creationId xmlns:a16="http://schemas.microsoft.com/office/drawing/2014/main" id="{C3112155-323B-4A34-A046-89E0784A574A}"/>
               </a:ext>
             </a:extLst>
           </p:cNvPr>
@@ -5963,204 +5963,21 @@
           <p:cNvPr id="7" name="">
             <a:extLst xmlns:a="http://schemas.openxmlformats.org/drawingml/2006/main">
               <a:ext uri="{FF2B5EF4-FFF2-40B4-BE49-F238E27FC236}">
-                <a16:creationId xmlns:a16="http://schemas.microsoft.com/office/drawing/2014/main" id="{5D3516BC-0275-4C81-B1FF-B8B6D28BD8DC}"/>
-              </a:ext>
-            </a:extLst>
-          </p:cNvPr>
-          <p:cNvSpPr>
-            <a:spLocks xmlns:a="http://schemas.openxmlformats.org/drawingml/2006/main" noGrp="1"/>
-          </p:cNvSpPr>
-          <p:nvPr/>
-        </p:nvSpPr>
-        <p:spPr>
-          <a:xfrm xmlns:a="http://schemas.openxmlformats.org/drawingml/2006/main">
-            <a:off x="838200" y="1981200"/>
-            <a:ext cx="76200" cy="647700"/>
-          </a:xfrm>
-          <a:prstGeom xmlns:a="http://schemas.openxmlformats.org/drawingml/2006/main" prst="rect">
-            <a:avLst/>
-          </a:prstGeom>
-          <a:solidFill xmlns:a="http://schemas.openxmlformats.org/drawingml/2006/main">
-            <a:srgbClr val="1F6B4A"/>
-          </a:solidFill>
-          <a:ln xmlns:a="http://schemas.openxmlformats.org/drawingml/2006/main" w="0">
-            <a:solidFill>
-              <a:srgbClr val="1F6B4A"/>
-            </a:solidFill>
-            <a:prstDash val="solid"/>
-          </a:ln>
-        </p:spPr>
-      </p:sp>
-      <p:sp>
-        <p:nvSpPr>
-          <p:cNvPr id="8" name="">
-            <a:extLst xmlns:a="http://schemas.openxmlformats.org/drawingml/2006/main">
-              <a:ext uri="{FF2B5EF4-FFF2-40B4-BE49-F238E27FC236}">
-                <a16:creationId xmlns:a16="http://schemas.microsoft.com/office/drawing/2014/main" id="{5A324ED2-1466-433C-B925-C19EF20CEA71}"/>
-              </a:ext>
-            </a:extLst>
-          </p:cNvPr>
-          <p:cNvSpPr>
-            <a:spLocks xmlns:a="http://schemas.openxmlformats.org/drawingml/2006/main" noGrp="1"/>
-          </p:cNvSpPr>
-          <p:nvPr/>
-        </p:nvSpPr>
-        <p:spPr>
-          <a:xfrm xmlns:a="http://schemas.openxmlformats.org/drawingml/2006/main">
-            <a:off x="1104900" y="1981200"/>
-            <a:ext cx="3143250" cy="266700"/>
-          </a:xfrm>
-          <a:prstGeom xmlns:a="http://schemas.openxmlformats.org/drawingml/2006/main" prst="rect">
-            <a:avLst/>
-          </a:prstGeom>
-          <a:noFill xmlns:a="http://schemas.openxmlformats.org/drawingml/2006/main"/>
-          <a:ln xmlns:a="http://schemas.openxmlformats.org/drawingml/2006/main" w="0">
-            <a:noFill/>
-            <a:prstDash val="solid"/>
-          </a:ln>
-        </p:spPr>
-        <p:txBody>
-          <a:bodyPr xmlns:a="http://schemas.openxmlformats.org/drawingml/2006/main"/>
-          <a:lstStyle xmlns:a="http://schemas.openxmlformats.org/drawingml/2006/main"/>
-          <a:p xmlns:a="http://schemas.openxmlformats.org/drawingml/2006/main">
-            <a:pPr>
-              <a:defRPr sz="1350" b="1">
-                <a:solidFill>
-                  <a:srgbClr val="142F4C"/>
-                </a:solidFill>
-              </a:defRPr>
-            </a:pPr>
-            <a:r>
-              <a:rPr sz="1350" b="1">
-                <a:solidFill>
-                  <a:srgbClr val="142F4C"/>
-                </a:solidFill>
-              </a:rPr>
-              <a:t>control design</a:t>
-            </a:r>
-          </a:p>
-        </p:txBody>
-      </p:sp>
-      <p:sp>
-        <p:nvSpPr>
-          <p:cNvPr id="9" name="">
-            <a:extLst xmlns:a="http://schemas.openxmlformats.org/drawingml/2006/main">
-              <a:ext uri="{FF2B5EF4-FFF2-40B4-BE49-F238E27FC236}">
-                <a16:creationId xmlns:a16="http://schemas.microsoft.com/office/drawing/2014/main" id="{EA014FE8-5BEA-4EDC-9E51-FEE7D5B4E68F}"/>
-              </a:ext>
-            </a:extLst>
-          </p:cNvPr>
-          <p:cNvSpPr>
-            <a:spLocks xmlns:a="http://schemas.openxmlformats.org/drawingml/2006/main" noGrp="1"/>
-          </p:cNvSpPr>
-          <p:nvPr/>
-        </p:nvSpPr>
-        <p:spPr>
-          <a:xfrm xmlns:a="http://schemas.openxmlformats.org/drawingml/2006/main">
-            <a:off x="4476750" y="1981200"/>
-            <a:ext cx="2952750" cy="266700"/>
-          </a:xfrm>
-          <a:prstGeom xmlns:a="http://schemas.openxmlformats.org/drawingml/2006/main" prst="rect">
-            <a:avLst/>
-          </a:prstGeom>
-          <a:noFill xmlns:a="http://schemas.openxmlformats.org/drawingml/2006/main"/>
-          <a:ln xmlns:a="http://schemas.openxmlformats.org/drawingml/2006/main" w="0">
-            <a:noFill/>
-            <a:prstDash val="solid"/>
-          </a:ln>
-        </p:spPr>
-        <p:txBody>
-          <a:bodyPr xmlns:a="http://schemas.openxmlformats.org/drawingml/2006/main"/>
-          <a:lstStyle xmlns:a="http://schemas.openxmlformats.org/drawingml/2006/main"/>
-          <a:p xmlns:a="http://schemas.openxmlformats.org/drawingml/2006/main">
-            <a:pPr>
-              <a:defRPr sz="1200">
-                <a:solidFill>
-                  <a:srgbClr val="5A6B7C"/>
-                </a:solidFill>
-              </a:defRPr>
-            </a:pPr>
-            <a:r>
-              <a:rPr sz="1200">
-                <a:solidFill>
-                  <a:srgbClr val="5A6B7C"/>
-                </a:solidFill>
-              </a:rPr>
-              <a:t>Recorded: Self-reported position retained unless separately evidenced.</a:t>
-            </a:r>
-          </a:p>
-        </p:txBody>
-      </p:sp>
-      <p:sp>
-        <p:nvSpPr>
-          <p:cNvPr id="10" name="">
-            <a:extLst xmlns:a="http://schemas.openxmlformats.org/drawingml/2006/main">
-              <a:ext uri="{FF2B5EF4-FFF2-40B4-BE49-F238E27FC236}">
-                <a16:creationId xmlns:a16="http://schemas.microsoft.com/office/drawing/2014/main" id="{8F91DC7D-3BE3-49AC-BB21-75467CE4C5E9}"/>
-              </a:ext>
-            </a:extLst>
-          </p:cNvPr>
-          <p:cNvSpPr>
-            <a:spLocks xmlns:a="http://schemas.openxmlformats.org/drawingml/2006/main" noGrp="1"/>
-          </p:cNvSpPr>
-          <p:nvPr/>
-        </p:nvSpPr>
-        <p:spPr>
-          <a:xfrm xmlns:a="http://schemas.openxmlformats.org/drawingml/2006/main">
-            <a:off x="7620000" y="1981200"/>
-            <a:ext cx="2571750" cy="495300"/>
-          </a:xfrm>
-          <a:prstGeom xmlns:a="http://schemas.openxmlformats.org/drawingml/2006/main" prst="rect">
-            <a:avLst/>
-          </a:prstGeom>
-          <a:noFill xmlns:a="http://schemas.openxmlformats.org/drawingml/2006/main"/>
-          <a:ln xmlns:a="http://schemas.openxmlformats.org/drawingml/2006/main" w="0">
-            <a:noFill/>
-            <a:prstDash val="solid"/>
-          </a:ln>
-        </p:spPr>
-        <p:txBody>
-          <a:bodyPr xmlns:a="http://schemas.openxmlformats.org/drawingml/2006/main"/>
-          <a:lstStyle xmlns:a="http://schemas.openxmlformats.org/drawingml/2006/main"/>
-          <a:p xmlns:a="http://schemas.openxmlformats.org/drawingml/2006/main">
-            <a:pPr>
-              <a:defRPr sz="1125">
-                <a:solidFill>
-                  <a:srgbClr val="1A2634"/>
-                </a:solidFill>
-              </a:defRPr>
-            </a:pPr>
-            <a:r>
-              <a:rPr sz="1125">
-                <a:solidFill>
-                  <a:srgbClr val="1A2634"/>
-                </a:solidFill>
-              </a:rPr>
-              <a:t>Review note: Design weakness: the control has no specification. Without red-flag definitions per process, monitoring frequency, population scope and an exception-handling route, two competent…</a:t>
-            </a:r>
-          </a:p>
-        </p:txBody>
-      </p:sp>
-      <p:sp>
-        <p:nvSpPr>
-          <p:cNvPr id="11" name="">
-            <a:extLst xmlns:a="http://schemas.openxmlformats.org/drawingml/2006/main">
-              <a:ext uri="{FF2B5EF4-FFF2-40B4-BE49-F238E27FC236}">
-                <a16:creationId xmlns:a16="http://schemas.microsoft.com/office/drawing/2014/main" id="{65D81EE8-DC2B-4A7B-AC7A-999F8F00AF60}"/>
-              </a:ext>
-            </a:extLst>
-          </p:cNvPr>
-          <p:cNvSpPr>
-            <a:spLocks xmlns:a="http://schemas.openxmlformats.org/drawingml/2006/main" noGrp="1"/>
-          </p:cNvSpPr>
-          <p:nvPr/>
-        </p:nvSpPr>
-        <p:spPr>
-          <a:xfrm xmlns:a="http://schemas.openxmlformats.org/drawingml/2006/main">
-            <a:off x="838200" y="2876550"/>
-            <a:ext cx="76200" cy="647700"/>
-          </a:xfrm>
-          <a:prstGeom xmlns:a="http://schemas.openxmlformats.org/drawingml/2006/main" prst="rect">
+                <a16:creationId xmlns:a16="http://schemas.microsoft.com/office/drawing/2014/main" id="{B012BE85-EC7C-485D-B41C-A7C8F5BFA714}"/>
+              </a:ext>
+            </a:extLst>
+          </p:cNvPr>
+          <p:cNvSpPr>
+            <a:spLocks xmlns:a="http://schemas.openxmlformats.org/drawingml/2006/main" noGrp="1"/>
+          </p:cNvSpPr>
+          <p:nvPr/>
+        </p:nvSpPr>
+        <p:spPr>
+          <a:xfrm xmlns:a="http://schemas.openxmlformats.org/drawingml/2006/main">
+            <a:off x="914400" y="2362200"/>
+            <a:ext cx="95250" cy="95250"/>
+          </a:xfrm>
+          <a:prstGeom xmlns:a="http://schemas.openxmlformats.org/drawingml/2006/main" prst="ellipse">
             <a:avLst/>
           </a:prstGeom>
           <a:solidFill xmlns:a="http://schemas.openxmlformats.org/drawingml/2006/main">
@@ -6176,357 +5993,74 @@
       </p:sp>
       <p:sp>
         <p:nvSpPr>
-          <p:cNvPr id="12" name="">
-            <a:extLst xmlns:a="http://schemas.openxmlformats.org/drawingml/2006/main">
-              <a:ext uri="{FF2B5EF4-FFF2-40B4-BE49-F238E27FC236}">
-                <a16:creationId xmlns:a16="http://schemas.microsoft.com/office/drawing/2014/main" id="{09801302-E456-4E35-96B8-653401049A14}"/>
-              </a:ext>
-            </a:extLst>
-          </p:cNvPr>
-          <p:cNvSpPr>
-            <a:spLocks xmlns:a="http://schemas.openxmlformats.org/drawingml/2006/main" noGrp="1"/>
-          </p:cNvSpPr>
-          <p:nvPr/>
-        </p:nvSpPr>
-        <p:spPr>
-          <a:xfrm xmlns:a="http://schemas.openxmlformats.org/drawingml/2006/main">
-            <a:off x="1104900" y="2876550"/>
-            <a:ext cx="3143250" cy="266700"/>
-          </a:xfrm>
-          <a:prstGeom xmlns:a="http://schemas.openxmlformats.org/drawingml/2006/main" prst="rect">
-            <a:avLst/>
-          </a:prstGeom>
-          <a:noFill xmlns:a="http://schemas.openxmlformats.org/drawingml/2006/main"/>
-          <a:ln xmlns:a="http://schemas.openxmlformats.org/drawingml/2006/main" w="0">
-            <a:noFill/>
-            <a:prstDash val="solid"/>
-          </a:ln>
-        </p:spPr>
-        <p:txBody>
-          <a:bodyPr xmlns:a="http://schemas.openxmlformats.org/drawingml/2006/main"/>
-          <a:lstStyle xmlns:a="http://schemas.openxmlformats.org/drawingml/2006/main"/>
-          <a:p xmlns:a="http://schemas.openxmlformats.org/drawingml/2006/main">
-            <a:pPr>
-              <a:defRPr sz="1350" b="1">
-                <a:solidFill>
-                  <a:srgbClr val="142F4C"/>
-                </a:solidFill>
-              </a:defRPr>
-            </a:pPr>
-            <a:r>
-              <a:rPr sz="1350" b="1">
-                <a:solidFill>
-                  <a:srgbClr val="142F4C"/>
-                </a:solidFill>
-              </a:rPr>
-              <a:t>decision</a:t>
-            </a:r>
-          </a:p>
-        </p:txBody>
-      </p:sp>
-      <p:sp>
-        <p:nvSpPr>
-          <p:cNvPr id="13" name="">
-            <a:extLst xmlns:a="http://schemas.openxmlformats.org/drawingml/2006/main">
-              <a:ext uri="{FF2B5EF4-FFF2-40B4-BE49-F238E27FC236}">
-                <a16:creationId xmlns:a16="http://schemas.microsoft.com/office/drawing/2014/main" id="{5B9DAFF2-4503-40CD-9FC6-BE0033E6D4CB}"/>
-              </a:ext>
-            </a:extLst>
-          </p:cNvPr>
-          <p:cNvSpPr>
-            <a:spLocks xmlns:a="http://schemas.openxmlformats.org/drawingml/2006/main" noGrp="1"/>
-          </p:cNvSpPr>
-          <p:nvPr/>
-        </p:nvSpPr>
-        <p:spPr>
-          <a:xfrm xmlns:a="http://schemas.openxmlformats.org/drawingml/2006/main">
-            <a:off x="4476750" y="2876550"/>
-            <a:ext cx="2952750" cy="266700"/>
-          </a:xfrm>
-          <a:prstGeom xmlns:a="http://schemas.openxmlformats.org/drawingml/2006/main" prst="rect">
-            <a:avLst/>
-          </a:prstGeom>
-          <a:noFill xmlns:a="http://schemas.openxmlformats.org/drawingml/2006/main"/>
-          <a:ln xmlns:a="http://schemas.openxmlformats.org/drawingml/2006/main" w="0">
-            <a:noFill/>
-            <a:prstDash val="solid"/>
-          </a:ln>
-        </p:spPr>
-        <p:txBody>
-          <a:bodyPr xmlns:a="http://schemas.openxmlformats.org/drawingml/2006/main"/>
-          <a:lstStyle xmlns:a="http://schemas.openxmlformats.org/drawingml/2006/main"/>
-          <a:p xmlns:a="http://schemas.openxmlformats.org/drawingml/2006/main">
-            <a:pPr>
-              <a:defRPr sz="1200">
-                <a:solidFill>
-                  <a:srgbClr val="5A6B7C"/>
-                </a:solidFill>
-              </a:defRPr>
-            </a:pPr>
-            <a:r>
-              <a:rPr sz="1200">
-                <a:solidFill>
-                  <a:srgbClr val="5A6B7C"/>
-                </a:solidFill>
-              </a:rPr>
-              <a:t>Recorded: Self-reported position retained unless separately evidenced.</a:t>
-            </a:r>
-          </a:p>
-        </p:txBody>
-      </p:sp>
-      <p:sp>
-        <p:nvSpPr>
-          <p:cNvPr id="14" name="">
-            <a:extLst xmlns:a="http://schemas.openxmlformats.org/drawingml/2006/main">
-              <a:ext uri="{FF2B5EF4-FFF2-40B4-BE49-F238E27FC236}">
-                <a16:creationId xmlns:a16="http://schemas.microsoft.com/office/drawing/2014/main" id="{1B6B4187-1B3A-4239-A73B-5E8FF85196AB}"/>
-              </a:ext>
-            </a:extLst>
-          </p:cNvPr>
-          <p:cNvSpPr>
-            <a:spLocks xmlns:a="http://schemas.openxmlformats.org/drawingml/2006/main" noGrp="1"/>
-          </p:cNvSpPr>
-          <p:nvPr/>
-        </p:nvSpPr>
-        <p:spPr>
-          <a:xfrm xmlns:a="http://schemas.openxmlformats.org/drawingml/2006/main">
-            <a:off x="7620000" y="2876550"/>
-            <a:ext cx="2571750" cy="495300"/>
-          </a:xfrm>
-          <a:prstGeom xmlns:a="http://schemas.openxmlformats.org/drawingml/2006/main" prst="rect">
-            <a:avLst/>
-          </a:prstGeom>
-          <a:noFill xmlns:a="http://schemas.openxmlformats.org/drawingml/2006/main"/>
-          <a:ln xmlns:a="http://schemas.openxmlformats.org/drawingml/2006/main" w="0">
-            <a:noFill/>
-            <a:prstDash val="solid"/>
-          </a:ln>
-        </p:spPr>
-        <p:txBody>
-          <a:bodyPr xmlns:a="http://schemas.openxmlformats.org/drawingml/2006/main"/>
-          <a:lstStyle xmlns:a="http://schemas.openxmlformats.org/drawingml/2006/main"/>
-          <a:p xmlns:a="http://schemas.openxmlformats.org/drawingml/2006/main">
-            <a:pPr>
-              <a:defRPr sz="1125">
+          <p:cNvPr id="8" name="">
+            <a:extLst xmlns:a="http://schemas.openxmlformats.org/drawingml/2006/main">
+              <a:ext uri="{FF2B5EF4-FFF2-40B4-BE49-F238E27FC236}">
+                <a16:creationId xmlns:a16="http://schemas.microsoft.com/office/drawing/2014/main" id="{626D9045-B7A6-468A-8187-EBC4A77571F2}"/>
+              </a:ext>
+            </a:extLst>
+          </p:cNvPr>
+          <p:cNvSpPr>
+            <a:spLocks xmlns:a="http://schemas.openxmlformats.org/drawingml/2006/main" noGrp="1"/>
+          </p:cNvSpPr>
+          <p:nvPr/>
+        </p:nvSpPr>
+        <p:spPr>
+          <a:xfrm xmlns:a="http://schemas.openxmlformats.org/drawingml/2006/main">
+            <a:off x="1143000" y="2286000"/>
+            <a:ext cx="8572500" cy="361950"/>
+          </a:xfrm>
+          <a:prstGeom xmlns:a="http://schemas.openxmlformats.org/drawingml/2006/main" prst="rect">
+            <a:avLst/>
+          </a:prstGeom>
+          <a:noFill xmlns:a="http://schemas.openxmlformats.org/drawingml/2006/main"/>
+          <a:ln xmlns:a="http://schemas.openxmlformats.org/drawingml/2006/main" w="0">
+            <a:noFill/>
+            <a:prstDash val="solid"/>
+          </a:ln>
+        </p:spPr>
+        <p:txBody>
+          <a:bodyPr xmlns:a="http://schemas.openxmlformats.org/drawingml/2006/main"/>
+          <a:lstStyle xmlns:a="http://schemas.openxmlformats.org/drawingml/2006/main"/>
+          <a:p xmlns:a="http://schemas.openxmlformats.org/drawingml/2006/main">
+            <a:pPr>
+              <a:defRPr sz="1350">
                 <a:solidFill>
                   <a:srgbClr val="1A2634"/>
                 </a:solidFill>
               </a:defRPr>
             </a:pPr>
             <a:r>
-              <a:rPr sz="1125">
+              <a:rPr sz="1350">
                 <a:solidFill>
                   <a:srgbClr val="1A2634"/>
                 </a:solidFill>
               </a:rPr>
-              <a:t>Review note: Viable options considered. Option A - leave accountability with the Finance Director as the policy currently states. Trade-off: preserves the approved policy…</a:t>
-            </a:r>
-          </a:p>
-        </p:txBody>
-      </p:sp>
-      <p:sp>
-        <p:nvSpPr>
-          <p:cNvPr id="15" name="">
-            <a:extLst xmlns:a="http://schemas.openxmlformats.org/drawingml/2006/main">
-              <a:ext uri="{FF2B5EF4-FFF2-40B4-BE49-F238E27FC236}">
-                <a16:creationId xmlns:a16="http://schemas.microsoft.com/office/drawing/2014/main" id="{F1526F73-B0C6-423B-BD34-8E2D75D0575C}"/>
-              </a:ext>
-            </a:extLst>
-          </p:cNvPr>
-          <p:cNvSpPr>
-            <a:spLocks xmlns:a="http://schemas.openxmlformats.org/drawingml/2006/main" noGrp="1"/>
-          </p:cNvSpPr>
-          <p:nvPr/>
-        </p:nvSpPr>
-        <p:spPr>
-          <a:xfrm xmlns:a="http://schemas.openxmlformats.org/drawingml/2006/main">
-            <a:off x="838200" y="3771900"/>
-            <a:ext cx="76200" cy="647700"/>
-          </a:xfrm>
-          <a:prstGeom xmlns:a="http://schemas.openxmlformats.org/drawingml/2006/main" prst="rect">
-            <a:avLst/>
-          </a:prstGeom>
-          <a:solidFill xmlns:a="http://schemas.openxmlformats.org/drawingml/2006/main">
-            <a:srgbClr val="1F6B4A"/>
-          </a:solidFill>
-          <a:ln xmlns:a="http://schemas.openxmlformats.org/drawingml/2006/main" w="0">
-            <a:solidFill>
-              <a:srgbClr val="1F6B4A"/>
-            </a:solidFill>
-            <a:prstDash val="solid"/>
-          </a:ln>
-        </p:spPr>
-      </p:sp>
-      <p:sp>
-        <p:nvSpPr>
-          <p:cNvPr id="16" name="">
-            <a:extLst xmlns:a="http://schemas.openxmlformats.org/drawingml/2006/main">
-              <a:ext uri="{FF2B5EF4-FFF2-40B4-BE49-F238E27FC236}">
-                <a16:creationId xmlns:a16="http://schemas.microsoft.com/office/drawing/2014/main" id="{427DB87D-E27B-4479-A6D7-12061F706E91}"/>
-              </a:ext>
-            </a:extLst>
-          </p:cNvPr>
-          <p:cNvSpPr>
-            <a:spLocks xmlns:a="http://schemas.openxmlformats.org/drawingml/2006/main" noGrp="1"/>
-          </p:cNvSpPr>
-          <p:nvPr/>
-        </p:nvSpPr>
-        <p:spPr>
-          <a:xfrm xmlns:a="http://schemas.openxmlformats.org/drawingml/2006/main">
-            <a:off x="1104900" y="3771900"/>
-            <a:ext cx="3143250" cy="266700"/>
-          </a:xfrm>
-          <a:prstGeom xmlns:a="http://schemas.openxmlformats.org/drawingml/2006/main" prst="rect">
-            <a:avLst/>
-          </a:prstGeom>
-          <a:noFill xmlns:a="http://schemas.openxmlformats.org/drawingml/2006/main"/>
-          <a:ln xmlns:a="http://schemas.openxmlformats.org/drawingml/2006/main" w="0">
-            <a:noFill/>
-            <a:prstDash val="solid"/>
-          </a:ln>
-        </p:spPr>
-        <p:txBody>
-          <a:bodyPr xmlns:a="http://schemas.openxmlformats.org/drawingml/2006/main"/>
-          <a:lstStyle xmlns:a="http://schemas.openxmlformats.org/drawingml/2006/main"/>
-          <a:p xmlns:a="http://schemas.openxmlformats.org/drawingml/2006/main">
-            <a:pPr>
-              <a:defRPr sz="1350" b="1">
-                <a:solidFill>
-                  <a:srgbClr val="142F4C"/>
-                </a:solidFill>
-              </a:defRPr>
-            </a:pPr>
-            <a:r>
-              <a:rPr sz="1350" b="1">
-                <a:solidFill>
-                  <a:srgbClr val="142F4C"/>
-                </a:solidFill>
-              </a:rPr>
-              <a:t>finding</a:t>
-            </a:r>
-          </a:p>
-        </p:txBody>
-      </p:sp>
-      <p:sp>
-        <p:nvSpPr>
-          <p:cNvPr id="17" name="">
-            <a:extLst xmlns:a="http://schemas.openxmlformats.org/drawingml/2006/main">
-              <a:ext uri="{FF2B5EF4-FFF2-40B4-BE49-F238E27FC236}">
-                <a16:creationId xmlns:a16="http://schemas.microsoft.com/office/drawing/2014/main" id="{0DB204FE-D831-49C0-A145-3343DC4299BF}"/>
-              </a:ext>
-            </a:extLst>
-          </p:cNvPr>
-          <p:cNvSpPr>
-            <a:spLocks xmlns:a="http://schemas.openxmlformats.org/drawingml/2006/main" noGrp="1"/>
-          </p:cNvSpPr>
-          <p:nvPr/>
-        </p:nvSpPr>
-        <p:spPr>
-          <a:xfrm xmlns:a="http://schemas.openxmlformats.org/drawingml/2006/main">
-            <a:off x="4476750" y="3771900"/>
-            <a:ext cx="2952750" cy="266700"/>
-          </a:xfrm>
-          <a:prstGeom xmlns:a="http://schemas.openxmlformats.org/drawingml/2006/main" prst="rect">
-            <a:avLst/>
-          </a:prstGeom>
-          <a:noFill xmlns:a="http://schemas.openxmlformats.org/drawingml/2006/main"/>
-          <a:ln xmlns:a="http://schemas.openxmlformats.org/drawingml/2006/main" w="0">
-            <a:noFill/>
-            <a:prstDash val="solid"/>
-          </a:ln>
-        </p:spPr>
-        <p:txBody>
-          <a:bodyPr xmlns:a="http://schemas.openxmlformats.org/drawingml/2006/main"/>
-          <a:lstStyle xmlns:a="http://schemas.openxmlformats.org/drawingml/2006/main"/>
-          <a:p xmlns:a="http://schemas.openxmlformats.org/drawingml/2006/main">
-            <a:pPr>
-              <a:defRPr sz="1200">
-                <a:solidFill>
-                  <a:srgbClr val="5A6B7C"/>
-                </a:solidFill>
-              </a:defRPr>
-            </a:pPr>
-            <a:r>
-              <a:rPr sz="1200">
-                <a:solidFill>
-                  <a:srgbClr val="5A6B7C"/>
-                </a:solidFill>
-              </a:rPr>
-              <a:t>Recorded: Self-reported position retained unless separately evidenced.</a:t>
-            </a:r>
-          </a:p>
-        </p:txBody>
-      </p:sp>
-      <p:sp>
-        <p:nvSpPr>
-          <p:cNvPr id="18" name="">
-            <a:extLst xmlns:a="http://schemas.openxmlformats.org/drawingml/2006/main">
-              <a:ext uri="{FF2B5EF4-FFF2-40B4-BE49-F238E27FC236}">
-                <a16:creationId xmlns:a16="http://schemas.microsoft.com/office/drawing/2014/main" id="{C4937E1B-F6C1-4362-AD0C-2B66FC321A56}"/>
-              </a:ext>
-            </a:extLst>
-          </p:cNvPr>
-          <p:cNvSpPr>
-            <a:spLocks xmlns:a="http://schemas.openxmlformats.org/drawingml/2006/main" noGrp="1"/>
-          </p:cNvSpPr>
-          <p:nvPr/>
-        </p:nvSpPr>
-        <p:spPr>
-          <a:xfrm xmlns:a="http://schemas.openxmlformats.org/drawingml/2006/main">
-            <a:off x="7620000" y="3771900"/>
-            <a:ext cx="2571750" cy="495300"/>
-          </a:xfrm>
-          <a:prstGeom xmlns:a="http://schemas.openxmlformats.org/drawingml/2006/main" prst="rect">
-            <a:avLst/>
-          </a:prstGeom>
-          <a:noFill xmlns:a="http://schemas.openxmlformats.org/drawingml/2006/main"/>
-          <a:ln xmlns:a="http://schemas.openxmlformats.org/drawingml/2006/main" w="0">
-            <a:noFill/>
-            <a:prstDash val="solid"/>
-          </a:ln>
-        </p:spPr>
-        <p:txBody>
-          <a:bodyPr xmlns:a="http://schemas.openxmlformats.org/drawingml/2006/main"/>
-          <a:lstStyle xmlns:a="http://schemas.openxmlformats.org/drawingml/2006/main"/>
-          <a:p xmlns:a="http://schemas.openxmlformats.org/drawingml/2006/main">
-            <a:pPr>
-              <a:defRPr sz="1125">
-                <a:solidFill>
-                  <a:srgbClr val="1A2634"/>
-                </a:solidFill>
-              </a:defRPr>
-            </a:pPr>
-            <a:r>
-              <a:rPr sz="1125">
-                <a:solidFill>
-                  <a:srgbClr val="1A2634"/>
-                </a:solidFill>
-              </a:rPr>
-              <a:t>Review note: Partially supported, and materially weaker than the self-assessed position. Kestrel asserts transaction and operational monitoring for unusual patterns. The evidence establishes that…</a:t>
-            </a:r>
-          </a:p>
-        </p:txBody>
-      </p:sp>
-      <p:sp>
-        <p:nvSpPr>
-          <p:cNvPr id="19" name="">
-            <a:extLst xmlns:a="http://schemas.openxmlformats.org/drawingml/2006/main">
-              <a:ext uri="{FF2B5EF4-FFF2-40B4-BE49-F238E27FC236}">
-                <a16:creationId xmlns:a16="http://schemas.microsoft.com/office/drawing/2014/main" id="{B964C89E-B7CD-4126-B555-47ADAE794851}"/>
-              </a:ext>
-            </a:extLst>
-          </p:cNvPr>
-          <p:cNvSpPr>
-            <a:spLocks xmlns:a="http://schemas.openxmlformats.org/drawingml/2006/main" noGrp="1"/>
-          </p:cNvSpPr>
-          <p:nvPr/>
-        </p:nvSpPr>
-        <p:spPr>
-          <a:xfrm xmlns:a="http://schemas.openxmlformats.org/drawingml/2006/main">
-            <a:off x="838200" y="4667250"/>
-            <a:ext cx="76200" cy="647700"/>
-          </a:xfrm>
-          <a:prstGeom xmlns:a="http://schemas.openxmlformats.org/drawingml/2006/main" prst="rect">
+              <a:t>No cross-domain interaction is currently recorded.</a:t>
+            </a:r>
+          </a:p>
+        </p:txBody>
+      </p:sp>
+      <p:sp>
+        <p:nvSpPr>
+          <p:cNvPr id="9" name="">
+            <a:extLst xmlns:a="http://schemas.openxmlformats.org/drawingml/2006/main">
+              <a:ext uri="{FF2B5EF4-FFF2-40B4-BE49-F238E27FC236}">
+                <a16:creationId xmlns:a16="http://schemas.microsoft.com/office/drawing/2014/main" id="{07AF4242-478F-4F92-8516-5B892AFFEC1C}"/>
+              </a:ext>
+            </a:extLst>
+          </p:cNvPr>
+          <p:cNvSpPr>
+            <a:spLocks xmlns:a="http://schemas.openxmlformats.org/drawingml/2006/main" noGrp="1"/>
+          </p:cNvSpPr>
+          <p:nvPr/>
+        </p:nvSpPr>
+        <p:spPr>
+          <a:xfrm xmlns:a="http://schemas.openxmlformats.org/drawingml/2006/main">
+            <a:off x="914400" y="2762250"/>
+            <a:ext cx="95250" cy="95250"/>
+          </a:xfrm>
+          <a:prstGeom xmlns:a="http://schemas.openxmlformats.org/drawingml/2006/main" prst="ellipse">
             <a:avLst/>
           </a:prstGeom>
           <a:solidFill xmlns:a="http://schemas.openxmlformats.org/drawingml/2006/main">
@@ -6542,150 +6076,50 @@
       </p:sp>
       <p:sp>
         <p:nvSpPr>
-          <p:cNvPr id="20" name="">
-            <a:extLst xmlns:a="http://schemas.openxmlformats.org/drawingml/2006/main">
-              <a:ext uri="{FF2B5EF4-FFF2-40B4-BE49-F238E27FC236}">
-                <a16:creationId xmlns:a16="http://schemas.microsoft.com/office/drawing/2014/main" id="{2E5715CD-C428-4C16-BCE3-EC0EB8F99184}"/>
-              </a:ext>
-            </a:extLst>
-          </p:cNvPr>
-          <p:cNvSpPr>
-            <a:spLocks xmlns:a="http://schemas.openxmlformats.org/drawingml/2006/main" noGrp="1"/>
-          </p:cNvSpPr>
-          <p:nvPr/>
-        </p:nvSpPr>
-        <p:spPr>
-          <a:xfrm xmlns:a="http://schemas.openxmlformats.org/drawingml/2006/main">
-            <a:off x="1104900" y="4667250"/>
-            <a:ext cx="3143250" cy="266700"/>
-          </a:xfrm>
-          <a:prstGeom xmlns:a="http://schemas.openxmlformats.org/drawingml/2006/main" prst="rect">
-            <a:avLst/>
-          </a:prstGeom>
-          <a:noFill xmlns:a="http://schemas.openxmlformats.org/drawingml/2006/main"/>
-          <a:ln xmlns:a="http://schemas.openxmlformats.org/drawingml/2006/main" w="0">
-            <a:noFill/>
-            <a:prstDash val="solid"/>
-          </a:ln>
-        </p:spPr>
-        <p:txBody>
-          <a:bodyPr xmlns:a="http://schemas.openxmlformats.org/drawingml/2006/main"/>
-          <a:lstStyle xmlns:a="http://schemas.openxmlformats.org/drawingml/2006/main"/>
-          <a:p xmlns:a="http://schemas.openxmlformats.org/drawingml/2006/main">
-            <a:pPr>
-              <a:defRPr sz="1350" b="1">
-                <a:solidFill>
-                  <a:srgbClr val="142F4C"/>
-                </a:solidFill>
-              </a:defRPr>
-            </a:pPr>
-            <a:r>
-              <a:rPr sz="1350" b="1">
-                <a:solidFill>
-                  <a:srgbClr val="142F4C"/>
-                </a:solidFill>
-              </a:rPr>
-              <a:t>Fraud Detection Capability: The organisation monitors transactions or operational activity for unusual patterns, anomalies or red flags.</a:t>
-            </a:r>
-          </a:p>
-        </p:txBody>
-      </p:sp>
-      <p:sp>
-        <p:nvSpPr>
-          <p:cNvPr id="21" name="">
-            <a:extLst xmlns:a="http://schemas.openxmlformats.org/drawingml/2006/main">
-              <a:ext uri="{FF2B5EF4-FFF2-40B4-BE49-F238E27FC236}">
-                <a16:creationId xmlns:a16="http://schemas.microsoft.com/office/drawing/2014/main" id="{E656196C-905B-4F4B-A8A7-C95C86D0BBF9}"/>
-              </a:ext>
-            </a:extLst>
-          </p:cNvPr>
-          <p:cNvSpPr>
-            <a:spLocks xmlns:a="http://schemas.openxmlformats.org/drawingml/2006/main" noGrp="1"/>
-          </p:cNvSpPr>
-          <p:nvPr/>
-        </p:nvSpPr>
-        <p:spPr>
-          <a:xfrm xmlns:a="http://schemas.openxmlformats.org/drawingml/2006/main">
-            <a:off x="4476750" y="4667250"/>
-            <a:ext cx="2952750" cy="266700"/>
-          </a:xfrm>
-          <a:prstGeom xmlns:a="http://schemas.openxmlformats.org/drawingml/2006/main" prst="rect">
-            <a:avLst/>
-          </a:prstGeom>
-          <a:noFill xmlns:a="http://schemas.openxmlformats.org/drawingml/2006/main"/>
-          <a:ln xmlns:a="http://schemas.openxmlformats.org/drawingml/2006/main" w="0">
-            <a:noFill/>
-            <a:prstDash val="solid"/>
-          </a:ln>
-        </p:spPr>
-        <p:txBody>
-          <a:bodyPr xmlns:a="http://schemas.openxmlformats.org/drawingml/2006/main"/>
-          <a:lstStyle xmlns:a="http://schemas.openxmlformats.org/drawingml/2006/main"/>
-          <a:p xmlns:a="http://schemas.openxmlformats.org/drawingml/2006/main">
-            <a:pPr>
-              <a:defRPr sz="1200">
-                <a:solidFill>
-                  <a:srgbClr val="5A6B7C"/>
-                </a:solidFill>
-              </a:defRPr>
-            </a:pPr>
-            <a:r>
-              <a:rPr sz="1200">
-                <a:solidFill>
-                  <a:srgbClr val="5A6B7C"/>
-                </a:solidFill>
-              </a:rPr>
-              <a:t>Recorded: Self-reported position: Partially designed — Some elements exist, but implementation is incomplete, inconsistent or not evidenced.</a:t>
-            </a:r>
-          </a:p>
-        </p:txBody>
-      </p:sp>
-      <p:sp>
-        <p:nvSpPr>
-          <p:cNvPr id="22" name="">
-            <a:extLst xmlns:a="http://schemas.openxmlformats.org/drawingml/2006/main">
-              <a:ext uri="{FF2B5EF4-FFF2-40B4-BE49-F238E27FC236}">
-                <a16:creationId xmlns:a16="http://schemas.microsoft.com/office/drawing/2014/main" id="{4FE61DAD-16A2-46EE-86C4-D386D91CD2C1}"/>
-              </a:ext>
-            </a:extLst>
-          </p:cNvPr>
-          <p:cNvSpPr>
-            <a:spLocks xmlns:a="http://schemas.openxmlformats.org/drawingml/2006/main" noGrp="1"/>
-          </p:cNvSpPr>
-          <p:nvPr/>
-        </p:nvSpPr>
-        <p:spPr>
-          <a:xfrm xmlns:a="http://schemas.openxmlformats.org/drawingml/2006/main">
-            <a:off x="7620000" y="4667250"/>
-            <a:ext cx="2571750" cy="495300"/>
-          </a:xfrm>
-          <a:prstGeom xmlns:a="http://schemas.openxmlformats.org/drawingml/2006/main" prst="rect">
-            <a:avLst/>
-          </a:prstGeom>
-          <a:noFill xmlns:a="http://schemas.openxmlformats.org/drawingml/2006/main"/>
-          <a:ln xmlns:a="http://schemas.openxmlformats.org/drawingml/2006/main" w="0">
-            <a:noFill/>
-            <a:prstDash val="solid"/>
-          </a:ln>
-        </p:spPr>
-        <p:txBody>
-          <a:bodyPr xmlns:a="http://schemas.openxmlformats.org/drawingml/2006/main"/>
-          <a:lstStyle xmlns:a="http://schemas.openxmlformats.org/drawingml/2006/main"/>
-          <a:p xmlns:a="http://schemas.openxmlformats.org/drawingml/2006/main">
-            <a:pPr>
-              <a:defRPr sz="1125">
+          <p:cNvPr id="10" name="">
+            <a:extLst xmlns:a="http://schemas.openxmlformats.org/drawingml/2006/main">
+              <a:ext uri="{FF2B5EF4-FFF2-40B4-BE49-F238E27FC236}">
+                <a16:creationId xmlns:a16="http://schemas.microsoft.com/office/drawing/2014/main" id="{ED34BB53-87C5-466B-869C-4282102B887D}"/>
+              </a:ext>
+            </a:extLst>
+          </p:cNvPr>
+          <p:cNvSpPr>
+            <a:spLocks xmlns:a="http://schemas.openxmlformats.org/drawingml/2006/main" noGrp="1"/>
+          </p:cNvSpPr>
+          <p:nvPr/>
+        </p:nvSpPr>
+        <p:spPr>
+          <a:xfrm xmlns:a="http://schemas.openxmlformats.org/drawingml/2006/main">
+            <a:off x="1143000" y="2686050"/>
+            <a:ext cx="8572500" cy="361950"/>
+          </a:xfrm>
+          <a:prstGeom xmlns:a="http://schemas.openxmlformats.org/drawingml/2006/main" prst="rect">
+            <a:avLst/>
+          </a:prstGeom>
+          <a:noFill xmlns:a="http://schemas.openxmlformats.org/drawingml/2006/main"/>
+          <a:ln xmlns:a="http://schemas.openxmlformats.org/drawingml/2006/main" w="0">
+            <a:noFill/>
+            <a:prstDash val="solid"/>
+          </a:ln>
+        </p:spPr>
+        <p:txBody>
+          <a:bodyPr xmlns:a="http://schemas.openxmlformats.org/drawingml/2006/main"/>
+          <a:lstStyle xmlns:a="http://schemas.openxmlformats.org/drawingml/2006/main"/>
+          <a:p xmlns:a="http://schemas.openxmlformats.org/drawingml/2006/main">
+            <a:pPr>
+              <a:defRPr sz="1350">
                 <a:solidFill>
                   <a:srgbClr val="1A2634"/>
                 </a:solidFill>
               </a:defRPr>
             </a:pPr>
             <a:r>
-              <a:rPr sz="1125">
+              <a:rPr sz="1350">
                 <a:solidFill>
                   <a:srgbClr val="1A2634"/>
                 </a:solidFill>
               </a:rPr>
-              <a:t>Review note: The supplied information does not establish an unqualified conclusion for the recorded scope.</a:t>
+              <a:t>Use the complete analytical register for the underlying question traces.</a:t>
             </a:r>
           </a:p>
         </p:txBody>
@@ -6693,7 +6127,7 @@
     </p:spTree>
     <p:extLst>
       <p:ext uri="{BB962C8B-B14F-4D97-AF65-F5344CB8AC3E}">
-        <p14:creationId xmlns:p14="http://schemas.microsoft.com/office/powerpoint/2010/main" val="445794860"/>
+        <p14:creationId xmlns:p14="http://schemas.microsoft.com/office/powerpoint/2010/main" val="682018881"/>
       </p:ext>
     </p:extLst>
   </p:cSld>
@@ -6724,7 +6158,7 @@
           <p:cNvPr id="32" name="">
             <a:extLst xmlns:a="http://schemas.openxmlformats.org/drawingml/2006/main">
               <a:ext uri="{FF2B5EF4-FFF2-40B4-BE49-F238E27FC236}">
-                <a16:creationId xmlns:a16="http://schemas.microsoft.com/office/drawing/2014/main" id="{8E25FE16-8A15-410E-9BE0-143AFB22F473}"/>
+                <a16:creationId xmlns:a16="http://schemas.microsoft.com/office/drawing/2014/main" id="{8BB9CD21-C22C-4D20-91D9-7A5B91CC8475}"/>
               </a:ext>
             </a:extLst>
           </p:cNvPr>
@@ -6774,7 +6208,7 @@
           <p:cNvPr id="2" name="">
             <a:extLst xmlns:a="http://schemas.openxmlformats.org/drawingml/2006/main">
               <a:ext uri="{FF2B5EF4-FFF2-40B4-BE49-F238E27FC236}">
-                <a16:creationId xmlns:a16="http://schemas.microsoft.com/office/drawing/2014/main" id="{9A2B0077-C379-4C83-AC18-CB196310ED0C}"/>
+                <a16:creationId xmlns:a16="http://schemas.microsoft.com/office/drawing/2014/main" id="{4696F86C-83EF-441A-8EFF-7851DB73CFF6}"/>
               </a:ext>
             </a:extLst>
           </p:cNvPr>
@@ -6824,7 +6258,7 @@
           <p:cNvPr id="3" name="">
             <a:extLst xmlns:a="http://schemas.openxmlformats.org/drawingml/2006/main">
               <a:ext uri="{FF2B5EF4-FFF2-40B4-BE49-F238E27FC236}">
-                <a16:creationId xmlns:a16="http://schemas.microsoft.com/office/drawing/2014/main" id="{DB7628B8-05AA-4C28-8B07-08DFA437AA9B}"/>
+                <a16:creationId xmlns:a16="http://schemas.microsoft.com/office/drawing/2014/main" id="{4CDA6D13-8760-4AB3-B9DF-9789A6421FB3}"/>
               </a:ext>
             </a:extLst>
           </p:cNvPr>
@@ -6874,7 +6308,7 @@
           <p:cNvPr id="4" name="">
             <a:extLst xmlns:a="http://schemas.openxmlformats.org/drawingml/2006/main">
               <a:ext uri="{FF2B5EF4-FFF2-40B4-BE49-F238E27FC236}">
-                <a16:creationId xmlns:a16="http://schemas.microsoft.com/office/drawing/2014/main" id="{11BCBA76-E98E-403E-AB9B-7ABAB3B07D51}"/>
+                <a16:creationId xmlns:a16="http://schemas.microsoft.com/office/drawing/2014/main" id="{04D1E092-4C49-4121-87E1-F702C18821E1}"/>
               </a:ext>
             </a:extLst>
           </p:cNvPr>
@@ -6905,7 +6339,7 @@
           <p:cNvPr id="5" name="">
             <a:extLst xmlns:a="http://schemas.openxmlformats.org/drawingml/2006/main">
               <a:ext uri="{FF2B5EF4-FFF2-40B4-BE49-F238E27FC236}">
-                <a16:creationId xmlns:a16="http://schemas.microsoft.com/office/drawing/2014/main" id="{2472AF65-0B12-4A4A-A0FC-B01C06C2D468}"/>
+                <a16:creationId xmlns:a16="http://schemas.microsoft.com/office/drawing/2014/main" id="{3E82A5FE-A7BB-4BFB-A116-82DA975E8A57}"/>
               </a:ext>
             </a:extLst>
           </p:cNvPr>
@@ -6955,7 +6389,7 @@
           <p:cNvPr id="6" name="">
             <a:extLst xmlns:a="http://schemas.openxmlformats.org/drawingml/2006/main">
               <a:ext uri="{FF2B5EF4-FFF2-40B4-BE49-F238E27FC236}">
-                <a16:creationId xmlns:a16="http://schemas.microsoft.com/office/drawing/2014/main" id="{4F7725BC-47B9-42EF-88D5-D7406A6DB844}"/>
+                <a16:creationId xmlns:a16="http://schemas.microsoft.com/office/drawing/2014/main" id="{E7248102-0F84-470F-A3D1-B03F23220F87}"/>
               </a:ext>
             </a:extLst>
           </p:cNvPr>
@@ -7005,7 +6439,7 @@
           <p:cNvPr id="7" name="">
             <a:extLst xmlns:a="http://schemas.openxmlformats.org/drawingml/2006/main">
               <a:ext uri="{FF2B5EF4-FFF2-40B4-BE49-F238E27FC236}">
-                <a16:creationId xmlns:a16="http://schemas.microsoft.com/office/drawing/2014/main" id="{5D758043-37CB-45C5-89DB-B91E4AD14F4B}"/>
+                <a16:creationId xmlns:a16="http://schemas.microsoft.com/office/drawing/2014/main" id="{AD697F2D-3AD6-44C5-AE1E-93EAD6465B45}"/>
               </a:ext>
             </a:extLst>
           </p:cNvPr>
@@ -7055,7 +6489,7 @@
           <p:cNvPr id="8" name="">
             <a:extLst xmlns:a="http://schemas.openxmlformats.org/drawingml/2006/main">
               <a:ext uri="{FF2B5EF4-FFF2-40B4-BE49-F238E27FC236}">
-                <a16:creationId xmlns:a16="http://schemas.microsoft.com/office/drawing/2014/main" id="{52589CE1-BEEB-4973-9C26-229D31A0A8E7}"/>
+                <a16:creationId xmlns:a16="http://schemas.microsoft.com/office/drawing/2014/main" id="{E4BA3A6D-210F-401C-8DE9-B012BB19376C}"/>
               </a:ext>
             </a:extLst>
           </p:cNvPr>
@@ -7088,7 +6522,7 @@
           <p:cNvPr id="9" name="">
             <a:extLst xmlns:a="http://schemas.openxmlformats.org/drawingml/2006/main">
               <a:ext uri="{FF2B5EF4-FFF2-40B4-BE49-F238E27FC236}">
-                <a16:creationId xmlns:a16="http://schemas.microsoft.com/office/drawing/2014/main" id="{2E906821-18AA-4888-BCD8-C75C20CFAE4A}"/>
+                <a16:creationId xmlns:a16="http://schemas.microsoft.com/office/drawing/2014/main" id="{3D82EF4F-8D37-47A1-BD74-544D0E93F00A}"/>
               </a:ext>
             </a:extLst>
           </p:cNvPr>
@@ -7121,7 +6555,7 @@
           <p:cNvPr id="10" name="">
             <a:extLst xmlns:a="http://schemas.openxmlformats.org/drawingml/2006/main">
               <a:ext uri="{FF2B5EF4-FFF2-40B4-BE49-F238E27FC236}">
-                <a16:creationId xmlns:a16="http://schemas.microsoft.com/office/drawing/2014/main" id="{5E953E44-C413-4CD0-9862-7DC505F52B98}"/>
+                <a16:creationId xmlns:a16="http://schemas.microsoft.com/office/drawing/2014/main" id="{E0C4A614-2F15-4F0F-B590-8B72FFF9A254}"/>
               </a:ext>
             </a:extLst>
           </p:cNvPr>
@@ -7171,7 +6605,7 @@
           <p:cNvPr id="11" name="">
             <a:extLst xmlns:a="http://schemas.openxmlformats.org/drawingml/2006/main">
               <a:ext uri="{FF2B5EF4-FFF2-40B4-BE49-F238E27FC236}">
-                <a16:creationId xmlns:a16="http://schemas.microsoft.com/office/drawing/2014/main" id="{63462F32-647B-424A-9DB9-167C268560E5}"/>
+                <a16:creationId xmlns:a16="http://schemas.microsoft.com/office/drawing/2014/main" id="{5E3EC976-8F7F-4BA3-8F31-7D45F4F1CF04}"/>
               </a:ext>
             </a:extLst>
           </p:cNvPr>
@@ -7221,7 +6655,7 @@
           <p:cNvPr id="12" name="">
             <a:extLst xmlns:a="http://schemas.openxmlformats.org/drawingml/2006/main">
               <a:ext uri="{FF2B5EF4-FFF2-40B4-BE49-F238E27FC236}">
-                <a16:creationId xmlns:a16="http://schemas.microsoft.com/office/drawing/2014/main" id="{B686102E-4F64-4E75-87B4-E81C5785DA41}"/>
+                <a16:creationId xmlns:a16="http://schemas.microsoft.com/office/drawing/2014/main" id="{F2009DCC-C7CF-4970-949A-07ABFEAF7E79}"/>
               </a:ext>
             </a:extLst>
           </p:cNvPr>
@@ -7271,7 +6705,7 @@
           <p:cNvPr id="13" name="">
             <a:extLst xmlns:a="http://schemas.openxmlformats.org/drawingml/2006/main">
               <a:ext uri="{FF2B5EF4-FFF2-40B4-BE49-F238E27FC236}">
-                <a16:creationId xmlns:a16="http://schemas.microsoft.com/office/drawing/2014/main" id="{6CC319DD-DC1E-4028-9526-C003FC76C2F6}"/>
+                <a16:creationId xmlns:a16="http://schemas.microsoft.com/office/drawing/2014/main" id="{6ED55B31-7DB4-4165-A772-21DF624E942D}"/>
               </a:ext>
             </a:extLst>
           </p:cNvPr>
@@ -7304,7 +6738,7 @@
           <p:cNvPr id="14" name="">
             <a:extLst xmlns:a="http://schemas.openxmlformats.org/drawingml/2006/main">
               <a:ext uri="{FF2B5EF4-FFF2-40B4-BE49-F238E27FC236}">
-                <a16:creationId xmlns:a16="http://schemas.microsoft.com/office/drawing/2014/main" id="{ED3AF546-6F2C-452C-BF7D-228B272BB3D8}"/>
+                <a16:creationId xmlns:a16="http://schemas.microsoft.com/office/drawing/2014/main" id="{46A393FC-5AD6-4D1C-B185-33C54C75B7FC}"/>
               </a:ext>
             </a:extLst>
           </p:cNvPr>
@@ -7337,7 +6771,7 @@
           <p:cNvPr id="15" name="">
             <a:extLst xmlns:a="http://schemas.openxmlformats.org/drawingml/2006/main">
               <a:ext uri="{FF2B5EF4-FFF2-40B4-BE49-F238E27FC236}">
-                <a16:creationId xmlns:a16="http://schemas.microsoft.com/office/drawing/2014/main" id="{7FF18383-8B70-4127-8EAE-96EE572C53E7}"/>
+                <a16:creationId xmlns:a16="http://schemas.microsoft.com/office/drawing/2014/main" id="{856A1515-1E13-4678-9D34-342E318D516B}"/>
               </a:ext>
             </a:extLst>
           </p:cNvPr>
@@ -7387,7 +6821,7 @@
           <p:cNvPr id="16" name="">
             <a:extLst xmlns:a="http://schemas.openxmlformats.org/drawingml/2006/main">
               <a:ext uri="{FF2B5EF4-FFF2-40B4-BE49-F238E27FC236}">
-                <a16:creationId xmlns:a16="http://schemas.microsoft.com/office/drawing/2014/main" id="{41C64CA4-7F68-4D10-8B79-F58984A67280}"/>
+                <a16:creationId xmlns:a16="http://schemas.microsoft.com/office/drawing/2014/main" id="{38999319-6C2C-42A0-B185-4D5A8546BE98}"/>
               </a:ext>
             </a:extLst>
           </p:cNvPr>
@@ -7437,7 +6871,7 @@
           <p:cNvPr id="17" name="">
             <a:extLst xmlns:a="http://schemas.openxmlformats.org/drawingml/2006/main">
               <a:ext uri="{FF2B5EF4-FFF2-40B4-BE49-F238E27FC236}">
-                <a16:creationId xmlns:a16="http://schemas.microsoft.com/office/drawing/2014/main" id="{3DE95C71-143E-45C0-9E47-4A6298D88CAA}"/>
+                <a16:creationId xmlns:a16="http://schemas.microsoft.com/office/drawing/2014/main" id="{B5321B91-6D51-4556-B17A-309E2DF43CCE}"/>
               </a:ext>
             </a:extLst>
           </p:cNvPr>
@@ -7487,7 +6921,7 @@
           <p:cNvPr id="18" name="">
             <a:extLst xmlns:a="http://schemas.openxmlformats.org/drawingml/2006/main">
               <a:ext uri="{FF2B5EF4-FFF2-40B4-BE49-F238E27FC236}">
-                <a16:creationId xmlns:a16="http://schemas.microsoft.com/office/drawing/2014/main" id="{38B708C0-B21C-460D-9BE5-9D8A8A4BCCA3}"/>
+                <a16:creationId xmlns:a16="http://schemas.microsoft.com/office/drawing/2014/main" id="{98BF1AC7-9459-4FBE-BD42-FE573B439800}"/>
               </a:ext>
             </a:extLst>
           </p:cNvPr>
@@ -7520,7 +6954,7 @@
           <p:cNvPr id="19" name="">
             <a:extLst xmlns:a="http://schemas.openxmlformats.org/drawingml/2006/main">
               <a:ext uri="{FF2B5EF4-FFF2-40B4-BE49-F238E27FC236}">
-                <a16:creationId xmlns:a16="http://schemas.microsoft.com/office/drawing/2014/main" id="{919E2D93-BC66-4235-843F-CBE0F6A6C4A5}"/>
+                <a16:creationId xmlns:a16="http://schemas.microsoft.com/office/drawing/2014/main" id="{0A7E5C28-E638-491A-8009-5DD734643B7C}"/>
               </a:ext>
             </a:extLst>
           </p:cNvPr>
@@ -7553,7 +6987,7 @@
           <p:cNvPr id="20" name="">
             <a:extLst xmlns:a="http://schemas.openxmlformats.org/drawingml/2006/main">
               <a:ext uri="{FF2B5EF4-FFF2-40B4-BE49-F238E27FC236}">
-                <a16:creationId xmlns:a16="http://schemas.microsoft.com/office/drawing/2014/main" id="{8B8D04AD-6148-4562-8D8A-429CF37CF2E2}"/>
+                <a16:creationId xmlns:a16="http://schemas.microsoft.com/office/drawing/2014/main" id="{AB92AE31-12A7-414B-A990-D07653037D7E}"/>
               </a:ext>
             </a:extLst>
           </p:cNvPr>
@@ -7603,7 +7037,7 @@
           <p:cNvPr id="21" name="">
             <a:extLst xmlns:a="http://schemas.openxmlformats.org/drawingml/2006/main">
               <a:ext uri="{FF2B5EF4-FFF2-40B4-BE49-F238E27FC236}">
-                <a16:creationId xmlns:a16="http://schemas.microsoft.com/office/drawing/2014/main" id="{8FDABE29-A5CD-40B7-AC81-F3B3D44B80A0}"/>
+                <a16:creationId xmlns:a16="http://schemas.microsoft.com/office/drawing/2014/main" id="{6C1F901D-D08B-4662-97F8-839BE1950D7A}"/>
               </a:ext>
             </a:extLst>
           </p:cNvPr>
@@ -7653,7 +7087,7 @@
           <p:cNvPr id="22" name="">
             <a:extLst xmlns:a="http://schemas.openxmlformats.org/drawingml/2006/main">
               <a:ext uri="{FF2B5EF4-FFF2-40B4-BE49-F238E27FC236}">
-                <a16:creationId xmlns:a16="http://schemas.microsoft.com/office/drawing/2014/main" id="{AD377CF0-F9E6-4BC1-BA2C-2BBFFEDD0CBA}"/>
+                <a16:creationId xmlns:a16="http://schemas.microsoft.com/office/drawing/2014/main" id="{D986D303-5793-4520-B566-8D602B36C935}"/>
               </a:ext>
             </a:extLst>
           </p:cNvPr>
@@ -7703,7 +7137,7 @@
           <p:cNvPr id="23" name="">
             <a:extLst xmlns:a="http://schemas.openxmlformats.org/drawingml/2006/main">
               <a:ext uri="{FF2B5EF4-FFF2-40B4-BE49-F238E27FC236}">
-                <a16:creationId xmlns:a16="http://schemas.microsoft.com/office/drawing/2014/main" id="{1997D485-B9B0-4F77-B00C-BD2B2E5E87EA}"/>
+                <a16:creationId xmlns:a16="http://schemas.microsoft.com/office/drawing/2014/main" id="{1EB77405-CFA7-4991-A5BE-EE6C288BB8AD}"/>
               </a:ext>
             </a:extLst>
           </p:cNvPr>
@@ -7736,7 +7170,7 @@
           <p:cNvPr id="24" name="">
             <a:extLst xmlns:a="http://schemas.openxmlformats.org/drawingml/2006/main">
               <a:ext uri="{FF2B5EF4-FFF2-40B4-BE49-F238E27FC236}">
-                <a16:creationId xmlns:a16="http://schemas.microsoft.com/office/drawing/2014/main" id="{EEEFD3A3-1731-43AB-A9D9-54BAA521A2A8}"/>
+                <a16:creationId xmlns:a16="http://schemas.microsoft.com/office/drawing/2014/main" id="{AEBE32F3-4EAB-408F-B261-41CCEFCE7FA7}"/>
               </a:ext>
             </a:extLst>
           </p:cNvPr>
@@ -7769,7 +7203,7 @@
           <p:cNvPr id="25" name="">
             <a:extLst xmlns:a="http://schemas.openxmlformats.org/drawingml/2006/main">
               <a:ext uri="{FF2B5EF4-FFF2-40B4-BE49-F238E27FC236}">
-                <a16:creationId xmlns:a16="http://schemas.microsoft.com/office/drawing/2014/main" id="{175F83A5-A3B0-477F-9F98-1DFDFDB98D97}"/>
+                <a16:creationId xmlns:a16="http://schemas.microsoft.com/office/drawing/2014/main" id="{161E6018-AE5E-42AE-9040-BA14F479F4BE}"/>
               </a:ext>
             </a:extLst>
           </p:cNvPr>
@@ -7819,7 +7253,7 @@
           <p:cNvPr id="26" name="">
             <a:extLst xmlns:a="http://schemas.openxmlformats.org/drawingml/2006/main">
               <a:ext uri="{FF2B5EF4-FFF2-40B4-BE49-F238E27FC236}">
-                <a16:creationId xmlns:a16="http://schemas.microsoft.com/office/drawing/2014/main" id="{ABB519FE-2F2C-4A05-813C-E843453AE72E}"/>
+                <a16:creationId xmlns:a16="http://schemas.microsoft.com/office/drawing/2014/main" id="{D14DEAC3-1B00-4D35-9EB6-D9A3D90325B1}"/>
               </a:ext>
             </a:extLst>
           </p:cNvPr>
@@ -7869,7 +7303,7 @@
           <p:cNvPr id="27" name="">
             <a:extLst xmlns:a="http://schemas.openxmlformats.org/drawingml/2006/main">
               <a:ext uri="{FF2B5EF4-FFF2-40B4-BE49-F238E27FC236}">
-                <a16:creationId xmlns:a16="http://schemas.microsoft.com/office/drawing/2014/main" id="{CEA62278-32A1-4036-AB76-CD63A839A9B7}"/>
+                <a16:creationId xmlns:a16="http://schemas.microsoft.com/office/drawing/2014/main" id="{F3DBDE0B-DBB2-4A3F-AB88-58CE7321DDBA}"/>
               </a:ext>
             </a:extLst>
           </p:cNvPr>
@@ -7919,7 +7353,7 @@
           <p:cNvPr id="28" name="">
             <a:extLst xmlns:a="http://schemas.openxmlformats.org/drawingml/2006/main">
               <a:ext uri="{FF2B5EF4-FFF2-40B4-BE49-F238E27FC236}">
-                <a16:creationId xmlns:a16="http://schemas.microsoft.com/office/drawing/2014/main" id="{2F39BFA4-4335-4234-A485-1E27C8B88310}"/>
+                <a16:creationId xmlns:a16="http://schemas.microsoft.com/office/drawing/2014/main" id="{B2384EFD-8B23-4391-94EE-7070E65A97EE}"/>
               </a:ext>
             </a:extLst>
           </p:cNvPr>
@@ -7952,7 +7386,7 @@
           <p:cNvPr id="29" name="">
             <a:extLst xmlns:a="http://schemas.openxmlformats.org/drawingml/2006/main">
               <a:ext uri="{FF2B5EF4-FFF2-40B4-BE49-F238E27FC236}">
-                <a16:creationId xmlns:a16="http://schemas.microsoft.com/office/drawing/2014/main" id="{EF4DBE9C-C26E-4892-9AC3-F186420FD376}"/>
+                <a16:creationId xmlns:a16="http://schemas.microsoft.com/office/drawing/2014/main" id="{68F899E0-DD00-4734-9615-760B90872C86}"/>
               </a:ext>
             </a:extLst>
           </p:cNvPr>
@@ -7985,7 +7419,7 @@
           <p:cNvPr id="30" name="">
             <a:extLst xmlns:a="http://schemas.openxmlformats.org/drawingml/2006/main">
               <a:ext uri="{FF2B5EF4-FFF2-40B4-BE49-F238E27FC236}">
-                <a16:creationId xmlns:a16="http://schemas.microsoft.com/office/drawing/2014/main" id="{562A53E1-8AFD-408A-B61B-793CAD07636E}"/>
+                <a16:creationId xmlns:a16="http://schemas.microsoft.com/office/drawing/2014/main" id="{FC398C22-6765-4F67-8EE1-801A31C631E3}"/>
               </a:ext>
             </a:extLst>
           </p:cNvPr>
@@ -8035,7 +7469,7 @@
           <p:cNvPr id="31" name="">
             <a:extLst xmlns:a="http://schemas.openxmlformats.org/drawingml/2006/main">
               <a:ext uri="{FF2B5EF4-FFF2-40B4-BE49-F238E27FC236}">
-                <a16:creationId xmlns:a16="http://schemas.microsoft.com/office/drawing/2014/main" id="{718F40CA-71DB-427C-9E9A-F000113BC260}"/>
+                <a16:creationId xmlns:a16="http://schemas.microsoft.com/office/drawing/2014/main" id="{CD0059B0-52E0-413A-8270-6A58210393BF}"/>
               </a:ext>
             </a:extLst>
           </p:cNvPr>
@@ -8083,7 +7517,7 @@
     </p:spTree>
     <p:extLst>
       <p:ext uri="{BB962C8B-B14F-4D97-AF65-F5344CB8AC3E}">
-        <p14:creationId xmlns:p14="http://schemas.microsoft.com/office/powerpoint/2010/main" val="41349895"/>
+        <p14:creationId xmlns:p14="http://schemas.microsoft.com/office/powerpoint/2010/main" val="617859556"/>
       </p:ext>
     </p:extLst>
   </p:cSld>
@@ -8114,7 +7548,7 @@
           <p:cNvPr id="22" name="">
             <a:extLst xmlns:a="http://schemas.openxmlformats.org/drawingml/2006/main">
               <a:ext uri="{FF2B5EF4-FFF2-40B4-BE49-F238E27FC236}">
-                <a16:creationId xmlns:a16="http://schemas.microsoft.com/office/drawing/2014/main" id="{134EFD82-C3EC-4632-823C-729955326ACD}"/>
+                <a16:creationId xmlns:a16="http://schemas.microsoft.com/office/drawing/2014/main" id="{0F246CDC-07E7-403E-9C5E-7EACD8752FCB}"/>
               </a:ext>
             </a:extLst>
           </p:cNvPr>
@@ -8164,7 +7598,7 @@
           <p:cNvPr id="2" name="">
             <a:extLst xmlns:a="http://schemas.openxmlformats.org/drawingml/2006/main">
               <a:ext uri="{FF2B5EF4-FFF2-40B4-BE49-F238E27FC236}">
-                <a16:creationId xmlns:a16="http://schemas.microsoft.com/office/drawing/2014/main" id="{83C6CFC2-119D-4BC0-BCA4-FD28063C78B3}"/>
+                <a16:creationId xmlns:a16="http://schemas.microsoft.com/office/drawing/2014/main" id="{D86016DE-4F50-4404-8BBD-0876F8BF9C51}"/>
               </a:ext>
             </a:extLst>
           </p:cNvPr>
@@ -8214,7 +7648,7 @@
           <p:cNvPr id="3" name="">
             <a:extLst xmlns:a="http://schemas.openxmlformats.org/drawingml/2006/main">
               <a:ext uri="{FF2B5EF4-FFF2-40B4-BE49-F238E27FC236}">
-                <a16:creationId xmlns:a16="http://schemas.microsoft.com/office/drawing/2014/main" id="{ED47D162-ABC5-4A93-B1D1-6E57CEB1F7E0}"/>
+                <a16:creationId xmlns:a16="http://schemas.microsoft.com/office/drawing/2014/main" id="{A45AFB43-C12D-4AED-BBCA-E2518DDB7682}"/>
               </a:ext>
             </a:extLst>
           </p:cNvPr>
@@ -8264,7 +7698,7 @@
           <p:cNvPr id="4" name="">
             <a:extLst xmlns:a="http://schemas.openxmlformats.org/drawingml/2006/main">
               <a:ext uri="{FF2B5EF4-FFF2-40B4-BE49-F238E27FC236}">
-                <a16:creationId xmlns:a16="http://schemas.microsoft.com/office/drawing/2014/main" id="{D3486118-E6D0-402B-AE51-3C8817EBEDB3}"/>
+                <a16:creationId xmlns:a16="http://schemas.microsoft.com/office/drawing/2014/main" id="{84AC03B5-8DF2-4D02-93D7-3BEC7836F1CF}"/>
               </a:ext>
             </a:extLst>
           </p:cNvPr>
@@ -8295,7 +7729,7 @@
           <p:cNvPr id="5" name="">
             <a:extLst xmlns:a="http://schemas.openxmlformats.org/drawingml/2006/main">
               <a:ext uri="{FF2B5EF4-FFF2-40B4-BE49-F238E27FC236}">
-                <a16:creationId xmlns:a16="http://schemas.microsoft.com/office/drawing/2014/main" id="{46B43ADE-4BB6-42FF-8608-0D7A34803FCF}"/>
+                <a16:creationId xmlns:a16="http://schemas.microsoft.com/office/drawing/2014/main" id="{60422F7A-E0BF-4C13-BB45-D85A04917171}"/>
               </a:ext>
             </a:extLst>
           </p:cNvPr>
@@ -8345,7 +7779,7 @@
           <p:cNvPr id="6" name="">
             <a:extLst xmlns:a="http://schemas.openxmlformats.org/drawingml/2006/main">
               <a:ext uri="{FF2B5EF4-FFF2-40B4-BE49-F238E27FC236}">
-                <a16:creationId xmlns:a16="http://schemas.microsoft.com/office/drawing/2014/main" id="{81126BB7-7F89-494D-9731-D590AAF97E1A}"/>
+                <a16:creationId xmlns:a16="http://schemas.microsoft.com/office/drawing/2014/main" id="{A7EA2A05-8566-4C6C-95B9-4DBFBBED25D9}"/>
               </a:ext>
             </a:extLst>
           </p:cNvPr>
@@ -8395,7 +7829,7 @@
           <p:cNvPr id="7" name="">
             <a:extLst xmlns:a="http://schemas.openxmlformats.org/drawingml/2006/main">
               <a:ext uri="{FF2B5EF4-FFF2-40B4-BE49-F238E27FC236}">
-                <a16:creationId xmlns:a16="http://schemas.microsoft.com/office/drawing/2014/main" id="{1DB5347D-F849-425A-A1F6-7DD7BDC203B8}"/>
+                <a16:creationId xmlns:a16="http://schemas.microsoft.com/office/drawing/2014/main" id="{E92E4FB2-817E-4F5C-B3F4-1F92615054A6}"/>
               </a:ext>
             </a:extLst>
           </p:cNvPr>
@@ -8430,7 +7864,7 @@
           <p:cNvPr id="8" name="">
             <a:extLst xmlns:a="http://schemas.openxmlformats.org/drawingml/2006/main">
               <a:ext uri="{FF2B5EF4-FFF2-40B4-BE49-F238E27FC236}">
-                <a16:creationId xmlns:a16="http://schemas.microsoft.com/office/drawing/2014/main" id="{AFE3C1AF-12B0-47BF-B7D0-F0FF9F1D7B73}"/>
+                <a16:creationId xmlns:a16="http://schemas.microsoft.com/office/drawing/2014/main" id="{305D08B0-34B7-4EE7-9998-FD86C65A8F16}"/>
               </a:ext>
             </a:extLst>
           </p:cNvPr>
@@ -8480,7 +7914,7 @@
           <p:cNvPr id="9" name="">
             <a:extLst xmlns:a="http://schemas.openxmlformats.org/drawingml/2006/main">
               <a:ext uri="{FF2B5EF4-FFF2-40B4-BE49-F238E27FC236}">
-                <a16:creationId xmlns:a16="http://schemas.microsoft.com/office/drawing/2014/main" id="{59D50987-6954-47DC-A257-6F0582395F2C}"/>
+                <a16:creationId xmlns:a16="http://schemas.microsoft.com/office/drawing/2014/main" id="{C43FCCC9-D305-43FB-AD49-60BA67BA411A}"/>
               </a:ext>
             </a:extLst>
           </p:cNvPr>
@@ -8530,7 +7964,7 @@
           <p:cNvPr id="10" name="">
             <a:extLst xmlns:a="http://schemas.openxmlformats.org/drawingml/2006/main">
               <a:ext uri="{FF2B5EF4-FFF2-40B4-BE49-F238E27FC236}">
-                <a16:creationId xmlns:a16="http://schemas.microsoft.com/office/drawing/2014/main" id="{F8CF9201-40FB-49A0-8442-EC7CB039CC78}"/>
+                <a16:creationId xmlns:a16="http://schemas.microsoft.com/office/drawing/2014/main" id="{2215EB15-7013-4F05-81C6-23C211F83BB8}"/>
               </a:ext>
             </a:extLst>
           </p:cNvPr>
@@ -8580,7 +8014,7 @@
           <p:cNvPr id="11" name="">
             <a:extLst xmlns:a="http://schemas.openxmlformats.org/drawingml/2006/main">
               <a:ext uri="{FF2B5EF4-FFF2-40B4-BE49-F238E27FC236}">
-                <a16:creationId xmlns:a16="http://schemas.microsoft.com/office/drawing/2014/main" id="{684BE82E-37E3-4BE9-8421-124838908D03}"/>
+                <a16:creationId xmlns:a16="http://schemas.microsoft.com/office/drawing/2014/main" id="{F96A6DD1-402C-417F-BF28-EB03C0477455}"/>
               </a:ext>
             </a:extLst>
           </p:cNvPr>
@@ -8630,7 +8064,7 @@
           <p:cNvPr id="12" name="">
             <a:extLst xmlns:a="http://schemas.openxmlformats.org/drawingml/2006/main">
               <a:ext uri="{FF2B5EF4-FFF2-40B4-BE49-F238E27FC236}">
-                <a16:creationId xmlns:a16="http://schemas.microsoft.com/office/drawing/2014/main" id="{825DF27B-27F6-40CA-93DB-1B79EAF4654A}"/>
+                <a16:creationId xmlns:a16="http://schemas.microsoft.com/office/drawing/2014/main" id="{C561ACEE-B269-4CCD-8746-8041CE5B0C0A}"/>
               </a:ext>
             </a:extLst>
           </p:cNvPr>
@@ -8665,7 +8099,7 @@
           <p:cNvPr id="13" name="">
             <a:extLst xmlns:a="http://schemas.openxmlformats.org/drawingml/2006/main">
               <a:ext uri="{FF2B5EF4-FFF2-40B4-BE49-F238E27FC236}">
-                <a16:creationId xmlns:a16="http://schemas.microsoft.com/office/drawing/2014/main" id="{694D5EC1-8293-427B-8B64-2A06AC2A79F0}"/>
+                <a16:creationId xmlns:a16="http://schemas.microsoft.com/office/drawing/2014/main" id="{A895BF2C-93D7-403B-B837-C82B07DA9CA5}"/>
               </a:ext>
             </a:extLst>
           </p:cNvPr>
@@ -8715,7 +8149,7 @@
           <p:cNvPr id="14" name="">
             <a:extLst xmlns:a="http://schemas.openxmlformats.org/drawingml/2006/main">
               <a:ext uri="{FF2B5EF4-FFF2-40B4-BE49-F238E27FC236}">
-                <a16:creationId xmlns:a16="http://schemas.microsoft.com/office/drawing/2014/main" id="{01F24B10-644B-477E-ADF4-93CE3B7CBF43}"/>
+                <a16:creationId xmlns:a16="http://schemas.microsoft.com/office/drawing/2014/main" id="{9E6B53EE-0E98-4109-A2E6-17C8E618A8F8}"/>
               </a:ext>
             </a:extLst>
           </p:cNvPr>
@@ -8765,7 +8199,7 @@
           <p:cNvPr id="15" name="">
             <a:extLst xmlns:a="http://schemas.openxmlformats.org/drawingml/2006/main">
               <a:ext uri="{FF2B5EF4-FFF2-40B4-BE49-F238E27FC236}">
-                <a16:creationId xmlns:a16="http://schemas.microsoft.com/office/drawing/2014/main" id="{522B5DA1-E14F-47E5-9801-6737AA55C27C}"/>
+                <a16:creationId xmlns:a16="http://schemas.microsoft.com/office/drawing/2014/main" id="{782B795C-6B6D-4ADE-ABFE-3C688082FAAC}"/>
               </a:ext>
             </a:extLst>
           </p:cNvPr>
@@ -8815,7 +8249,7 @@
           <p:cNvPr id="16" name="">
             <a:extLst xmlns:a="http://schemas.openxmlformats.org/drawingml/2006/main">
               <a:ext uri="{FF2B5EF4-FFF2-40B4-BE49-F238E27FC236}">
-                <a16:creationId xmlns:a16="http://schemas.microsoft.com/office/drawing/2014/main" id="{9D0FC37D-8F52-4A08-BD8B-CC06531DA19A}"/>
+                <a16:creationId xmlns:a16="http://schemas.microsoft.com/office/drawing/2014/main" id="{4CB756EB-A976-4553-BA84-FB56D1A78DD6}"/>
               </a:ext>
             </a:extLst>
           </p:cNvPr>
@@ -8865,7 +8299,7 @@
           <p:cNvPr id="17" name="">
             <a:extLst xmlns:a="http://schemas.openxmlformats.org/drawingml/2006/main">
               <a:ext uri="{FF2B5EF4-FFF2-40B4-BE49-F238E27FC236}">
-                <a16:creationId xmlns:a16="http://schemas.microsoft.com/office/drawing/2014/main" id="{01102B22-AC50-441B-AD66-65B4A9018CBD}"/>
+                <a16:creationId xmlns:a16="http://schemas.microsoft.com/office/drawing/2014/main" id="{0F542ECB-F12D-48F6-9AC9-D9B743C2C0A5}"/>
               </a:ext>
             </a:extLst>
           </p:cNvPr>
@@ -8900,7 +8334,7 @@
           <p:cNvPr id="18" name="">
             <a:extLst xmlns:a="http://schemas.openxmlformats.org/drawingml/2006/main">
               <a:ext uri="{FF2B5EF4-FFF2-40B4-BE49-F238E27FC236}">
-                <a16:creationId xmlns:a16="http://schemas.microsoft.com/office/drawing/2014/main" id="{AD3DA666-F6F3-40EF-80BE-1BE95EE00D21}"/>
+                <a16:creationId xmlns:a16="http://schemas.microsoft.com/office/drawing/2014/main" id="{03B5F343-8F86-44AF-A2F1-1E259EC0FDB6}"/>
               </a:ext>
             </a:extLst>
           </p:cNvPr>
@@ -8950,7 +8384,7 @@
           <p:cNvPr id="19" name="">
             <a:extLst xmlns:a="http://schemas.openxmlformats.org/drawingml/2006/main">
               <a:ext uri="{FF2B5EF4-FFF2-40B4-BE49-F238E27FC236}">
-                <a16:creationId xmlns:a16="http://schemas.microsoft.com/office/drawing/2014/main" id="{8ACAFB3B-91E7-4E3A-A5B2-CBA7A3571470}"/>
+                <a16:creationId xmlns:a16="http://schemas.microsoft.com/office/drawing/2014/main" id="{22F2F139-2DA0-4101-8071-8BF377661C53}"/>
               </a:ext>
             </a:extLst>
           </p:cNvPr>
@@ -9000,7 +8434,7 @@
           <p:cNvPr id="20" name="">
             <a:extLst xmlns:a="http://schemas.openxmlformats.org/drawingml/2006/main">
               <a:ext uri="{FF2B5EF4-FFF2-40B4-BE49-F238E27FC236}">
-                <a16:creationId xmlns:a16="http://schemas.microsoft.com/office/drawing/2014/main" id="{AC269FBF-E41D-4275-886B-EE0485562194}"/>
+                <a16:creationId xmlns:a16="http://schemas.microsoft.com/office/drawing/2014/main" id="{0B914F8B-91F5-4386-9A99-E95D71176C19}"/>
               </a:ext>
             </a:extLst>
           </p:cNvPr>
@@ -9050,7 +8484,7 @@
           <p:cNvPr id="21" name="">
             <a:extLst xmlns:a="http://schemas.openxmlformats.org/drawingml/2006/main">
               <a:ext uri="{FF2B5EF4-FFF2-40B4-BE49-F238E27FC236}">
-                <a16:creationId xmlns:a16="http://schemas.microsoft.com/office/drawing/2014/main" id="{7E28C1FE-BC9E-4227-8B00-065B6D2662B0}"/>
+                <a16:creationId xmlns:a16="http://schemas.microsoft.com/office/drawing/2014/main" id="{BB2349B4-FE03-4E5B-92BF-2865C52FFC74}"/>
               </a:ext>
             </a:extLst>
           </p:cNvPr>
@@ -9098,7 +8532,7 @@
     </p:spTree>
     <p:extLst>
       <p:ext uri="{BB962C8B-B14F-4D97-AF65-F5344CB8AC3E}">
-        <p14:creationId xmlns:p14="http://schemas.microsoft.com/office/powerpoint/2010/main" val="502274825"/>
+        <p14:creationId xmlns:p14="http://schemas.microsoft.com/office/powerpoint/2010/main" val="88905234"/>
       </p:ext>
     </p:extLst>
   </p:cSld>
@@ -9129,7 +8563,7 @@
           <p:cNvPr id="24" name="">
             <a:extLst xmlns:a="http://schemas.openxmlformats.org/drawingml/2006/main">
               <a:ext uri="{FF2B5EF4-FFF2-40B4-BE49-F238E27FC236}">
-                <a16:creationId xmlns:a16="http://schemas.microsoft.com/office/drawing/2014/main" id="{091D8200-EF46-403D-AE01-0D540014BC19}"/>
+                <a16:creationId xmlns:a16="http://schemas.microsoft.com/office/drawing/2014/main" id="{1FD58E55-63A0-4C44-99D7-ED28941D3CCA}"/>
               </a:ext>
             </a:extLst>
           </p:cNvPr>
@@ -9179,7 +8613,7 @@
           <p:cNvPr id="2" name="">
             <a:extLst xmlns:a="http://schemas.openxmlformats.org/drawingml/2006/main">
               <a:ext uri="{FF2B5EF4-FFF2-40B4-BE49-F238E27FC236}">
-                <a16:creationId xmlns:a16="http://schemas.microsoft.com/office/drawing/2014/main" id="{BD57159E-4A9D-42E9-9AA2-0F3775C54A2C}"/>
+                <a16:creationId xmlns:a16="http://schemas.microsoft.com/office/drawing/2014/main" id="{9DFF551B-E445-4183-8010-1FC29C0F3D21}"/>
               </a:ext>
             </a:extLst>
           </p:cNvPr>
@@ -9229,7 +8663,7 @@
           <p:cNvPr id="3" name="">
             <a:extLst xmlns:a="http://schemas.openxmlformats.org/drawingml/2006/main">
               <a:ext uri="{FF2B5EF4-FFF2-40B4-BE49-F238E27FC236}">
-                <a16:creationId xmlns:a16="http://schemas.microsoft.com/office/drawing/2014/main" id="{45AF0946-02D9-4051-8B50-45EB036081EA}"/>
+                <a16:creationId xmlns:a16="http://schemas.microsoft.com/office/drawing/2014/main" id="{D63C65FF-CFE2-4685-BAA4-668B59DB5CD6}"/>
               </a:ext>
             </a:extLst>
           </p:cNvPr>
@@ -9279,7 +8713,7 @@
           <p:cNvPr id="4" name="">
             <a:extLst xmlns:a="http://schemas.openxmlformats.org/drawingml/2006/main">
               <a:ext uri="{FF2B5EF4-FFF2-40B4-BE49-F238E27FC236}">
-                <a16:creationId xmlns:a16="http://schemas.microsoft.com/office/drawing/2014/main" id="{B22150E0-EB03-4B41-8DA9-F84AFE596822}"/>
+                <a16:creationId xmlns:a16="http://schemas.microsoft.com/office/drawing/2014/main" id="{8FD7DE58-64CE-4FA5-B5BD-D49E7F3DA3A9}"/>
               </a:ext>
             </a:extLst>
           </p:cNvPr>
@@ -9310,7 +8744,7 @@
           <p:cNvPr id="5" name="">
             <a:extLst xmlns:a="http://schemas.openxmlformats.org/drawingml/2006/main">
               <a:ext uri="{FF2B5EF4-FFF2-40B4-BE49-F238E27FC236}">
-                <a16:creationId xmlns:a16="http://schemas.microsoft.com/office/drawing/2014/main" id="{9F7DE107-66EE-40D9-8D48-1B5915ED7D55}"/>
+                <a16:creationId xmlns:a16="http://schemas.microsoft.com/office/drawing/2014/main" id="{B5A33DE0-81A9-4646-A74E-97F83705BC12}"/>
               </a:ext>
             </a:extLst>
           </p:cNvPr>
@@ -9360,7 +8794,7 @@
           <p:cNvPr id="6" name="">
             <a:extLst xmlns:a="http://schemas.openxmlformats.org/drawingml/2006/main">
               <a:ext uri="{FF2B5EF4-FFF2-40B4-BE49-F238E27FC236}">
-                <a16:creationId xmlns:a16="http://schemas.microsoft.com/office/drawing/2014/main" id="{7CACC288-9936-494C-9CC5-C98137D89DB6}"/>
+                <a16:creationId xmlns:a16="http://schemas.microsoft.com/office/drawing/2014/main" id="{650E5C52-8419-4F31-AA54-81C68BF46572}"/>
               </a:ext>
             </a:extLst>
           </p:cNvPr>
@@ -9410,7 +8844,7 @@
           <p:cNvPr id="7" name="">
             <a:extLst xmlns:a="http://schemas.openxmlformats.org/drawingml/2006/main">
               <a:ext uri="{FF2B5EF4-FFF2-40B4-BE49-F238E27FC236}">
-                <a16:creationId xmlns:a16="http://schemas.microsoft.com/office/drawing/2014/main" id="{39911EF7-EC02-40A2-B84D-DD51307943CE}"/>
+                <a16:creationId xmlns:a16="http://schemas.microsoft.com/office/drawing/2014/main" id="{97BD35CC-DF03-48D1-9BDE-1A6F4D1A9102}"/>
               </a:ext>
             </a:extLst>
           </p:cNvPr>
@@ -9460,7 +8894,7 @@
           <p:cNvPr id="8" name="">
             <a:extLst xmlns:a="http://schemas.openxmlformats.org/drawingml/2006/main">
               <a:ext uri="{FF2B5EF4-FFF2-40B4-BE49-F238E27FC236}">
-                <a16:creationId xmlns:a16="http://schemas.microsoft.com/office/drawing/2014/main" id="{48843D9C-E25C-4797-AAE2-5BC3F9E184EF}"/>
+                <a16:creationId xmlns:a16="http://schemas.microsoft.com/office/drawing/2014/main" id="{4A574667-ED40-4CE8-A27E-A412862EFF58}"/>
               </a:ext>
             </a:extLst>
           </p:cNvPr>
@@ -9495,7 +8929,7 @@
           <p:cNvPr id="9" name="">
             <a:extLst xmlns:a="http://schemas.openxmlformats.org/drawingml/2006/main">
               <a:ext uri="{FF2B5EF4-FFF2-40B4-BE49-F238E27FC236}">
-                <a16:creationId xmlns:a16="http://schemas.microsoft.com/office/drawing/2014/main" id="{AFB45680-D46D-414F-B0E8-5023B8B9EB90}"/>
+                <a16:creationId xmlns:a16="http://schemas.microsoft.com/office/drawing/2014/main" id="{2A7721C7-4457-4AD0-B940-1ECB4702DFD1}"/>
               </a:ext>
             </a:extLst>
           </p:cNvPr>
@@ -9545,7 +8979,7 @@
           <p:cNvPr id="10" name="">
             <a:extLst xmlns:a="http://schemas.openxmlformats.org/drawingml/2006/main">
               <a:ext uri="{FF2B5EF4-FFF2-40B4-BE49-F238E27FC236}">
-                <a16:creationId xmlns:a16="http://schemas.microsoft.com/office/drawing/2014/main" id="{CE616CF6-FD07-487C-BDE5-5D227FF151BA}"/>
+                <a16:creationId xmlns:a16="http://schemas.microsoft.com/office/drawing/2014/main" id="{1411C314-74D5-44E7-A3BB-B6545284B550}"/>
               </a:ext>
             </a:extLst>
           </p:cNvPr>
@@ -9585,7 +9019,7 @@
                   <a:srgbClr val="142F4C"/>
                 </a:solidFill>
               </a:rPr>
-              <a:t>Option A - retain accountability with the Finance Director (rejected: design and adjudication would sit with one executive)</a:t>
+              <a:t>Option A — deliver through existing internal ownership</a:t>
             </a:r>
           </a:p>
         </p:txBody>
@@ -9595,7 +9029,7 @@
           <p:cNvPr id="11" name="">
             <a:extLst xmlns:a="http://schemas.openxmlformats.org/drawingml/2006/main">
               <a:ext uri="{FF2B5EF4-FFF2-40B4-BE49-F238E27FC236}">
-                <a16:creationId xmlns:a16="http://schemas.microsoft.com/office/drawing/2014/main" id="{C106A9CA-DBBD-46A2-B8FF-E2D432E94587}"/>
+                <a16:creationId xmlns:a16="http://schemas.microsoft.com/office/drawing/2014/main" id="{754E0E4B-6019-4B80-8E75-95CFC25B97F1}"/>
               </a:ext>
             </a:extLst>
           </p:cNvPr>
@@ -9635,7 +9069,7 @@
                   <a:srgbClr val="5A6B7C"/>
                 </a:solidFill>
               </a:rPr>
-              <a:t>Cost: Cost and effort require management confirmation before approval.</a:t>
+              <a:t>Cost: Internal capacity and management time.</a:t>
             </a:r>
           </a:p>
           <a:p xmlns:a="http://schemas.openxmlformats.org/drawingml/2006/main">
@@ -9669,7 +9103,7 @@
                   <a:srgbClr val="5A6B7C"/>
                 </a:solidFill>
               </a:rPr>
-              <a:t>Trade-off: Uses internal capacity and may move more slowly where capability is immature.</a:t>
+              <a:t>Trade-off: May move more slowly where capability is immature.</a:t>
             </a:r>
           </a:p>
           <a:p xmlns:a="http://schemas.openxmlformats.org/drawingml/2006/main">
@@ -9686,7 +9120,7 @@
                   <a:srgbClr val="5A6B7C"/>
                 </a:solidFill>
               </a:rPr>
-              <a:t>Rejection reason: rejected: design and adjudication would sit with one executive</a:t>
+              <a:t>Recommended option</a:t>
             </a:r>
           </a:p>
         </p:txBody>
@@ -9696,7 +9130,7 @@
           <p:cNvPr id="12" name="">
             <a:extLst xmlns:a="http://schemas.openxmlformats.org/drawingml/2006/main">
               <a:ext uri="{FF2B5EF4-FFF2-40B4-BE49-F238E27FC236}">
-                <a16:creationId xmlns:a16="http://schemas.microsoft.com/office/drawing/2014/main" id="{DADE4D0A-4CDB-469D-B19D-107E87EF9191}"/>
+                <a16:creationId xmlns:a16="http://schemas.microsoft.com/office/drawing/2014/main" id="{BA7767E4-A149-4EAC-BB2D-777B1CA86703}"/>
               </a:ext>
             </a:extLst>
           </p:cNvPr>
@@ -9731,7 +9165,7 @@
           <p:cNvPr id="13" name="">
             <a:extLst xmlns:a="http://schemas.openxmlformats.org/drawingml/2006/main">
               <a:ext uri="{FF2B5EF4-FFF2-40B4-BE49-F238E27FC236}">
-                <a16:creationId xmlns:a16="http://schemas.microsoft.com/office/drawing/2014/main" id="{925B99AC-2162-44C1-A736-CD1029EBF6A2}"/>
+                <a16:creationId xmlns:a16="http://schemas.microsoft.com/office/drawing/2014/main" id="{60E74458-A664-4C86-A3FB-43CD3C7EA6AC}"/>
               </a:ext>
             </a:extLst>
           </p:cNvPr>
@@ -9781,7 +9215,7 @@
           <p:cNvPr id="14" name="">
             <a:extLst xmlns:a="http://schemas.openxmlformats.org/drawingml/2006/main">
               <a:ext uri="{FF2B5EF4-FFF2-40B4-BE49-F238E27FC236}">
-                <a16:creationId xmlns:a16="http://schemas.microsoft.com/office/drawing/2014/main" id="{28403F59-AD88-4520-A005-30342A27EC97}"/>
+                <a16:creationId xmlns:a16="http://schemas.microsoft.com/office/drawing/2014/main" id="{A63B3E34-84AD-497C-9660-BC39DA23E291}"/>
               </a:ext>
             </a:extLst>
           </p:cNvPr>
@@ -9821,7 +9255,7 @@
                   <a:srgbClr val="142F4C"/>
                 </a:solidFill>
               </a:rPr>
-              <a:t>Option B - delegate detection design to the Financial Controller with quarterly Audit and Risk Committee reporting (recommended and accepted)</a:t>
+              <a:t>Option B — use bounded specialist support</a:t>
             </a:r>
           </a:p>
         </p:txBody>
@@ -9831,7 +9265,7 @@
           <p:cNvPr id="15" name="">
             <a:extLst xmlns:a="http://schemas.openxmlformats.org/drawingml/2006/main">
               <a:ext uri="{FF2B5EF4-FFF2-40B4-BE49-F238E27FC236}">
-                <a16:creationId xmlns:a16="http://schemas.microsoft.com/office/drawing/2014/main" id="{74FD47CF-59F5-4E50-9249-487E91924478}"/>
+                <a16:creationId xmlns:a16="http://schemas.microsoft.com/office/drawing/2014/main" id="{DFA721BC-29BA-454A-843B-B12533A2C269}"/>
               </a:ext>
             </a:extLst>
           </p:cNvPr>
@@ -9871,7 +9305,7 @@
                   <a:srgbClr val="5A6B7C"/>
                 </a:solidFill>
               </a:rPr>
-              <a:t>Cost: Cost and effort require management confirmation before approval.</a:t>
+              <a:t>Cost: Targeted specialist budget and handover effort.</a:t>
             </a:r>
           </a:p>
           <a:p xmlns:a="http://schemas.openxmlformats.org/drawingml/2006/main">
@@ -9888,7 +9322,7 @@
                   <a:srgbClr val="5A6B7C"/>
                 </a:solidFill>
               </a:rPr>
-              <a:t>Benefit: Adds focused specialist capacity against the named priority.</a:t>
+              <a:t>Benefit: Adds focused capacity against the named priority.</a:t>
             </a:r>
           </a:p>
           <a:p xmlns:a="http://schemas.openxmlformats.org/drawingml/2006/main">
@@ -9905,7 +9339,7 @@
                   <a:srgbClr val="5A6B7C"/>
                 </a:solidFill>
               </a:rPr>
-              <a:t>Trade-off: Introduces external cost, handover effort and a dependency on clear scope.</a:t>
+              <a:t>Trade-off: Requires clear scope, procurement and transfer of ownership.</a:t>
             </a:r>
           </a:p>
           <a:p xmlns:a="http://schemas.openxmlformats.org/drawingml/2006/main">
@@ -9932,7 +9366,7 @@
           <p:cNvPr id="16" name="">
             <a:extLst xmlns:a="http://schemas.openxmlformats.org/drawingml/2006/main">
               <a:ext uri="{FF2B5EF4-FFF2-40B4-BE49-F238E27FC236}">
-                <a16:creationId xmlns:a16="http://schemas.microsoft.com/office/drawing/2014/main" id="{25A17970-F6A0-45DA-8937-4CE5CA028C63}"/>
+                <a16:creationId xmlns:a16="http://schemas.microsoft.com/office/drawing/2014/main" id="{B2982639-28D4-4920-B56E-A1589026D6C5}"/>
               </a:ext>
             </a:extLst>
           </p:cNvPr>
@@ -9967,7 +9401,7 @@
           <p:cNvPr id="17" name="">
             <a:extLst xmlns:a="http://schemas.openxmlformats.org/drawingml/2006/main">
               <a:ext uri="{FF2B5EF4-FFF2-40B4-BE49-F238E27FC236}">
-                <a16:creationId xmlns:a16="http://schemas.microsoft.com/office/drawing/2014/main" id="{3B53975F-C856-46CA-823E-BD42FDDBE47D}"/>
+                <a16:creationId xmlns:a16="http://schemas.microsoft.com/office/drawing/2014/main" id="{FCC534E4-9458-4351-962C-5D35F1955EA8}"/>
               </a:ext>
             </a:extLst>
           </p:cNvPr>
@@ -10017,7 +9451,7 @@
           <p:cNvPr id="18" name="">
             <a:extLst xmlns:a="http://schemas.openxmlformats.org/drawingml/2006/main">
               <a:ext uri="{FF2B5EF4-FFF2-40B4-BE49-F238E27FC236}">
-                <a16:creationId xmlns:a16="http://schemas.microsoft.com/office/drawing/2014/main" id="{3E9995D6-DA30-440E-A87F-40361B391C6A}"/>
+                <a16:creationId xmlns:a16="http://schemas.microsoft.com/office/drawing/2014/main" id="{1114F0F6-59E0-4B63-9457-13C41D56C55D}"/>
               </a:ext>
             </a:extLst>
           </p:cNvPr>
@@ -10057,7 +9491,7 @@
                   <a:srgbClr val="142F4C"/>
                 </a:solidFill>
               </a:rPr>
-              <a:t>Option C - outsource monitoring to an external provider (rejected at current maturity: Kestrel cannot yet specify the indicator set it needs)</a:t>
+              <a:t>Option C — combine internal ownership with targeted specialist support</a:t>
             </a:r>
           </a:p>
         </p:txBody>
@@ -10067,7 +9501,7 @@
           <p:cNvPr id="19" name="">
             <a:extLst xmlns:a="http://schemas.openxmlformats.org/drawingml/2006/main">
               <a:ext uri="{FF2B5EF4-FFF2-40B4-BE49-F238E27FC236}">
-                <a16:creationId xmlns:a16="http://schemas.microsoft.com/office/drawing/2014/main" id="{F8DEEC7D-8758-4F68-8F14-C32B880BD1F2}"/>
+                <a16:creationId xmlns:a16="http://schemas.microsoft.com/office/drawing/2014/main" id="{BA658372-FAE7-4096-A856-69705B72E677}"/>
               </a:ext>
             </a:extLst>
           </p:cNvPr>
@@ -10107,7 +9541,7 @@
                   <a:srgbClr val="5A6B7C"/>
                 </a:solidFill>
               </a:rPr>
-              <a:t>Cost: Cost and effort require management confirmation before approval.</a:t>
+              <a:t>Cost: Combined internal capacity plus targeted specialist budget.</a:t>
             </a:r>
           </a:p>
           <a:p xmlns:a="http://schemas.openxmlformats.org/drawingml/2006/main">
@@ -10124,7 +9558,7 @@
                   <a:srgbClr val="5A6B7C"/>
                 </a:solidFill>
               </a:rPr>
-              <a:t>Benefit: Combines internal accountability with targeted specialist support.</a:t>
+              <a:t>Benefit: Keeps accountability internal while accelerating the priority design.</a:t>
             </a:r>
           </a:p>
           <a:p xmlns:a="http://schemas.openxmlformats.org/drawingml/2006/main">
@@ -10158,7 +9592,7 @@
                   <a:srgbClr val="5A6B7C"/>
                 </a:solidFill>
               </a:rPr>
-              <a:t>Rejection reason: rejected at current maturity: Kestrel cannot yet specify the indicator set it needs</a:t>
+              <a:t>Recommended option</a:t>
             </a:r>
           </a:p>
         </p:txBody>
@@ -10168,7 +9602,7 @@
           <p:cNvPr id="20" name="">
             <a:extLst xmlns:a="http://schemas.openxmlformats.org/drawingml/2006/main">
               <a:ext uri="{FF2B5EF4-FFF2-40B4-BE49-F238E27FC236}">
-                <a16:creationId xmlns:a16="http://schemas.microsoft.com/office/drawing/2014/main" id="{27F175AC-FCDA-4F86-9E10-F4D4A568315E}"/>
+                <a16:creationId xmlns:a16="http://schemas.microsoft.com/office/drawing/2014/main" id="{174953EA-34E6-463E-906B-5894CECE973A}"/>
               </a:ext>
             </a:extLst>
           </p:cNvPr>
@@ -10203,7 +9637,7 @@
           <p:cNvPr id="21" name="">
             <a:extLst xmlns:a="http://schemas.openxmlformats.org/drawingml/2006/main">
               <a:ext uri="{FF2B5EF4-FFF2-40B4-BE49-F238E27FC236}">
-                <a16:creationId xmlns:a16="http://schemas.microsoft.com/office/drawing/2014/main" id="{1CA1A955-4BDD-4D12-A70E-7AF2409EC467}"/>
+                <a16:creationId xmlns:a16="http://schemas.microsoft.com/office/drawing/2014/main" id="{2E2C06C7-5AB1-4281-A75D-FEEC9F6F00A9}"/>
               </a:ext>
             </a:extLst>
           </p:cNvPr>
@@ -10243,7 +9677,7 @@
                   <a:srgbClr val="142F4C"/>
                 </a:solidFill>
               </a:rPr>
-              <a:t>MK recommendation: Viable options considered. Option A - leave accountability with the Finance Director as the policy currently states. Trade-off:…</a:t>
+              <a:t>Deterministic recommendation: Name one accountable executive per linked control and approve a 30-day escalation route.</a:t>
             </a:r>
           </a:p>
         </p:txBody>
@@ -10253,7 +9687,7 @@
           <p:cNvPr id="22" name="">
             <a:extLst xmlns:a="http://schemas.openxmlformats.org/drawingml/2006/main">
               <a:ext uri="{FF2B5EF4-FFF2-40B4-BE49-F238E27FC236}">
-                <a16:creationId xmlns:a16="http://schemas.microsoft.com/office/drawing/2014/main" id="{AC9C194D-71A1-44E4-B2B0-98399AB9E023}"/>
+                <a16:creationId xmlns:a16="http://schemas.microsoft.com/office/drawing/2014/main" id="{7DF00DB0-EFB5-4CC3-B5A8-A554700F85A5}"/>
               </a:ext>
             </a:extLst>
           </p:cNvPr>
@@ -10293,7 +9727,7 @@
                   <a:srgbClr val="142F4C"/>
                 </a:solidFill>
               </a:rPr>
-              <a:t>Recommendation rationale: The recommendation follows the linked deterministic finding and risk priorities; management must confirm the final route, cost and…</a:t>
+              <a:t>Recommendation rationale: The recorded assessment links this decision to 8 material finding(s) and 8 risk(s). Management should confirm the final…</a:t>
             </a:r>
           </a:p>
         </p:txBody>
@@ -10303,7 +9737,7 @@
           <p:cNvPr id="23" name="">
             <a:extLst xmlns:a="http://schemas.openxmlformats.org/drawingml/2006/main">
               <a:ext uri="{FF2B5EF4-FFF2-40B4-BE49-F238E27FC236}">
-                <a16:creationId xmlns:a16="http://schemas.microsoft.com/office/drawing/2014/main" id="{1243896E-2CA4-430D-8DC2-F76FD6ED0228}"/>
+                <a16:creationId xmlns:a16="http://schemas.microsoft.com/office/drawing/2014/main" id="{F8D02962-A0A6-4A98-AB6C-AF35B009E85F}"/>
               </a:ext>
             </a:extLst>
           </p:cNvPr>
@@ -10343,7 +9777,7 @@
                   <a:srgbClr val="142F4C"/>
                 </a:solidFill>
               </a:rPr>
-              <a:t>Owner: CEO / Managing Director · Deadline: 30 days</a:t>
+              <a:t>Owner: CEO / Managing Director · Target period: 30 days</a:t>
             </a:r>
           </a:p>
         </p:txBody>
@@ -10351,7 +9785,7 @@
     </p:spTree>
     <p:extLst>
       <p:ext uri="{BB962C8B-B14F-4D97-AF65-F5344CB8AC3E}">
-        <p14:creationId xmlns:p14="http://schemas.microsoft.com/office/powerpoint/2010/main" val="1676871416"/>
+        <p14:creationId xmlns:p14="http://schemas.microsoft.com/office/powerpoint/2010/main" val="1551737851"/>
       </p:ext>
     </p:extLst>
   </p:cSld>
@@ -10382,7 +9816,7 @@
           <p:cNvPr id="30" name="">
             <a:extLst xmlns:a="http://schemas.openxmlformats.org/drawingml/2006/main">
               <a:ext uri="{FF2B5EF4-FFF2-40B4-BE49-F238E27FC236}">
-                <a16:creationId xmlns:a16="http://schemas.microsoft.com/office/drawing/2014/main" id="{C53CDAB7-45B1-4570-A241-9514A25548AA}"/>
+                <a16:creationId xmlns:a16="http://schemas.microsoft.com/office/drawing/2014/main" id="{BFD2B7AB-7CBF-44FB-8E68-A1500BF39715}"/>
               </a:ext>
             </a:extLst>
           </p:cNvPr>
@@ -10432,7 +9866,7 @@
           <p:cNvPr id="2" name="">
             <a:extLst xmlns:a="http://schemas.openxmlformats.org/drawingml/2006/main">
               <a:ext uri="{FF2B5EF4-FFF2-40B4-BE49-F238E27FC236}">
-                <a16:creationId xmlns:a16="http://schemas.microsoft.com/office/drawing/2014/main" id="{7F46292A-5BE8-4CAA-9158-E4B16A258B3A}"/>
+                <a16:creationId xmlns:a16="http://schemas.microsoft.com/office/drawing/2014/main" id="{BDFAB711-3F74-4C02-B1FA-51A414407F8A}"/>
               </a:ext>
             </a:extLst>
           </p:cNvPr>
@@ -10482,7 +9916,7 @@
           <p:cNvPr id="3" name="">
             <a:extLst xmlns:a="http://schemas.openxmlformats.org/drawingml/2006/main">
               <a:ext uri="{FF2B5EF4-FFF2-40B4-BE49-F238E27FC236}">
-                <a16:creationId xmlns:a16="http://schemas.microsoft.com/office/drawing/2014/main" id="{42D80E31-B409-43E9-B2DE-B7C50E930D06}"/>
+                <a16:creationId xmlns:a16="http://schemas.microsoft.com/office/drawing/2014/main" id="{9667757B-E051-4B8A-9932-E551B627FCE5}"/>
               </a:ext>
             </a:extLst>
           </p:cNvPr>
@@ -10532,7 +9966,7 @@
           <p:cNvPr id="4" name="">
             <a:extLst xmlns:a="http://schemas.openxmlformats.org/drawingml/2006/main">
               <a:ext uri="{FF2B5EF4-FFF2-40B4-BE49-F238E27FC236}">
-                <a16:creationId xmlns:a16="http://schemas.microsoft.com/office/drawing/2014/main" id="{FB38F29A-8AA8-4BD5-9F9D-928CD2F601A2}"/>
+                <a16:creationId xmlns:a16="http://schemas.microsoft.com/office/drawing/2014/main" id="{E7F2A9D9-6341-447B-9401-B09F660158AA}"/>
               </a:ext>
             </a:extLst>
           </p:cNvPr>
@@ -10563,7 +9997,7 @@
           <p:cNvPr id="5" name="">
             <a:extLst xmlns:a="http://schemas.openxmlformats.org/drawingml/2006/main">
               <a:ext uri="{FF2B5EF4-FFF2-40B4-BE49-F238E27FC236}">
-                <a16:creationId xmlns:a16="http://schemas.microsoft.com/office/drawing/2014/main" id="{03DA3849-EFA1-4B32-B9DA-D94CF090530E}"/>
+                <a16:creationId xmlns:a16="http://schemas.microsoft.com/office/drawing/2014/main" id="{EDB8067E-4AFF-4D0C-9F17-D6D6AD92FB67}"/>
               </a:ext>
             </a:extLst>
           </p:cNvPr>
@@ -10613,7 +10047,7 @@
           <p:cNvPr id="6" name="">
             <a:extLst xmlns:a="http://schemas.openxmlformats.org/drawingml/2006/main">
               <a:ext uri="{FF2B5EF4-FFF2-40B4-BE49-F238E27FC236}">
-                <a16:creationId xmlns:a16="http://schemas.microsoft.com/office/drawing/2014/main" id="{9BC56F33-4BD0-4A0B-8AB5-63EDA7ADA74A}"/>
+                <a16:creationId xmlns:a16="http://schemas.microsoft.com/office/drawing/2014/main" id="{C4D6B9B9-F383-4BFA-BA91-B4D5875FA100}"/>
               </a:ext>
             </a:extLst>
           </p:cNvPr>
@@ -10663,7 +10097,7 @@
           <p:cNvPr id="7" name="">
             <a:extLst xmlns:a="http://schemas.openxmlformats.org/drawingml/2006/main">
               <a:ext uri="{FF2B5EF4-FFF2-40B4-BE49-F238E27FC236}">
-                <a16:creationId xmlns:a16="http://schemas.microsoft.com/office/drawing/2014/main" id="{65108431-5230-409E-9D86-482D39CF82DB}"/>
+                <a16:creationId xmlns:a16="http://schemas.microsoft.com/office/drawing/2014/main" id="{DE1E2133-3FFD-498A-B172-E0266D9A9315}"/>
               </a:ext>
             </a:extLst>
           </p:cNvPr>
@@ -10698,7 +10132,7 @@
           <p:cNvPr id="8" name="">
             <a:extLst xmlns:a="http://schemas.openxmlformats.org/drawingml/2006/main">
               <a:ext uri="{FF2B5EF4-FFF2-40B4-BE49-F238E27FC236}">
-                <a16:creationId xmlns:a16="http://schemas.microsoft.com/office/drawing/2014/main" id="{61CB5E99-D0DE-4AF4-BFBB-6C9D653E35CD}"/>
+                <a16:creationId xmlns:a16="http://schemas.microsoft.com/office/drawing/2014/main" id="{DFE7F380-C845-42FF-BA5D-85ACA54CB121}"/>
               </a:ext>
             </a:extLst>
           </p:cNvPr>
@@ -10731,7 +10165,7 @@
           <p:cNvPr id="9" name="">
             <a:extLst xmlns:a="http://schemas.openxmlformats.org/drawingml/2006/main">
               <a:ext uri="{FF2B5EF4-FFF2-40B4-BE49-F238E27FC236}">
-                <a16:creationId xmlns:a16="http://schemas.microsoft.com/office/drawing/2014/main" id="{011286B1-C06B-4135-A0D8-42539FB6FD80}"/>
+                <a16:creationId xmlns:a16="http://schemas.microsoft.com/office/drawing/2014/main" id="{9D68893C-66D3-4D36-90CF-C9FB409219B0}"/>
               </a:ext>
             </a:extLst>
           </p:cNvPr>
@@ -10781,7 +10215,7 @@
           <p:cNvPr id="10" name="">
             <a:extLst xmlns:a="http://schemas.openxmlformats.org/drawingml/2006/main">
               <a:ext uri="{FF2B5EF4-FFF2-40B4-BE49-F238E27FC236}">
-                <a16:creationId xmlns:a16="http://schemas.microsoft.com/office/drawing/2014/main" id="{361745C8-6408-4AD0-A85C-9E307830781B}"/>
+                <a16:creationId xmlns:a16="http://schemas.microsoft.com/office/drawing/2014/main" id="{F819EE08-A0BA-4888-943D-6F12F594CF8D}"/>
               </a:ext>
             </a:extLst>
           </p:cNvPr>
@@ -10814,7 +10248,7 @@
           <p:cNvPr id="11" name="">
             <a:extLst xmlns:a="http://schemas.openxmlformats.org/drawingml/2006/main">
               <a:ext uri="{FF2B5EF4-FFF2-40B4-BE49-F238E27FC236}">
-                <a16:creationId xmlns:a16="http://schemas.microsoft.com/office/drawing/2014/main" id="{FE831D9C-FD7B-4087-A321-A777BFF73422}"/>
+                <a16:creationId xmlns:a16="http://schemas.microsoft.com/office/drawing/2014/main" id="{9C51C2F6-7ECA-474D-BD3D-E8AFEB288091}"/>
               </a:ext>
             </a:extLst>
           </p:cNvPr>
@@ -10864,7 +10298,7 @@
           <p:cNvPr id="12" name="">
             <a:extLst xmlns:a="http://schemas.openxmlformats.org/drawingml/2006/main">
               <a:ext uri="{FF2B5EF4-FFF2-40B4-BE49-F238E27FC236}">
-                <a16:creationId xmlns:a16="http://schemas.microsoft.com/office/drawing/2014/main" id="{901654F2-D941-4B96-85D6-D2F446957657}"/>
+                <a16:creationId xmlns:a16="http://schemas.microsoft.com/office/drawing/2014/main" id="{B951593C-8D76-4143-8D4B-530088515CBA}"/>
               </a:ext>
             </a:extLst>
           </p:cNvPr>
@@ -10897,7 +10331,7 @@
           <p:cNvPr id="13" name="">
             <a:extLst xmlns:a="http://schemas.openxmlformats.org/drawingml/2006/main">
               <a:ext uri="{FF2B5EF4-FFF2-40B4-BE49-F238E27FC236}">
-                <a16:creationId xmlns:a16="http://schemas.microsoft.com/office/drawing/2014/main" id="{6840C705-D5E5-4605-B70D-3C05328BC39F}"/>
+                <a16:creationId xmlns:a16="http://schemas.microsoft.com/office/drawing/2014/main" id="{28EE8ED2-DFFC-4D90-8726-A27CF10FB204}"/>
               </a:ext>
             </a:extLst>
           </p:cNvPr>
@@ -10947,7 +10381,7 @@
           <p:cNvPr id="14" name="">
             <a:extLst xmlns:a="http://schemas.openxmlformats.org/drawingml/2006/main">
               <a:ext uri="{FF2B5EF4-FFF2-40B4-BE49-F238E27FC236}">
-                <a16:creationId xmlns:a16="http://schemas.microsoft.com/office/drawing/2014/main" id="{4057BBE0-AA88-40D2-9643-C88B9BB7FC64}"/>
+                <a16:creationId xmlns:a16="http://schemas.microsoft.com/office/drawing/2014/main" id="{651D3C0A-75E5-4067-8C23-26BED4BCC8F6}"/>
               </a:ext>
             </a:extLst>
           </p:cNvPr>
@@ -10980,7 +10414,7 @@
           <p:cNvPr id="15" name="">
             <a:extLst xmlns:a="http://schemas.openxmlformats.org/drawingml/2006/main">
               <a:ext uri="{FF2B5EF4-FFF2-40B4-BE49-F238E27FC236}">
-                <a16:creationId xmlns:a16="http://schemas.microsoft.com/office/drawing/2014/main" id="{CB1871BF-B7EF-4B42-BC61-46B8C8687ECA}"/>
+                <a16:creationId xmlns:a16="http://schemas.microsoft.com/office/drawing/2014/main" id="{48A4255A-0F44-4E97-A86A-89A55EBBCEB6}"/>
               </a:ext>
             </a:extLst>
           </p:cNvPr>
@@ -11030,7 +10464,7 @@
           <p:cNvPr id="16" name="">
             <a:extLst xmlns:a="http://schemas.openxmlformats.org/drawingml/2006/main">
               <a:ext uri="{FF2B5EF4-FFF2-40B4-BE49-F238E27FC236}">
-                <a16:creationId xmlns:a16="http://schemas.microsoft.com/office/drawing/2014/main" id="{D2EB16F4-4974-415B-BACC-CC1658020D5C}"/>
+                <a16:creationId xmlns:a16="http://schemas.microsoft.com/office/drawing/2014/main" id="{34E22110-54C8-4969-9C3F-21828ED086C2}"/>
               </a:ext>
             </a:extLst>
           </p:cNvPr>
@@ -11065,7 +10499,7 @@
           <p:cNvPr id="17" name="">
             <a:extLst xmlns:a="http://schemas.openxmlformats.org/drawingml/2006/main">
               <a:ext uri="{FF2B5EF4-FFF2-40B4-BE49-F238E27FC236}">
-                <a16:creationId xmlns:a16="http://schemas.microsoft.com/office/drawing/2014/main" id="{CCDD7697-8007-4C5B-98A5-B113C134187F}"/>
+                <a16:creationId xmlns:a16="http://schemas.microsoft.com/office/drawing/2014/main" id="{5AEF76D6-C305-4E33-8605-9FC1C8B52663}"/>
               </a:ext>
             </a:extLst>
           </p:cNvPr>
@@ -11098,7 +10532,7 @@
           <p:cNvPr id="18" name="">
             <a:extLst xmlns:a="http://schemas.openxmlformats.org/drawingml/2006/main">
               <a:ext uri="{FF2B5EF4-FFF2-40B4-BE49-F238E27FC236}">
-                <a16:creationId xmlns:a16="http://schemas.microsoft.com/office/drawing/2014/main" id="{6901DE07-0645-4216-B106-47112329145E}"/>
+                <a16:creationId xmlns:a16="http://schemas.microsoft.com/office/drawing/2014/main" id="{E7CEA54E-F15B-4A91-8C76-871E3859C4E3}"/>
               </a:ext>
             </a:extLst>
           </p:cNvPr>
@@ -11148,7 +10582,7 @@
           <p:cNvPr id="19" name="">
             <a:extLst xmlns:a="http://schemas.openxmlformats.org/drawingml/2006/main">
               <a:ext uri="{FF2B5EF4-FFF2-40B4-BE49-F238E27FC236}">
-                <a16:creationId xmlns:a16="http://schemas.microsoft.com/office/drawing/2014/main" id="{755E0D4B-81E8-4953-BF9D-16A1F7FFF6DD}"/>
+                <a16:creationId xmlns:a16="http://schemas.microsoft.com/office/drawing/2014/main" id="{B116BE9A-6182-4D1B-997F-ED3BA8FBEFB4}"/>
               </a:ext>
             </a:extLst>
           </p:cNvPr>
@@ -11181,7 +10615,7 @@
           <p:cNvPr id="20" name="">
             <a:extLst xmlns:a="http://schemas.openxmlformats.org/drawingml/2006/main">
               <a:ext uri="{FF2B5EF4-FFF2-40B4-BE49-F238E27FC236}">
-                <a16:creationId xmlns:a16="http://schemas.microsoft.com/office/drawing/2014/main" id="{26CC047A-FC00-467B-B5FF-0A9796319060}"/>
+                <a16:creationId xmlns:a16="http://schemas.microsoft.com/office/drawing/2014/main" id="{679C228D-234E-46FC-99A2-4FD1D420B370}"/>
               </a:ext>
             </a:extLst>
           </p:cNvPr>
@@ -11231,7 +10665,7 @@
           <p:cNvPr id="21" name="">
             <a:extLst xmlns:a="http://schemas.openxmlformats.org/drawingml/2006/main">
               <a:ext uri="{FF2B5EF4-FFF2-40B4-BE49-F238E27FC236}">
-                <a16:creationId xmlns:a16="http://schemas.microsoft.com/office/drawing/2014/main" id="{0F4F79AF-CEC6-4552-9424-6406EDCB4753}"/>
+                <a16:creationId xmlns:a16="http://schemas.microsoft.com/office/drawing/2014/main" id="{52367B0B-0C2B-4277-B2E8-E24E54F20CBC}"/>
               </a:ext>
             </a:extLst>
           </p:cNvPr>
@@ -11264,7 +10698,7 @@
           <p:cNvPr id="22" name="">
             <a:extLst xmlns:a="http://schemas.openxmlformats.org/drawingml/2006/main">
               <a:ext uri="{FF2B5EF4-FFF2-40B4-BE49-F238E27FC236}">
-                <a16:creationId xmlns:a16="http://schemas.microsoft.com/office/drawing/2014/main" id="{0FE756E5-708E-46A3-9649-680A6B0AF197}"/>
+                <a16:creationId xmlns:a16="http://schemas.microsoft.com/office/drawing/2014/main" id="{EFD5953F-245E-4C50-A99C-15D93A2CBBDA}"/>
               </a:ext>
             </a:extLst>
           </p:cNvPr>
@@ -11314,7 +10748,7 @@
           <p:cNvPr id="23" name="">
             <a:extLst xmlns:a="http://schemas.openxmlformats.org/drawingml/2006/main">
               <a:ext uri="{FF2B5EF4-FFF2-40B4-BE49-F238E27FC236}">
-                <a16:creationId xmlns:a16="http://schemas.microsoft.com/office/drawing/2014/main" id="{E2C19006-D19A-4C6E-AD91-B5E97D856C05}"/>
+                <a16:creationId xmlns:a16="http://schemas.microsoft.com/office/drawing/2014/main" id="{C4E172BB-59CE-4F90-B60E-732297559F97}"/>
               </a:ext>
             </a:extLst>
           </p:cNvPr>
@@ -11347,7 +10781,7 @@
           <p:cNvPr id="24" name="">
             <a:extLst xmlns:a="http://schemas.openxmlformats.org/drawingml/2006/main">
               <a:ext uri="{FF2B5EF4-FFF2-40B4-BE49-F238E27FC236}">
-                <a16:creationId xmlns:a16="http://schemas.microsoft.com/office/drawing/2014/main" id="{AAB2FD2B-A2A8-4A18-9D82-13E8B3382621}"/>
+                <a16:creationId xmlns:a16="http://schemas.microsoft.com/office/drawing/2014/main" id="{921420B6-4F90-4A33-AEDC-FD2678EB6BD3}"/>
               </a:ext>
             </a:extLst>
           </p:cNvPr>
@@ -11397,7 +10831,7 @@
           <p:cNvPr id="25" name="">
             <a:extLst xmlns:a="http://schemas.openxmlformats.org/drawingml/2006/main">
               <a:ext uri="{FF2B5EF4-FFF2-40B4-BE49-F238E27FC236}">
-                <a16:creationId xmlns:a16="http://schemas.microsoft.com/office/drawing/2014/main" id="{2398FCD4-D692-41C2-8DF6-F62C90D9FA85}"/>
+                <a16:creationId xmlns:a16="http://schemas.microsoft.com/office/drawing/2014/main" id="{B0041535-99CA-4321-8353-E1E021087FB2}"/>
               </a:ext>
             </a:extLst>
           </p:cNvPr>
@@ -11432,7 +10866,7 @@
           <p:cNvPr id="26" name="">
             <a:extLst xmlns:a="http://schemas.openxmlformats.org/drawingml/2006/main">
               <a:ext uri="{FF2B5EF4-FFF2-40B4-BE49-F238E27FC236}">
-                <a16:creationId xmlns:a16="http://schemas.microsoft.com/office/drawing/2014/main" id="{CEFFF89B-AD13-4FCB-9A8C-47A3F2CE0EDE}"/>
+                <a16:creationId xmlns:a16="http://schemas.microsoft.com/office/drawing/2014/main" id="{30391056-AD51-4433-933D-B2EE2D3D6A8E}"/>
               </a:ext>
             </a:extLst>
           </p:cNvPr>
@@ -11465,7 +10899,7 @@
           <p:cNvPr id="27" name="">
             <a:extLst xmlns:a="http://schemas.openxmlformats.org/drawingml/2006/main">
               <a:ext uri="{FF2B5EF4-FFF2-40B4-BE49-F238E27FC236}">
-                <a16:creationId xmlns:a16="http://schemas.microsoft.com/office/drawing/2014/main" id="{1F62F1EF-4084-40BD-B0A5-C76D15E1E66A}"/>
+                <a16:creationId xmlns:a16="http://schemas.microsoft.com/office/drawing/2014/main" id="{31FE62A9-7108-43CB-9124-C79B993EFA5F}"/>
               </a:ext>
             </a:extLst>
           </p:cNvPr>
@@ -11515,7 +10949,7 @@
           <p:cNvPr id="28" name="">
             <a:extLst xmlns:a="http://schemas.openxmlformats.org/drawingml/2006/main">
               <a:ext uri="{FF2B5EF4-FFF2-40B4-BE49-F238E27FC236}">
-                <a16:creationId xmlns:a16="http://schemas.microsoft.com/office/drawing/2014/main" id="{B089555E-41D6-4CD6-BCC9-8187EFA02101}"/>
+                <a16:creationId xmlns:a16="http://schemas.microsoft.com/office/drawing/2014/main" id="{71DD0141-14CF-4454-A0DC-DAF3B9BBE531}"/>
               </a:ext>
             </a:extLst>
           </p:cNvPr>
@@ -11548,7 +10982,7 @@
           <p:cNvPr id="29" name="">
             <a:extLst xmlns:a="http://schemas.openxmlformats.org/drawingml/2006/main">
               <a:ext uri="{FF2B5EF4-FFF2-40B4-BE49-F238E27FC236}">
-                <a16:creationId xmlns:a16="http://schemas.microsoft.com/office/drawing/2014/main" id="{0C728B78-1BA1-4586-A2AF-FBE270AFC1CD}"/>
+                <a16:creationId xmlns:a16="http://schemas.microsoft.com/office/drawing/2014/main" id="{8E090205-21CB-47BA-BF15-439DAE3EC3DF}"/>
               </a:ext>
             </a:extLst>
           </p:cNvPr>
@@ -11596,7 +11030,7 @@
     </p:spTree>
     <p:extLst>
       <p:ext uri="{BB962C8B-B14F-4D97-AF65-F5344CB8AC3E}">
-        <p14:creationId xmlns:p14="http://schemas.microsoft.com/office/powerpoint/2010/main" val="551909309"/>
+        <p14:creationId xmlns:p14="http://schemas.microsoft.com/office/powerpoint/2010/main" val="848243159"/>
       </p:ext>
     </p:extLst>
   </p:cSld>
@@ -11627,7 +11061,7 @@
           <p:cNvPr id="35" name="">
             <a:extLst xmlns:a="http://schemas.openxmlformats.org/drawingml/2006/main">
               <a:ext uri="{FF2B5EF4-FFF2-40B4-BE49-F238E27FC236}">
-                <a16:creationId xmlns:a16="http://schemas.microsoft.com/office/drawing/2014/main" id="{E62D8FDA-0B1A-4CE0-9869-27A046229F53}"/>
+                <a16:creationId xmlns:a16="http://schemas.microsoft.com/office/drawing/2014/main" id="{3CB06C7F-AE53-4179-AF8F-5AD40E5C188D}"/>
               </a:ext>
             </a:extLst>
           </p:cNvPr>
@@ -11677,7 +11111,7 @@
           <p:cNvPr id="2" name="">
             <a:extLst xmlns:a="http://schemas.openxmlformats.org/drawingml/2006/main">
               <a:ext uri="{FF2B5EF4-FFF2-40B4-BE49-F238E27FC236}">
-                <a16:creationId xmlns:a16="http://schemas.microsoft.com/office/drawing/2014/main" id="{0BC1E598-0C61-4354-A9CA-8F74F66988B1}"/>
+                <a16:creationId xmlns:a16="http://schemas.microsoft.com/office/drawing/2014/main" id="{2C2AD135-E91F-4403-A2F3-68EE24D3BEE5}"/>
               </a:ext>
             </a:extLst>
           </p:cNvPr>
@@ -11727,7 +11161,7 @@
           <p:cNvPr id="3" name="">
             <a:extLst xmlns:a="http://schemas.openxmlformats.org/drawingml/2006/main">
               <a:ext uri="{FF2B5EF4-FFF2-40B4-BE49-F238E27FC236}">
-                <a16:creationId xmlns:a16="http://schemas.microsoft.com/office/drawing/2014/main" id="{A55D80B6-885A-41C0-8322-D4B3EC870D5B}"/>
+                <a16:creationId xmlns:a16="http://schemas.microsoft.com/office/drawing/2014/main" id="{BA067062-D009-4744-8D8E-8AAFA185AFC8}"/>
               </a:ext>
             </a:extLst>
           </p:cNvPr>
@@ -11777,7 +11211,7 @@
           <p:cNvPr id="4" name="">
             <a:extLst xmlns:a="http://schemas.openxmlformats.org/drawingml/2006/main">
               <a:ext uri="{FF2B5EF4-FFF2-40B4-BE49-F238E27FC236}">
-                <a16:creationId xmlns:a16="http://schemas.microsoft.com/office/drawing/2014/main" id="{17904AEE-999C-48D0-BA20-66F4FA1A78E9}"/>
+                <a16:creationId xmlns:a16="http://schemas.microsoft.com/office/drawing/2014/main" id="{F7EBB1CE-E2B2-4A21-B6F3-B92BAF4E5313}"/>
               </a:ext>
             </a:extLst>
           </p:cNvPr>
@@ -11808,7 +11242,7 @@
           <p:cNvPr id="5" name="">
             <a:extLst xmlns:a="http://schemas.openxmlformats.org/drawingml/2006/main">
               <a:ext uri="{FF2B5EF4-FFF2-40B4-BE49-F238E27FC236}">
-                <a16:creationId xmlns:a16="http://schemas.microsoft.com/office/drawing/2014/main" id="{81920C4C-413F-4666-83F5-EDEDADFCD44F}"/>
+                <a16:creationId xmlns:a16="http://schemas.microsoft.com/office/drawing/2014/main" id="{03A8CC85-1E2F-4120-AA0D-C5B009509BC8}"/>
               </a:ext>
             </a:extLst>
           </p:cNvPr>
@@ -11858,7 +11292,7 @@
           <p:cNvPr id="6" name="">
             <a:extLst xmlns:a="http://schemas.openxmlformats.org/drawingml/2006/main">
               <a:ext uri="{FF2B5EF4-FFF2-40B4-BE49-F238E27FC236}">
-                <a16:creationId xmlns:a16="http://schemas.microsoft.com/office/drawing/2014/main" id="{25E39E66-59E4-437D-995A-8EB8040BDDAD}"/>
+                <a16:creationId xmlns:a16="http://schemas.microsoft.com/office/drawing/2014/main" id="{1B530D7D-E856-4D10-81DB-5F2D2228613B}"/>
               </a:ext>
             </a:extLst>
           </p:cNvPr>
@@ -11908,7 +11342,7 @@
           <p:cNvPr id="7" name="">
             <a:extLst xmlns:a="http://schemas.openxmlformats.org/drawingml/2006/main">
               <a:ext uri="{FF2B5EF4-FFF2-40B4-BE49-F238E27FC236}">
-                <a16:creationId xmlns:a16="http://schemas.microsoft.com/office/drawing/2014/main" id="{B677A021-E574-4C69-AF9B-FB6D2EA8E4A4}"/>
+                <a16:creationId xmlns:a16="http://schemas.microsoft.com/office/drawing/2014/main" id="{5D03A3F7-C3C9-4AAF-B3C2-EE60B53F69E8}"/>
               </a:ext>
             </a:extLst>
           </p:cNvPr>
@@ -11939,7 +11373,7 @@
           <p:cNvPr id="8" name="">
             <a:extLst xmlns:a="http://schemas.openxmlformats.org/drawingml/2006/main">
               <a:ext uri="{FF2B5EF4-FFF2-40B4-BE49-F238E27FC236}">
-                <a16:creationId xmlns:a16="http://schemas.microsoft.com/office/drawing/2014/main" id="{3B621E58-47F3-47D7-89D5-A9D6986428F1}"/>
+                <a16:creationId xmlns:a16="http://schemas.microsoft.com/office/drawing/2014/main" id="{6D3E66EB-DB1F-4CE8-A8C6-80748E2D2C9F}"/>
               </a:ext>
             </a:extLst>
           </p:cNvPr>
@@ -11989,7 +11423,7 @@
           <p:cNvPr id="9" name="">
             <a:extLst xmlns:a="http://schemas.openxmlformats.org/drawingml/2006/main">
               <a:ext uri="{FF2B5EF4-FFF2-40B4-BE49-F238E27FC236}">
-                <a16:creationId xmlns:a16="http://schemas.microsoft.com/office/drawing/2014/main" id="{11221F50-EF2E-443D-84C7-2B5BBAC51171}"/>
+                <a16:creationId xmlns:a16="http://schemas.microsoft.com/office/drawing/2014/main" id="{66CAD25F-E18C-4E4D-899F-66DDABE0AFC3}"/>
               </a:ext>
             </a:extLst>
           </p:cNvPr>
@@ -12039,7 +11473,7 @@
           <p:cNvPr id="10" name="">
             <a:extLst xmlns:a="http://schemas.openxmlformats.org/drawingml/2006/main">
               <a:ext uri="{FF2B5EF4-FFF2-40B4-BE49-F238E27FC236}">
-                <a16:creationId xmlns:a16="http://schemas.microsoft.com/office/drawing/2014/main" id="{FE4866E0-9EA2-4CCE-88DD-3E5F3381AEB9}"/>
+                <a16:creationId xmlns:a16="http://schemas.microsoft.com/office/drawing/2014/main" id="{FBD5D5C5-055E-4451-B665-59FDD396A3F4}"/>
               </a:ext>
             </a:extLst>
           </p:cNvPr>
@@ -12089,7 +11523,7 @@
           <p:cNvPr id="11" name="">
             <a:extLst xmlns:a="http://schemas.openxmlformats.org/drawingml/2006/main">
               <a:ext uri="{FF2B5EF4-FFF2-40B4-BE49-F238E27FC236}">
-                <a16:creationId xmlns:a16="http://schemas.microsoft.com/office/drawing/2014/main" id="{7BD3CD45-D910-4075-BD4C-39D66578FE55}"/>
+                <a16:creationId xmlns:a16="http://schemas.microsoft.com/office/drawing/2014/main" id="{F53E1B1F-02ED-4D3F-8595-0ED1B1CBF99E}"/>
               </a:ext>
             </a:extLst>
           </p:cNvPr>
@@ -12139,7 +11573,7 @@
           <p:cNvPr id="12" name="">
             <a:extLst xmlns:a="http://schemas.openxmlformats.org/drawingml/2006/main">
               <a:ext uri="{FF2B5EF4-FFF2-40B4-BE49-F238E27FC236}">
-                <a16:creationId xmlns:a16="http://schemas.microsoft.com/office/drawing/2014/main" id="{B587DB79-C7C4-4130-AE77-0E89023B4699}"/>
+                <a16:creationId xmlns:a16="http://schemas.microsoft.com/office/drawing/2014/main" id="{5D02D7F3-2843-487C-BAC7-0C814B697E9F}"/>
               </a:ext>
             </a:extLst>
           </p:cNvPr>
@@ -12170,7 +11604,7 @@
           <p:cNvPr id="13" name="">
             <a:extLst xmlns:a="http://schemas.openxmlformats.org/drawingml/2006/main">
               <a:ext uri="{FF2B5EF4-FFF2-40B4-BE49-F238E27FC236}">
-                <a16:creationId xmlns:a16="http://schemas.microsoft.com/office/drawing/2014/main" id="{2FD35E16-97E4-476E-B76E-777F1EA96ACC}"/>
+                <a16:creationId xmlns:a16="http://schemas.microsoft.com/office/drawing/2014/main" id="{A69A52C4-64BC-4A85-AC7B-CB570A5B4F92}"/>
               </a:ext>
             </a:extLst>
           </p:cNvPr>
@@ -12220,7 +11654,7 @@
           <p:cNvPr id="14" name="">
             <a:extLst xmlns:a="http://schemas.openxmlformats.org/drawingml/2006/main">
               <a:ext uri="{FF2B5EF4-FFF2-40B4-BE49-F238E27FC236}">
-                <a16:creationId xmlns:a16="http://schemas.microsoft.com/office/drawing/2014/main" id="{F60CA730-6860-443B-8801-F9A8CFD8F43E}"/>
+                <a16:creationId xmlns:a16="http://schemas.microsoft.com/office/drawing/2014/main" id="{77830D5C-01AE-4238-86BC-D10C69BDD107}"/>
               </a:ext>
             </a:extLst>
           </p:cNvPr>
@@ -12270,7 +11704,7 @@
           <p:cNvPr id="15" name="">
             <a:extLst xmlns:a="http://schemas.openxmlformats.org/drawingml/2006/main">
               <a:ext uri="{FF2B5EF4-FFF2-40B4-BE49-F238E27FC236}">
-                <a16:creationId xmlns:a16="http://schemas.microsoft.com/office/drawing/2014/main" id="{A21D1653-9FA2-43D0-946C-7193BBB298E2}"/>
+                <a16:creationId xmlns:a16="http://schemas.microsoft.com/office/drawing/2014/main" id="{0FAB5083-352F-4361-88CB-7C51DD5FAFDB}"/>
               </a:ext>
             </a:extLst>
           </p:cNvPr>
@@ -12320,7 +11754,7 @@
           <p:cNvPr id="16" name="">
             <a:extLst xmlns:a="http://schemas.openxmlformats.org/drawingml/2006/main">
               <a:ext uri="{FF2B5EF4-FFF2-40B4-BE49-F238E27FC236}">
-                <a16:creationId xmlns:a16="http://schemas.microsoft.com/office/drawing/2014/main" id="{F682F86B-9DE0-4874-A667-772492F0C316}"/>
+                <a16:creationId xmlns:a16="http://schemas.microsoft.com/office/drawing/2014/main" id="{75C6D59A-D8BC-413B-8CE9-F746F10B4B38}"/>
               </a:ext>
             </a:extLst>
           </p:cNvPr>
@@ -12370,7 +11804,7 @@
           <p:cNvPr id="17" name="">
             <a:extLst xmlns:a="http://schemas.openxmlformats.org/drawingml/2006/main">
               <a:ext uri="{FF2B5EF4-FFF2-40B4-BE49-F238E27FC236}">
-                <a16:creationId xmlns:a16="http://schemas.microsoft.com/office/drawing/2014/main" id="{9FA5F53E-8DB8-4B32-9923-F0CA3267914F}"/>
+                <a16:creationId xmlns:a16="http://schemas.microsoft.com/office/drawing/2014/main" id="{F2914561-6543-46C3-9E55-250911ECB782}"/>
               </a:ext>
             </a:extLst>
           </p:cNvPr>
@@ -12401,7 +11835,7 @@
           <p:cNvPr id="18" name="">
             <a:extLst xmlns:a="http://schemas.openxmlformats.org/drawingml/2006/main">
               <a:ext uri="{FF2B5EF4-FFF2-40B4-BE49-F238E27FC236}">
-                <a16:creationId xmlns:a16="http://schemas.microsoft.com/office/drawing/2014/main" id="{CAEDF892-4D44-45CE-AF95-0C21C8F9E534}"/>
+                <a16:creationId xmlns:a16="http://schemas.microsoft.com/office/drawing/2014/main" id="{C444C08E-B10B-43FE-9C88-8640E2464154}"/>
               </a:ext>
             </a:extLst>
           </p:cNvPr>
@@ -12451,7 +11885,7 @@
           <p:cNvPr id="19" name="">
             <a:extLst xmlns:a="http://schemas.openxmlformats.org/drawingml/2006/main">
               <a:ext uri="{FF2B5EF4-FFF2-40B4-BE49-F238E27FC236}">
-                <a16:creationId xmlns:a16="http://schemas.microsoft.com/office/drawing/2014/main" id="{CF220A8A-59BB-490C-B8BF-432E49B636F7}"/>
+                <a16:creationId xmlns:a16="http://schemas.microsoft.com/office/drawing/2014/main" id="{D68F3431-CD54-431A-9A8E-B7B537B6BBD3}"/>
               </a:ext>
             </a:extLst>
           </p:cNvPr>
@@ -12501,7 +11935,7 @@
           <p:cNvPr id="20" name="">
             <a:extLst xmlns:a="http://schemas.openxmlformats.org/drawingml/2006/main">
               <a:ext uri="{FF2B5EF4-FFF2-40B4-BE49-F238E27FC236}">
-                <a16:creationId xmlns:a16="http://schemas.microsoft.com/office/drawing/2014/main" id="{5D36247E-2DA7-4C34-8669-D4F23F2E21F1}"/>
+                <a16:creationId xmlns:a16="http://schemas.microsoft.com/office/drawing/2014/main" id="{AAA21641-3A4E-4D4F-A9DF-901B7286C26E}"/>
               </a:ext>
             </a:extLst>
           </p:cNvPr>
@@ -12551,7 +11985,7 @@
           <p:cNvPr id="21" name="">
             <a:extLst xmlns:a="http://schemas.openxmlformats.org/drawingml/2006/main">
               <a:ext uri="{FF2B5EF4-FFF2-40B4-BE49-F238E27FC236}">
-                <a16:creationId xmlns:a16="http://schemas.microsoft.com/office/drawing/2014/main" id="{93774A2A-E785-4B80-82BC-0F2956868D43}"/>
+                <a16:creationId xmlns:a16="http://schemas.microsoft.com/office/drawing/2014/main" id="{40255283-7B82-4A2C-90C4-FC6A01863F7C}"/>
               </a:ext>
             </a:extLst>
           </p:cNvPr>
@@ -12601,7 +12035,7 @@
           <p:cNvPr id="22" name="">
             <a:extLst xmlns:a="http://schemas.openxmlformats.org/drawingml/2006/main">
               <a:ext uri="{FF2B5EF4-FFF2-40B4-BE49-F238E27FC236}">
-                <a16:creationId xmlns:a16="http://schemas.microsoft.com/office/drawing/2014/main" id="{0DE7CDEC-1937-4DC1-983B-B7FE078A40A0}"/>
+                <a16:creationId xmlns:a16="http://schemas.microsoft.com/office/drawing/2014/main" id="{900AB3D5-A7B4-41AB-A4DD-5B237E864958}"/>
               </a:ext>
             </a:extLst>
           </p:cNvPr>
@@ -12632,7 +12066,7 @@
           <p:cNvPr id="23" name="">
             <a:extLst xmlns:a="http://schemas.openxmlformats.org/drawingml/2006/main">
               <a:ext uri="{FF2B5EF4-FFF2-40B4-BE49-F238E27FC236}">
-                <a16:creationId xmlns:a16="http://schemas.microsoft.com/office/drawing/2014/main" id="{8CCFA851-4B4F-4ADC-9953-16EA6D428078}"/>
+                <a16:creationId xmlns:a16="http://schemas.microsoft.com/office/drawing/2014/main" id="{43512A6F-F800-461A-A17E-C19EB91DEBEA}"/>
               </a:ext>
             </a:extLst>
           </p:cNvPr>
@@ -12682,7 +12116,7 @@
           <p:cNvPr id="24" name="">
             <a:extLst xmlns:a="http://schemas.openxmlformats.org/drawingml/2006/main">
               <a:ext uri="{FF2B5EF4-FFF2-40B4-BE49-F238E27FC236}">
-                <a16:creationId xmlns:a16="http://schemas.microsoft.com/office/drawing/2014/main" id="{89A23C2C-7296-4AA5-9C7B-897EAF869D61}"/>
+                <a16:creationId xmlns:a16="http://schemas.microsoft.com/office/drawing/2014/main" id="{FB817DC7-F2CA-48BC-9DC0-A04E08E86F6C}"/>
               </a:ext>
             </a:extLst>
           </p:cNvPr>
@@ -12732,7 +12166,7 @@
           <p:cNvPr id="25" name="">
             <a:extLst xmlns:a="http://schemas.openxmlformats.org/drawingml/2006/main">
               <a:ext uri="{FF2B5EF4-FFF2-40B4-BE49-F238E27FC236}">
-                <a16:creationId xmlns:a16="http://schemas.microsoft.com/office/drawing/2014/main" id="{0D298707-2178-4A47-9938-9D59B106A50A}"/>
+                <a16:creationId xmlns:a16="http://schemas.microsoft.com/office/drawing/2014/main" id="{87C0F565-2266-442E-BB94-C39C725A930F}"/>
               </a:ext>
             </a:extLst>
           </p:cNvPr>
@@ -12782,7 +12216,7 @@
           <p:cNvPr id="26" name="">
             <a:extLst xmlns:a="http://schemas.openxmlformats.org/drawingml/2006/main">
               <a:ext uri="{FF2B5EF4-FFF2-40B4-BE49-F238E27FC236}">
-                <a16:creationId xmlns:a16="http://schemas.microsoft.com/office/drawing/2014/main" id="{3CF48F6D-360C-4B88-8B5E-3639E3173AD1}"/>
+                <a16:creationId xmlns:a16="http://schemas.microsoft.com/office/drawing/2014/main" id="{0FBA4822-FFAA-43AE-B449-43CA658E4C85}"/>
               </a:ext>
             </a:extLst>
           </p:cNvPr>
@@ -12832,7 +12266,7 @@
           <p:cNvPr id="27" name="">
             <a:extLst xmlns:a="http://schemas.openxmlformats.org/drawingml/2006/main">
               <a:ext uri="{FF2B5EF4-FFF2-40B4-BE49-F238E27FC236}">
-                <a16:creationId xmlns:a16="http://schemas.microsoft.com/office/drawing/2014/main" id="{3313EF43-161D-4683-BC71-DB25B4E487C5}"/>
+                <a16:creationId xmlns:a16="http://schemas.microsoft.com/office/drawing/2014/main" id="{78A9E94D-6FA5-43D6-937D-973955C06048}"/>
               </a:ext>
             </a:extLst>
           </p:cNvPr>
@@ -12863,7 +12297,7 @@
           <p:cNvPr id="28" name="">
             <a:extLst xmlns:a="http://schemas.openxmlformats.org/drawingml/2006/main">
               <a:ext uri="{FF2B5EF4-FFF2-40B4-BE49-F238E27FC236}">
-                <a16:creationId xmlns:a16="http://schemas.microsoft.com/office/drawing/2014/main" id="{39C61D55-1192-49A5-B422-4B61EB8C66C7}"/>
+                <a16:creationId xmlns:a16="http://schemas.microsoft.com/office/drawing/2014/main" id="{B0DD2FEA-80F0-4796-B2F0-E7601C02EBA5}"/>
               </a:ext>
             </a:extLst>
           </p:cNvPr>
@@ -12913,7 +12347,7 @@
           <p:cNvPr id="29" name="">
             <a:extLst xmlns:a="http://schemas.openxmlformats.org/drawingml/2006/main">
               <a:ext uri="{FF2B5EF4-FFF2-40B4-BE49-F238E27FC236}">
-                <a16:creationId xmlns:a16="http://schemas.microsoft.com/office/drawing/2014/main" id="{B694E88B-8DCB-4EA0-9E55-B41B22BE84EE}"/>
+                <a16:creationId xmlns:a16="http://schemas.microsoft.com/office/drawing/2014/main" id="{1D429046-1F89-49E0-BEFD-03F32EF8A607}"/>
               </a:ext>
             </a:extLst>
           </p:cNvPr>
@@ -12963,7 +12397,7 @@
           <p:cNvPr id="30" name="">
             <a:extLst xmlns:a="http://schemas.openxmlformats.org/drawingml/2006/main">
               <a:ext uri="{FF2B5EF4-FFF2-40B4-BE49-F238E27FC236}">
-                <a16:creationId xmlns:a16="http://schemas.microsoft.com/office/drawing/2014/main" id="{84788481-54B7-4F68-939D-2F74A60C61C6}"/>
+                <a16:creationId xmlns:a16="http://schemas.microsoft.com/office/drawing/2014/main" id="{6448FC2C-D3DD-4F33-BAE2-A30E1502D11F}"/>
               </a:ext>
             </a:extLst>
           </p:cNvPr>
@@ -13013,7 +12447,7 @@
           <p:cNvPr id="31" name="">
             <a:extLst xmlns:a="http://schemas.openxmlformats.org/drawingml/2006/main">
               <a:ext uri="{FF2B5EF4-FFF2-40B4-BE49-F238E27FC236}">
-                <a16:creationId xmlns:a16="http://schemas.microsoft.com/office/drawing/2014/main" id="{0CC5AFB3-494B-454C-8EDF-0A75F6C58897}"/>
+                <a16:creationId xmlns:a16="http://schemas.microsoft.com/office/drawing/2014/main" id="{AA0518EE-BC2D-40C6-B1FC-D1B7B8A59DD9}"/>
               </a:ext>
             </a:extLst>
           </p:cNvPr>
@@ -13063,7 +12497,7 @@
           <p:cNvPr id="32" name="">
             <a:extLst xmlns:a="http://schemas.openxmlformats.org/drawingml/2006/main">
               <a:ext uri="{FF2B5EF4-FFF2-40B4-BE49-F238E27FC236}">
-                <a16:creationId xmlns:a16="http://schemas.microsoft.com/office/drawing/2014/main" id="{FF53C60B-CC9A-4BFB-A0AD-AC1F5EDCDCAD}"/>
+                <a16:creationId xmlns:a16="http://schemas.microsoft.com/office/drawing/2014/main" id="{0F0D4435-3579-4E27-A34E-4498192D4269}"/>
               </a:ext>
             </a:extLst>
           </p:cNvPr>
@@ -13113,7 +12547,7 @@
           <p:cNvPr id="33" name="">
             <a:extLst xmlns:a="http://schemas.openxmlformats.org/drawingml/2006/main">
               <a:ext uri="{FF2B5EF4-FFF2-40B4-BE49-F238E27FC236}">
-                <a16:creationId xmlns:a16="http://schemas.microsoft.com/office/drawing/2014/main" id="{9BBD5993-CC83-40FB-B178-671010AE4EEA}"/>
+                <a16:creationId xmlns:a16="http://schemas.microsoft.com/office/drawing/2014/main" id="{C06A8CAB-B792-4B74-B53E-6A7F108A6D88}"/>
               </a:ext>
             </a:extLst>
           </p:cNvPr>
@@ -13163,7 +12597,7 @@
           <p:cNvPr id="34" name="">
             <a:extLst xmlns:a="http://schemas.openxmlformats.org/drawingml/2006/main">
               <a:ext uri="{FF2B5EF4-FFF2-40B4-BE49-F238E27FC236}">
-                <a16:creationId xmlns:a16="http://schemas.microsoft.com/office/drawing/2014/main" id="{7649C361-D09A-429B-B20C-06BD7F9B6EFE}"/>
+                <a16:creationId xmlns:a16="http://schemas.microsoft.com/office/drawing/2014/main" id="{606DF820-A65A-41E5-8C1F-309359C85F98}"/>
               </a:ext>
             </a:extLst>
           </p:cNvPr>
@@ -13211,7 +12645,7 @@
     </p:spTree>
     <p:extLst>
       <p:ext uri="{BB962C8B-B14F-4D97-AF65-F5344CB8AC3E}">
-        <p14:creationId xmlns:p14="http://schemas.microsoft.com/office/powerpoint/2010/main" val="785619931"/>
+        <p14:creationId xmlns:p14="http://schemas.microsoft.com/office/powerpoint/2010/main" val="1312100928"/>
       </p:ext>
     </p:extLst>
   </p:cSld>

</xml_diff>